<commit_message>
Use installment duration for MC3 FIDC preset
</commit_message>
<xml_diff>
--- a/outputs/modelo_fidc_mc3_comite_trava_30.pptx
+++ b/outputs/modelo_fidc_mc3_comite_trava_30.pptx
@@ -641,76 +641,76 @@
                   <c:v>300.0</c:v>
                 </c:pt>
                 <c:pt idx="1">
-                  <c:v>350.8802860528661</c:v>
+                  <c:v>300.0</c:v>
                 </c:pt>
                 <c:pt idx="2">
-                  <c:v>422.2639618154886</c:v>
+                  <c:v>310.09438211985076</c:v>
                 </c:pt>
                 <c:pt idx="3">
-                  <c:v>494.35759424248266</c:v>
+                  <c:v>318.78460001773846</c:v>
                 </c:pt>
                 <c:pt idx="4">
-                  <c:v>560.4584261729063</c:v>
+                  <c:v>322.7727899454315</c:v>
                 </c:pt>
                 <c:pt idx="5">
-                  <c:v>628.561922763068</c:v>
+                  <c:v>326.53771235678806</c:v>
                 </c:pt>
                 <c:pt idx="6">
-                  <c:v>697.7750909316574</c:v>
+                  <c:v>328.49673575303854</c:v>
                 </c:pt>
                 <c:pt idx="7">
-                  <c:v>751.2323743086431</c:v>
+                  <c:v>328.17666308278456</c:v>
                 </c:pt>
                 <c:pt idx="8">
-                  <c:v>805.1395342065393</c:v>
+                  <c:v>328.17666308278456</c:v>
                 </c:pt>
                 <c:pt idx="9">
-                  <c:v>854.5759046227555</c:v>
+                  <c:v>328.17666308278456</c:v>
                 </c:pt>
                 <c:pt idx="10">
-                  <c:v>895.90378426582</c:v>
+                  <c:v>328.17666308278456</c:v>
                 </c:pt>
                 <c:pt idx="11">
-                  <c:v>940.8969996006837</c:v>
+                  <c:v>328.17666308278456</c:v>
                 </c:pt>
                 <c:pt idx="12">
-                  <c:v>975.1076779606046</c:v>
+                  <c:v>328.17666308278456</c:v>
                 </c:pt>
                 <c:pt idx="13">
-                  <c:v>1003.4702031926548</c:v>
+                  <c:v>328.17666308278456</c:v>
                 </c:pt>
                 <c:pt idx="14">
-                  <c:v>1037.2166722769887</c:v>
+                  <c:v>328.17666308278456</c:v>
                 </c:pt>
                 <c:pt idx="15">
-                  <c:v>1065.6401089559329</c:v>
+                  <c:v>328.17666308278456</c:v>
                 </c:pt>
                 <c:pt idx="16">
-                  <c:v>1089.4820742958004</c:v>
+                  <c:v>328.17666308278456</c:v>
                 </c:pt>
                 <c:pt idx="17">
-                  <c:v>1113.142460163834</c:v>
+                  <c:v>328.17666308278456</c:v>
                 </c:pt>
                 <c:pt idx="18">
-                  <c:v>1134.7379399297447</c:v>
+                  <c:v>328.17666308278456</c:v>
                 </c:pt>
                 <c:pt idx="19">
-                  <c:v>1154.7048011888662</c:v>
+                  <c:v>328.17666308278456</c:v>
                 </c:pt>
                 <c:pt idx="20">
-                  <c:v>1171.4773380364716</c:v>
+                  <c:v>328.17666308278456</c:v>
                 </c:pt>
                 <c:pt idx="21">
-                  <c:v>1184.5936345724058</c:v>
+                  <c:v>328.17666308278456</c:v>
                 </c:pt>
                 <c:pt idx="22">
-                  <c:v>1196.414661304148</c:v>
+                  <c:v>328.17666308278456</c:v>
                 </c:pt>
                 <c:pt idx="23">
-                  <c:v>1206.9914078435845</c:v>
+                  <c:v>328.17666308278456</c:v>
                 </c:pt>
                 <c:pt idx="24">
-                  <c:v>1215.0684012434233</c:v>
+                  <c:v>328.17666308278456</c:v>
                 </c:pt>
               </c:numCache>
             </c:numRef>
@@ -1181,76 +1181,76 @@
                   <c:v>0.0</c:v>
                 </c:pt>
                 <c:pt idx="1">
-                  <c:v>31.89820782298783</c:v>
+                  <c:v>30.0</c:v>
                 </c:pt>
                 <c:pt idx="2">
-                  <c:v>35.18866348462405</c:v>
+                  <c:v>30.12394321167599</c:v>
                 </c:pt>
                 <c:pt idx="3">
-                  <c:v>38.027507249421745</c:v>
+                  <c:v>30.097163680256944</c:v>
                 </c:pt>
                 <c:pt idx="4">
-                  <c:v>40.032744726636174</c:v>
+                  <c:v>30.09335562100375</c:v>
                 </c:pt>
                 <c:pt idx="5">
-                  <c:v>42.09120018502687</c:v>
+                  <c:v>30.051293729072576</c:v>
                 </c:pt>
                 <c:pt idx="6">
-                  <c:v>44.16298043871249</c:v>
+                  <c:v>30.029259180154433</c:v>
                 </c:pt>
                 <c:pt idx="7">
-                  <c:v>45.25496230774959</c:v>
+                  <c:v>30.0</c:v>
                 </c:pt>
                 <c:pt idx="8">
-                  <c:v>46.450357742684965</c:v>
+                  <c:v>30.0</c:v>
                 </c:pt>
                 <c:pt idx="9">
-                  <c:v>47.46471946189089</c:v>
+                  <c:v>30.0</c:v>
                 </c:pt>
                 <c:pt idx="10">
-                  <c:v>48.12087645256851</c:v>
+                  <c:v>30.0</c:v>
                 </c:pt>
                 <c:pt idx="11">
-                  <c:v>49.0618365956324</c:v>
+                  <c:v>30.0</c:v>
                 </c:pt>
                 <c:pt idx="12">
-                  <c:v>49.525784997999104</c:v>
+                  <c:v>30.0</c:v>
                 </c:pt>
                 <c:pt idx="13">
-                  <c:v>49.78701540302261</c:v>
+                  <c:v>30.0</c:v>
                 </c:pt>
                 <c:pt idx="14">
-                  <c:v>50.397441245822584</c:v>
+                  <c:v>30.0</c:v>
                 </c:pt>
                 <c:pt idx="15">
-                  <c:v>50.82005606508794</c:v>
+                  <c:v>30.0</c:v>
                 </c:pt>
                 <c:pt idx="16">
-                  <c:v>51.09430974429689</c:v>
+                  <c:v>30.0</c:v>
                 </c:pt>
                 <c:pt idx="17">
-                  <c:v>51.424986307857345</c:v>
+                  <c:v>30.0</c:v>
                 </c:pt>
                 <c:pt idx="18">
-                  <c:v>51.71872489531162</c:v>
+                  <c:v>30.0</c:v>
                 </c:pt>
                 <c:pt idx="19">
-                  <c:v>52.628768146837416</c:v>
+                  <c:v>30.0</c:v>
                 </c:pt>
                 <c:pt idx="20">
-                  <c:v>53.39322149636717</c:v>
+                  <c:v>30.0</c:v>
                 </c:pt>
                 <c:pt idx="21">
-                  <c:v>53.9910318879271</c:v>
+                  <c:v>30.0</c:v>
                 </c:pt>
                 <c:pt idx="22">
-                  <c:v>54.529806884343415</c:v>
+                  <c:v>30.0</c:v>
                 </c:pt>
                 <c:pt idx="23">
-                  <c:v>55.011870473928184</c:v>
+                  <c:v>30.0</c:v>
                 </c:pt>
                 <c:pt idx="24">
-                  <c:v>55.380001110023215</c:v>
+                  <c:v>30.0</c:v>
                 </c:pt>
               </c:numCache>
             </c:numRef>
@@ -1388,73 +1388,73 @@
                   <c:v>30.0</c:v>
                 </c:pt>
                 <c:pt idx="1">
-                  <c:v>33.389177693187264</c:v>
+                  <c:v>30.0</c:v>
                 </c:pt>
                 <c:pt idx="2">
-                  <c:v>37.62608229283166</c:v>
+                  <c:v>30.699545271112804</c:v>
                 </c:pt>
                 <c:pt idx="3">
-                  <c:v>41.39108727784557</c:v>
+                  <c:v>31.29067714727804</c:v>
                 </c:pt>
                 <c:pt idx="4">
-                  <c:v>44.46464988731205</c:v>
+                  <c:v>31.55860158957226</c:v>
                 </c:pt>
                 <c:pt idx="5">
-                  <c:v>47.3114509751883</c:v>
+                  <c:v>31.80961677551064</c:v>
                 </c:pt>
                 <c:pt idx="6">
-                  <c:v>49.92041247970517</c:v>
+                  <c:v>31.9395020259857</c:v>
                 </c:pt>
                 <c:pt idx="7">
-                  <c:v>51.76513338647953</c:v>
+                  <c:v>31.91831470856493</c:v>
                 </c:pt>
                 <c:pt idx="8">
-                  <c:v>53.49268396109087</c:v>
+                  <c:v>31.91831470856493</c:v>
                 </c:pt>
                 <c:pt idx="9">
-                  <c:v>54.97164223898948</c:v>
+                  <c:v>31.91831470856493</c:v>
                 </c:pt>
                 <c:pt idx="10">
-                  <c:v>56.13770661481148</c:v>
+                  <c:v>31.91831470856493</c:v>
                 </c:pt>
                 <c:pt idx="11">
-                  <c:v>57.34040587737398</c:v>
+                  <c:v>31.91831470856493</c:v>
                 </c:pt>
                 <c:pt idx="12">
-                  <c:v>58.21164160310997</c:v>
+                  <c:v>31.91831470856493</c:v>
                 </c:pt>
                 <c:pt idx="13">
-                  <c:v>58.90741154802382</c:v>
+                  <c:v>31.91831470856493</c:v>
                 </c:pt>
                 <c:pt idx="14">
-                  <c:v>59.70565956620124</c:v>
+                  <c:v>31.91831470856493</c:v>
                 </c:pt>
                 <c:pt idx="15">
-                  <c:v>60.3543215602455</c:v>
+                  <c:v>31.91831470856493</c:v>
                 </c:pt>
                 <c:pt idx="16">
-                  <c:v>60.88253634641939</c:v>
+                  <c:v>31.91831470856493</c:v>
                 </c:pt>
                 <c:pt idx="17">
-                  <c:v>61.3929950139302</c:v>
+                  <c:v>31.91831470856493</c:v>
                 </c:pt>
                 <c:pt idx="18">
-                  <c:v>61.84741238703527</c:v>
+                  <c:v>31.91831470856493</c:v>
                 </c:pt>
                 <c:pt idx="19">
-                  <c:v>66.43725349020052</c:v>
+                  <c:v>36.00362742845521</c:v>
                 </c:pt>
                 <c:pt idx="20">
-                  <c:v>71.51247598948206</c:v>
+                  <c:v>41.288220055420446</c:v>
                 </c:pt>
                 <c:pt idx="21">
-                  <c:v>77.19265920860391</c:v>
+                  <c:v>48.39102861354642</c:v>
                 </c:pt>
                 <c:pt idx="22">
-                  <c:v>83.6801076687297</c:v>
+                  <c:v>58.44538212630196</c:v>
                 </c:pt>
                 <c:pt idx="23">
-                  <c:v>91.18604200636686</c:v>
+                  <c:v>73.77353803812755</c:v>
                 </c:pt>
                 <c:pt idx="24">
                   <c:v>100.0</c:v>
@@ -4942,7 +4942,7 @@
                         </a:defRPr>
                       </a:pPr>
                       <a:r>
-                        <a:t>6,0m</a:t>
+                        <a:t>3,15m</a:t>
                       </a:r>
                     </a:p>
                   </a:txBody>
@@ -5832,7 +5832,11 @@
             </a:r>
             <a:br/>
             <a:r>
-              <a:t>•  Prazo Médio: 6 meses</a:t>
+              <a:t>•  Parcelas médias: 7,0 parcelas</a:t>
+            </a:r>
+            <a:br/>
+            <a:r>
+              <a:t>•  Prazo médio econômico: 3,15 meses</a:t>
             </a:r>
             <a:br/>
             <a:r>
@@ -6209,7 +6213,7 @@
                         </a:defRPr>
                       </a:pPr>
                       <a:r>
-                        <a:t>16,67</a:t>
+                        <a:t>31,70</a:t>
                       </a:r>
                     </a:p>
                   </a:txBody>
@@ -6233,7 +6237,7 @@
                         </a:defRPr>
                       </a:pPr>
                       <a:r>
-                        <a:t>1/6 da carteira vence</a:t>
+                        <a:t>1/3,15 da carteira vence</a:t>
                       </a:r>
                     </a:p>
                   </a:txBody>
@@ -6283,7 +6287,7 @@
                         </a:defRPr>
                       </a:pPr>
                       <a:r>
-                        <a:t>-6,67</a:t>
+                        <a:t>-12,68</a:t>
                       </a:r>
                     </a:p>
                   </a:txBody>
@@ -6505,7 +6509,7 @@
                         </a:defRPr>
                       </a:pPr>
                       <a:r>
-                        <a:t>5,09</a:t>
+                        <a:t>-0,73</a:t>
                       </a:r>
                     </a:p>
                   </a:txBody>
@@ -6916,7 +6920,7 @@
                 <a:gridCol w="1554480"/>
                 <a:gridCol w="3886200"/>
               </a:tblGrid>
-              <a:tr h="402336">
+              <a:tr h="335280">
                 <a:tc>
                   <a:txBody>
                     <a:bodyPr/>
@@ -6966,7 +6970,7 @@
                   </a:tcPr>
                 </a:tc>
               </a:tr>
-              <a:tr h="402336">
+              <a:tr h="335280">
                 <a:tc>
                   <a:txBody>
                     <a:bodyPr/>
@@ -7016,7 +7020,7 @@
                   </a:tcPr>
                 </a:tc>
               </a:tr>
-              <a:tr h="402336">
+              <a:tr h="335280">
                 <a:tc>
                   <a:txBody>
                     <a:bodyPr/>
@@ -7066,7 +7070,7 @@
                   </a:tcPr>
                 </a:tc>
               </a:tr>
-              <a:tr h="402336">
+              <a:tr h="335280">
                 <a:tc>
                   <a:txBody>
                     <a:bodyPr/>
@@ -7116,7 +7120,7 @@
                   </a:tcPr>
                 </a:tc>
               </a:tr>
-              <a:tr h="402336">
+              <a:tr h="335280">
                 <a:tc>
                   <a:txBody>
                     <a:bodyPr/>
@@ -7162,6 +7166,56 @@
                   <a:tcPr anchor="ctr" marL="36576" marR="36576" marT="18288" marB="18288">
                     <a:solidFill>
                       <a:srgbClr val="F7F7F7"/>
+                    </a:solidFill>
+                  </a:tcPr>
+                </a:tc>
+              </a:tr>
+              <a:tr h="335280">
+                <a:tc>
+                  <a:txBody>
+                    <a:bodyPr/>
+                    <a:lstStyle/>
+                    <a:p>
+                      <a:pPr algn="l">
+                        <a:defRPr sz="660" b="0">
+                          <a:solidFill>
+                            <a:srgbClr val="1F1F1F"/>
+                          </a:solidFill>
+                          <a:latin typeface="Calibri"/>
+                        </a:defRPr>
+                      </a:pPr>
+                      <a:r>
+                        <a:t>Aporte SUB</a:t>
+                      </a:r>
+                    </a:p>
+                  </a:txBody>
+                  <a:tcPr anchor="ctr" marL="36576" marR="36576" marT="18288" marB="18288">
+                    <a:solidFill>
+                      <a:srgbClr val="FFFFFF"/>
+                    </a:solidFill>
+                  </a:tcPr>
+                </a:tc>
+                <a:tc>
+                  <a:txBody>
+                    <a:bodyPr/>
+                    <a:lstStyle/>
+                    <a:p>
+                      <a:pPr algn="l">
+                        <a:defRPr sz="660" b="0">
+                          <a:solidFill>
+                            <a:srgbClr val="1F1F1F"/>
+                          </a:solidFill>
+                          <a:latin typeface="Calibri"/>
+                        </a:defRPr>
+                      </a:pPr>
+                      <a:r>
+                        <a:t>max(30% x originada acumulada - SUB, 0)</a:t>
+                      </a:r>
+                    </a:p>
+                  </a:txBody>
+                  <a:tcPr anchor="ctr" marL="36576" marR="36576" marT="18288" marB="18288">
+                    <a:solidFill>
+                      <a:srgbClr val="FFFFFF"/>
                     </a:solidFill>
                   </a:tcPr>
                 </a:tc>
@@ -7189,11 +7243,12 @@
                 <a:tableStyleId>{5C22544A-7EE6-4342-B048-85BDC9FD1C3A}</a:tableStyleId>
               </a:tblPr>
               <a:tblGrid>
-                <a:gridCol w="914400"/>
-                <a:gridCol w="2331720"/>
-                <a:gridCol w="2331720"/>
-                <a:gridCol w="2331720"/>
-                <a:gridCol w="2953512"/>
+                <a:gridCol w="822960"/>
+                <a:gridCol w="2057400"/>
+                <a:gridCol w="2057400"/>
+                <a:gridCol w="1965960"/>
+                <a:gridCol w="1965960"/>
+                <a:gridCol w="1993392"/>
               </a:tblGrid>
               <a:tr h="233680">
                 <a:tc>
@@ -7306,6 +7361,30 @@
                         </a:defRPr>
                       </a:pPr>
                       <a:r>
+                        <a:t>Aporte SUB</a:t>
+                      </a:r>
+                    </a:p>
+                  </a:txBody>
+                  <a:tcPr anchor="ctr" marL="36576" marR="36576" marT="18288" marB="18288">
+                    <a:solidFill>
+                      <a:srgbClr val="1F1F1F"/>
+                    </a:solidFill>
+                  </a:tcPr>
+                </a:tc>
+                <a:tc>
+                  <a:txBody>
+                    <a:bodyPr/>
+                    <a:lstStyle/>
+                    <a:p>
+                      <a:pPr algn="l">
+                        <a:defRPr sz="750" b="1">
+                          <a:solidFill>
+                            <a:srgbClr val="FFFFFF"/>
+                          </a:solidFill>
+                          <a:latin typeface="Calibri"/>
+                        </a:defRPr>
+                      </a:pPr>
+                      <a:r>
                         <a:t>Colchão</a:t>
                       </a:r>
                     </a:p>
@@ -7356,7 +7435,7 @@
                         </a:defRPr>
                       </a:pPr>
                       <a:r>
-                        <a:t>R$ 100 mi</a:t>
+                        <a:t>R$ 190,2 mi</a:t>
                       </a:r>
                     </a:p>
                   </a:txBody>
@@ -7380,7 +7459,7 @@
                         </a:defRPr>
                       </a:pPr>
                       <a:r>
-                        <a:t>R$ 100 mi</a:t>
+                        <a:t>R$ 0,00</a:t>
                       </a:r>
                     </a:p>
                   </a:txBody>
@@ -7404,7 +7483,7 @@
                         </a:defRPr>
                       </a:pPr>
                       <a:r>
-                        <a:t>R$ 0,00</a:t>
+                        <a:t>R$ 190,2 mi</a:t>
                       </a:r>
                     </a:p>
                   </a:txBody>
@@ -7428,7 +7507,31 @@
                         </a:defRPr>
                       </a:pPr>
                       <a:r>
-                        <a:t>31,90%</a:t>
+                        <a:t>R$ 7,3 mi</a:t>
+                      </a:r>
+                    </a:p>
+                  </a:txBody>
+                  <a:tcPr anchor="ctr" marL="36576" marR="36576" marT="18288" marB="18288">
+                    <a:solidFill>
+                      <a:srgbClr val="FFFFFF"/>
+                    </a:solidFill>
+                  </a:tcPr>
+                </a:tc>
+                <a:tc>
+                  <a:txBody>
+                    <a:bodyPr/>
+                    <a:lstStyle/>
+                    <a:p>
+                      <a:pPr algn="l">
+                        <a:defRPr sz="660" b="0">
+                          <a:solidFill>
+                            <a:srgbClr val="1F1F1F"/>
+                          </a:solidFill>
+                          <a:latin typeface="Calibri"/>
+                        </a:defRPr>
+                      </a:pPr>
+                      <a:r>
+                        <a:t>30,00%</a:t>
                       </a:r>
                     </a:p>
                   </a:txBody>
@@ -7478,7 +7581,7 @@
                         </a:defRPr>
                       </a:pPr>
                       <a:r>
-                        <a:t>R$ 100 mi</a:t>
+                        <a:t>R$ 154 mi</a:t>
                       </a:r>
                     </a:p>
                   </a:txBody>
@@ -7502,7 +7605,7 @@
                         </a:defRPr>
                       </a:pPr>
                       <a:r>
-                        <a:t>R$ 100 mi</a:t>
+                        <a:t>R$ 29,4 mi</a:t>
                       </a:r>
                     </a:p>
                   </a:txBody>
@@ -7526,6 +7629,30 @@
                         </a:defRPr>
                       </a:pPr>
                       <a:r>
+                        <a:t>R$ 124,6 mi</a:t>
+                      </a:r>
+                    </a:p>
+                  </a:txBody>
+                  <a:tcPr anchor="ctr" marL="36576" marR="36576" marT="18288" marB="18288">
+                    <a:solidFill>
+                      <a:srgbClr val="F7F7F7"/>
+                    </a:solidFill>
+                  </a:tcPr>
+                </a:tc>
+                <a:tc>
+                  <a:txBody>
+                    <a:bodyPr/>
+                    <a:lstStyle/>
+                    <a:p>
+                      <a:pPr algn="l">
+                        <a:defRPr sz="660" b="0">
+                          <a:solidFill>
+                            <a:srgbClr val="1F1F1F"/>
+                          </a:solidFill>
+                          <a:latin typeface="Calibri"/>
+                        </a:defRPr>
+                      </a:pPr>
+                      <a:r>
                         <a:t>R$ 0,00</a:t>
                       </a:r>
                     </a:p>
@@ -7550,7 +7677,7 @@
                         </a:defRPr>
                       </a:pPr>
                       <a:r>
-                        <a:t>35,19%</a:t>
+                        <a:t>30,12%</a:t>
                       </a:r>
                     </a:p>
                   </a:txBody>
@@ -7600,7 +7727,7 @@
                         </a:defRPr>
                       </a:pPr>
                       <a:r>
-                        <a:t>R$ 100 mi</a:t>
+                        <a:t>R$ 130,3 mi</a:t>
                       </a:r>
                     </a:p>
                   </a:txBody>
@@ -7624,7 +7751,7 @@
                         </a:defRPr>
                       </a:pPr>
                       <a:r>
-                        <a:t>R$ 100 mi</a:t>
+                        <a:t>R$ 29,8 mi</a:t>
                       </a:r>
                     </a:p>
                   </a:txBody>
@@ -7648,6 +7775,30 @@
                         </a:defRPr>
                       </a:pPr>
                       <a:r>
+                        <a:t>R$ 100,5 mi</a:t>
+                      </a:r>
+                    </a:p>
+                  </a:txBody>
+                  <a:tcPr anchor="ctr" marL="36576" marR="36576" marT="18288" marB="18288">
+                    <a:solidFill>
+                      <a:srgbClr val="FFFFFF"/>
+                    </a:solidFill>
+                  </a:tcPr>
+                </a:tc>
+                <a:tc>
+                  <a:txBody>
+                    <a:bodyPr/>
+                    <a:lstStyle/>
+                    <a:p>
+                      <a:pPr algn="l">
+                        <a:defRPr sz="660" b="0">
+                          <a:solidFill>
+                            <a:srgbClr val="1F1F1F"/>
+                          </a:solidFill>
+                          <a:latin typeface="Calibri"/>
+                        </a:defRPr>
+                      </a:pPr>
+                      <a:r>
                         <a:t>R$ 0,00</a:t>
                       </a:r>
                     </a:p>
@@ -7672,7 +7823,7 @@
                         </a:defRPr>
                       </a:pPr>
                       <a:r>
-                        <a:t>38,03%</a:t>
+                        <a:t>30,10%</a:t>
                       </a:r>
                     </a:p>
                   </a:txBody>
@@ -7722,7 +7873,7 @@
                         </a:defRPr>
                       </a:pPr>
                       <a:r>
-                        <a:t>R$ 100 mi</a:t>
+                        <a:t>R$ 111,2 mi</a:t>
                       </a:r>
                     </a:p>
                   </a:txBody>
@@ -7746,7 +7897,7 @@
                         </a:defRPr>
                       </a:pPr>
                       <a:r>
-                        <a:t>R$ 100 mi</a:t>
+                        <a:t>R$ 13,4 mi</a:t>
                       </a:r>
                     </a:p>
                   </a:txBody>
@@ -7770,6 +7921,30 @@
                         </a:defRPr>
                       </a:pPr>
                       <a:r>
+                        <a:t>R$ 97,8 mi</a:t>
+                      </a:r>
+                    </a:p>
+                  </a:txBody>
+                  <a:tcPr anchor="ctr" marL="36576" marR="36576" marT="18288" marB="18288">
+                    <a:solidFill>
+                      <a:srgbClr val="F7F7F7"/>
+                    </a:solidFill>
+                  </a:tcPr>
+                </a:tc>
+                <a:tc>
+                  <a:txBody>
+                    <a:bodyPr/>
+                    <a:lstStyle/>
+                    <a:p>
+                      <a:pPr algn="l">
+                        <a:defRPr sz="660" b="0">
+                          <a:solidFill>
+                            <a:srgbClr val="1F1F1F"/>
+                          </a:solidFill>
+                          <a:latin typeface="Calibri"/>
+                        </a:defRPr>
+                      </a:pPr>
+                      <a:r>
                         <a:t>R$ 0,00</a:t>
                       </a:r>
                     </a:p>
@@ -7794,7 +7969,7 @@
                         </a:defRPr>
                       </a:pPr>
                       <a:r>
-                        <a:t>40,03%</a:t>
+                        <a:t>30,09%</a:t>
                       </a:r>
                     </a:p>
                   </a:txBody>
@@ -7844,7 +8019,7 @@
                         </a:defRPr>
                       </a:pPr>
                       <a:r>
-                        <a:t>R$ 93,3 mi</a:t>
+                        <a:t>R$ 68,5 mi</a:t>
                       </a:r>
                     </a:p>
                   </a:txBody>
@@ -7868,7 +8043,7 @@
                         </a:defRPr>
                       </a:pPr>
                       <a:r>
-                        <a:t>R$ 93,3 mi</a:t>
+                        <a:t>R$ 14 mi</a:t>
                       </a:r>
                     </a:p>
                   </a:txBody>
@@ -7892,6 +8067,30 @@
                         </a:defRPr>
                       </a:pPr>
                       <a:r>
+                        <a:t>R$ 54,4 mi</a:t>
+                      </a:r>
+                    </a:p>
+                  </a:txBody>
+                  <a:tcPr anchor="ctr" marL="36576" marR="36576" marT="18288" marB="18288">
+                    <a:solidFill>
+                      <a:srgbClr val="FFFFFF"/>
+                    </a:solidFill>
+                  </a:tcPr>
+                </a:tc>
+                <a:tc>
+                  <a:txBody>
+                    <a:bodyPr/>
+                    <a:lstStyle/>
+                    <a:p>
+                      <a:pPr algn="l">
+                        <a:defRPr sz="660" b="0">
+                          <a:solidFill>
+                            <a:srgbClr val="1F1F1F"/>
+                          </a:solidFill>
+                          <a:latin typeface="Calibri"/>
+                        </a:defRPr>
+                      </a:pPr>
+                      <a:r>
                         <a:t>R$ 0,00</a:t>
                       </a:r>
                     </a:p>
@@ -7916,7 +8115,7 @@
                         </a:defRPr>
                       </a:pPr>
                       <a:r>
-                        <a:t>42,09%</a:t>
+                        <a:t>30,05%</a:t>
                       </a:r>
                     </a:p>
                   </a:txBody>
@@ -7966,7 +8165,7 @@
                         </a:defRPr>
                       </a:pPr>
                       <a:r>
-                        <a:t>R$ 86,7 mi</a:t>
+                        <a:t>R$ 38,6 mi</a:t>
                       </a:r>
                     </a:p>
                   </a:txBody>
@@ -7990,7 +8189,7 @@
                         </a:defRPr>
                       </a:pPr>
                       <a:r>
-                        <a:t>R$ 86,7 mi</a:t>
+                        <a:t>R$ 7,3 mi</a:t>
                       </a:r>
                     </a:p>
                   </a:txBody>
@@ -8014,6 +8213,30 @@
                         </a:defRPr>
                       </a:pPr>
                       <a:r>
+                        <a:t>R$ 31,3 mi</a:t>
+                      </a:r>
+                    </a:p>
+                  </a:txBody>
+                  <a:tcPr anchor="ctr" marL="36576" marR="36576" marT="18288" marB="18288">
+                    <a:solidFill>
+                      <a:srgbClr val="F7F7F7"/>
+                    </a:solidFill>
+                  </a:tcPr>
+                </a:tc>
+                <a:tc>
+                  <a:txBody>
+                    <a:bodyPr/>
+                    <a:lstStyle/>
+                    <a:p>
+                      <a:pPr algn="l">
+                        <a:defRPr sz="660" b="0">
+                          <a:solidFill>
+                            <a:srgbClr val="1F1F1F"/>
+                          </a:solidFill>
+                          <a:latin typeface="Calibri"/>
+                        </a:defRPr>
+                      </a:pPr>
+                      <a:r>
                         <a:t>R$ 0,00</a:t>
                       </a:r>
                     </a:p>
@@ -8038,7 +8261,7 @@
                         </a:defRPr>
                       </a:pPr>
                       <a:r>
-                        <a:t>44,16%</a:t>
+                        <a:t>30,03%</a:t>
                       </a:r>
                     </a:p>
                   </a:txBody>
@@ -8088,7 +8311,7 @@
                         </a:defRPr>
                       </a:pPr>
                       <a:r>
-                        <a:t>R$ 80 mi</a:t>
+                        <a:t>R$ 16,1 mi</a:t>
                       </a:r>
                     </a:p>
                   </a:txBody>
@@ -8112,7 +8335,7 @@
                         </a:defRPr>
                       </a:pPr>
                       <a:r>
-                        <a:t>R$ 80 mi</a:t>
+                        <a:t>R$ 0,00</a:t>
                       </a:r>
                     </a:p>
                   </a:txBody>
@@ -8136,7 +8359,7 @@
                         </a:defRPr>
                       </a:pPr>
                       <a:r>
-                        <a:t>R$ 0,00</a:t>
+                        <a:t>R$ 16,1 mi</a:t>
                       </a:r>
                     </a:p>
                   </a:txBody>
@@ -8160,7 +8383,31 @@
                         </a:defRPr>
                       </a:pPr>
                       <a:r>
-                        <a:t>45,25%</a:t>
+                        <a:t>R$ 1,1 mi</a:t>
+                      </a:r>
+                    </a:p>
+                  </a:txBody>
+                  <a:tcPr anchor="ctr" marL="36576" marR="36576" marT="18288" marB="18288">
+                    <a:solidFill>
+                      <a:srgbClr val="FFFFFF"/>
+                    </a:solidFill>
+                  </a:tcPr>
+                </a:tc>
+                <a:tc>
+                  <a:txBody>
+                    <a:bodyPr/>
+                    <a:lstStyle/>
+                    <a:p>
+                      <a:pPr algn="l">
+                        <a:defRPr sz="660" b="0">
+                          <a:solidFill>
+                            <a:srgbClr val="1F1F1F"/>
+                          </a:solidFill>
+                          <a:latin typeface="Calibri"/>
+                        </a:defRPr>
+                      </a:pPr>
+                      <a:r>
+                        <a:t>30,00%</a:t>
                       </a:r>
                     </a:p>
                   </a:txBody>
@@ -8210,7 +8457,7 @@
                         </a:defRPr>
                       </a:pPr>
                       <a:r>
-                        <a:t>R$ 73,3 mi</a:t>
+                        <a:t>R$ 0,00</a:t>
                       </a:r>
                     </a:p>
                   </a:txBody>
@@ -8234,7 +8481,7 @@
                         </a:defRPr>
                       </a:pPr>
                       <a:r>
-                        <a:t>R$ 73,3 mi</a:t>
+                        <a:t>R$ 0,00</a:t>
                       </a:r>
                     </a:p>
                   </a:txBody>
@@ -8282,7 +8529,31 @@
                         </a:defRPr>
                       </a:pPr>
                       <a:r>
-                        <a:t>46,45%</a:t>
+                        <a:t>R$ 3 mi</a:t>
+                      </a:r>
+                    </a:p>
+                  </a:txBody>
+                  <a:tcPr anchor="ctr" marL="36576" marR="36576" marT="18288" marB="18288">
+                    <a:solidFill>
+                      <a:srgbClr val="F7F7F7"/>
+                    </a:solidFill>
+                  </a:tcPr>
+                </a:tc>
+                <a:tc>
+                  <a:txBody>
+                    <a:bodyPr/>
+                    <a:lstStyle/>
+                    <a:p>
+                      <a:pPr algn="l">
+                        <a:defRPr sz="660" b="0">
+                          <a:solidFill>
+                            <a:srgbClr val="1F1F1F"/>
+                          </a:solidFill>
+                          <a:latin typeface="Calibri"/>
+                        </a:defRPr>
+                      </a:pPr>
+                      <a:r>
+                        <a:t>30,00%</a:t>
                       </a:r>
                     </a:p>
                   </a:txBody>
@@ -8938,7 +9209,7 @@
               </a:defRPr>
             </a:pPr>
             <a:r>
-              <a:t>6,0 meses</a:t>
+              <a:t>3,15 meses</a:t>
             </a:r>
           </a:p>
           <a:p>
@@ -8954,7 +9225,7 @@
               </a:defRPr>
             </a:pPr>
             <a:r>
-              <a:t>Prazo de giro</a:t>
+              <a:t>Duration econômica</a:t>
             </a:r>
           </a:p>
         </p:txBody>
@@ -9028,7 +9299,7 @@
               </a:defRPr>
             </a:pPr>
             <a:r>
-              <a:t>R$ 4 bi</a:t>
+              <a:t>R$ 7,3 bi</a:t>
             </a:r>
           </a:p>
           <a:p>
@@ -9134,7 +9405,7 @@
               </a:defRPr>
             </a:pPr>
             <a:r>
-              <a:t>Colchão acumulado</a:t>
+              <a:t>Cenário paralelo sem perda</a:t>
             </a:r>
           </a:p>
         </p:txBody>
@@ -9192,7 +9463,7 @@
               </a:defRPr>
             </a:pPr>
             <a:r>
-              <a:t>COLCHÃO SOBRE CARTEIRA ORIGINADA</a:t>
+              <a:t>COLCHÃO S/ PERDAS SOBRE ORIGINADA</a:t>
             </a:r>
           </a:p>
           <a:p>
@@ -9208,7 +9479,7 @@
               </a:defRPr>
             </a:pPr>
             <a:r>
-              <a:t>91,40%</a:t>
+              <a:t>50,72%</a:t>
             </a:r>
           </a:p>
           <a:p>
@@ -9318,19 +9589,19 @@
             </a:r>
             <a:br/>
             <a:r>
-              <a:t>•  Carteira originada efetiva: R$ 2,2 bi.</a:t>
+              <a:t>•  Carteira originada efetiva: R$ 1,1 bi.</a:t>
             </a:r>
             <a:br/>
             <a:r>
-              <a:t>•  SUB final projetada: R$ 1,2 bi.</a:t>
+              <a:t>•  SUB final projetada: R$ 328,2 mi.</a:t>
             </a:r>
             <a:br/>
             <a:r>
-              <a:t>•  Principal bloqueado pela trava: R$ 0,00.</a:t>
+              <a:t>•  Principal bloqueado pela trava: R$ 615 mi.</a:t>
             </a:r>
             <a:br/>
             <a:r>
-              <a:t>•  Colchão final sobre originada: 55,38%.</a:t>
+              <a:t>•  Colchão final sobre originada: 30,00%.</a:t>
             </a:r>
           </a:p>
         </p:txBody>

</xml_diff>

<commit_message>
Fix MC3 FIDC cash reinvestment and native PPT charts
</commit_message>
<xml_diff>
--- a/outputs/modelo_fidc_mc3_comite_trava_30.pptx
+++ b/outputs/modelo_fidc_mc3_comite_trava_30.pptx
@@ -644,73 +644,73 @@
                   <c:v>300.0</c:v>
                 </c:pt>
                 <c:pt idx="2">
-                  <c:v>310.09438211985076</c:v>
+                  <c:v>300.0</c:v>
                 </c:pt>
                 <c:pt idx="3">
-                  <c:v>318.78460001773846</c:v>
+                  <c:v>300.0</c:v>
                 </c:pt>
                 <c:pt idx="4">
-                  <c:v>322.7727899454315</c:v>
+                  <c:v>300.0</c:v>
                 </c:pt>
                 <c:pt idx="5">
-                  <c:v>326.53771235678806</c:v>
+                  <c:v>308.31513277677607</c:v>
                 </c:pt>
                 <c:pt idx="6">
-                  <c:v>328.49673575303854</c:v>
+                  <c:v>304.19418723430715</c:v>
                 </c:pt>
                 <c:pt idx="7">
-                  <c:v>328.17666308278456</c:v>
+                  <c:v>302.9845736541306</c:v>
                 </c:pt>
                 <c:pt idx="8">
-                  <c:v>328.17666308278456</c:v>
+                  <c:v>300.0</c:v>
                 </c:pt>
                 <c:pt idx="9">
-                  <c:v>328.17666308278456</c:v>
+                  <c:v>300.0</c:v>
                 </c:pt>
                 <c:pt idx="10">
-                  <c:v>328.17666308278456</c:v>
+                  <c:v>299.99999999999994</c:v>
                 </c:pt>
                 <c:pt idx="11">
-                  <c:v>328.17666308278456</c:v>
+                  <c:v>299.99999999999994</c:v>
                 </c:pt>
                 <c:pt idx="12">
-                  <c:v>328.17666308278456</c:v>
+                  <c:v>300.0</c:v>
                 </c:pt>
                 <c:pt idx="13">
-                  <c:v>328.17666308278456</c:v>
+                  <c:v>299.99999999999994</c:v>
                 </c:pt>
                 <c:pt idx="14">
-                  <c:v>328.17666308278456</c:v>
+                  <c:v>300.0</c:v>
                 </c:pt>
                 <c:pt idx="15">
-                  <c:v>328.17666308278456</c:v>
+                  <c:v>299.99999999999994</c:v>
                 </c:pt>
                 <c:pt idx="16">
-                  <c:v>328.17666308278456</c:v>
+                  <c:v>299.99999999999994</c:v>
                 </c:pt>
                 <c:pt idx="17">
-                  <c:v>328.17666308278456</c:v>
+                  <c:v>299.99999999999994</c:v>
                 </c:pt>
                 <c:pt idx="18">
-                  <c:v>328.17666308278456</c:v>
+                  <c:v>299.99999999999994</c:v>
                 </c:pt>
                 <c:pt idx="19">
-                  <c:v>328.17666308278456</c:v>
+                  <c:v>291.2674868775933</c:v>
                 </c:pt>
                 <c:pt idx="20">
-                  <c:v>328.17666308278456</c:v>
+                  <c:v>284.1896088466156</c:v>
                 </c:pt>
                 <c:pt idx="21">
-                  <c:v>328.17666308278456</c:v>
+                  <c:v>278.53631898713996</c:v>
                 </c:pt>
                 <c:pt idx="22">
-                  <c:v>328.17666308278456</c:v>
+                  <c:v>274.47662412358306</c:v>
                 </c:pt>
                 <c:pt idx="23">
-                  <c:v>328.17666308278456</c:v>
+                  <c:v>271.45124061607135</c:v>
                 </c:pt>
                 <c:pt idx="24">
-                  <c:v>328.17666308278456</c:v>
+                  <c:v>270.1223847196461</c:v>
                 </c:pt>
               </c:numCache>
             </c:numRef>
@@ -1181,76 +1181,76 @@
                   <c:v>0.0</c:v>
                 </c:pt>
                 <c:pt idx="1">
-                  <c:v>30.0</c:v>
+                  <c:v>26.25</c:v>
                 </c:pt>
                 <c:pt idx="2">
-                  <c:v>30.12394321167599</c:v>
+                  <c:v>23.333333333333332</c:v>
                 </c:pt>
                 <c:pt idx="3">
-                  <c:v>30.097163680256944</c:v>
+                  <c:v>21.0</c:v>
                 </c:pt>
                 <c:pt idx="4">
-                  <c:v>30.09335562100375</c:v>
+                  <c:v>19.090909090909093</c:v>
                 </c:pt>
                 <c:pt idx="5">
-                  <c:v>30.051293729072576</c:v>
+                  <c:v>18.09835628887579</c:v>
                 </c:pt>
                 <c:pt idx="6">
-                  <c:v>30.029259180154433</c:v>
+                  <c:v>16.810924642854705</c:v>
                 </c:pt>
                 <c:pt idx="7">
-                  <c:v>30.0</c:v>
+                  <c:v>15.976784831282465</c:v>
                 </c:pt>
                 <c:pt idx="8">
-                  <c:v>30.0</c:v>
+                  <c:v>15.2729294369571</c:v>
                 </c:pt>
                 <c:pt idx="9">
-                  <c:v>30.0</c:v>
+                  <c:v>14.883858869606643</c:v>
                 </c:pt>
                 <c:pt idx="10">
-                  <c:v>30.0</c:v>
+                  <c:v>14.613998352850063</c:v>
                 </c:pt>
                 <c:pt idx="11">
-                  <c:v>30.0</c:v>
+                  <c:v>14.433768303308202</c:v>
                 </c:pt>
                 <c:pt idx="12">
-                  <c:v>30.0</c:v>
+                  <c:v>14.319501189480135</c:v>
                 </c:pt>
                 <c:pt idx="13">
-                  <c:v>30.0</c:v>
+                  <c:v>14.253240168918174</c:v>
                 </c:pt>
                 <c:pt idx="14">
-                  <c:v>30.0</c:v>
+                  <c:v>14.220965307922148</c:v>
                 </c:pt>
                 <c:pt idx="15">
-                  <c:v>30.0</c:v>
+                  <c:v>14.211809048686092</c:v>
                 </c:pt>
                 <c:pt idx="16">
-                  <c:v>30.0</c:v>
+                  <c:v>14.211809048686092</c:v>
                 </c:pt>
                 <c:pt idx="17">
-                  <c:v>30.0</c:v>
+                  <c:v>14.211809048686092</c:v>
                 </c:pt>
                 <c:pt idx="18">
-                  <c:v>30.0</c:v>
+                  <c:v>14.211809048686092</c:v>
                 </c:pt>
                 <c:pt idx="19">
-                  <c:v>30.0</c:v>
+                  <c:v>13.798126351983461</c:v>
                 </c:pt>
                 <c:pt idx="20">
-                  <c:v>30.0</c:v>
+                  <c:v>13.462828181829645</c:v>
                 </c:pt>
                 <c:pt idx="21">
-                  <c:v>30.0</c:v>
+                  <c:v>13.195016595230507</c:v>
                 </c:pt>
                 <c:pt idx="22">
-                  <c:v>30.0</c:v>
+                  <c:v>13.002697901241167</c:v>
                 </c:pt>
                 <c:pt idx="23">
-                  <c:v>30.0</c:v>
+                  <c:v>12.859377325548497</c:v>
                 </c:pt>
                 <c:pt idx="24">
-                  <c:v>30.0</c:v>
+                  <c:v>12.796425838037775</c:v>
                 </c:pt>
               </c:numCache>
             </c:numRef>
@@ -1391,70 +1391,70 @@
                   <c:v>30.0</c:v>
                 </c:pt>
                 <c:pt idx="2">
-                  <c:v>30.699545271112804</c:v>
+                  <c:v>30.0</c:v>
                 </c:pt>
                 <c:pt idx="3">
-                  <c:v>31.29067714727804</c:v>
+                  <c:v>30.0</c:v>
                 </c:pt>
                 <c:pt idx="4">
-                  <c:v>31.55860158957226</c:v>
+                  <c:v>30.0</c:v>
                 </c:pt>
                 <c:pt idx="5">
-                  <c:v>31.80961677551064</c:v>
+                  <c:v>30.577259306593373</c:v>
                 </c:pt>
                 <c:pt idx="6">
-                  <c:v>31.9395020259857</c:v>
+                  <c:v>30.292366865028463</c:v>
                 </c:pt>
                 <c:pt idx="7">
-                  <c:v>31.91831470856493</c:v>
+                  <c:v>30.208298473652484</c:v>
                 </c:pt>
                 <c:pt idx="8">
-                  <c:v>31.91831470856493</c:v>
+                  <c:v>30.0</c:v>
                 </c:pt>
                 <c:pt idx="9">
-                  <c:v>31.91831470856493</c:v>
+                  <c:v>30.0</c:v>
                 </c:pt>
                 <c:pt idx="10">
-                  <c:v>31.91831470856493</c:v>
+                  <c:v>29.999999999999993</c:v>
                 </c:pt>
                 <c:pt idx="11">
-                  <c:v>31.91831470856493</c:v>
+                  <c:v>29.999999999999993</c:v>
                 </c:pt>
                 <c:pt idx="12">
-                  <c:v>31.91831470856493</c:v>
+                  <c:v>30.0</c:v>
                 </c:pt>
                 <c:pt idx="13">
-                  <c:v>31.91831470856493</c:v>
+                  <c:v>29.999999999999993</c:v>
                 </c:pt>
                 <c:pt idx="14">
-                  <c:v>31.91831470856493</c:v>
+                  <c:v>30.0</c:v>
                 </c:pt>
                 <c:pt idx="15">
-                  <c:v>31.91831470856493</c:v>
+                  <c:v>29.999999999999993</c:v>
                 </c:pt>
                 <c:pt idx="16">
-                  <c:v>31.91831470856493</c:v>
+                  <c:v>29.999999999999993</c:v>
                 </c:pt>
                 <c:pt idx="17">
-                  <c:v>31.91831470856493</c:v>
+                  <c:v>29.999999999999993</c:v>
                 </c:pt>
                 <c:pt idx="18">
-                  <c:v>31.91831470856493</c:v>
+                  <c:v>29.999999999999993</c:v>
                 </c:pt>
                 <c:pt idx="19">
-                  <c:v>36.00362742845521</c:v>
+                  <c:v>33.30290575388994</c:v>
                 </c:pt>
                 <c:pt idx="20">
-                  <c:v>41.288220055420446</c:v>
+                  <c:v>37.848735918514464</c:v>
                 </c:pt>
                 <c:pt idx="21">
-                  <c:v>48.39102861354642</c:v>
+                  <c:v>44.3150714720813</c:v>
                 </c:pt>
                 <c:pt idx="22">
-                  <c:v>58.44538212630196</c:v>
+                  <c:v>54.0510519916046</c:v>
                 </c:pt>
                 <c:pt idx="23">
-                  <c:v>73.77353803812755</c:v>
+                  <c:v>69.94040612981128</c:v>
                 </c:pt>
                 <c:pt idx="24">
                   <c:v>100.0</c:v>
@@ -1464,6 +1464,30 @@
           </c:val>
           <c:smooth val="0"/>
         </c:ser>
+        <c:dLbls>
+          <c:numFmt formatCode="0\%" sourceLinked="0"/>
+          <c:txPr>
+            <a:bodyPr/>
+            <a:lstStyle/>
+            <a:p>
+              <a:pPr>
+                <a:defRPr sz="700">
+                  <a:solidFill>
+                    <a:srgbClr val="333333"/>
+                  </a:solidFill>
+                </a:defRPr>
+              </a:pPr>
+            </a:p>
+          </c:txPr>
+          <c:dLblPos val="t"/>
+          <c:showLegendKey val="0"/>
+          <c:showVal val="1"/>
+          <c:showCatName val="0"/>
+          <c:showSerName val="0"/>
+          <c:showPercent val="0"/>
+          <c:showBubbleSize val="0"/>
+          <c:showLeaderLines val="1"/>
+        </c:dLbls>
         <c:marker val="1"/>
         <c:smooth val="0"/>
         <c:axId val="2118791784"/>
@@ -1497,7 +1521,9 @@
       </c:catAx>
       <c:valAx>
         <c:axId val="2140495176"/>
-        <c:scaling/>
+        <c:scaling>
+          <c:min val="0.0"/>
+        </c:scaling>
         <c:delete val="0"/>
         <c:axPos val="l"/>
         <c:majorGridlines/>
@@ -5292,7 +5318,7 @@
                         </a:defRPr>
                       </a:pPr>
                       <a:r>
-                        <a:t>3 meses</a:t>
+                        <a:t>3.0 meses</a:t>
                       </a:r>
                     </a:p>
                   </a:txBody>
@@ -5844,7 +5870,7 @@
             </a:r>
             <a:br/>
             <a:r>
-              <a:t>•  Reinv. limitado pela trava de subordinação mínima</a:t>
+              <a:t>•  Reinv. de principal e excesso dentro da janela elegível</a:t>
             </a:r>
           </a:p>
         </p:txBody>
@@ -5916,15 +5942,15 @@
               </a:defRPr>
             </a:pPr>
             <a:r>
-              <a:t>•  Dos recebíveis que vencem, apenas 60% são efetivamente recebidos.</a:t>
+              <a:t>•  Principal vencendo: 1/7 da carteira por mês.</a:t>
             </a:r>
             <a:br/>
             <a:r>
-              <a:t>•  O principal recebido só compra novos DCs se a trava de 30% seguir atendida.</a:t>
+              <a:t>•  PDD: 40% da carteira provisionado linearmente até Over90.</a:t>
             </a:r>
             <a:br/>
             <a:r>
-              <a:t>•  Caixa bloqueado ou fora da janela de reinvestimento passa a render SELIC.</a:t>
+              <a:t>•  Excesso de caixa positivo é reinvestido em nova carteira.</a:t>
             </a:r>
           </a:p>
         </p:txBody>
@@ -6213,7 +6239,7 @@
                         </a:defRPr>
                       </a:pPr>
                       <a:r>
-                        <a:t>31,70</a:t>
+                        <a:t>14,29</a:t>
                       </a:r>
                     </a:p>
                   </a:txBody>
@@ -6237,7 +6263,7 @@
                         </a:defRPr>
                       </a:pPr>
                       <a:r>
-                        <a:t>1/3,15 da carteira vence</a:t>
+                        <a:t>1/7 da carteira vence</a:t>
                       </a:r>
                     </a:p>
                   </a:txBody>
@@ -6263,7 +6289,7 @@
                         </a:defRPr>
                       </a:pPr>
                       <a:r>
-                        <a:t>NPL provisionado</a:t>
+                        <a:t>PDD</a:t>
                       </a:r>
                     </a:p>
                   </a:txBody>
@@ -6287,7 +6313,7 @@
                         </a:defRPr>
                       </a:pPr>
                       <a:r>
-                        <a:t>-12,68</a:t>
+                        <a:t>-13,33</a:t>
                       </a:r>
                     </a:p>
                   </a:txBody>
@@ -6311,7 +6337,7 @@
                         </a:defRPr>
                       </a:pPr>
                       <a:r>
-                        <a:t>40% do principal vencido</a:t>
+                        <a:t>40% da carteira / 3 meses</a:t>
                       </a:r>
                     </a:p>
                   </a:txBody>
@@ -6435,7 +6461,7 @@
                         </a:defRPr>
                       </a:pPr>
                       <a:r>
-                        <a:t>-0,80</a:t>
+                        <a:t>-0,74</a:t>
                       </a:r>
                     </a:p>
                   </a:txBody>
@@ -6509,7 +6535,7 @@
                         </a:defRPr>
                       </a:pPr>
                       <a:r>
-                        <a:t>-0,73</a:t>
+                        <a:t>12,77</a:t>
                       </a:r>
                     </a:p>
                   </a:txBody>
@@ -6533,7 +6559,7 @@
                         </a:defRPr>
                       </a:pPr>
                       <a:r>
-                        <a:t>—</a:t>
+                        <a:t>Reinveste em carteira nova</a:t>
                       </a:r>
                     </a:p>
                   </a:txBody>
@@ -6809,7 +6835,7 @@
               </a:defRPr>
             </a:pPr>
             <a:r>
-              <a:t>Modelagem FIDC | Trava de Subordinação e Reinvestimento</a:t>
+              <a:t>Modelagem FIDC | Subordinação e Reinvestimento</a:t>
             </a:r>
           </a:p>
         </p:txBody>
@@ -6881,19 +6907,19 @@
               </a:defRPr>
             </a:pPr>
             <a:r>
-              <a:t>•  Trava mínima: SUB disponível / carteira originada acumulada &gt;= 30,00%.</a:t>
+              <a:t>•  Principal recebido e excesso de caixa podem ser reinvestidos integralmente.</a:t>
             </a:r>
             <a:br/>
             <a:r>
-              <a:t>•  A capacidade de compra é calculada antes de cada nova originação.</a:t>
+              <a:t>•  Subordinação mínima estrutural: SUB disponível / PL FIDC &gt;= 30,00%.</a:t>
             </a:r>
             <a:br/>
             <a:r>
-              <a:t>•  Só o excedente que preserva a trava é reinvestido em novos recebíveis.</a:t>
+              <a:t>•  Se perdas/custos consumirem SUB abaixo do piso, o modelo registra aporte necessário.</a:t>
             </a:r>
             <a:br/>
             <a:r>
-              <a:t>•  O principal bloqueado permanece no fundo como caixa aplicado à SELIC.</a:t>
+              <a:t>•  SUB / carteira originada acumulada fica como métrica de colchão econômico.</a:t>
             </a:r>
           </a:p>
         </p:txBody>
@@ -7009,7 +7035,7 @@
                         </a:defRPr>
                       </a:pPr>
                       <a:r>
-                        <a:t>30% x carteira originada acumulada</a:t>
+                        <a:t>SUB / PL FIDC &gt;= 30%</a:t>
                       </a:r>
                     </a:p>
                   </a:txBody>
@@ -7035,7 +7061,7 @@
                         </a:defRPr>
                       </a:pPr>
                       <a:r>
-                        <a:t>Capacidade</a:t>
+                        <a:t>Caixa reinvestível</a:t>
                       </a:r>
                     </a:p>
                   </a:txBody>
@@ -7059,7 +7085,7 @@
                         </a:defRPr>
                       </a:pPr>
                       <a:r>
-                        <a:t>max(SUB preliminar / 30% - originada anterior, 0)</a:t>
+                        <a:t>principal recebido + max(excesso de caixa, 0)</a:t>
                       </a:r>
                     </a:p>
                   </a:txBody>
@@ -7109,7 +7135,7 @@
                         </a:defRPr>
                       </a:pPr>
                       <a:r>
-                        <a:t>min(principal recebido líquido, capacidade)</a:t>
+                        <a:t>se elegível: caixa reinvestível; se não: 0</a:t>
                       </a:r>
                     </a:p>
                   </a:txBody>
@@ -7135,7 +7161,7 @@
                         </a:defRPr>
                       </a:pPr>
                       <a:r>
-                        <a:t>Bloqueio</a:t>
+                        <a:t>Subordinação</a:t>
                       </a:r>
                     </a:p>
                   </a:txBody>
@@ -7159,7 +7185,7 @@
                         </a:defRPr>
                       </a:pPr>
                       <a:r>
-                        <a:t>principal recebido líquido - nova originação</a:t>
+                        <a:t>SUB disponível / PL FIDC</a:t>
                       </a:r>
                     </a:p>
                   </a:txBody>
@@ -7209,7 +7235,7 @@
                         </a:defRPr>
                       </a:pPr>
                       <a:r>
-                        <a:t>max(30% x originada acumulada - SUB, 0)</a:t>
+                        <a:t>max((30% x PL - SUB) / 70%, 0)</a:t>
                       </a:r>
                     </a:p>
                   </a:txBody>
@@ -7313,6 +7339,30 @@
                         </a:defRPr>
                       </a:pPr>
                       <a:r>
+                        <a:t>Excesso reinv.</a:t>
+                      </a:r>
+                    </a:p>
+                  </a:txBody>
+                  <a:tcPr anchor="ctr" marL="36576" marR="36576" marT="18288" marB="18288">
+                    <a:solidFill>
+                      <a:srgbClr val="1F1F1F"/>
+                    </a:solidFill>
+                  </a:tcPr>
+                </a:tc>
+                <a:tc>
+                  <a:txBody>
+                    <a:bodyPr/>
+                    <a:lstStyle/>
+                    <a:p>
+                      <a:pPr algn="l">
+                        <a:defRPr sz="750" b="1">
+                          <a:solidFill>
+                            <a:srgbClr val="FFFFFF"/>
+                          </a:solidFill>
+                          <a:latin typeface="Calibri"/>
+                        </a:defRPr>
+                      </a:pPr>
+                      <a:r>
                         <a:t>Nova originação</a:t>
                       </a:r>
                     </a:p>
@@ -7337,7 +7387,7 @@
                         </a:defRPr>
                       </a:pPr>
                       <a:r>
-                        <a:t>Bloqueado</a:t>
+                        <a:t>Aporte SUB</a:t>
                       </a:r>
                     </a:p>
                   </a:txBody>
@@ -7361,31 +7411,7 @@
                         </a:defRPr>
                       </a:pPr>
                       <a:r>
-                        <a:t>Aporte SUB</a:t>
-                      </a:r>
-                    </a:p>
-                  </a:txBody>
-                  <a:tcPr anchor="ctr" marL="36576" marR="36576" marT="18288" marB="18288">
-                    <a:solidFill>
-                      <a:srgbClr val="1F1F1F"/>
-                    </a:solidFill>
-                  </a:tcPr>
-                </a:tc>
-                <a:tc>
-                  <a:txBody>
-                    <a:bodyPr/>
-                    <a:lstStyle/>
-                    <a:p>
-                      <a:pPr algn="l">
-                        <a:defRPr sz="750" b="1">
-                          <a:solidFill>
-                            <a:srgbClr val="FFFFFF"/>
-                          </a:solidFill>
-                          <a:latin typeface="Calibri"/>
-                        </a:defRPr>
-                      </a:pPr>
-                      <a:r>
-                        <a:t>Colchão</a:t>
+                        <a:t>Sub/PL</a:t>
                       </a:r>
                     </a:p>
                   </a:txBody>
@@ -7435,7 +7461,7 @@
                         </a:defRPr>
                       </a:pPr>
                       <a:r>
-                        <a:t>R$ 190,2 mi</a:t>
+                        <a:t>R$ 142,9 mi</a:t>
                       </a:r>
                     </a:p>
                   </a:txBody>
@@ -7483,7 +7509,7 @@
                         </a:defRPr>
                       </a:pPr>
                       <a:r>
-                        <a:t>R$ 190,2 mi</a:t>
+                        <a:t>R$ 142,9 mi</a:t>
                       </a:r>
                     </a:p>
                   </a:txBody>
@@ -7507,7 +7533,7 @@
                         </a:defRPr>
                       </a:pPr>
                       <a:r>
-                        <a:t>R$ 7,3 mi</a:t>
+                        <a:t>R$ 15,2 mi</a:t>
                       </a:r>
                     </a:p>
                   </a:txBody>
@@ -7581,7 +7607,7 @@
                         </a:defRPr>
                       </a:pPr>
                       <a:r>
-                        <a:t>R$ 154 mi</a:t>
+                        <a:t>R$ 142,9 mi</a:t>
                       </a:r>
                     </a:p>
                   </a:txBody>
@@ -7605,7 +7631,7 @@
                         </a:defRPr>
                       </a:pPr>
                       <a:r>
-                        <a:t>R$ 29,4 mi</a:t>
+                        <a:t>R$ 0,00</a:t>
                       </a:r>
                     </a:p>
                   </a:txBody>
@@ -7629,7 +7655,7 @@
                         </a:defRPr>
                       </a:pPr>
                       <a:r>
-                        <a:t>R$ 124,6 mi</a:t>
+                        <a:t>R$ 142,9 mi</a:t>
                       </a:r>
                     </a:p>
                   </a:txBody>
@@ -7653,7 +7679,7 @@
                         </a:defRPr>
                       </a:pPr>
                       <a:r>
-                        <a:t>R$ 0,00</a:t>
+                        <a:t>R$ 15,3 mi</a:t>
                       </a:r>
                     </a:p>
                   </a:txBody>
@@ -7677,7 +7703,7 @@
                         </a:defRPr>
                       </a:pPr>
                       <a:r>
-                        <a:t>30,12%</a:t>
+                        <a:t>30,00%</a:t>
                       </a:r>
                     </a:p>
                   </a:txBody>
@@ -7727,7 +7753,7 @@
                         </a:defRPr>
                       </a:pPr>
                       <a:r>
-                        <a:t>R$ 130,3 mi</a:t>
+                        <a:t>R$ 142,9 mi</a:t>
                       </a:r>
                     </a:p>
                   </a:txBody>
@@ -7751,7 +7777,7 @@
                         </a:defRPr>
                       </a:pPr>
                       <a:r>
-                        <a:t>R$ 29,8 mi</a:t>
+                        <a:t>R$ 0,00</a:t>
                       </a:r>
                     </a:p>
                   </a:txBody>
@@ -7775,7 +7801,7 @@
                         </a:defRPr>
                       </a:pPr>
                       <a:r>
-                        <a:t>R$ 100,5 mi</a:t>
+                        <a:t>R$ 142,9 mi</a:t>
                       </a:r>
                     </a:p>
                   </a:txBody>
@@ -7799,7 +7825,7 @@
                         </a:defRPr>
                       </a:pPr>
                       <a:r>
-                        <a:t>R$ 0,00</a:t>
+                        <a:t>R$ 2,2 mi</a:t>
                       </a:r>
                     </a:p>
                   </a:txBody>
@@ -7823,7 +7849,7 @@
                         </a:defRPr>
                       </a:pPr>
                       <a:r>
-                        <a:t>30,10%</a:t>
+                        <a:t>30,00%</a:t>
                       </a:r>
                     </a:p>
                   </a:txBody>
@@ -7873,7 +7899,7 @@
                         </a:defRPr>
                       </a:pPr>
                       <a:r>
-                        <a:t>R$ 111,2 mi</a:t>
+                        <a:t>R$ 142,9 mi</a:t>
                       </a:r>
                     </a:p>
                   </a:txBody>
@@ -7897,7 +7923,7 @@
                         </a:defRPr>
                       </a:pPr>
                       <a:r>
-                        <a:t>R$ 13,4 mi</a:t>
+                        <a:t>R$ 0,00</a:t>
                       </a:r>
                     </a:p>
                   </a:txBody>
@@ -7921,7 +7947,7 @@
                         </a:defRPr>
                       </a:pPr>
                       <a:r>
-                        <a:t>R$ 97,8 mi</a:t>
+                        <a:t>R$ 142,9 mi</a:t>
                       </a:r>
                     </a:p>
                   </a:txBody>
@@ -7945,7 +7971,7 @@
                         </a:defRPr>
                       </a:pPr>
                       <a:r>
-                        <a:t>R$ 0,00</a:t>
+                        <a:t>R$ 2,3 mi</a:t>
                       </a:r>
                     </a:p>
                   </a:txBody>
@@ -7969,7 +7995,7 @@
                         </a:defRPr>
                       </a:pPr>
                       <a:r>
-                        <a:t>30,09%</a:t>
+                        <a:t>30,00%</a:t>
                       </a:r>
                     </a:p>
                   </a:txBody>
@@ -8019,7 +8045,7 @@
                         </a:defRPr>
                       </a:pPr>
                       <a:r>
-                        <a:t>R$ 68,5 mi</a:t>
+                        <a:t>R$ 123,8 mi</a:t>
                       </a:r>
                     </a:p>
                   </a:txBody>
@@ -8043,7 +8069,7 @@
                         </a:defRPr>
                       </a:pPr>
                       <a:r>
-                        <a:t>R$ 14 mi</a:t>
+                        <a:t>R$ 8,3 mi</a:t>
                       </a:r>
                     </a:p>
                   </a:txBody>
@@ -8067,7 +8093,7 @@
                         </a:defRPr>
                       </a:pPr>
                       <a:r>
-                        <a:t>R$ 54,4 mi</a:t>
+                        <a:t>R$ 132,1 mi</a:t>
                       </a:r>
                     </a:p>
                   </a:txBody>
@@ -8115,7 +8141,7 @@
                         </a:defRPr>
                       </a:pPr>
                       <a:r>
-                        <a:t>30,05%</a:t>
+                        <a:t>30,58%</a:t>
                       </a:r>
                     </a:p>
                   </a:txBody>
@@ -8165,7 +8191,7 @@
                         </a:defRPr>
                       </a:pPr>
                       <a:r>
-                        <a:t>R$ 38,6 mi</a:t>
+                        <a:t>R$ 105,9 mi</a:t>
                       </a:r>
                     </a:p>
                   </a:txBody>
@@ -8189,7 +8215,7 @@
                         </a:defRPr>
                       </a:pPr>
                       <a:r>
-                        <a:t>R$ 7,3 mi</a:t>
+                        <a:t>R$ 0,00</a:t>
                       </a:r>
                     </a:p>
                   </a:txBody>
@@ -8213,7 +8239,7 @@
                         </a:defRPr>
                       </a:pPr>
                       <a:r>
-                        <a:t>R$ 31,3 mi</a:t>
+                        <a:t>R$ 105,9 mi</a:t>
                       </a:r>
                     </a:p>
                   </a:txBody>
@@ -8261,7 +8287,7 @@
                         </a:defRPr>
                       </a:pPr>
                       <a:r>
-                        <a:t>30,03%</a:t>
+                        <a:t>30,29%</a:t>
                       </a:r>
                     </a:p>
                   </a:txBody>
@@ -8311,7 +8337,7 @@
                         </a:defRPr>
                       </a:pPr>
                       <a:r>
-                        <a:t>R$ 16,1 mi</a:t>
+                        <a:t>R$ 86,9 mi</a:t>
                       </a:r>
                     </a:p>
                   </a:txBody>
@@ -8359,7 +8385,7 @@
                         </a:defRPr>
                       </a:pPr>
                       <a:r>
-                        <a:t>R$ 16,1 mi</a:t>
+                        <a:t>R$ 86,9 mi</a:t>
                       </a:r>
                     </a:p>
                   </a:txBody>
@@ -8383,7 +8409,7 @@
                         </a:defRPr>
                       </a:pPr>
                       <a:r>
-                        <a:t>R$ 1,1 mi</a:t>
+                        <a:t>R$ 0,00</a:t>
                       </a:r>
                     </a:p>
                   </a:txBody>
@@ -8407,7 +8433,7 @@
                         </a:defRPr>
                       </a:pPr>
                       <a:r>
-                        <a:t>30,00%</a:t>
+                        <a:t>30,21%</a:t>
                       </a:r>
                     </a:p>
                   </a:txBody>
@@ -8457,6 +8483,30 @@
                         </a:defRPr>
                       </a:pPr>
                       <a:r>
+                        <a:t>R$ 67,9 mi</a:t>
+                      </a:r>
+                    </a:p>
+                  </a:txBody>
+                  <a:tcPr anchor="ctr" marL="36576" marR="36576" marT="18288" marB="18288">
+                    <a:solidFill>
+                      <a:srgbClr val="F7F7F7"/>
+                    </a:solidFill>
+                  </a:tcPr>
+                </a:tc>
+                <a:tc>
+                  <a:txBody>
+                    <a:bodyPr/>
+                    <a:lstStyle/>
+                    <a:p>
+                      <a:pPr algn="l">
+                        <a:defRPr sz="660" b="0">
+                          <a:solidFill>
+                            <a:srgbClr val="1F1F1F"/>
+                          </a:solidFill>
+                          <a:latin typeface="Calibri"/>
+                        </a:defRPr>
+                      </a:pPr>
+                      <a:r>
                         <a:t>R$ 0,00</a:t>
                       </a:r>
                     </a:p>
@@ -8481,7 +8531,7 @@
                         </a:defRPr>
                       </a:pPr>
                       <a:r>
-                        <a:t>R$ 0,00</a:t>
+                        <a:t>R$ 67,9 mi</a:t>
                       </a:r>
                     </a:p>
                   </a:txBody>
@@ -8505,31 +8555,7 @@
                         </a:defRPr>
                       </a:pPr>
                       <a:r>
-                        <a:t>R$ 0,00</a:t>
-                      </a:r>
-                    </a:p>
-                  </a:txBody>
-                  <a:tcPr anchor="ctr" marL="36576" marR="36576" marT="18288" marB="18288">
-                    <a:solidFill>
-                      <a:srgbClr val="F7F7F7"/>
-                    </a:solidFill>
-                  </a:tcPr>
-                </a:tc>
-                <a:tc>
-                  <a:txBody>
-                    <a:bodyPr/>
-                    <a:lstStyle/>
-                    <a:p>
-                      <a:pPr algn="l">
-                        <a:defRPr sz="660" b="0">
-                          <a:solidFill>
-                            <a:srgbClr val="1F1F1F"/>
-                          </a:solidFill>
-                          <a:latin typeface="Calibri"/>
-                        </a:defRPr>
-                      </a:pPr>
-                      <a:r>
-                        <a:t>R$ 3 mi</a:t>
+                        <a:t>R$ 62.917,94</a:t>
                       </a:r>
                     </a:p>
                   </a:txBody>
@@ -8599,7 +8625,7 @@
               </a:defRPr>
             </a:pPr>
             <a:r>
-              <a:t>Leitura: quando a SUB ainda está exatamente no nível mínimo, a carteira não recompra todo o principal; primeiro acumula excesso econômico para abrir capacidade.</a:t>
+              <a:t>Leitura: reinvestimento troca caixa por carteira e não consome PL; a trava de 30% é testada no PL econômico da estrutura.</a:t>
             </a:r>
           </a:p>
         </p:txBody>
@@ -9029,7 +9055,7 @@
               </a:defRPr>
             </a:pPr>
             <a:r>
-              <a:t>1,62 anos</a:t>
+              <a:t>1,56 anos</a:t>
             </a:r>
           </a:p>
           <a:p>
@@ -9299,7 +9325,7 @@
               </a:defRPr>
             </a:pPr>
             <a:r>
-              <a:t>R$ 7,3 bi</a:t>
+              <a:t>R$ 24,2 bi</a:t>
             </a:r>
           </a:p>
           <a:p>
@@ -9389,7 +9415,7 @@
               </a:defRPr>
             </a:pPr>
             <a:r>
-              <a:t>R$ 3,7 bi</a:t>
+              <a:t>R$ 17,1 bi</a:t>
             </a:r>
           </a:p>
           <a:p>
@@ -9479,7 +9505,7 @@
               </a:defRPr>
             </a:pPr>
             <a:r>
-              <a:t>50,72%</a:t>
+              <a:t>70,49%</a:t>
             </a:r>
           </a:p>
           <a:p>
@@ -9585,23 +9611,19 @@
               </a:defRPr>
             </a:pPr>
             <a:r>
-              <a:t>•  Trava: SUB / carteira originada &gt;= 30,00%.</a:t>
+              <a:t>•  PDD: 40% da carteira provisionado em 3 meses até Over90.</a:t>
             </a:r>
             <a:br/>
             <a:r>
-              <a:t>•  Carteira originada efetiva: R$ 1,1 bi.</a:t>
+              <a:t>•  Nova originação inclui principal recebido e excesso de caixa positivo.</a:t>
             </a:r>
             <a:br/>
             <a:r>
-              <a:t>•  SUB final projetada: R$ 328,2 mi.</a:t>
+              <a:t>•  Carteira originada efetiva: R$ 2,1 bi.</a:t>
             </a:r>
             <a:br/>
             <a:r>
-              <a:t>•  Principal bloqueado pela trava: R$ 615 mi.</a:t>
-            </a:r>
-            <a:br/>
-            <a:r>
-              <a:t>•  Colchão final sobre originada: 30,00%.</a:t>
+              <a:t>•  SUB / PL final: 100,00%; colchão sobre originada: 12,80%.</a:t>
             </a:r>
           </a:p>
         </p:txBody>

</xml_diff>

<commit_message>
Fix native PPT chart axis IDs
</commit_message>
<xml_diff>
--- a/outputs/modelo_fidc_mc3_comite_trava_30.pptx
+++ b/outputs/modelo_fidc_mc3_comite_trava_30.pptx
@@ -916,11 +916,11 @@
           <c:showPercent val="0"/>
           <c:showBubbleSize val="0"/>
         </c:dLbls>
-        <c:axId val="2193807368"/>
-        <c:axId val="2194249048"/>
+        <c:axId val="1000001"/>
+        <c:axId val="1000002"/>
       </c:areaChart>
       <c:catAx>
-        <c:axId val="2193807368"/>
+        <c:axId val="1000001"/>
         <c:scaling>
           <c:orientation val="minMax"/>
         </c:scaling>
@@ -939,7 +939,7 @@
             </a:pPr>
           </a:p>
         </c:txPr>
-        <c:crossAx val="2194249048"/>
+        <c:crossAx val="1000002"/>
         <c:crosses val="autoZero"/>
         <c:auto val="1"/>
         <c:lblAlgn val="ctr"/>
@@ -947,7 +947,7 @@
         <c:noMultiLvlLbl val="0"/>
       </c:catAx>
       <c:valAx>
-        <c:axId val="2194249048"/>
+        <c:axId val="1000002"/>
         <c:scaling>
           <c:orientation val="minMax"/>
         </c:scaling>
@@ -982,7 +982,7 @@
             </a:pPr>
           </a:p>
         </c:txPr>
-        <c:crossAx val="2193807368"/>
+        <c:crossAx val="1000001"/>
         <c:crosses val="autoZero"/>
         <c:crossBetween val="midCat"/>
       </c:valAx>
@@ -1490,11 +1490,11 @@
         </c:dLbls>
         <c:marker val="1"/>
         <c:smooth val="0"/>
-        <c:axId val="2118791784"/>
-        <c:axId val="2140495176"/>
+        <c:axId val="1000001"/>
+        <c:axId val="1000002"/>
       </c:lineChart>
       <c:catAx>
-        <c:axId val="2118791784"/>
+        <c:axId val="1000001"/>
         <c:scaling>
           <c:orientation val="minMax"/>
         </c:scaling>
@@ -1512,7 +1512,7 @@
             </a:pPr>
           </a:p>
         </c:txPr>
-        <c:crossAx val="2140495176"/>
+        <c:crossAx val="1000002"/>
         <c:crosses val="autoZero"/>
         <c:auto val="1"/>
         <c:lblAlgn val="ctr"/>
@@ -1520,7 +1520,7 @@
         <c:noMultiLvlLbl val="0"/>
       </c:catAx>
       <c:valAx>
-        <c:axId val="2140495176"/>
+        <c:axId val="1000002"/>
         <c:scaling>
           <c:min val="0.0"/>
         </c:scaling>
@@ -1555,7 +1555,7 @@
             </a:pPr>
           </a:p>
         </c:txPr>
-        <c:crossAx val="2118791784"/>
+        <c:crossAx val="1000001"/>
         <c:crosses val="autoZero"/>
       </c:valAx>
     </c:plotArea>

</xml_diff>

<commit_message>
Limit originated denominator to excess cash
</commit_message>
<xml_diff>
--- a/outputs/modelo_fidc_mc3_comite_trava_30.pptx
+++ b/outputs/modelo_fidc_mc3_comite_trava_30.pptx
@@ -641,7 +641,7 @@
                   <c:v>300.0</c:v>
                 </c:pt>
                 <c:pt idx="1">
-                  <c:v>300.0</c:v>
+                  <c:v>299.99999999999994</c:v>
                 </c:pt>
                 <c:pt idx="2">
                   <c:v>300.0</c:v>
@@ -650,16 +650,16 @@
                   <c:v>300.0</c:v>
                 </c:pt>
                 <c:pt idx="4">
-                  <c:v>300.0</c:v>
+                  <c:v>304.50917027707686</c:v>
                 </c:pt>
                 <c:pt idx="5">
-                  <c:v>308.31513277677607</c:v>
+                  <c:v>307.1566830895734</c:v>
                 </c:pt>
                 <c:pt idx="6">
-                  <c:v>304.19418723430715</c:v>
+                  <c:v>303.09409257726134</c:v>
                 </c:pt>
                 <c:pt idx="7">
-                  <c:v>302.9845736541306</c:v>
+                  <c:v>305.8688077874529</c:v>
                 </c:pt>
                 <c:pt idx="8">
                   <c:v>300.0</c:v>
@@ -671,7 +671,7 @@
                   <c:v>299.99999999999994</c:v>
                 </c:pt>
                 <c:pt idx="11">
-                  <c:v>299.99999999999994</c:v>
+                  <c:v>300.0</c:v>
                 </c:pt>
                 <c:pt idx="12">
                   <c:v>300.0</c:v>
@@ -680,37 +680,37 @@
                   <c:v>299.99999999999994</c:v>
                 </c:pt>
                 <c:pt idx="14">
+                  <c:v>299.99999999999994</c:v>
+                </c:pt>
+                <c:pt idx="15">
                   <c:v>300.0</c:v>
                 </c:pt>
-                <c:pt idx="15">
-                  <c:v>299.99999999999994</c:v>
-                </c:pt>
                 <c:pt idx="16">
-                  <c:v>299.99999999999994</c:v>
+                  <c:v>300.0</c:v>
                 </c:pt>
                 <c:pt idx="17">
-                  <c:v>299.99999999999994</c:v>
+                  <c:v>300.0</c:v>
                 </c:pt>
                 <c:pt idx="18">
                   <c:v>299.99999999999994</c:v>
                 </c:pt>
                 <c:pt idx="19">
-                  <c:v>291.2674868775933</c:v>
+                  <c:v>290.87567775378324</c:v>
                 </c:pt>
                 <c:pt idx="20">
-                  <c:v>284.1896088466156</c:v>
+                  <c:v>284.1394576824742</c:v>
                 </c:pt>
                 <c:pt idx="21">
-                  <c:v>278.53631898713996</c:v>
+                  <c:v>278.21280296135416</c:v>
                 </c:pt>
                 <c:pt idx="22">
-                  <c:v>274.47662412358306</c:v>
+                  <c:v>273.9432659845634</c:v>
                 </c:pt>
                 <c:pt idx="23">
-                  <c:v>271.45124061607135</c:v>
+                  <c:v>271.1937944167908</c:v>
                 </c:pt>
                 <c:pt idx="24">
-                  <c:v>270.1223847196461</c:v>
+                  <c:v>269.6585514706476</c:v>
                 </c:pt>
               </c:numCache>
             </c:numRef>
@@ -1181,76 +1181,76 @@
                   <c:v>0.0</c:v>
                 </c:pt>
                 <c:pt idx="1">
-                  <c:v>26.25</c:v>
+                  <c:v>29.999999999999993</c:v>
                 </c:pt>
                 <c:pt idx="2">
-                  <c:v>23.333333333333332</c:v>
+                  <c:v>30.0</c:v>
                 </c:pt>
                 <c:pt idx="3">
-                  <c:v>21.0</c:v>
+                  <c:v>30.0</c:v>
                 </c:pt>
                 <c:pt idx="4">
-                  <c:v>19.090909090909093</c:v>
+                  <c:v>30.3142250252512</c:v>
                 </c:pt>
                 <c:pt idx="5">
-                  <c:v>18.09835628887579</c:v>
+                  <c:v>30.49740802467135</c:v>
                 </c:pt>
                 <c:pt idx="6">
-                  <c:v>16.810924642854705</c:v>
+                  <c:v>30.094035780756972</c:v>
                 </c:pt>
                 <c:pt idx="7">
-                  <c:v>15.976784831282465</c:v>
+                  <c:v>30.286097481708936</c:v>
                 </c:pt>
                 <c:pt idx="8">
-                  <c:v>15.2729294369571</c:v>
+                  <c:v>29.704987933344245</c:v>
                 </c:pt>
                 <c:pt idx="9">
-                  <c:v>14.883858869606643</c:v>
+                  <c:v>29.704987933344245</c:v>
                 </c:pt>
                 <c:pt idx="10">
-                  <c:v>14.613998352850063</c:v>
+                  <c:v>29.704987933344242</c:v>
                 </c:pt>
                 <c:pt idx="11">
-                  <c:v>14.433768303308202</c:v>
+                  <c:v>29.704987933344245</c:v>
                 </c:pt>
                 <c:pt idx="12">
-                  <c:v>14.319501189480135</c:v>
+                  <c:v>29.704987933344245</c:v>
                 </c:pt>
                 <c:pt idx="13">
-                  <c:v>14.253240168918174</c:v>
+                  <c:v>29.704987933344242</c:v>
                 </c:pt>
                 <c:pt idx="14">
-                  <c:v>14.220965307922148</c:v>
+                  <c:v>29.704987933344242</c:v>
                 </c:pt>
                 <c:pt idx="15">
-                  <c:v>14.211809048686092</c:v>
+                  <c:v>29.704987933344245</c:v>
                 </c:pt>
                 <c:pt idx="16">
-                  <c:v>14.211809048686092</c:v>
+                  <c:v>29.704987933344245</c:v>
                 </c:pt>
                 <c:pt idx="17">
-                  <c:v>14.211809048686092</c:v>
+                  <c:v>29.704987933344245</c:v>
                 </c:pt>
                 <c:pt idx="18">
-                  <c:v>14.211809048686092</c:v>
+                  <c:v>29.704987933344242</c:v>
                 </c:pt>
                 <c:pt idx="19">
-                  <c:v>13.798126351983461</c:v>
+                  <c:v>28.801528325931532</c:v>
                 </c:pt>
                 <c:pt idx="20">
-                  <c:v>13.462828181829645</c:v>
+                  <c:v>28.13453053948291</c:v>
                 </c:pt>
                 <c:pt idx="21">
-                  <c:v>13.195016595230507</c:v>
+                  <c:v>27.54769318289635</c:v>
                 </c:pt>
                 <c:pt idx="22">
-                  <c:v>13.002697901241167</c:v>
+                  <c:v>27.124938034974566</c:v>
                 </c:pt>
                 <c:pt idx="23">
-                  <c:v>12.859377325548497</c:v>
+                  <c:v>26.8526946358287</c:v>
                 </c:pt>
                 <c:pt idx="24">
-                  <c:v>12.796425838037775</c:v>
+                  <c:v>26.700680058528913</c:v>
                 </c:pt>
               </c:numCache>
             </c:numRef>
@@ -1388,7 +1388,7 @@
                   <c:v>30.0</c:v>
                 </c:pt>
                 <c:pt idx="1">
-                  <c:v>30.0</c:v>
+                  <c:v>29.999999999999993</c:v>
                 </c:pt>
                 <c:pt idx="2">
                   <c:v>30.0</c:v>
@@ -1397,16 +1397,16 @@
                   <c:v>30.0</c:v>
                 </c:pt>
                 <c:pt idx="4">
-                  <c:v>30.0</c:v>
+                  <c:v>30.3142250252512</c:v>
                 </c:pt>
                 <c:pt idx="5">
-                  <c:v>30.577259306593373</c:v>
+                  <c:v>30.49740802467135</c:v>
                 </c:pt>
                 <c:pt idx="6">
-                  <c:v>30.292366865028463</c:v>
+                  <c:v>30.21591840886214</c:v>
                 </c:pt>
                 <c:pt idx="7">
-                  <c:v>30.208298473652484</c:v>
+                  <c:v>30.408419608940207</c:v>
                 </c:pt>
                 <c:pt idx="8">
                   <c:v>30.0</c:v>
@@ -1418,7 +1418,7 @@
                   <c:v>29.999999999999993</c:v>
                 </c:pt>
                 <c:pt idx="11">
-                  <c:v>29.999999999999993</c:v>
+                  <c:v>30.0</c:v>
                 </c:pt>
                 <c:pt idx="12">
                   <c:v>30.0</c:v>
@@ -1427,34 +1427,34 @@
                   <c:v>29.999999999999993</c:v>
                 </c:pt>
                 <c:pt idx="14">
+                  <c:v>29.999999999999993</c:v>
+                </c:pt>
+                <c:pt idx="15">
                   <c:v>30.0</c:v>
                 </c:pt>
-                <c:pt idx="15">
-                  <c:v>29.999999999999993</c:v>
-                </c:pt>
                 <c:pt idx="16">
-                  <c:v>29.999999999999993</c:v>
+                  <c:v>30.0</c:v>
                 </c:pt>
                 <c:pt idx="17">
-                  <c:v>29.999999999999993</c:v>
+                  <c:v>30.0</c:v>
                 </c:pt>
                 <c:pt idx="18">
                   <c:v>29.999999999999993</c:v>
                 </c:pt>
                 <c:pt idx="19">
-                  <c:v>33.30290575388994</c:v>
+                  <c:v>33.27301298256658</c:v>
                 </c:pt>
                 <c:pt idx="20">
-                  <c:v>37.848735918514464</c:v>
+                  <c:v>37.84458443633356</c:v>
                 </c:pt>
                 <c:pt idx="21">
-                  <c:v>44.3150714720813</c:v>
+                  <c:v>44.28639493653697</c:v>
                 </c:pt>
                 <c:pt idx="22">
-                  <c:v>54.0510519916046</c:v>
+                  <c:v>54.00274058628328</c:v>
                 </c:pt>
                 <c:pt idx="23">
-                  <c:v>69.94040612981128</c:v>
+                  <c:v>69.92045377846262</c:v>
                 </c:pt>
                 <c:pt idx="24">
                   <c:v>100.0</c:v>
@@ -5318,7 +5318,7 @@
                         </a:defRPr>
                       </a:pPr>
                       <a:r>
-                        <a:t>3.0 meses</a:t>
+                        <a:t>3 meses</a:t>
                       </a:r>
                     </a:p>
                   </a:txBody>
@@ -5870,7 +5870,7 @@
             </a:r>
             <a:br/>
             <a:r>
-              <a:t>•  Reinv. de principal e excesso dentro da janela elegível</a:t>
+              <a:t>•  Nova carteira incremental vem do excesso de caixa</a:t>
             </a:r>
           </a:p>
         </p:txBody>
@@ -5950,7 +5950,7 @@
             </a:r>
             <a:br/>
             <a:r>
-              <a:t>•  Excesso de caixa positivo é reinvestido em nova carteira.</a:t>
+              <a:t>•  Excesso de caixa positivo aumenta a carteira originada acumulada.</a:t>
             </a:r>
           </a:p>
         </p:txBody>
@@ -6165,7 +6165,7 @@
                         </a:defRPr>
                       </a:pPr>
                       <a:r>
-                        <a:t>12,59</a:t>
+                        <a:t>11,89</a:t>
                       </a:r>
                     </a:p>
                   </a:txBody>
@@ -6461,7 +6461,7 @@
                         </a:defRPr>
                       </a:pPr>
                       <a:r>
-                        <a:t>-0,74</a:t>
+                        <a:t>-0,70</a:t>
                       </a:r>
                     </a:p>
                   </a:txBody>
@@ -6535,7 +6535,7 @@
                         </a:defRPr>
                       </a:pPr>
                       <a:r>
-                        <a:t>12,77</a:t>
+                        <a:t>-2,18</a:t>
                       </a:r>
                     </a:p>
                   </a:txBody>
@@ -6559,7 +6559,7 @@
                         </a:defRPr>
                       </a:pPr>
                       <a:r>
-                        <a:t>Reinveste em carteira nova</a:t>
+                        <a:t>Se positivo, origina carteira incremental</a:t>
                       </a:r>
                     </a:p>
                   </a:txBody>
@@ -6907,7 +6907,7 @@
               </a:defRPr>
             </a:pPr>
             <a:r>
-              <a:t>•  Principal recebido e excesso de caixa podem ser reinvestidos integralmente.</a:t>
+              <a:t>•  Principal recebido repõe a carteira; só o excesso de caixa aumenta a originada acumulada.</a:t>
             </a:r>
             <a:br/>
             <a:r>
@@ -7061,7 +7061,7 @@
                         </a:defRPr>
                       </a:pPr>
                       <a:r>
-                        <a:t>Caixa reinvestível</a:t>
+                        <a:t>Reposição</a:t>
                       </a:r>
                     </a:p>
                   </a:txBody>
@@ -7085,7 +7085,7 @@
                         </a:defRPr>
                       </a:pPr>
                       <a:r>
-                        <a:t>principal recebido + max(excesso de caixa, 0)</a:t>
+                        <a:t>principal recebido mantém o saldo da carteira</a:t>
                       </a:r>
                     </a:p>
                   </a:txBody>
@@ -7135,7 +7135,7 @@
                         </a:defRPr>
                       </a:pPr>
                       <a:r>
-                        <a:t>se elegível: caixa reinvestível; se não: 0</a:t>
+                        <a:t>se elegível: max(excesso de caixa, 0); se não: 0</a:t>
                       </a:r>
                     </a:p>
                   </a:txBody>
@@ -7509,7 +7509,7 @@
                         </a:defRPr>
                       </a:pPr>
                       <a:r>
-                        <a:t>R$ 142,9 mi</a:t>
+                        <a:t>R$ 0,00</a:t>
                       </a:r>
                     </a:p>
                   </a:txBody>
@@ -7533,7 +7533,7 @@
                         </a:defRPr>
                       </a:pPr>
                       <a:r>
-                        <a:t>R$ 15,2 mi</a:t>
+                        <a:t>R$ 21,8 mi</a:t>
                       </a:r>
                     </a:p>
                   </a:txBody>
@@ -7655,7 +7655,7 @@
                         </a:defRPr>
                       </a:pPr>
                       <a:r>
-                        <a:t>R$ 142,9 mi</a:t>
+                        <a:t>R$ 0,00</a:t>
                       </a:r>
                     </a:p>
                   </a:txBody>
@@ -7679,7 +7679,7 @@
                         </a:defRPr>
                       </a:pPr>
                       <a:r>
-                        <a:t>R$ 15,3 mi</a:t>
+                        <a:t>R$ 1,9 mi</a:t>
                       </a:r>
                     </a:p>
                   </a:txBody>
@@ -7801,7 +7801,7 @@
                         </a:defRPr>
                       </a:pPr>
                       <a:r>
-                        <a:t>R$ 142,9 mi</a:t>
+                        <a:t>R$ 0,00</a:t>
                       </a:r>
                     </a:p>
                   </a:txBody>
@@ -7825,7 +7825,7 @@
                         </a:defRPr>
                       </a:pPr>
                       <a:r>
-                        <a:t>R$ 2,2 mi</a:t>
+                        <a:t>R$ 15,4 mi</a:t>
                       </a:r>
                     </a:p>
                   </a:txBody>
@@ -7923,6 +7923,54 @@
                         </a:defRPr>
                       </a:pPr>
                       <a:r>
+                        <a:t>R$ 4,5 mi</a:t>
+                      </a:r>
+                    </a:p>
+                  </a:txBody>
+                  <a:tcPr anchor="ctr" marL="36576" marR="36576" marT="18288" marB="18288">
+                    <a:solidFill>
+                      <a:srgbClr val="F7F7F7"/>
+                    </a:solidFill>
+                  </a:tcPr>
+                </a:tc>
+                <a:tc>
+                  <a:txBody>
+                    <a:bodyPr/>
+                    <a:lstStyle/>
+                    <a:p>
+                      <a:pPr algn="l">
+                        <a:defRPr sz="660" b="0">
+                          <a:solidFill>
+                            <a:srgbClr val="1F1F1F"/>
+                          </a:solidFill>
+                          <a:latin typeface="Calibri"/>
+                        </a:defRPr>
+                      </a:pPr>
+                      <a:r>
+                        <a:t>R$ 4,5 mi</a:t>
+                      </a:r>
+                    </a:p>
+                  </a:txBody>
+                  <a:tcPr anchor="ctr" marL="36576" marR="36576" marT="18288" marB="18288">
+                    <a:solidFill>
+                      <a:srgbClr val="F7F7F7"/>
+                    </a:solidFill>
+                  </a:tcPr>
+                </a:tc>
+                <a:tc>
+                  <a:txBody>
+                    <a:bodyPr/>
+                    <a:lstStyle/>
+                    <a:p>
+                      <a:pPr algn="l">
+                        <a:defRPr sz="660" b="0">
+                          <a:solidFill>
+                            <a:srgbClr val="1F1F1F"/>
+                          </a:solidFill>
+                          <a:latin typeface="Calibri"/>
+                        </a:defRPr>
+                      </a:pPr>
+                      <a:r>
                         <a:t>R$ 0,00</a:t>
                       </a:r>
                     </a:p>
@@ -7947,55 +7995,7 @@
                         </a:defRPr>
                       </a:pPr>
                       <a:r>
-                        <a:t>R$ 142,9 mi</a:t>
-                      </a:r>
-                    </a:p>
-                  </a:txBody>
-                  <a:tcPr anchor="ctr" marL="36576" marR="36576" marT="18288" marB="18288">
-                    <a:solidFill>
-                      <a:srgbClr val="F7F7F7"/>
-                    </a:solidFill>
-                  </a:tcPr>
-                </a:tc>
-                <a:tc>
-                  <a:txBody>
-                    <a:bodyPr/>
-                    <a:lstStyle/>
-                    <a:p>
-                      <a:pPr algn="l">
-                        <a:defRPr sz="660" b="0">
-                          <a:solidFill>
-                            <a:srgbClr val="1F1F1F"/>
-                          </a:solidFill>
-                          <a:latin typeface="Calibri"/>
-                        </a:defRPr>
-                      </a:pPr>
-                      <a:r>
-                        <a:t>R$ 2,3 mi</a:t>
-                      </a:r>
-                    </a:p>
-                  </a:txBody>
-                  <a:tcPr anchor="ctr" marL="36576" marR="36576" marT="18288" marB="18288">
-                    <a:solidFill>
-                      <a:srgbClr val="F7F7F7"/>
-                    </a:solidFill>
-                  </a:tcPr>
-                </a:tc>
-                <a:tc>
-                  <a:txBody>
-                    <a:bodyPr/>
-                    <a:lstStyle/>
-                    <a:p>
-                      <a:pPr algn="l">
-                        <a:defRPr sz="660" b="0">
-                          <a:solidFill>
-                            <a:srgbClr val="1F1F1F"/>
-                          </a:solidFill>
-                          <a:latin typeface="Calibri"/>
-                        </a:defRPr>
-                      </a:pPr>
-                      <a:r>
-                        <a:t>30,00%</a:t>
+                        <a:t>30,31%</a:t>
                       </a:r>
                     </a:p>
                   </a:txBody>
@@ -8045,7 +8045,7 @@
                         </a:defRPr>
                       </a:pPr>
                       <a:r>
-                        <a:t>R$ 123,8 mi</a:t>
+                        <a:t>R$ 124,5 mi</a:t>
                       </a:r>
                     </a:p>
                   </a:txBody>
@@ -8069,7 +8069,7 @@
                         </a:defRPr>
                       </a:pPr>
                       <a:r>
-                        <a:t>R$ 8,3 mi</a:t>
+                        <a:t>R$ 2,6 mi</a:t>
                       </a:r>
                     </a:p>
                   </a:txBody>
@@ -8093,7 +8093,7 @@
                         </a:defRPr>
                       </a:pPr>
                       <a:r>
-                        <a:t>R$ 132,1 mi</a:t>
+                        <a:t>R$ 2,6 mi</a:t>
                       </a:r>
                     </a:p>
                   </a:txBody>
@@ -8141,7 +8141,7 @@
                         </a:defRPr>
                       </a:pPr>
                       <a:r>
-                        <a:t>30,58%</a:t>
+                        <a:t>30,50%</a:t>
                       </a:r>
                     </a:p>
                   </a:txBody>
@@ -8191,7 +8191,7 @@
                         </a:defRPr>
                       </a:pPr>
                       <a:r>
-                        <a:t>R$ 105,9 mi</a:t>
+                        <a:t>R$ 105,8 mi</a:t>
                       </a:r>
                     </a:p>
                   </a:txBody>
@@ -8239,7 +8239,7 @@
                         </a:defRPr>
                       </a:pPr>
                       <a:r>
-                        <a:t>R$ 105,9 mi</a:t>
+                        <a:t>R$ 0,00</a:t>
                       </a:r>
                     </a:p>
                   </a:txBody>
@@ -8287,7 +8287,7 @@
                         </a:defRPr>
                       </a:pPr>
                       <a:r>
-                        <a:t>30,29%</a:t>
+                        <a:t>30,22%</a:t>
                       </a:r>
                     </a:p>
                   </a:txBody>
@@ -8337,7 +8337,7 @@
                         </a:defRPr>
                       </a:pPr>
                       <a:r>
-                        <a:t>R$ 86,9 mi</a:t>
+                        <a:t>R$ 86,7 mi</a:t>
                       </a:r>
                     </a:p>
                   </a:txBody>
@@ -8361,6 +8361,54 @@
                         </a:defRPr>
                       </a:pPr>
                       <a:r>
+                        <a:t>R$ 2,8 mi</a:t>
+                      </a:r>
+                    </a:p>
+                  </a:txBody>
+                  <a:tcPr anchor="ctr" marL="36576" marR="36576" marT="18288" marB="18288">
+                    <a:solidFill>
+                      <a:srgbClr val="FFFFFF"/>
+                    </a:solidFill>
+                  </a:tcPr>
+                </a:tc>
+                <a:tc>
+                  <a:txBody>
+                    <a:bodyPr/>
+                    <a:lstStyle/>
+                    <a:p>
+                      <a:pPr algn="l">
+                        <a:defRPr sz="660" b="0">
+                          <a:solidFill>
+                            <a:srgbClr val="1F1F1F"/>
+                          </a:solidFill>
+                          <a:latin typeface="Calibri"/>
+                        </a:defRPr>
+                      </a:pPr>
+                      <a:r>
+                        <a:t>R$ 2,8 mi</a:t>
+                      </a:r>
+                    </a:p>
+                  </a:txBody>
+                  <a:tcPr anchor="ctr" marL="36576" marR="36576" marT="18288" marB="18288">
+                    <a:solidFill>
+                      <a:srgbClr val="FFFFFF"/>
+                    </a:solidFill>
+                  </a:tcPr>
+                </a:tc>
+                <a:tc>
+                  <a:txBody>
+                    <a:bodyPr/>
+                    <a:lstStyle/>
+                    <a:p>
+                      <a:pPr algn="l">
+                        <a:defRPr sz="660" b="0">
+                          <a:solidFill>
+                            <a:srgbClr val="1F1F1F"/>
+                          </a:solidFill>
+                          <a:latin typeface="Calibri"/>
+                        </a:defRPr>
+                      </a:pPr>
+                      <a:r>
                         <a:t>R$ 0,00</a:t>
                       </a:r>
                     </a:p>
@@ -8385,55 +8433,7 @@
                         </a:defRPr>
                       </a:pPr>
                       <a:r>
-                        <a:t>R$ 86,9 mi</a:t>
-                      </a:r>
-                    </a:p>
-                  </a:txBody>
-                  <a:tcPr anchor="ctr" marL="36576" marR="36576" marT="18288" marB="18288">
-                    <a:solidFill>
-                      <a:srgbClr val="FFFFFF"/>
-                    </a:solidFill>
-                  </a:tcPr>
-                </a:tc>
-                <a:tc>
-                  <a:txBody>
-                    <a:bodyPr/>
-                    <a:lstStyle/>
-                    <a:p>
-                      <a:pPr algn="l">
-                        <a:defRPr sz="660" b="0">
-                          <a:solidFill>
-                            <a:srgbClr val="1F1F1F"/>
-                          </a:solidFill>
-                          <a:latin typeface="Calibri"/>
-                        </a:defRPr>
-                      </a:pPr>
-                      <a:r>
-                        <a:t>R$ 0,00</a:t>
-                      </a:r>
-                    </a:p>
-                  </a:txBody>
-                  <a:tcPr anchor="ctr" marL="36576" marR="36576" marT="18288" marB="18288">
-                    <a:solidFill>
-                      <a:srgbClr val="FFFFFF"/>
-                    </a:solidFill>
-                  </a:tcPr>
-                </a:tc>
-                <a:tc>
-                  <a:txBody>
-                    <a:bodyPr/>
-                    <a:lstStyle/>
-                    <a:p>
-                      <a:pPr algn="l">
-                        <a:defRPr sz="660" b="0">
-                          <a:solidFill>
-                            <a:srgbClr val="1F1F1F"/>
-                          </a:solidFill>
-                          <a:latin typeface="Calibri"/>
-                        </a:defRPr>
-                      </a:pPr>
-                      <a:r>
-                        <a:t>30,21%</a:t>
+                        <a:t>30,41%</a:t>
                       </a:r>
                     </a:p>
                   </a:txBody>
@@ -8483,7 +8483,7 @@
                         </a:defRPr>
                       </a:pPr>
                       <a:r>
-                        <a:t>R$ 67,9 mi</a:t>
+                        <a:t>R$ 68,1 mi</a:t>
                       </a:r>
                     </a:p>
                   </a:txBody>
@@ -8531,7 +8531,7 @@
                         </a:defRPr>
                       </a:pPr>
                       <a:r>
-                        <a:t>R$ 67,9 mi</a:t>
+                        <a:t>R$ 0,00</a:t>
                       </a:r>
                     </a:p>
                   </a:txBody>
@@ -8555,7 +8555,7 @@
                         </a:defRPr>
                       </a:pPr>
                       <a:r>
-                        <a:t>R$ 62.917,94</a:t>
+                        <a:t>R$ 50.908,78</a:t>
                       </a:r>
                     </a:p>
                   </a:txBody>
@@ -8625,7 +8625,7 @@
               </a:defRPr>
             </a:pPr>
             <a:r>
-              <a:t>Leitura: reinvestimento troca caixa por carteira e não consome PL; a trava de 30% é testada no PL econômico da estrutura.</a:t>
+              <a:t>Leitura: giro do principal não aumenta o denominador; a originada acumulada cresce apenas com excesso de caixa reinvestido.</a:t>
             </a:r>
           </a:p>
         </p:txBody>
@@ -9309,7 +9309,7 @@
               </a:defRPr>
             </a:pPr>
             <a:r>
-              <a:t>CARTEIRA ORIGINADA EFETIVA</a:t>
+              <a:t>ORIGINADA EFETIVA S/ PERDAS</a:t>
             </a:r>
           </a:p>
           <a:p>
@@ -9325,7 +9325,7 @@
               </a:defRPr>
             </a:pPr>
             <a:r>
-              <a:t>R$ 24,2 bi</a:t>
+              <a:t>R$ 12,2 bi</a:t>
             </a:r>
           </a:p>
           <a:p>
@@ -9341,7 +9341,7 @@
               </a:defRPr>
             </a:pPr>
             <a:r>
-              <a:t>Base de comparação</a:t>
+              <a:t>Cenário paralelo sem perda</a:t>
             </a:r>
           </a:p>
         </p:txBody>
@@ -9415,7 +9415,7 @@
               </a:defRPr>
             </a:pPr>
             <a:r>
-              <a:t>R$ 17,1 bi</a:t>
+              <a:t>R$ 17,2 bi</a:t>
             </a:r>
           </a:p>
           <a:p>
@@ -9505,7 +9505,7 @@
               </a:defRPr>
             </a:pPr>
             <a:r>
-              <a:t>70,49%</a:t>
+              <a:t>141,24%</a:t>
             </a:r>
           </a:p>
           <a:p>
@@ -9615,15 +9615,15 @@
             </a:r>
             <a:br/>
             <a:r>
-              <a:t>•  Nova originação inclui principal recebido e excesso de caixa positivo.</a:t>
+              <a:t>•  Nova originação incremental usa apenas excesso de caixa positivo.</a:t>
             </a:r>
             <a:br/>
             <a:r>
-              <a:t>•  Carteira originada efetiva: R$ 2,1 bi.</a:t>
+              <a:t>•  Carteira originada efetiva: R$ 1 bi.</a:t>
             </a:r>
             <a:br/>
             <a:r>
-              <a:t>•  SUB / PL final: 100,00%; colchão sobre originada: 12,80%.</a:t>
+              <a:t>•  SUB / PL final: 100,00%; colchão sobre originada: 26,70%.</a:t>
             </a:r>
           </a:p>
         </p:txBody>

</xml_diff>

<commit_message>
Use unique native chart axis ids
</commit_message>
<xml_diff>
--- a/outputs/modelo_fidc_mc3_comite_trava_30.pptx
+++ b/outputs/modelo_fidc_mc3_comite_trava_30.pptx
@@ -1490,11 +1490,11 @@
         </c:dLbls>
         <c:marker val="1"/>
         <c:smooth val="0"/>
-        <c:axId val="1000001"/>
-        <c:axId val="1000002"/>
+        <c:axId val="1000003"/>
+        <c:axId val="1000004"/>
       </c:lineChart>
       <c:catAx>
-        <c:axId val="1000001"/>
+        <c:axId val="1000003"/>
         <c:scaling>
           <c:orientation val="minMax"/>
         </c:scaling>
@@ -1512,7 +1512,7 @@
             </a:pPr>
           </a:p>
         </c:txPr>
-        <c:crossAx val="1000002"/>
+        <c:crossAx val="1000004"/>
         <c:crosses val="autoZero"/>
         <c:auto val="1"/>
         <c:lblAlgn val="ctr"/>
@@ -1520,7 +1520,7 @@
         <c:noMultiLvlLbl val="0"/>
       </c:catAx>
       <c:valAx>
-        <c:axId val="1000002"/>
+        <c:axId val="1000004"/>
         <c:scaling>
           <c:min val="0.0"/>
         </c:scaling>
@@ -1555,7 +1555,7 @@
             </a:pPr>
           </a:p>
         </c:txPr>
-        <c:crossAx val="1000001"/>
+        <c:crossAx val="1000003"/>
         <c:crosses val="autoZero"/>
       </c:valAx>
     </c:plotArea>

</xml_diff>

<commit_message>
Refina modelagem MC3 de FIDC
</commit_message>
<xml_diff>
--- a/outputs/modelo_fidc_mc3_comite_trava_30.pptx
+++ b/outputs/modelo_fidc_mc3_comite_trava_30.pptx
@@ -737,7 +737,7 @@
                   <c:v>303.09409257726134</c:v>
                 </c:pt>
                 <c:pt idx="7">
-                  <c:v>305.8688077874529</c:v>
+                  <c:v>305.8688077874528</c:v>
                 </c:pt>
                 <c:pt idx="8">
                   <c:v>300</c:v>
@@ -1431,10 +1431,10 @@
                   <c:v>0.3049740802467135</c:v>
                 </c:pt>
                 <c:pt idx="6">
-                  <c:v>0.3009403578075697</c:v>
+                  <c:v>0.30094035780756967</c:v>
                 </c:pt>
                 <c:pt idx="7">
-                  <c:v>0.30286097481708935</c:v>
+                  <c:v>0.30286097481708923</c:v>
                 </c:pt>
                 <c:pt idx="8">
                   <c:v>0.29704987933344246</c:v>
@@ -1674,7 +1674,7 @@
                   <c:v>0.3021591840886214</c:v>
                 </c:pt>
                 <c:pt idx="7">
-                  <c:v>0.30408419608940207</c:v>
+                  <c:v>0.304084196089402</c:v>
                 </c:pt>
                 <c:pt idx="8">
                   <c:v>0.3</c:v>
@@ -3060,7 +3060,7 @@
                 <a:gridCol w="2560320"/>
                 <a:gridCol w="2423160"/>
               </a:tblGrid>
-              <a:tr h="242732">
+              <a:tr h="232178">
                 <a:tc>
                   <a:txBody>
                     <a:bodyPr/>
@@ -3198,7 +3198,7 @@
                   </a:tcPr>
                 </a:tc>
               </a:tr>
-              <a:tr h="242732">
+              <a:tr h="232178">
                 <a:tc>
                   <a:txBody>
                     <a:bodyPr/>
@@ -3336,7 +3336,7 @@
                   </a:tcPr>
                 </a:tc>
               </a:tr>
-              <a:tr h="242732">
+              <a:tr h="232178">
                 <a:tc>
                   <a:txBody>
                     <a:bodyPr/>
@@ -3474,7 +3474,145 @@
                   </a:tcPr>
                 </a:tc>
               </a:tr>
-              <a:tr h="242732">
+              <a:tr h="232178">
+                <a:tc>
+                  <a:txBody>
+                    <a:bodyPr/>
+                    <a:lstStyle/>
+                    <a:p>
+                      <a:pPr algn="l" indent="0" marL="0">
+                        <a:buNone/>
+                      </a:pPr>
+                      <a:r>
+                        <a:rPr lang="en-US" sz="615" dirty="0">
+                          <a:solidFill>
+                            <a:srgbClr val="1F1F1F"/>
+                          </a:solidFill>
+                          <a:latin typeface="Calibri" pitchFamily="34" charset="0"/>
+                          <a:ea typeface="Calibri" pitchFamily="34" charset="-122"/>
+                          <a:cs typeface="Calibri" pitchFamily="34" charset="-120"/>
+                        </a:rPr>
+                        <a:t>Limite estoque revolvente</a:t>
+                      </a:r>
+                      <a:endParaRPr lang="en-US" sz="615" dirty="0">
+                        <a:latin typeface="Calibri" charset="0"/>
+                        <a:ea typeface="Calibri" charset="0"/>
+                        <a:cs typeface="Calibri" charset="0"/>
+                      </a:endParaRPr>
+                    </a:p>
+                  </a:txBody>
+                  <a:tcPr marL="36576" marR="36576" marT="18288" marB="18288" anchor="mid">
+                    <a:lnL w="5715" cap="flat" cmpd="sng" algn="ctr">
+                      <a:solidFill>
+                        <a:srgbClr val="FFFFFF"/>
+                      </a:solidFill>
+                      <a:prstDash val="solid"/>
+                      <a:round/>
+                      <a:headEnd type="none" w="med" len="med"/>
+                      <a:tailEnd type="none" w="med" len="med"/>
+                    </a:lnL>
+                    <a:lnR w="5715" cap="flat" cmpd="sng" algn="ctr">
+                      <a:solidFill>
+                        <a:srgbClr val="FFFFFF"/>
+                      </a:solidFill>
+                      <a:prstDash val="solid"/>
+                      <a:round/>
+                      <a:headEnd type="none" w="med" len="med"/>
+                      <a:tailEnd type="none" w="med" len="med"/>
+                    </a:lnR>
+                    <a:lnT w="5715" cap="flat" cmpd="sng" algn="ctr">
+                      <a:solidFill>
+                        <a:srgbClr val="FFFFFF"/>
+                      </a:solidFill>
+                      <a:prstDash val="solid"/>
+                      <a:round/>
+                      <a:headEnd type="none" w="med" len="med"/>
+                      <a:tailEnd type="none" w="med" len="med"/>
+                    </a:lnT>
+                    <a:lnB w="5715" cap="flat" cmpd="sng" algn="ctr">
+                      <a:solidFill>
+                        <a:srgbClr val="FFFFFF"/>
+                      </a:solidFill>
+                      <a:prstDash val="solid"/>
+                      <a:round/>
+                      <a:headEnd type="none" w="med" len="med"/>
+                      <a:tailEnd type="none" w="med" len="med"/>
+                    </a:lnB>
+                    <a:solidFill>
+                      <a:srgbClr val="FFFFFF"/>
+                    </a:solidFill>
+                  </a:tcPr>
+                </a:tc>
+                <a:tc>
+                  <a:txBody>
+                    <a:bodyPr/>
+                    <a:lstStyle/>
+                    <a:p>
+                      <a:pPr algn="ctr" indent="0" marL="0">
+                        <a:buNone/>
+                      </a:pPr>
+                      <a:r>
+                        <a:rPr lang="en-US" sz="615" dirty="0">
+                          <a:solidFill>
+                            <a:srgbClr val="1F1F1F"/>
+                          </a:solidFill>
+                          <a:latin typeface="Calibri" pitchFamily="34" charset="0"/>
+                          <a:ea typeface="Calibri" pitchFamily="34" charset="-122"/>
+                          <a:cs typeface="Calibri" pitchFamily="34" charset="-120"/>
+                        </a:rPr>
+                        <a:t>1,00x volume inicial</a:t>
+                      </a:r>
+                      <a:endParaRPr lang="en-US" sz="615" dirty="0">
+                        <a:latin typeface="Calibri" charset="0"/>
+                        <a:ea typeface="Calibri" charset="0"/>
+                        <a:cs typeface="Calibri" charset="0"/>
+                      </a:endParaRPr>
+                    </a:p>
+                  </a:txBody>
+                  <a:tcPr marL="36576" marR="36576" marT="18288" marB="18288" anchor="mid">
+                    <a:lnL w="5715" cap="flat" cmpd="sng" algn="ctr">
+                      <a:solidFill>
+                        <a:srgbClr val="FFFFFF"/>
+                      </a:solidFill>
+                      <a:prstDash val="solid"/>
+                      <a:round/>
+                      <a:headEnd type="none" w="med" len="med"/>
+                      <a:tailEnd type="none" w="med" len="med"/>
+                    </a:lnL>
+                    <a:lnR w="5715" cap="flat" cmpd="sng" algn="ctr">
+                      <a:solidFill>
+                        <a:srgbClr val="FFFFFF"/>
+                      </a:solidFill>
+                      <a:prstDash val="solid"/>
+                      <a:round/>
+                      <a:headEnd type="none" w="med" len="med"/>
+                      <a:tailEnd type="none" w="med" len="med"/>
+                    </a:lnR>
+                    <a:lnT w="5715" cap="flat" cmpd="sng" algn="ctr">
+                      <a:solidFill>
+                        <a:srgbClr val="FFFFFF"/>
+                      </a:solidFill>
+                      <a:prstDash val="solid"/>
+                      <a:round/>
+                      <a:headEnd type="none" w="med" len="med"/>
+                      <a:tailEnd type="none" w="med" len="med"/>
+                    </a:lnT>
+                    <a:lnB w="5715" cap="flat" cmpd="sng" algn="ctr">
+                      <a:solidFill>
+                        <a:srgbClr val="FFFFFF"/>
+                      </a:solidFill>
+                      <a:prstDash val="solid"/>
+                      <a:round/>
+                      <a:headEnd type="none" w="med" len="med"/>
+                      <a:tailEnd type="none" w="med" len="med"/>
+                    </a:lnB>
+                    <a:solidFill>
+                      <a:srgbClr val="FFFFFF"/>
+                    </a:solidFill>
+                  </a:tcPr>
+                </a:tc>
+              </a:tr>
+              <a:tr h="232178">
                 <a:tc>
                   <a:txBody>
                     <a:bodyPr/>
@@ -3539,7 +3677,7 @@
                       <a:tailEnd type="none" w="med" len="med"/>
                     </a:lnB>
                     <a:solidFill>
-                      <a:srgbClr val="FFFFFF"/>
+                      <a:srgbClr val="F1F1F1"/>
                     </a:solidFill>
                   </a:tcPr>
                 </a:tc>
@@ -3607,12 +3745,12 @@
                       <a:tailEnd type="none" w="med" len="med"/>
                     </a:lnB>
                     <a:solidFill>
-                      <a:srgbClr val="FFFFFF"/>
+                      <a:srgbClr val="F1F1F1"/>
                     </a:solidFill>
                   </a:tcPr>
                 </a:tc>
               </a:tr>
-              <a:tr h="242732">
+              <a:tr h="232178">
                 <a:tc>
                   <a:txBody>
                     <a:bodyPr/>
@@ -3677,7 +3815,7 @@
                       <a:tailEnd type="none" w="med" len="med"/>
                     </a:lnB>
                     <a:solidFill>
-                      <a:srgbClr val="F1F1F1"/>
+                      <a:srgbClr val="FFFFFF"/>
                     </a:solidFill>
                   </a:tcPr>
                 </a:tc>
@@ -3745,12 +3883,12 @@
                       <a:tailEnd type="none" w="med" len="med"/>
                     </a:lnB>
                     <a:solidFill>
-                      <a:srgbClr val="F1F1F1"/>
+                      <a:srgbClr val="FFFFFF"/>
                     </a:solidFill>
                   </a:tcPr>
                 </a:tc>
               </a:tr>
-              <a:tr h="242732">
+              <a:tr h="232178">
                 <a:tc>
                   <a:txBody>
                     <a:bodyPr/>
@@ -3815,7 +3953,7 @@
                       <a:tailEnd type="none" w="med" len="med"/>
                     </a:lnB>
                     <a:solidFill>
-                      <a:srgbClr val="FFFFFF"/>
+                      <a:srgbClr val="F1F1F1"/>
                     </a:solidFill>
                   </a:tcPr>
                 </a:tc>
@@ -3883,12 +4021,12 @@
                       <a:tailEnd type="none" w="med" len="med"/>
                     </a:lnB>
                     <a:solidFill>
-                      <a:srgbClr val="FFFFFF"/>
+                      <a:srgbClr val="F1F1F1"/>
                     </a:solidFill>
                   </a:tcPr>
                 </a:tc>
               </a:tr>
-              <a:tr h="242732">
+              <a:tr h="232178">
                 <a:tc>
                   <a:txBody>
                     <a:bodyPr/>
@@ -3953,7 +4091,7 @@
                       <a:tailEnd type="none" w="med" len="med"/>
                     </a:lnB>
                     <a:solidFill>
-                      <a:srgbClr val="F1F1F1"/>
+                      <a:srgbClr val="FFFFFF"/>
                     </a:solidFill>
                   </a:tcPr>
                 </a:tc>
@@ -4021,12 +4159,12 @@
                       <a:tailEnd type="none" w="med" len="med"/>
                     </a:lnB>
                     <a:solidFill>
-                      <a:srgbClr val="F1F1F1"/>
+                      <a:srgbClr val="FFFFFF"/>
                     </a:solidFill>
                   </a:tcPr>
                 </a:tc>
               </a:tr>
-              <a:tr h="242732">
+              <a:tr h="232178">
                 <a:tc>
                   <a:txBody>
                     <a:bodyPr/>
@@ -4091,7 +4229,7 @@
                       <a:tailEnd type="none" w="med" len="med"/>
                     </a:lnB>
                     <a:solidFill>
-                      <a:srgbClr val="FFFFFF"/>
+                      <a:srgbClr val="F1F1F1"/>
                     </a:solidFill>
                   </a:tcPr>
                 </a:tc>
@@ -4159,12 +4297,12 @@
                       <a:tailEnd type="none" w="med" len="med"/>
                     </a:lnB>
                     <a:solidFill>
-                      <a:srgbClr val="FFFFFF"/>
+                      <a:srgbClr val="F1F1F1"/>
                     </a:solidFill>
                   </a:tcPr>
                 </a:tc>
               </a:tr>
-              <a:tr h="242732">
+              <a:tr h="232178">
                 <a:tc>
                   <a:txBody>
                     <a:bodyPr/>
@@ -4229,7 +4367,7 @@
                       <a:tailEnd type="none" w="med" len="med"/>
                     </a:lnB>
                     <a:solidFill>
-                      <a:srgbClr val="F1F1F1"/>
+                      <a:srgbClr val="FFFFFF"/>
                     </a:solidFill>
                   </a:tcPr>
                 </a:tc>
@@ -4297,12 +4435,12 @@
                       <a:tailEnd type="none" w="med" len="med"/>
                     </a:lnB>
                     <a:solidFill>
-                      <a:srgbClr val="F1F1F1"/>
+                      <a:srgbClr val="FFFFFF"/>
                     </a:solidFill>
                   </a:tcPr>
                 </a:tc>
               </a:tr>
-              <a:tr h="242732">
+              <a:tr h="232178">
                 <a:tc>
                   <a:txBody>
                     <a:bodyPr/>
@@ -4367,7 +4505,7 @@
                       <a:tailEnd type="none" w="med" len="med"/>
                     </a:lnB>
                     <a:solidFill>
-                      <a:srgbClr val="FFFFFF"/>
+                      <a:srgbClr val="F1F1F1"/>
                     </a:solidFill>
                   </a:tcPr>
                 </a:tc>
@@ -4435,12 +4573,12 @@
                       <a:tailEnd type="none" w="med" len="med"/>
                     </a:lnB>
                     <a:solidFill>
-                      <a:srgbClr val="FFFFFF"/>
+                      <a:srgbClr val="F1F1F1"/>
                     </a:solidFill>
                   </a:tcPr>
                 </a:tc>
               </a:tr>
-              <a:tr h="242732">
+              <a:tr h="232178">
                 <a:tc>
                   <a:txBody>
                     <a:bodyPr/>
@@ -4505,7 +4643,7 @@
                       <a:tailEnd type="none" w="med" len="med"/>
                     </a:lnB>
                     <a:solidFill>
-                      <a:srgbClr val="F1F1F1"/>
+                      <a:srgbClr val="FFFFFF"/>
                     </a:solidFill>
                   </a:tcPr>
                 </a:tc>
@@ -4573,12 +4711,12 @@
                       <a:tailEnd type="none" w="med" len="med"/>
                     </a:lnB>
                     <a:solidFill>
-                      <a:srgbClr val="F1F1F1"/>
+                      <a:srgbClr val="FFFFFF"/>
                     </a:solidFill>
                   </a:tcPr>
                 </a:tc>
               </a:tr>
-              <a:tr h="242732">
+              <a:tr h="232178">
                 <a:tc>
                   <a:txBody>
                     <a:bodyPr/>
@@ -4643,7 +4781,7 @@
                       <a:tailEnd type="none" w="med" len="med"/>
                     </a:lnB>
                     <a:solidFill>
-                      <a:srgbClr val="FFFFFF"/>
+                      <a:srgbClr val="F1F1F1"/>
                     </a:solidFill>
                   </a:tcPr>
                 </a:tc>
@@ -4711,12 +4849,12 @@
                       <a:tailEnd type="none" w="med" len="med"/>
                     </a:lnB>
                     <a:solidFill>
-                      <a:srgbClr val="FFFFFF"/>
+                      <a:srgbClr val="F1F1F1"/>
                     </a:solidFill>
                   </a:tcPr>
                 </a:tc>
               </a:tr>
-              <a:tr h="242732">
+              <a:tr h="232178">
                 <a:tc>
                   <a:txBody>
                     <a:bodyPr/>
@@ -4735,6 +4873,144 @@
                           <a:cs typeface="Calibri" pitchFamily="34" charset="-120"/>
                         </a:rPr>
                         <a:t>Cobertura mínima NPL 90+</a:t>
+                      </a:r>
+                      <a:endParaRPr lang="en-US" sz="615" dirty="0">
+                        <a:latin typeface="Calibri" charset="0"/>
+                        <a:ea typeface="Calibri" charset="0"/>
+                        <a:cs typeface="Calibri" charset="0"/>
+                      </a:endParaRPr>
+                    </a:p>
+                  </a:txBody>
+                  <a:tcPr marL="36576" marR="36576" marT="18288" marB="18288" anchor="mid">
+                    <a:lnL w="5715" cap="flat" cmpd="sng" algn="ctr">
+                      <a:solidFill>
+                        <a:srgbClr val="FFFFFF"/>
+                      </a:solidFill>
+                      <a:prstDash val="solid"/>
+                      <a:round/>
+                      <a:headEnd type="none" w="med" len="med"/>
+                      <a:tailEnd type="none" w="med" len="med"/>
+                    </a:lnL>
+                    <a:lnR w="5715" cap="flat" cmpd="sng" algn="ctr">
+                      <a:solidFill>
+                        <a:srgbClr val="FFFFFF"/>
+                      </a:solidFill>
+                      <a:prstDash val="solid"/>
+                      <a:round/>
+                      <a:headEnd type="none" w="med" len="med"/>
+                      <a:tailEnd type="none" w="med" len="med"/>
+                    </a:lnR>
+                    <a:lnT w="5715" cap="flat" cmpd="sng" algn="ctr">
+                      <a:solidFill>
+                        <a:srgbClr val="FFFFFF"/>
+                      </a:solidFill>
+                      <a:prstDash val="solid"/>
+                      <a:round/>
+                      <a:headEnd type="none" w="med" len="med"/>
+                      <a:tailEnd type="none" w="med" len="med"/>
+                    </a:lnT>
+                    <a:lnB w="5715" cap="flat" cmpd="sng" algn="ctr">
+                      <a:solidFill>
+                        <a:srgbClr val="FFFFFF"/>
+                      </a:solidFill>
+                      <a:prstDash val="solid"/>
+                      <a:round/>
+                      <a:headEnd type="none" w="med" len="med"/>
+                      <a:tailEnd type="none" w="med" len="med"/>
+                    </a:lnB>
+                    <a:solidFill>
+                      <a:srgbClr val="FFFFFF"/>
+                    </a:solidFill>
+                  </a:tcPr>
+                </a:tc>
+                <a:tc>
+                  <a:txBody>
+                    <a:bodyPr/>
+                    <a:lstStyle/>
+                    <a:p>
+                      <a:pPr algn="ctr" indent="0" marL="0">
+                        <a:buNone/>
+                      </a:pPr>
+                      <a:r>
+                        <a:rPr lang="en-US" sz="615" dirty="0">
+                          <a:solidFill>
+                            <a:srgbClr val="1F1F1F"/>
+                          </a:solidFill>
+                          <a:latin typeface="Calibri" pitchFamily="34" charset="0"/>
+                          <a:ea typeface="Calibri" pitchFamily="34" charset="-122"/>
+                          <a:cs typeface="Calibri" pitchFamily="34" charset="-120"/>
+                        </a:rPr>
+                        <a:t>100%</a:t>
+                      </a:r>
+                      <a:endParaRPr lang="en-US" sz="615" dirty="0">
+                        <a:latin typeface="Calibri" charset="0"/>
+                        <a:ea typeface="Calibri" charset="0"/>
+                        <a:cs typeface="Calibri" charset="0"/>
+                      </a:endParaRPr>
+                    </a:p>
+                  </a:txBody>
+                  <a:tcPr marL="36576" marR="36576" marT="18288" marB="18288" anchor="mid">
+                    <a:lnL w="5715" cap="flat" cmpd="sng" algn="ctr">
+                      <a:solidFill>
+                        <a:srgbClr val="FFFFFF"/>
+                      </a:solidFill>
+                      <a:prstDash val="solid"/>
+                      <a:round/>
+                      <a:headEnd type="none" w="med" len="med"/>
+                      <a:tailEnd type="none" w="med" len="med"/>
+                    </a:lnL>
+                    <a:lnR w="5715" cap="flat" cmpd="sng" algn="ctr">
+                      <a:solidFill>
+                        <a:srgbClr val="FFFFFF"/>
+                      </a:solidFill>
+                      <a:prstDash val="solid"/>
+                      <a:round/>
+                      <a:headEnd type="none" w="med" len="med"/>
+                      <a:tailEnd type="none" w="med" len="med"/>
+                    </a:lnR>
+                    <a:lnT w="5715" cap="flat" cmpd="sng" algn="ctr">
+                      <a:solidFill>
+                        <a:srgbClr val="FFFFFF"/>
+                      </a:solidFill>
+                      <a:prstDash val="solid"/>
+                      <a:round/>
+                      <a:headEnd type="none" w="med" len="med"/>
+                      <a:tailEnd type="none" w="med" len="med"/>
+                    </a:lnT>
+                    <a:lnB w="5715" cap="flat" cmpd="sng" algn="ctr">
+                      <a:solidFill>
+                        <a:srgbClr val="FFFFFF"/>
+                      </a:solidFill>
+                      <a:prstDash val="solid"/>
+                      <a:round/>
+                      <a:headEnd type="none" w="med" len="med"/>
+                      <a:tailEnd type="none" w="med" len="med"/>
+                    </a:lnB>
+                    <a:solidFill>
+                      <a:srgbClr val="FFFFFF"/>
+                    </a:solidFill>
+                  </a:tcPr>
+                </a:tc>
+              </a:tr>
+              <a:tr h="232178">
+                <a:tc>
+                  <a:txBody>
+                    <a:bodyPr/>
+                    <a:lstStyle/>
+                    <a:p>
+                      <a:pPr algn="l" indent="0" marL="0">
+                        <a:buNone/>
+                      </a:pPr>
+                      <a:r>
+                        <a:rPr lang="en-US" sz="615" dirty="0">
+                          <a:solidFill>
+                            <a:srgbClr val="1F1F1F"/>
+                          </a:solidFill>
+                          <a:latin typeface="Calibri" pitchFamily="34" charset="0"/>
+                          <a:ea typeface="Calibri" pitchFamily="34" charset="-122"/>
+                          <a:cs typeface="Calibri" pitchFamily="34" charset="-120"/>
+                        </a:rPr>
+                        <a:t>LGD econômica</a:t>
                       </a:r>
                       <a:endParaRPr lang="en-US" sz="615" dirty="0">
                         <a:latin typeface="Calibri" charset="0"/>
@@ -4854,145 +5130,7 @@
                   </a:tcPr>
                 </a:tc>
               </a:tr>
-              <a:tr h="242732">
-                <a:tc>
-                  <a:txBody>
-                    <a:bodyPr/>
-                    <a:lstStyle/>
-                    <a:p>
-                      <a:pPr algn="l" indent="0" marL="0">
-                        <a:buNone/>
-                      </a:pPr>
-                      <a:r>
-                        <a:rPr lang="en-US" sz="615" dirty="0">
-                          <a:solidFill>
-                            <a:srgbClr val="1F1F1F"/>
-                          </a:solidFill>
-                          <a:latin typeface="Calibri" pitchFamily="34" charset="0"/>
-                          <a:ea typeface="Calibri" pitchFamily="34" charset="-122"/>
-                          <a:cs typeface="Calibri" pitchFamily="34" charset="-120"/>
-                        </a:rPr>
-                        <a:t>LGD econômica</a:t>
-                      </a:r>
-                      <a:endParaRPr lang="en-US" sz="615" dirty="0">
-                        <a:latin typeface="Calibri" charset="0"/>
-                        <a:ea typeface="Calibri" charset="0"/>
-                        <a:cs typeface="Calibri" charset="0"/>
-                      </a:endParaRPr>
-                    </a:p>
-                  </a:txBody>
-                  <a:tcPr marL="36576" marR="36576" marT="18288" marB="18288" anchor="mid">
-                    <a:lnL w="5715" cap="flat" cmpd="sng" algn="ctr">
-                      <a:solidFill>
-                        <a:srgbClr val="FFFFFF"/>
-                      </a:solidFill>
-                      <a:prstDash val="solid"/>
-                      <a:round/>
-                      <a:headEnd type="none" w="med" len="med"/>
-                      <a:tailEnd type="none" w="med" len="med"/>
-                    </a:lnL>
-                    <a:lnR w="5715" cap="flat" cmpd="sng" algn="ctr">
-                      <a:solidFill>
-                        <a:srgbClr val="FFFFFF"/>
-                      </a:solidFill>
-                      <a:prstDash val="solid"/>
-                      <a:round/>
-                      <a:headEnd type="none" w="med" len="med"/>
-                      <a:tailEnd type="none" w="med" len="med"/>
-                    </a:lnR>
-                    <a:lnT w="5715" cap="flat" cmpd="sng" algn="ctr">
-                      <a:solidFill>
-                        <a:srgbClr val="FFFFFF"/>
-                      </a:solidFill>
-                      <a:prstDash val="solid"/>
-                      <a:round/>
-                      <a:headEnd type="none" w="med" len="med"/>
-                      <a:tailEnd type="none" w="med" len="med"/>
-                    </a:lnT>
-                    <a:lnB w="5715" cap="flat" cmpd="sng" algn="ctr">
-                      <a:solidFill>
-                        <a:srgbClr val="FFFFFF"/>
-                      </a:solidFill>
-                      <a:prstDash val="solid"/>
-                      <a:round/>
-                      <a:headEnd type="none" w="med" len="med"/>
-                      <a:tailEnd type="none" w="med" len="med"/>
-                    </a:lnB>
-                    <a:solidFill>
-                      <a:srgbClr val="FFFFFF"/>
-                    </a:solidFill>
-                  </a:tcPr>
-                </a:tc>
-                <a:tc>
-                  <a:txBody>
-                    <a:bodyPr/>
-                    <a:lstStyle/>
-                    <a:p>
-                      <a:pPr algn="ctr" indent="0" marL="0">
-                        <a:buNone/>
-                      </a:pPr>
-                      <a:r>
-                        <a:rPr lang="en-US" sz="615" dirty="0">
-                          <a:solidFill>
-                            <a:srgbClr val="1F1F1F"/>
-                          </a:solidFill>
-                          <a:latin typeface="Calibri" pitchFamily="34" charset="0"/>
-                          <a:ea typeface="Calibri" pitchFamily="34" charset="-122"/>
-                          <a:cs typeface="Calibri" pitchFamily="34" charset="-120"/>
-                        </a:rPr>
-                        <a:t>100%</a:t>
-                      </a:r>
-                      <a:endParaRPr lang="en-US" sz="615" dirty="0">
-                        <a:latin typeface="Calibri" charset="0"/>
-                        <a:ea typeface="Calibri" charset="0"/>
-                        <a:cs typeface="Calibri" charset="0"/>
-                      </a:endParaRPr>
-                    </a:p>
-                  </a:txBody>
-                  <a:tcPr marL="36576" marR="36576" marT="18288" marB="18288" anchor="mid">
-                    <a:lnL w="5715" cap="flat" cmpd="sng" algn="ctr">
-                      <a:solidFill>
-                        <a:srgbClr val="FFFFFF"/>
-                      </a:solidFill>
-                      <a:prstDash val="solid"/>
-                      <a:round/>
-                      <a:headEnd type="none" w="med" len="med"/>
-                      <a:tailEnd type="none" w="med" len="med"/>
-                    </a:lnL>
-                    <a:lnR w="5715" cap="flat" cmpd="sng" algn="ctr">
-                      <a:solidFill>
-                        <a:srgbClr val="FFFFFF"/>
-                      </a:solidFill>
-                      <a:prstDash val="solid"/>
-                      <a:round/>
-                      <a:headEnd type="none" w="med" len="med"/>
-                      <a:tailEnd type="none" w="med" len="med"/>
-                    </a:lnR>
-                    <a:lnT w="5715" cap="flat" cmpd="sng" algn="ctr">
-                      <a:solidFill>
-                        <a:srgbClr val="FFFFFF"/>
-                      </a:solidFill>
-                      <a:prstDash val="solid"/>
-                      <a:round/>
-                      <a:headEnd type="none" w="med" len="med"/>
-                      <a:tailEnd type="none" w="med" len="med"/>
-                    </a:lnT>
-                    <a:lnB w="5715" cap="flat" cmpd="sng" algn="ctr">
-                      <a:solidFill>
-                        <a:srgbClr val="FFFFFF"/>
-                      </a:solidFill>
-                      <a:prstDash val="solid"/>
-                      <a:round/>
-                      <a:headEnd type="none" w="med" len="med"/>
-                      <a:tailEnd type="none" w="med" len="med"/>
-                    </a:lnB>
-                    <a:solidFill>
-                      <a:srgbClr val="FFFFFF"/>
-                    </a:solidFill>
-                  </a:tcPr>
-                </a:tc>
-              </a:tr>
-              <a:tr h="242732">
+              <a:tr h="232178">
                 <a:tc>
                   <a:txBody>
                     <a:bodyPr/>
@@ -5057,7 +5195,7 @@
                       <a:tailEnd type="none" w="med" len="med"/>
                     </a:lnB>
                     <a:solidFill>
-                      <a:srgbClr val="F1F1F1"/>
+                      <a:srgbClr val="FFFFFF"/>
                     </a:solidFill>
                   </a:tcPr>
                 </a:tc>
@@ -5125,12 +5263,12 @@
                       <a:tailEnd type="none" w="med" len="med"/>
                     </a:lnB>
                     <a:solidFill>
-                      <a:srgbClr val="F1F1F1"/>
+                      <a:srgbClr val="FFFFFF"/>
                     </a:solidFill>
                   </a:tcPr>
                 </a:tc>
               </a:tr>
-              <a:tr h="242732">
+              <a:tr h="232178">
                 <a:tc>
                   <a:txBody>
                     <a:bodyPr/>
@@ -5195,7 +5333,7 @@
                       <a:tailEnd type="none" w="med" len="med"/>
                     </a:lnB>
                     <a:solidFill>
-                      <a:srgbClr val="FFFFFF"/>
+                      <a:srgbClr val="F1F1F1"/>
                     </a:solidFill>
                   </a:tcPr>
                 </a:tc>
@@ -5263,12 +5401,12 @@
                       <a:tailEnd type="none" w="med" len="med"/>
                     </a:lnB>
                     <a:solidFill>
-                      <a:srgbClr val="FFFFFF"/>
+                      <a:srgbClr val="F1F1F1"/>
                     </a:solidFill>
                   </a:tcPr>
                 </a:tc>
               </a:tr>
-              <a:tr h="242732">
+              <a:tr h="232178">
                 <a:tc>
                   <a:txBody>
                     <a:bodyPr/>
@@ -5333,7 +5471,7 @@
                       <a:tailEnd type="none" w="med" len="med"/>
                     </a:lnB>
                     <a:solidFill>
-                      <a:srgbClr val="F1F1F1"/>
+                      <a:srgbClr val="FFFFFF"/>
                     </a:solidFill>
                   </a:tcPr>
                 </a:tc>
@@ -5401,12 +5539,12 @@
                       <a:tailEnd type="none" w="med" len="med"/>
                     </a:lnB>
                     <a:solidFill>
-                      <a:srgbClr val="F1F1F1"/>
+                      <a:srgbClr val="FFFFFF"/>
                     </a:solidFill>
                   </a:tcPr>
                 </a:tc>
               </a:tr>
-              <a:tr h="242732">
+              <a:tr h="232178">
                 <a:tc>
                   <a:txBody>
                     <a:bodyPr/>
@@ -5471,7 +5609,7 @@
                       <a:tailEnd type="none" w="med" len="med"/>
                     </a:lnB>
                     <a:solidFill>
-                      <a:srgbClr val="FFFFFF"/>
+                      <a:srgbClr val="F1F1F1"/>
                     </a:solidFill>
                   </a:tcPr>
                 </a:tc>
@@ -5539,12 +5677,12 @@
                       <a:tailEnd type="none" w="med" len="med"/>
                     </a:lnB>
                     <a:solidFill>
-                      <a:srgbClr val="FFFFFF"/>
+                      <a:srgbClr val="F1F1F1"/>
                     </a:solidFill>
                   </a:tcPr>
                 </a:tc>
               </a:tr>
-              <a:tr h="242732">
+              <a:tr h="232178">
                 <a:tc>
                   <a:txBody>
                     <a:bodyPr/>
@@ -5609,7 +5747,7 @@
                       <a:tailEnd type="none" w="med" len="med"/>
                     </a:lnB>
                     <a:solidFill>
-                      <a:srgbClr val="F1F1F1"/>
+                      <a:srgbClr val="FFFFFF"/>
                     </a:solidFill>
                   </a:tcPr>
                 </a:tc>
@@ -5677,12 +5815,12 @@
                       <a:tailEnd type="none" w="med" len="med"/>
                     </a:lnB>
                     <a:solidFill>
-                      <a:srgbClr val="F1F1F1"/>
+                      <a:srgbClr val="FFFFFF"/>
                     </a:solidFill>
                   </a:tcPr>
                 </a:tc>
               </a:tr>
-              <a:tr h="242732">
+              <a:tr h="232178">
                 <a:tc>
                   <a:txBody>
                     <a:bodyPr/>
@@ -5747,7 +5885,7 @@
                       <a:tailEnd type="none" w="med" len="med"/>
                     </a:lnB>
                     <a:solidFill>
-                      <a:srgbClr val="FFFFFF"/>
+                      <a:srgbClr val="F1F1F1"/>
                     </a:solidFill>
                   </a:tcPr>
                 </a:tc>
@@ -5815,12 +5953,12 @@
                       <a:tailEnd type="none" w="med" len="med"/>
                     </a:lnB>
                     <a:solidFill>
-                      <a:srgbClr val="FFFFFF"/>
+                      <a:srgbClr val="F1F1F1"/>
                     </a:solidFill>
                   </a:tcPr>
                 </a:tc>
               </a:tr>
-              <a:tr h="242732">
+              <a:tr h="232178">
                 <a:tc>
                   <a:txBody>
                     <a:bodyPr/>
@@ -5885,7 +6023,7 @@
                       <a:tailEnd type="none" w="med" len="med"/>
                     </a:lnB>
                     <a:solidFill>
-                      <a:srgbClr val="F1F1F1"/>
+                      <a:srgbClr val="FFFFFF"/>
                     </a:solidFill>
                   </a:tcPr>
                 </a:tc>
@@ -5953,12 +6091,12 @@
                       <a:tailEnd type="none" w="med" len="med"/>
                     </a:lnB>
                     <a:solidFill>
-                      <a:srgbClr val="F1F1F1"/>
+                      <a:srgbClr val="FFFFFF"/>
                     </a:solidFill>
                   </a:tcPr>
                 </a:tc>
               </a:tr>
-              <a:tr h="242732">
+              <a:tr h="232178">
                 <a:tc>
                   <a:txBody>
                     <a:bodyPr/>
@@ -6023,7 +6161,7 @@
                       <a:tailEnd type="none" w="med" len="med"/>
                     </a:lnB>
                     <a:solidFill>
-                      <a:srgbClr val="FFFFFF"/>
+                      <a:srgbClr val="F1F1F1"/>
                     </a:solidFill>
                   </a:tcPr>
                 </a:tc>
@@ -6091,7 +6229,7 @@
                       <a:tailEnd type="none" w="med" len="med"/>
                     </a:lnB>
                     <a:solidFill>
-                      <a:srgbClr val="FFFFFF"/>
+                      <a:srgbClr val="F1F1F1"/>
                     </a:solidFill>
                   </a:tcPr>
                 </a:tc>
@@ -6261,7 +6399,7 @@
                 <a:ea typeface="Calibri" pitchFamily="34" charset="-122"/>
                 <a:cs typeface="Calibri" pitchFamily="34" charset="-120"/>
               </a:rPr>
-              <a:t>•  Nova carteira incremental vem do excesso de caixa</a:t>
+              <a:t>•  Limite estoque: 1,00x volume inicial</a:t>
             </a:r>
             <a:endParaRPr lang="en-US" sz="1000" dirty="0"/>
           </a:p>
@@ -6377,7 +6515,7 @@
                 <a:ea typeface="Calibri" pitchFamily="34" charset="-122"/>
                 <a:cs typeface="Calibri" pitchFamily="34" charset="-120"/>
               </a:rPr>
-              <a:t>•  Excesso de caixa positivo aumenta a carteira originada acumulada.</a:t>
+              <a:t>•  Excesso positivo reinveste só até o limite de estoque; saldo fica em caixa/PL.</a:t>
             </a:r>
             <a:endParaRPr lang="en-US" sz="1000" dirty="0"/>
           </a:p>
@@ -8006,7 +8144,7 @@
                           <a:ea typeface="Calibri" pitchFamily="34" charset="-122"/>
                           <a:cs typeface="Calibri" pitchFamily="34" charset="-120"/>
                         </a:rPr>
-                        <a:t>Se positivo, origina carteira incremental</a:t>
+                        <a:t>Reinveste até limite; saldo fica em caixa</a:t>
                       </a:r>
                       <a:endParaRPr lang="en-US" sz="620" dirty="0">
                         <a:latin typeface="Calibri" charset="0"/>
@@ -8461,6 +8599,23 @@
                 <a:ea typeface="Calibri" pitchFamily="34" charset="-122"/>
                 <a:cs typeface="Calibri" pitchFamily="34" charset="-120"/>
               </a:rPr>
+              <a:t>•  Limite de estoque impede que excesso de spread infle a carteira para múltiplos irreais.</a:t>
+            </a:r>
+            <a:endParaRPr lang="en-US" sz="1000" dirty="0"/>
+          </a:p>
+          <a:p>
+            <a:pPr algn="l" indent="0" marL="0">
+              <a:buNone/>
+            </a:pPr>
+            <a:r>
+              <a:rPr lang="en-US" sz="1000" dirty="0">
+                <a:solidFill>
+                  <a:srgbClr val="2B2B2B"/>
+                </a:solidFill>
+                <a:latin typeface="Calibri" pitchFamily="34" charset="0"/>
+                <a:ea typeface="Calibri" pitchFamily="34" charset="-122"/>
+                <a:cs typeface="Calibri" pitchFamily="34" charset="-120"/>
+              </a:rPr>
               <a:t>•  Se perdas/custos consumirem SUB abaixo do piso, o modelo registra aporte necessário.</a:t>
             </a:r>
             <a:endParaRPr lang="en-US" sz="1000" dirty="0"/>
@@ -8510,7 +8665,7 @@
                 <a:gridCol w="1554480"/>
                 <a:gridCol w="3886200"/>
               </a:tblGrid>
-              <a:tr h="335280">
+              <a:tr h="287383">
                 <a:tc>
                   <a:txBody>
                     <a:bodyPr/>
@@ -8648,7 +8803,7 @@
                   </a:tcPr>
                 </a:tc>
               </a:tr>
-              <a:tr h="335280">
+              <a:tr h="287383">
                 <a:tc>
                   <a:txBody>
                     <a:bodyPr/>
@@ -8786,7 +8941,7 @@
                   </a:tcPr>
                 </a:tc>
               </a:tr>
-              <a:tr h="335280">
+              <a:tr h="287383">
                 <a:tc>
                   <a:txBody>
                     <a:bodyPr/>
@@ -8924,7 +9079,7 @@
                   </a:tcPr>
                 </a:tc>
               </a:tr>
-              <a:tr h="335280">
+              <a:tr h="287383">
                 <a:tc>
                   <a:txBody>
                     <a:bodyPr/>
@@ -9010,7 +9165,7 @@
                           <a:ea typeface="Calibri" pitchFamily="34" charset="-122"/>
                           <a:cs typeface="Calibri" pitchFamily="34" charset="-120"/>
                         </a:rPr>
-                        <a:t>se elegível: max(excesso de caixa, 0); se não: 0</a:t>
+                        <a:t>min(max(excesso, 0), limite estoque - carteira pós-reposição)</a:t>
                       </a:r>
                       <a:endParaRPr lang="en-US" sz="635" dirty="0">
                         <a:latin typeface="Calibri" charset="0"/>
@@ -9062,7 +9217,145 @@
                   </a:tcPr>
                 </a:tc>
               </a:tr>
-              <a:tr h="335280">
+              <a:tr h="287383">
+                <a:tc>
+                  <a:txBody>
+                    <a:bodyPr/>
+                    <a:lstStyle/>
+                    <a:p>
+                      <a:pPr algn="l" indent="0" marL="0">
+                        <a:buNone/>
+                      </a:pPr>
+                      <a:r>
+                        <a:rPr lang="en-US" sz="635" dirty="0">
+                          <a:solidFill>
+                            <a:srgbClr val="1F1F1F"/>
+                          </a:solidFill>
+                          <a:latin typeface="Calibri" pitchFamily="34" charset="0"/>
+                          <a:ea typeface="Calibri" pitchFamily="34" charset="-122"/>
+                          <a:cs typeface="Calibri" pitchFamily="34" charset="-120"/>
+                        </a:rPr>
+                        <a:t>Caixa retido</a:t>
+                      </a:r>
+                      <a:endParaRPr lang="en-US" sz="635" dirty="0">
+                        <a:latin typeface="Calibri" charset="0"/>
+                        <a:ea typeface="Calibri" charset="0"/>
+                        <a:cs typeface="Calibri" charset="0"/>
+                      </a:endParaRPr>
+                    </a:p>
+                  </a:txBody>
+                  <a:tcPr marL="36576" marR="36576" marT="18288" marB="18288" anchor="mid">
+                    <a:lnL w="5715" cap="flat" cmpd="sng" algn="ctr">
+                      <a:solidFill>
+                        <a:srgbClr val="FFFFFF"/>
+                      </a:solidFill>
+                      <a:prstDash val="solid"/>
+                      <a:round/>
+                      <a:headEnd type="none" w="med" len="med"/>
+                      <a:tailEnd type="none" w="med" len="med"/>
+                    </a:lnL>
+                    <a:lnR w="5715" cap="flat" cmpd="sng" algn="ctr">
+                      <a:solidFill>
+                        <a:srgbClr val="FFFFFF"/>
+                      </a:solidFill>
+                      <a:prstDash val="solid"/>
+                      <a:round/>
+                      <a:headEnd type="none" w="med" len="med"/>
+                      <a:tailEnd type="none" w="med" len="med"/>
+                    </a:lnR>
+                    <a:lnT w="5715" cap="flat" cmpd="sng" algn="ctr">
+                      <a:solidFill>
+                        <a:srgbClr val="FFFFFF"/>
+                      </a:solidFill>
+                      <a:prstDash val="solid"/>
+                      <a:round/>
+                      <a:headEnd type="none" w="med" len="med"/>
+                      <a:tailEnd type="none" w="med" len="med"/>
+                    </a:lnT>
+                    <a:lnB w="5715" cap="flat" cmpd="sng" algn="ctr">
+                      <a:solidFill>
+                        <a:srgbClr val="FFFFFF"/>
+                      </a:solidFill>
+                      <a:prstDash val="solid"/>
+                      <a:round/>
+                      <a:headEnd type="none" w="med" len="med"/>
+                      <a:tailEnd type="none" w="med" len="med"/>
+                    </a:lnB>
+                    <a:solidFill>
+                      <a:srgbClr val="F1F1F1"/>
+                    </a:solidFill>
+                  </a:tcPr>
+                </a:tc>
+                <a:tc>
+                  <a:txBody>
+                    <a:bodyPr/>
+                    <a:lstStyle/>
+                    <a:p>
+                      <a:pPr algn="ctr" indent="0" marL="0">
+                        <a:buNone/>
+                      </a:pPr>
+                      <a:r>
+                        <a:rPr lang="en-US" sz="635" dirty="0">
+                          <a:solidFill>
+                            <a:srgbClr val="1F1F1F"/>
+                          </a:solidFill>
+                          <a:latin typeface="Calibri" pitchFamily="34" charset="0"/>
+                          <a:ea typeface="Calibri" pitchFamily="34" charset="-122"/>
+                          <a:cs typeface="Calibri" pitchFamily="34" charset="-120"/>
+                        </a:rPr>
+                        <a:t>excesso não reinvestido fica em caixa SELIC/PL</a:t>
+                      </a:r>
+                      <a:endParaRPr lang="en-US" sz="635" dirty="0">
+                        <a:latin typeface="Calibri" charset="0"/>
+                        <a:ea typeface="Calibri" charset="0"/>
+                        <a:cs typeface="Calibri" charset="0"/>
+                      </a:endParaRPr>
+                    </a:p>
+                  </a:txBody>
+                  <a:tcPr marL="36576" marR="36576" marT="18288" marB="18288" anchor="mid">
+                    <a:lnL w="5715" cap="flat" cmpd="sng" algn="ctr">
+                      <a:solidFill>
+                        <a:srgbClr val="FFFFFF"/>
+                      </a:solidFill>
+                      <a:prstDash val="solid"/>
+                      <a:round/>
+                      <a:headEnd type="none" w="med" len="med"/>
+                      <a:tailEnd type="none" w="med" len="med"/>
+                    </a:lnL>
+                    <a:lnR w="5715" cap="flat" cmpd="sng" algn="ctr">
+                      <a:solidFill>
+                        <a:srgbClr val="FFFFFF"/>
+                      </a:solidFill>
+                      <a:prstDash val="solid"/>
+                      <a:round/>
+                      <a:headEnd type="none" w="med" len="med"/>
+                      <a:tailEnd type="none" w="med" len="med"/>
+                    </a:lnR>
+                    <a:lnT w="5715" cap="flat" cmpd="sng" algn="ctr">
+                      <a:solidFill>
+                        <a:srgbClr val="FFFFFF"/>
+                      </a:solidFill>
+                      <a:prstDash val="solid"/>
+                      <a:round/>
+                      <a:headEnd type="none" w="med" len="med"/>
+                      <a:tailEnd type="none" w="med" len="med"/>
+                    </a:lnT>
+                    <a:lnB w="5715" cap="flat" cmpd="sng" algn="ctr">
+                      <a:solidFill>
+                        <a:srgbClr val="FFFFFF"/>
+                      </a:solidFill>
+                      <a:prstDash val="solid"/>
+                      <a:round/>
+                      <a:headEnd type="none" w="med" len="med"/>
+                      <a:tailEnd type="none" w="med" len="med"/>
+                    </a:lnB>
+                    <a:solidFill>
+                      <a:srgbClr val="F1F1F1"/>
+                    </a:solidFill>
+                  </a:tcPr>
+                </a:tc>
+              </a:tr>
+              <a:tr h="287383">
                 <a:tc>
                   <a:txBody>
                     <a:bodyPr/>
@@ -9127,7 +9420,7 @@
                       <a:tailEnd type="none" w="med" len="med"/>
                     </a:lnB>
                     <a:solidFill>
-                      <a:srgbClr val="F1F1F1"/>
+                      <a:srgbClr val="FFFFFF"/>
                     </a:solidFill>
                   </a:tcPr>
                 </a:tc>
@@ -9195,12 +9488,12 @@
                       <a:tailEnd type="none" w="med" len="med"/>
                     </a:lnB>
                     <a:solidFill>
-                      <a:srgbClr val="F1F1F1"/>
+                      <a:srgbClr val="FFFFFF"/>
                     </a:solidFill>
                   </a:tcPr>
                 </a:tc>
               </a:tr>
-              <a:tr h="335280">
+              <a:tr h="287383">
                 <a:tc>
                   <a:txBody>
                     <a:bodyPr/>
@@ -9265,7 +9558,7 @@
                       <a:tailEnd type="none" w="med" len="med"/>
                     </a:lnB>
                     <a:solidFill>
-                      <a:srgbClr val="FFFFFF"/>
+                      <a:srgbClr val="F1F1F1"/>
                     </a:solidFill>
                   </a:tcPr>
                 </a:tc>
@@ -9333,7 +9626,7 @@
                       <a:tailEnd type="none" w="med" len="med"/>
                     </a:lnB>
                     <a:solidFill>
-                      <a:srgbClr val="FFFFFF"/>
+                      <a:srgbClr val="F1F1F1"/>
                     </a:solidFill>
                   </a:tcPr>
                 </a:tc>
@@ -9365,12 +9658,13 @@
             <a:tbl>
               <a:tblPr/>
               <a:tblGrid>
-                <a:gridCol w="822960"/>
-                <a:gridCol w="2057400"/>
-                <a:gridCol w="2057400"/>
-                <a:gridCol w="1965960"/>
-                <a:gridCol w="1965960"/>
-                <a:gridCol w="1993392"/>
+                <a:gridCol w="640080"/>
+                <a:gridCol w="1627632"/>
+                <a:gridCol w="1499616"/>
+                <a:gridCol w="1417320"/>
+                <a:gridCol w="1508760"/>
+                <a:gridCol w="1481328"/>
+                <a:gridCol w="2688336"/>
               </a:tblGrid>
               <a:tr h="233680">
                 <a:tc>
@@ -9527,6 +9821,74 @@
                           <a:cs typeface="Calibri" pitchFamily="34" charset="-120"/>
                         </a:rPr>
                         <a:t>Excesso reinv.</a:t>
+                      </a:r>
+                      <a:endParaRPr lang="en-US" sz="680" dirty="0">
+                        <a:latin typeface="Calibri" charset="0"/>
+                        <a:ea typeface="Calibri" charset="0"/>
+                        <a:cs typeface="Calibri" charset="0"/>
+                      </a:endParaRPr>
+                    </a:p>
+                  </a:txBody>
+                  <a:tcPr marL="36576" marR="36576" marT="18288" marB="18288" anchor="mid">
+                    <a:lnL w="5715" cap="flat" cmpd="sng" algn="ctr">
+                      <a:solidFill>
+                        <a:srgbClr val="FFFFFF"/>
+                      </a:solidFill>
+                      <a:prstDash val="solid"/>
+                      <a:round/>
+                      <a:headEnd type="none" w="med" len="med"/>
+                      <a:tailEnd type="none" w="med" len="med"/>
+                    </a:lnL>
+                    <a:lnR w="5715" cap="flat" cmpd="sng" algn="ctr">
+                      <a:solidFill>
+                        <a:srgbClr val="FFFFFF"/>
+                      </a:solidFill>
+                      <a:prstDash val="solid"/>
+                      <a:round/>
+                      <a:headEnd type="none" w="med" len="med"/>
+                      <a:tailEnd type="none" w="med" len="med"/>
+                    </a:lnR>
+                    <a:lnT w="5715" cap="flat" cmpd="sng" algn="ctr">
+                      <a:solidFill>
+                        <a:srgbClr val="FFFFFF"/>
+                      </a:solidFill>
+                      <a:prstDash val="solid"/>
+                      <a:round/>
+                      <a:headEnd type="none" w="med" len="med"/>
+                      <a:tailEnd type="none" w="med" len="med"/>
+                    </a:lnT>
+                    <a:lnB w="5715" cap="flat" cmpd="sng" algn="ctr">
+                      <a:solidFill>
+                        <a:srgbClr val="FFFFFF"/>
+                      </a:solidFill>
+                      <a:prstDash val="solid"/>
+                      <a:round/>
+                      <a:headEnd type="none" w="med" len="med"/>
+                      <a:tailEnd type="none" w="med" len="med"/>
+                    </a:lnB>
+                    <a:solidFill>
+                      <a:srgbClr val="1F1F1F"/>
+                    </a:solidFill>
+                  </a:tcPr>
+                </a:tc>
+                <a:tc>
+                  <a:txBody>
+                    <a:bodyPr/>
+                    <a:lstStyle/>
+                    <a:p>
+                      <a:pPr algn="ctr" indent="0" marL="0">
+                        <a:buNone/>
+                      </a:pPr>
+                      <a:r>
+                        <a:rPr lang="en-US" sz="680" b="1" dirty="0">
+                          <a:solidFill>
+                            <a:srgbClr val="FFFFFF"/>
+                          </a:solidFill>
+                          <a:latin typeface="Calibri" pitchFamily="34" charset="0"/>
+                          <a:ea typeface="Calibri" pitchFamily="34" charset="-122"/>
+                          <a:cs typeface="Calibri" pitchFamily="34" charset="-120"/>
+                        </a:rPr>
+                        <a:t>Retido limite</a:t>
                       </a:r>
                       <a:endParaRPr lang="en-US" sz="680" dirty="0">
                         <a:latin typeface="Calibri" charset="0"/>
@@ -10072,6 +10434,74 @@
                           <a:ea typeface="Calibri" pitchFamily="34" charset="-122"/>
                           <a:cs typeface="Calibri" pitchFamily="34" charset="-120"/>
                         </a:rPr>
+                        <a:t>R$ 0,00</a:t>
+                      </a:r>
+                      <a:endParaRPr lang="en-US" sz="615" dirty="0">
+                        <a:latin typeface="Calibri" charset="0"/>
+                        <a:ea typeface="Calibri" charset="0"/>
+                        <a:cs typeface="Calibri" charset="0"/>
+                      </a:endParaRPr>
+                    </a:p>
+                  </a:txBody>
+                  <a:tcPr marL="36576" marR="36576" marT="18288" marB="18288" anchor="mid">
+                    <a:lnL w="5715" cap="flat" cmpd="sng" algn="ctr">
+                      <a:solidFill>
+                        <a:srgbClr val="FFFFFF"/>
+                      </a:solidFill>
+                      <a:prstDash val="solid"/>
+                      <a:round/>
+                      <a:headEnd type="none" w="med" len="med"/>
+                      <a:tailEnd type="none" w="med" len="med"/>
+                    </a:lnL>
+                    <a:lnR w="5715" cap="flat" cmpd="sng" algn="ctr">
+                      <a:solidFill>
+                        <a:srgbClr val="FFFFFF"/>
+                      </a:solidFill>
+                      <a:prstDash val="solid"/>
+                      <a:round/>
+                      <a:headEnd type="none" w="med" len="med"/>
+                      <a:tailEnd type="none" w="med" len="med"/>
+                    </a:lnR>
+                    <a:lnT w="5715" cap="flat" cmpd="sng" algn="ctr">
+                      <a:solidFill>
+                        <a:srgbClr val="FFFFFF"/>
+                      </a:solidFill>
+                      <a:prstDash val="solid"/>
+                      <a:round/>
+                      <a:headEnd type="none" w="med" len="med"/>
+                      <a:tailEnd type="none" w="med" len="med"/>
+                    </a:lnT>
+                    <a:lnB w="5715" cap="flat" cmpd="sng" algn="ctr">
+                      <a:solidFill>
+                        <a:srgbClr val="FFFFFF"/>
+                      </a:solidFill>
+                      <a:prstDash val="solid"/>
+                      <a:round/>
+                      <a:headEnd type="none" w="med" len="med"/>
+                      <a:tailEnd type="none" w="med" len="med"/>
+                    </a:lnB>
+                    <a:solidFill>
+                      <a:srgbClr val="FFFFFF"/>
+                    </a:solidFill>
+                  </a:tcPr>
+                </a:tc>
+                <a:tc>
+                  <a:txBody>
+                    <a:bodyPr/>
+                    <a:lstStyle/>
+                    <a:p>
+                      <a:pPr algn="ctr" indent="0" marL="0">
+                        <a:buNone/>
+                      </a:pPr>
+                      <a:r>
+                        <a:rPr lang="en-US" sz="615" dirty="0">
+                          <a:solidFill>
+                            <a:srgbClr val="1F1F1F"/>
+                          </a:solidFill>
+                          <a:latin typeface="Calibri" pitchFamily="34" charset="0"/>
+                          <a:ea typeface="Calibri" pitchFamily="34" charset="-122"/>
+                          <a:cs typeface="Calibri" pitchFamily="34" charset="-120"/>
+                        </a:rPr>
                         <a:t>R$ 21,8 mi</a:t>
                       </a:r>
                       <a:endParaRPr lang="en-US" sz="615" dirty="0">
@@ -10482,6 +10912,74 @@
                           <a:ea typeface="Calibri" pitchFamily="34" charset="-122"/>
                           <a:cs typeface="Calibri" pitchFamily="34" charset="-120"/>
                         </a:rPr>
+                        <a:t>R$ 0,00</a:t>
+                      </a:r>
+                      <a:endParaRPr lang="en-US" sz="615" dirty="0">
+                        <a:latin typeface="Calibri" charset="0"/>
+                        <a:ea typeface="Calibri" charset="0"/>
+                        <a:cs typeface="Calibri" charset="0"/>
+                      </a:endParaRPr>
+                    </a:p>
+                  </a:txBody>
+                  <a:tcPr marL="36576" marR="36576" marT="18288" marB="18288" anchor="mid">
+                    <a:lnL w="5715" cap="flat" cmpd="sng" algn="ctr">
+                      <a:solidFill>
+                        <a:srgbClr val="FFFFFF"/>
+                      </a:solidFill>
+                      <a:prstDash val="solid"/>
+                      <a:round/>
+                      <a:headEnd type="none" w="med" len="med"/>
+                      <a:tailEnd type="none" w="med" len="med"/>
+                    </a:lnL>
+                    <a:lnR w="5715" cap="flat" cmpd="sng" algn="ctr">
+                      <a:solidFill>
+                        <a:srgbClr val="FFFFFF"/>
+                      </a:solidFill>
+                      <a:prstDash val="solid"/>
+                      <a:round/>
+                      <a:headEnd type="none" w="med" len="med"/>
+                      <a:tailEnd type="none" w="med" len="med"/>
+                    </a:lnR>
+                    <a:lnT w="5715" cap="flat" cmpd="sng" algn="ctr">
+                      <a:solidFill>
+                        <a:srgbClr val="FFFFFF"/>
+                      </a:solidFill>
+                      <a:prstDash val="solid"/>
+                      <a:round/>
+                      <a:headEnd type="none" w="med" len="med"/>
+                      <a:tailEnd type="none" w="med" len="med"/>
+                    </a:lnT>
+                    <a:lnB w="5715" cap="flat" cmpd="sng" algn="ctr">
+                      <a:solidFill>
+                        <a:srgbClr val="FFFFFF"/>
+                      </a:solidFill>
+                      <a:prstDash val="solid"/>
+                      <a:round/>
+                      <a:headEnd type="none" w="med" len="med"/>
+                      <a:tailEnd type="none" w="med" len="med"/>
+                    </a:lnB>
+                    <a:solidFill>
+                      <a:srgbClr val="F1F1F1"/>
+                    </a:solidFill>
+                  </a:tcPr>
+                </a:tc>
+                <a:tc>
+                  <a:txBody>
+                    <a:bodyPr/>
+                    <a:lstStyle/>
+                    <a:p>
+                      <a:pPr algn="ctr" indent="0" marL="0">
+                        <a:buNone/>
+                      </a:pPr>
+                      <a:r>
+                        <a:rPr lang="en-US" sz="615" dirty="0">
+                          <a:solidFill>
+                            <a:srgbClr val="1F1F1F"/>
+                          </a:solidFill>
+                          <a:latin typeface="Calibri" pitchFamily="34" charset="0"/>
+                          <a:ea typeface="Calibri" pitchFamily="34" charset="-122"/>
+                          <a:cs typeface="Calibri" pitchFamily="34" charset="-120"/>
+                        </a:rPr>
                         <a:t>R$ 1,9 mi</a:t>
                       </a:r>
                       <a:endParaRPr lang="en-US" sz="615" dirty="0">
@@ -10892,6 +11390,74 @@
                           <a:ea typeface="Calibri" pitchFamily="34" charset="-122"/>
                           <a:cs typeface="Calibri" pitchFamily="34" charset="-120"/>
                         </a:rPr>
+                        <a:t>R$ 0,00</a:t>
+                      </a:r>
+                      <a:endParaRPr lang="en-US" sz="615" dirty="0">
+                        <a:latin typeface="Calibri" charset="0"/>
+                        <a:ea typeface="Calibri" charset="0"/>
+                        <a:cs typeface="Calibri" charset="0"/>
+                      </a:endParaRPr>
+                    </a:p>
+                  </a:txBody>
+                  <a:tcPr marL="36576" marR="36576" marT="18288" marB="18288" anchor="mid">
+                    <a:lnL w="5715" cap="flat" cmpd="sng" algn="ctr">
+                      <a:solidFill>
+                        <a:srgbClr val="FFFFFF"/>
+                      </a:solidFill>
+                      <a:prstDash val="solid"/>
+                      <a:round/>
+                      <a:headEnd type="none" w="med" len="med"/>
+                      <a:tailEnd type="none" w="med" len="med"/>
+                    </a:lnL>
+                    <a:lnR w="5715" cap="flat" cmpd="sng" algn="ctr">
+                      <a:solidFill>
+                        <a:srgbClr val="FFFFFF"/>
+                      </a:solidFill>
+                      <a:prstDash val="solid"/>
+                      <a:round/>
+                      <a:headEnd type="none" w="med" len="med"/>
+                      <a:tailEnd type="none" w="med" len="med"/>
+                    </a:lnR>
+                    <a:lnT w="5715" cap="flat" cmpd="sng" algn="ctr">
+                      <a:solidFill>
+                        <a:srgbClr val="FFFFFF"/>
+                      </a:solidFill>
+                      <a:prstDash val="solid"/>
+                      <a:round/>
+                      <a:headEnd type="none" w="med" len="med"/>
+                      <a:tailEnd type="none" w="med" len="med"/>
+                    </a:lnT>
+                    <a:lnB w="5715" cap="flat" cmpd="sng" algn="ctr">
+                      <a:solidFill>
+                        <a:srgbClr val="FFFFFF"/>
+                      </a:solidFill>
+                      <a:prstDash val="solid"/>
+                      <a:round/>
+                      <a:headEnd type="none" w="med" len="med"/>
+                      <a:tailEnd type="none" w="med" len="med"/>
+                    </a:lnB>
+                    <a:solidFill>
+                      <a:srgbClr val="FFFFFF"/>
+                    </a:solidFill>
+                  </a:tcPr>
+                </a:tc>
+                <a:tc>
+                  <a:txBody>
+                    <a:bodyPr/>
+                    <a:lstStyle/>
+                    <a:p>
+                      <a:pPr algn="ctr" indent="0" marL="0">
+                        <a:buNone/>
+                      </a:pPr>
+                      <a:r>
+                        <a:rPr lang="en-US" sz="615" dirty="0">
+                          <a:solidFill>
+                            <a:srgbClr val="1F1F1F"/>
+                          </a:solidFill>
+                          <a:latin typeface="Calibri" pitchFamily="34" charset="0"/>
+                          <a:ea typeface="Calibri" pitchFamily="34" charset="-122"/>
+                          <a:cs typeface="Calibri" pitchFamily="34" charset="-120"/>
+                        </a:rPr>
                         <a:t>R$ 15,4 mi</a:t>
                       </a:r>
                       <a:endParaRPr lang="en-US" sz="615" dirty="0">
@@ -11234,6 +11800,74 @@
                           <a:ea typeface="Calibri" pitchFamily="34" charset="-122"/>
                           <a:cs typeface="Calibri" pitchFamily="34" charset="-120"/>
                         </a:rPr>
+                        <a:t>R$ 0,00</a:t>
+                      </a:r>
+                      <a:endParaRPr lang="en-US" sz="615" dirty="0">
+                        <a:latin typeface="Calibri" charset="0"/>
+                        <a:ea typeface="Calibri" charset="0"/>
+                        <a:cs typeface="Calibri" charset="0"/>
+                      </a:endParaRPr>
+                    </a:p>
+                  </a:txBody>
+                  <a:tcPr marL="36576" marR="36576" marT="18288" marB="18288" anchor="mid">
+                    <a:lnL w="5715" cap="flat" cmpd="sng" algn="ctr">
+                      <a:solidFill>
+                        <a:srgbClr val="FFFFFF"/>
+                      </a:solidFill>
+                      <a:prstDash val="solid"/>
+                      <a:round/>
+                      <a:headEnd type="none" w="med" len="med"/>
+                      <a:tailEnd type="none" w="med" len="med"/>
+                    </a:lnL>
+                    <a:lnR w="5715" cap="flat" cmpd="sng" algn="ctr">
+                      <a:solidFill>
+                        <a:srgbClr val="FFFFFF"/>
+                      </a:solidFill>
+                      <a:prstDash val="solid"/>
+                      <a:round/>
+                      <a:headEnd type="none" w="med" len="med"/>
+                      <a:tailEnd type="none" w="med" len="med"/>
+                    </a:lnR>
+                    <a:lnT w="5715" cap="flat" cmpd="sng" algn="ctr">
+                      <a:solidFill>
+                        <a:srgbClr val="FFFFFF"/>
+                      </a:solidFill>
+                      <a:prstDash val="solid"/>
+                      <a:round/>
+                      <a:headEnd type="none" w="med" len="med"/>
+                      <a:tailEnd type="none" w="med" len="med"/>
+                    </a:lnT>
+                    <a:lnB w="5715" cap="flat" cmpd="sng" algn="ctr">
+                      <a:solidFill>
+                        <a:srgbClr val="FFFFFF"/>
+                      </a:solidFill>
+                      <a:prstDash val="solid"/>
+                      <a:round/>
+                      <a:headEnd type="none" w="med" len="med"/>
+                      <a:tailEnd type="none" w="med" len="med"/>
+                    </a:lnB>
+                    <a:solidFill>
+                      <a:srgbClr val="F1F1F1"/>
+                    </a:solidFill>
+                  </a:tcPr>
+                </a:tc>
+                <a:tc>
+                  <a:txBody>
+                    <a:bodyPr/>
+                    <a:lstStyle/>
+                    <a:p>
+                      <a:pPr algn="ctr" indent="0" marL="0">
+                        <a:buNone/>
+                      </a:pPr>
+                      <a:r>
+                        <a:rPr lang="en-US" sz="615" dirty="0">
+                          <a:solidFill>
+                            <a:srgbClr val="1F1F1F"/>
+                          </a:solidFill>
+                          <a:latin typeface="Calibri" pitchFamily="34" charset="0"/>
+                          <a:ea typeface="Calibri" pitchFamily="34" charset="-122"/>
+                          <a:cs typeface="Calibri" pitchFamily="34" charset="-120"/>
+                        </a:rPr>
                         <a:t>R$ 4,5 mi</a:t>
                       </a:r>
                       <a:endParaRPr lang="en-US" sz="615" dirty="0">
@@ -11644,6 +12278,74 @@
                           <a:ea typeface="Calibri" pitchFamily="34" charset="-122"/>
                           <a:cs typeface="Calibri" pitchFamily="34" charset="-120"/>
                         </a:rPr>
+                        <a:t>R$ 0,00</a:t>
+                      </a:r>
+                      <a:endParaRPr lang="en-US" sz="615" dirty="0">
+                        <a:latin typeface="Calibri" charset="0"/>
+                        <a:ea typeface="Calibri" charset="0"/>
+                        <a:cs typeface="Calibri" charset="0"/>
+                      </a:endParaRPr>
+                    </a:p>
+                  </a:txBody>
+                  <a:tcPr marL="36576" marR="36576" marT="18288" marB="18288" anchor="mid">
+                    <a:lnL w="5715" cap="flat" cmpd="sng" algn="ctr">
+                      <a:solidFill>
+                        <a:srgbClr val="FFFFFF"/>
+                      </a:solidFill>
+                      <a:prstDash val="solid"/>
+                      <a:round/>
+                      <a:headEnd type="none" w="med" len="med"/>
+                      <a:tailEnd type="none" w="med" len="med"/>
+                    </a:lnL>
+                    <a:lnR w="5715" cap="flat" cmpd="sng" algn="ctr">
+                      <a:solidFill>
+                        <a:srgbClr val="FFFFFF"/>
+                      </a:solidFill>
+                      <a:prstDash val="solid"/>
+                      <a:round/>
+                      <a:headEnd type="none" w="med" len="med"/>
+                      <a:tailEnd type="none" w="med" len="med"/>
+                    </a:lnR>
+                    <a:lnT w="5715" cap="flat" cmpd="sng" algn="ctr">
+                      <a:solidFill>
+                        <a:srgbClr val="FFFFFF"/>
+                      </a:solidFill>
+                      <a:prstDash val="solid"/>
+                      <a:round/>
+                      <a:headEnd type="none" w="med" len="med"/>
+                      <a:tailEnd type="none" w="med" len="med"/>
+                    </a:lnT>
+                    <a:lnB w="5715" cap="flat" cmpd="sng" algn="ctr">
+                      <a:solidFill>
+                        <a:srgbClr val="FFFFFF"/>
+                      </a:solidFill>
+                      <a:prstDash val="solid"/>
+                      <a:round/>
+                      <a:headEnd type="none" w="med" len="med"/>
+                      <a:tailEnd type="none" w="med" len="med"/>
+                    </a:lnB>
+                    <a:solidFill>
+                      <a:srgbClr val="FFFFFF"/>
+                    </a:solidFill>
+                  </a:tcPr>
+                </a:tc>
+                <a:tc>
+                  <a:txBody>
+                    <a:bodyPr/>
+                    <a:lstStyle/>
+                    <a:p>
+                      <a:pPr algn="ctr" indent="0" marL="0">
+                        <a:buNone/>
+                      </a:pPr>
+                      <a:r>
+                        <a:rPr lang="en-US" sz="615" dirty="0">
+                          <a:solidFill>
+                            <a:srgbClr val="1F1F1F"/>
+                          </a:solidFill>
+                          <a:latin typeface="Calibri" pitchFamily="34" charset="0"/>
+                          <a:ea typeface="Calibri" pitchFamily="34" charset="-122"/>
+                          <a:cs typeface="Calibri" pitchFamily="34" charset="-120"/>
+                        </a:rPr>
                         <a:t>R$ 2,6 mi</a:t>
                       </a:r>
                       <a:endParaRPr lang="en-US" sz="615" dirty="0">
@@ -12190,6 +12892,74 @@
                           <a:ea typeface="Calibri" pitchFamily="34" charset="-122"/>
                           <a:cs typeface="Calibri" pitchFamily="34" charset="-120"/>
                         </a:rPr>
+                        <a:t>R$ 0,00</a:t>
+                      </a:r>
+                      <a:endParaRPr lang="en-US" sz="615" dirty="0">
+                        <a:latin typeface="Calibri" charset="0"/>
+                        <a:ea typeface="Calibri" charset="0"/>
+                        <a:cs typeface="Calibri" charset="0"/>
+                      </a:endParaRPr>
+                    </a:p>
+                  </a:txBody>
+                  <a:tcPr marL="36576" marR="36576" marT="18288" marB="18288" anchor="mid">
+                    <a:lnL w="5715" cap="flat" cmpd="sng" algn="ctr">
+                      <a:solidFill>
+                        <a:srgbClr val="FFFFFF"/>
+                      </a:solidFill>
+                      <a:prstDash val="solid"/>
+                      <a:round/>
+                      <a:headEnd type="none" w="med" len="med"/>
+                      <a:tailEnd type="none" w="med" len="med"/>
+                    </a:lnL>
+                    <a:lnR w="5715" cap="flat" cmpd="sng" algn="ctr">
+                      <a:solidFill>
+                        <a:srgbClr val="FFFFFF"/>
+                      </a:solidFill>
+                      <a:prstDash val="solid"/>
+                      <a:round/>
+                      <a:headEnd type="none" w="med" len="med"/>
+                      <a:tailEnd type="none" w="med" len="med"/>
+                    </a:lnR>
+                    <a:lnT w="5715" cap="flat" cmpd="sng" algn="ctr">
+                      <a:solidFill>
+                        <a:srgbClr val="FFFFFF"/>
+                      </a:solidFill>
+                      <a:prstDash val="solid"/>
+                      <a:round/>
+                      <a:headEnd type="none" w="med" len="med"/>
+                      <a:tailEnd type="none" w="med" len="med"/>
+                    </a:lnT>
+                    <a:lnB w="5715" cap="flat" cmpd="sng" algn="ctr">
+                      <a:solidFill>
+                        <a:srgbClr val="FFFFFF"/>
+                      </a:solidFill>
+                      <a:prstDash val="solid"/>
+                      <a:round/>
+                      <a:headEnd type="none" w="med" len="med"/>
+                      <a:tailEnd type="none" w="med" len="med"/>
+                    </a:lnB>
+                    <a:solidFill>
+                      <a:srgbClr val="F1F1F1"/>
+                    </a:solidFill>
+                  </a:tcPr>
+                </a:tc>
+                <a:tc>
+                  <a:txBody>
+                    <a:bodyPr/>
+                    <a:lstStyle/>
+                    <a:p>
+                      <a:pPr algn="ctr" indent="0" marL="0">
+                        <a:buNone/>
+                      </a:pPr>
+                      <a:r>
+                        <a:rPr lang="en-US" sz="615" dirty="0">
+                          <a:solidFill>
+                            <a:srgbClr val="1F1F1F"/>
+                          </a:solidFill>
+                          <a:latin typeface="Calibri" pitchFamily="34" charset="0"/>
+                          <a:ea typeface="Calibri" pitchFamily="34" charset="-122"/>
+                          <a:cs typeface="Calibri" pitchFamily="34" charset="-120"/>
+                        </a:rPr>
                         <a:t>30,22%</a:t>
                       </a:r>
                       <a:endParaRPr lang="en-US" sz="615" dirty="0">
@@ -12464,6 +13234,74 @@
                           <a:ea typeface="Calibri" pitchFamily="34" charset="-122"/>
                           <a:cs typeface="Calibri" pitchFamily="34" charset="-120"/>
                         </a:rPr>
+                        <a:t>R$ 0,00</a:t>
+                      </a:r>
+                      <a:endParaRPr lang="en-US" sz="615" dirty="0">
+                        <a:latin typeface="Calibri" charset="0"/>
+                        <a:ea typeface="Calibri" charset="0"/>
+                        <a:cs typeface="Calibri" charset="0"/>
+                      </a:endParaRPr>
+                    </a:p>
+                  </a:txBody>
+                  <a:tcPr marL="36576" marR="36576" marT="18288" marB="18288" anchor="mid">
+                    <a:lnL w="5715" cap="flat" cmpd="sng" algn="ctr">
+                      <a:solidFill>
+                        <a:srgbClr val="FFFFFF"/>
+                      </a:solidFill>
+                      <a:prstDash val="solid"/>
+                      <a:round/>
+                      <a:headEnd type="none" w="med" len="med"/>
+                      <a:tailEnd type="none" w="med" len="med"/>
+                    </a:lnL>
+                    <a:lnR w="5715" cap="flat" cmpd="sng" algn="ctr">
+                      <a:solidFill>
+                        <a:srgbClr val="FFFFFF"/>
+                      </a:solidFill>
+                      <a:prstDash val="solid"/>
+                      <a:round/>
+                      <a:headEnd type="none" w="med" len="med"/>
+                      <a:tailEnd type="none" w="med" len="med"/>
+                    </a:lnR>
+                    <a:lnT w="5715" cap="flat" cmpd="sng" algn="ctr">
+                      <a:solidFill>
+                        <a:srgbClr val="FFFFFF"/>
+                      </a:solidFill>
+                      <a:prstDash val="solid"/>
+                      <a:round/>
+                      <a:headEnd type="none" w="med" len="med"/>
+                      <a:tailEnd type="none" w="med" len="med"/>
+                    </a:lnT>
+                    <a:lnB w="5715" cap="flat" cmpd="sng" algn="ctr">
+                      <a:solidFill>
+                        <a:srgbClr val="FFFFFF"/>
+                      </a:solidFill>
+                      <a:prstDash val="solid"/>
+                      <a:round/>
+                      <a:headEnd type="none" w="med" len="med"/>
+                      <a:tailEnd type="none" w="med" len="med"/>
+                    </a:lnB>
+                    <a:solidFill>
+                      <a:srgbClr val="FFFFFF"/>
+                    </a:solidFill>
+                  </a:tcPr>
+                </a:tc>
+                <a:tc>
+                  <a:txBody>
+                    <a:bodyPr/>
+                    <a:lstStyle/>
+                    <a:p>
+                      <a:pPr algn="ctr" indent="0" marL="0">
+                        <a:buNone/>
+                      </a:pPr>
+                      <a:r>
+                        <a:rPr lang="en-US" sz="615" dirty="0">
+                          <a:solidFill>
+                            <a:srgbClr val="1F1F1F"/>
+                          </a:solidFill>
+                          <a:latin typeface="Calibri" pitchFamily="34" charset="0"/>
+                          <a:ea typeface="Calibri" pitchFamily="34" charset="-122"/>
+                          <a:cs typeface="Calibri" pitchFamily="34" charset="-120"/>
+                        </a:rPr>
                         <a:t>R$ 2,8 mi</a:t>
                       </a:r>
                       <a:endParaRPr lang="en-US" sz="615" dirty="0">
@@ -12739,6 +13577,74 @@
                           <a:cs typeface="Calibri" pitchFamily="34" charset="-120"/>
                         </a:rPr>
                         <a:t>R$ 68,1 mi</a:t>
+                      </a:r>
+                      <a:endParaRPr lang="en-US" sz="615" dirty="0">
+                        <a:latin typeface="Calibri" charset="0"/>
+                        <a:ea typeface="Calibri" charset="0"/>
+                        <a:cs typeface="Calibri" charset="0"/>
+                      </a:endParaRPr>
+                    </a:p>
+                  </a:txBody>
+                  <a:tcPr marL="36576" marR="36576" marT="18288" marB="18288" anchor="mid">
+                    <a:lnL w="5715" cap="flat" cmpd="sng" algn="ctr">
+                      <a:solidFill>
+                        <a:srgbClr val="FFFFFF"/>
+                      </a:solidFill>
+                      <a:prstDash val="solid"/>
+                      <a:round/>
+                      <a:headEnd type="none" w="med" len="med"/>
+                      <a:tailEnd type="none" w="med" len="med"/>
+                    </a:lnL>
+                    <a:lnR w="5715" cap="flat" cmpd="sng" algn="ctr">
+                      <a:solidFill>
+                        <a:srgbClr val="FFFFFF"/>
+                      </a:solidFill>
+                      <a:prstDash val="solid"/>
+                      <a:round/>
+                      <a:headEnd type="none" w="med" len="med"/>
+                      <a:tailEnd type="none" w="med" len="med"/>
+                    </a:lnR>
+                    <a:lnT w="5715" cap="flat" cmpd="sng" algn="ctr">
+                      <a:solidFill>
+                        <a:srgbClr val="FFFFFF"/>
+                      </a:solidFill>
+                      <a:prstDash val="solid"/>
+                      <a:round/>
+                      <a:headEnd type="none" w="med" len="med"/>
+                      <a:tailEnd type="none" w="med" len="med"/>
+                    </a:lnT>
+                    <a:lnB w="5715" cap="flat" cmpd="sng" algn="ctr">
+                      <a:solidFill>
+                        <a:srgbClr val="FFFFFF"/>
+                      </a:solidFill>
+                      <a:prstDash val="solid"/>
+                      <a:round/>
+                      <a:headEnd type="none" w="med" len="med"/>
+                      <a:tailEnd type="none" w="med" len="med"/>
+                    </a:lnB>
+                    <a:solidFill>
+                      <a:srgbClr val="F1F1F1"/>
+                    </a:solidFill>
+                  </a:tcPr>
+                </a:tc>
+                <a:tc>
+                  <a:txBody>
+                    <a:bodyPr/>
+                    <a:lstStyle/>
+                    <a:p>
+                      <a:pPr algn="ctr" indent="0" marL="0">
+                        <a:buNone/>
+                      </a:pPr>
+                      <a:r>
+                        <a:rPr lang="en-US" sz="615" dirty="0">
+                          <a:solidFill>
+                            <a:srgbClr val="1F1F1F"/>
+                          </a:solidFill>
+                          <a:latin typeface="Calibri" pitchFamily="34" charset="0"/>
+                          <a:ea typeface="Calibri" pitchFamily="34" charset="-122"/>
+                          <a:cs typeface="Calibri" pitchFamily="34" charset="-120"/>
+                        </a:rPr>
+                        <a:t>R$ 0,00</a:t>
                       </a:r>
                       <a:endParaRPr lang="en-US" sz="615" dirty="0">
                         <a:latin typeface="Calibri" charset="0"/>
@@ -13101,7 +14007,7 @@
                 <a:ea typeface="Calibri" pitchFamily="34" charset="-122"/>
                 <a:cs typeface="Calibri" pitchFamily="34" charset="-120"/>
               </a:rPr>
-              <a:t>Leitura: giro do principal não aumenta o denominador; a originada acumulada cresce apenas com excesso de caixa reinvestido.</a:t>
+              <a:t>Leitura: giro do principal não aumenta o denominador; excesso retido por limite fica em caixa/PL.</a:t>
             </a:r>
             <a:endParaRPr lang="en-US" sz="840" dirty="0"/>
           </a:p>
@@ -14134,7 +15040,7 @@
                 <a:ea typeface="Calibri" pitchFamily="34" charset="-122"/>
                 <a:cs typeface="Calibri" pitchFamily="34" charset="-120"/>
               </a:rPr>
-              <a:t>R$ 12,2 bi</a:t>
+              <a:t>R$ 1 bi</a:t>
             </a:r>
             <a:endParaRPr lang="en-US" sz="800" dirty="0"/>
           </a:p>
@@ -14291,7 +15197,7 @@
                 <a:ea typeface="Calibri" pitchFamily="34" charset="-122"/>
                 <a:cs typeface="Calibri" pitchFamily="34" charset="-120"/>
               </a:rPr>
-              <a:t>R$ 17,2 bi</a:t>
+              <a:t>R$ 3,7 bi</a:t>
             </a:r>
             <a:endParaRPr lang="en-US" sz="800" dirty="0"/>
           </a:p>
@@ -14448,7 +15354,7 @@
                 <a:ea typeface="Calibri" pitchFamily="34" charset="-122"/>
                 <a:cs typeface="Calibri" pitchFamily="34" charset="-120"/>
               </a:rPr>
-              <a:t>141,24%</a:t>
+              <a:t>366,97%</a:t>
             </a:r>
             <a:endParaRPr lang="en-US" sz="800" dirty="0"/>
           </a:p>
@@ -14628,7 +15534,7 @@
                 <a:ea typeface="Calibri" pitchFamily="34" charset="-122"/>
                 <a:cs typeface="Calibri" pitchFamily="34" charset="-120"/>
               </a:rPr>
-              <a:t>•  PDD: 40% da carteira provisionado em 3 meses até Over90.</a:t>
+              <a:t>•  Receita inicial cobre PDD: R$ 118,9 mi / R$ 133,3 mi = 0,9x.</a:t>
             </a:r>
             <a:endParaRPr lang="en-US" sz="1000" dirty="0"/>
           </a:p>
@@ -14645,7 +15551,7 @@
                 <a:ea typeface="Calibri" pitchFamily="34" charset="-122"/>
                 <a:cs typeface="Calibri" pitchFamily="34" charset="-120"/>
               </a:rPr>
-              <a:t>•  Nova originação incremental usa apenas excesso de caixa positivo.</a:t>
+              <a:t>•  Limite de estoque: R$ 1 bi; excesso retido: R$ 0,00.</a:t>
             </a:r>
             <a:endParaRPr lang="en-US" sz="1000" dirty="0"/>
           </a:p>
@@ -14662,7 +15568,7 @@
                 <a:ea typeface="Calibri" pitchFamily="34" charset="-122"/>
                 <a:cs typeface="Calibri" pitchFamily="34" charset="-120"/>
               </a:rPr>
-              <a:t>•  Cards s/ perdas usam cenário paralelo sem PDD; gráfico abaixo usa cenário com perdas.</a:t>
+              <a:t>•  Caixa final aplicado/retido: R$ 0,00.</a:t>
             </a:r>
             <a:endParaRPr lang="en-US" sz="1000" dirty="0"/>
           </a:p>

</xml_diff>

<commit_message>
Corrige stress de perda 50 no grafico MC3
</commit_message>
<xml_diff>
--- a/outputs/modelo_fidc_mc3_comite_trava_30.pptx
+++ b/outputs/modelo_fidc_mc3_comite_trava_30.pptx
@@ -719,76 +719,76 @@
                   <c:v>300</c:v>
                 </c:pt>
                 <c:pt idx="1">
-                  <c:v>411.5190458992693</c:v>
+                  <c:v>299.99999999999994</c:v>
                 </c:pt>
                 <c:pt idx="2">
-                  <c:v>545.8182220517353</c:v>
+                  <c:v>300</c:v>
                 </c:pt>
                 <c:pt idx="3">
-                  <c:v>669.5261137266235</c:v>
+                  <c:v>300</c:v>
                 </c:pt>
                 <c:pt idx="4">
-                  <c:v>760.0619106309151</c:v>
+                  <c:v>304.50917027707686</c:v>
                 </c:pt>
                 <c:pt idx="5">
-                  <c:v>852.7345681468702</c:v>
+                  <c:v>307.1566830895734</c:v>
                 </c:pt>
                 <c:pt idx="6">
-                  <c:v>940.3565164565254</c:v>
+                  <c:v>303.09409257726134</c:v>
                 </c:pt>
                 <c:pt idx="7">
-                  <c:v>1044.8362893439592</c:v>
+                  <c:v>305.8688077874529</c:v>
                 </c:pt>
                 <c:pt idx="8">
-                  <c:v>1136.791464261285</c:v>
+                  <c:v>300</c:v>
                 </c:pt>
                 <c:pt idx="9">
-                  <c:v>1230.9255443039924</c:v>
+                  <c:v>300</c:v>
                 </c:pt>
                 <c:pt idx="10">
-                  <c:v>1319.5913162557595</c:v>
+                  <c:v>299.99999999999994</c:v>
                 </c:pt>
                 <c:pt idx="11">
-                  <c:v>1402.5268998935026</c:v>
+                  <c:v>300</c:v>
                 </c:pt>
                 <c:pt idx="12">
-                  <c:v>1503.3748897632895</c:v>
+                  <c:v>300</c:v>
                 </c:pt>
                 <c:pt idx="13">
-                  <c:v>1598.433670460236</c:v>
+                  <c:v>299.99999999999994</c:v>
                 </c:pt>
                 <c:pt idx="14">
-                  <c:v>1695.2892601539245</c:v>
+                  <c:v>299.99999999999994</c:v>
                 </c:pt>
                 <c:pt idx="15">
-                  <c:v>1793.7936879135061</c:v>
+                  <c:v>300</c:v>
                 </c:pt>
                 <c:pt idx="16">
-                  <c:v>1910.9181935533147</c:v>
+                  <c:v>300</c:v>
                 </c:pt>
                 <c:pt idx="17">
-                  <c:v>2021.7631248416371</c:v>
+                  <c:v>299.99999999999994</c:v>
                 </c:pt>
                 <c:pt idx="18">
-                  <c:v>2144.435722630061</c:v>
+                  <c:v>300</c:v>
                 </c:pt>
                 <c:pt idx="19">
-                  <c:v>2242.95236899374</c:v>
+                  <c:v>290.8757210485456</c:v>
                 </c:pt>
                 <c:pt idx="20">
-                  <c:v>2299.658991134761</c:v>
+                  <c:v>284.1395009646291</c:v>
                 </c:pt>
                 <c:pt idx="21">
-                  <c:v>2349.3170048667985</c:v>
+                  <c:v>278.2128462309053</c:v>
                 </c:pt>
                 <c:pt idx="22">
-                  <c:v>2386.6874309924106</c:v>
+                  <c:v>273.9433092415145</c:v>
                 </c:pt>
                 <c:pt idx="23">
-                  <c:v>2412.7822348203326</c:v>
+                  <c:v>271.19383766114544</c:v>
                 </c:pt>
                 <c:pt idx="24">
-                  <c:v>2439.81907675824</c:v>
+                  <c:v>269.6585947024095</c:v>
                 </c:pt>
               </c:numCache>
             </c:numRef>
@@ -1410,76 +1410,76 @@
                 <c:formatCode>General</c:formatCode>
                 <c:ptCount val="24"/>
                 <c:pt idx="0">
-                  <c:v>0.35531938250793377</c:v>
+                  <c:v>0.35532028128893556</c:v>
                 </c:pt>
                 <c:pt idx="1">
-                  <c:v>0.4138891280458993</c:v>
+                  <c:v>0.41388878258936646</c:v>
                 </c:pt>
                 <c:pt idx="2">
-                  <c:v>0.45183260077616044</c:v>
+                  <c:v>0.4518326029785575</c:v>
                 </c:pt>
                 <c:pt idx="3">
-                  <c:v>0.49607414953617546</c:v>
+                  <c:v>0.496074151536955</c:v>
                 </c:pt>
                 <c:pt idx="4">
-                  <c:v>0.533464899454743</c:v>
+                  <c:v>0.5334649012883411</c:v>
                 </c:pt>
                 <c:pt idx="5">
-                  <c:v>0.5619849806394872</c:v>
+                  <c:v>0.561980400661805</c:v>
                 </c:pt>
                 <c:pt idx="6">
-                  <c:v>0.5937839867022942</c:v>
+                  <c:v>0.5937809335655025</c:v>
                 </c:pt>
                 <c:pt idx="7">
-                  <c:v>0.61544474921246</c:v>
+                  <c:v>0.6154478043478446</c:v>
                 </c:pt>
                 <c:pt idx="8">
-                  <c:v>0.6348775415350533</c:v>
+                  <c:v>0.6348873905535913</c:v>
                 </c:pt>
                 <c:pt idx="9">
-                  <c:v>0.6496307526918621</c:v>
+                  <c:v>0.6496308204374076</c:v>
                 </c:pt>
                 <c:pt idx="10">
-                  <c:v>0.6604564832974147</c:v>
+                  <c:v>0.6604565473416335</c:v>
                 </c:pt>
                 <c:pt idx="11">
-                  <c:v>0.6757441737407156</c:v>
+                  <c:v>0.6757421646493329</c:v>
                 </c:pt>
                 <c:pt idx="12">
-                  <c:v>0.6874067602693429</c:v>
+                  <c:v>0.6874067976515464</c:v>
                 </c:pt>
                 <c:pt idx="13">
-                  <c:v>0.698383363819778</c:v>
+                  <c:v>0.6983833994642017</c:v>
                 </c:pt>
                 <c:pt idx="14">
-                  <c:v>0.7087202307535998</c:v>
+                  <c:v>0.7087202648198763</c:v>
                 </c:pt>
                 <c:pt idx="15">
-                  <c:v>0.7229113693087696</c:v>
+                  <c:v>0.7229130067926535</c:v>
                 </c:pt>
                 <c:pt idx="16">
-                  <c:v>0.7342050175417882</c:v>
+                  <c:v>0.7342043324065556</c:v>
                 </c:pt>
                 <c:pt idx="17">
-                  <c:v>0.7852736348620859</c:v>
+                  <c:v>0.7852785261673522</c:v>
                 </c:pt>
                 <c:pt idx="18">
-                  <c:v>0.830553194577918</c:v>
+                  <c:v>0.8305577074154066</c:v>
                 </c:pt>
                 <c:pt idx="19">
-                  <c:v>0.8661829070556077</c:v>
+                  <c:v>0.866185909109282</c:v>
                 </c:pt>
                 <c:pt idx="20">
-                  <c:v>0.900990255708556</c:v>
+                  <c:v>0.9009889474147746</c:v>
                 </c:pt>
                 <c:pt idx="21">
-                  <c:v>0.9312474581254311</c:v>
+                  <c:v>0.9312481157134902</c:v>
                 </c:pt>
                 <c:pt idx="22">
-                  <c:v>0.9571347061474391</c:v>
+                  <c:v>0.9571360520638265</c:v>
                 </c:pt>
                 <c:pt idx="23">
-                  <c:v>0.9825909765362755</c:v>
+                  <c:v>0.9825922600903996</c:v>
                 </c:pt>
               </c:numCache>
             </c:numRef>
@@ -1644,76 +1644,76 @@
                 <c:formatCode>General</c:formatCode>
                 <c:ptCount val="24"/>
                 <c:pt idx="0">
-                  <c:v>0.3643066573247061</c:v>
+                  <c:v>0.2977580394682725</c:v>
                 </c:pt>
                 <c:pt idx="1">
-                  <c:v>0.43278568027875697</c:v>
+                  <c:v>0.31150658038790974</c:v>
                 </c:pt>
                 <c:pt idx="2">
-                  <c:v>0.48002685708621584</c:v>
+                  <c:v>0.31343118563634753</c:v>
                 </c:pt>
                 <c:pt idx="3">
-                  <c:v>0.5153095801350509</c:v>
+                  <c:v>0.31648964763067633</c:v>
                 </c:pt>
                 <c:pt idx="4">
-                  <c:v>0.5458826246667815</c:v>
+                  <c:v>0.31884200796203</c:v>
                 </c:pt>
                 <c:pt idx="5">
-                  <c:v>0.5687389613151401</c:v>
+                  <c:v>0.31845500745571914</c:v>
                 </c:pt>
                 <c:pt idx="6">
-                  <c:v>0.5966977277066091</c:v>
+                  <c:v>0.32222059252586877</c:v>
                 </c:pt>
                 <c:pt idx="7">
-                  <c:v>0.614601040202578</c:v>
+                  <c:v>0.32161128899806996</c:v>
                 </c:pt>
                 <c:pt idx="8">
-                  <c:v>0.6308977647522341</c:v>
+                  <c:v>0.3210916883298545</c:v>
                 </c:pt>
                 <c:pt idx="9">
-                  <c:v>0.6426340426472543</c:v>
+                  <c:v>0.31902821670816034</c:v>
                 </c:pt>
                 <c:pt idx="10">
-                  <c:v>0.650473264464868</c:v>
+                  <c:v>0.31574425512746684</c:v>
                 </c:pt>
                 <c:pt idx="11">
-                  <c:v>0.6638269960013204</c:v>
+                  <c:v>0.31567271169811906</c:v>
                 </c:pt>
                 <c:pt idx="12">
-                  <c:v>0.6667617289441501</c:v>
+                  <c:v>0.31428831462521056</c:v>
                 </c:pt>
                 <c:pt idx="13">
-                  <c:v>0.6696889104936935</c:v>
+                  <c:v>0.3130805866683232</c:v>
                 </c:pt>
                 <c:pt idx="14">
-                  <c:v>0.6725550845337198</c:v>
+                  <c:v>0.3119924505957278</c:v>
                 </c:pt>
                 <c:pt idx="15">
-                  <c:v>0.6802858594536576</c:v>
+                  <c:v>0.31317309355908146</c:v>
                 </c:pt>
                 <c:pt idx="16">
-                  <c:v>0.6852522336057867</c:v>
+                  <c:v>0.3132408008678476</c:v>
                 </c:pt>
                 <c:pt idx="17">
-                  <c:v>0.730451075028922</c:v>
+                  <c:v>0.329835107461231</c:v>
                 </c:pt>
                 <c:pt idx="18">
-                  <c:v>0.7691195715799184</c:v>
+                  <c:v>0.3430691763787842</c:v>
                 </c:pt>
                 <c:pt idx="19">
-                  <c:v>0.7966840873161174</c:v>
+                  <c:v>0.3507475950530244</c:v>
                 </c:pt>
                 <c:pt idx="20">
-                  <c:v>0.8228176536262455</c:v>
+                  <c:v>0.3579679495809608</c:v>
                 </c:pt>
                 <c:pt idx="21">
-                  <c:v>0.8447862201659263</c:v>
+                  <c:v>0.36277185361004055</c:v>
                 </c:pt>
                 <c:pt idx="22">
-                  <c:v>0.8627893861045599</c:v>
+                  <c:v>0.36587183524654665</c:v>
                 </c:pt>
                 <c:pt idx="23">
-                  <c:v>0.8806638411303136</c:v>
+                  <c:v>0.36858409468093983</c:v>
                 </c:pt>
               </c:numCache>
             </c:numRef>
@@ -1878,76 +1878,76 @@
                 <c:formatCode>General</c:formatCode>
                 <c:ptCount val="24"/>
                 <c:pt idx="0">
-                  <c:v>0.368972968296308</c:v>
+                  <c:v>0.2698598680085226</c:v>
                 </c:pt>
                 <c:pt idx="1">
-                  <c:v>0.4428961292776709</c:v>
+                  <c:v>0.2603368227991252</c:v>
                 </c:pt>
                 <c:pt idx="2">
-                  <c:v>0.49548596548718493</c:v>
+                  <c:v>0.24424283545045805</c:v>
                 </c:pt>
                 <c:pt idx="3">
-                  <c:v>0.5260734041386572</c:v>
+                  <c:v>0.24045818887851528</c:v>
                 </c:pt>
                 <c:pt idx="4">
-                  <c:v>0.5529518572212431</c:v>
+                  <c:v>0.23734007111571204</c:v>
                 </c:pt>
                 <c:pt idx="5">
-                  <c:v>0.5726408801213352</c:v>
+                  <c:v>0.23232068588095112</c:v>
                 </c:pt>
                 <c:pt idx="6">
-                  <c:v>0.598402622870002</c:v>
+                  <c:v>0.2320903116461056</c:v>
                 </c:pt>
                 <c:pt idx="7">
-                  <c:v>0.6141018450273329</c:v>
+                  <c:v>0.2281967638123475</c:v>
                 </c:pt>
                 <c:pt idx="8">
-                  <c:v>0.6285198629500509</c:v>
+                  <c:v>0.22475854930987152</c:v>
                 </c:pt>
                 <c:pt idx="9">
-                  <c:v>0.6384169874656185</c:v>
+                  <c:v>0.22039869688269484</c:v>
                 </c:pt>
                 <c:pt idx="10">
-                  <c:v>0.6444091881601676</c:v>
+                  <c:v>0.2154680112030049</c:v>
                 </c:pt>
                 <c:pt idx="11">
-                  <c:v>0.6565373724025745</c:v>
+                  <c:v>0.21290992970531977</c:v>
                 </c:pt>
                 <c:pt idx="12">
-                  <c:v>0.6542559260564179</c:v>
+                  <c:v>0.20970832538801493</c:v>
                 </c:pt>
                 <c:pt idx="13">
-                  <c:v>0.6524581035407182</c:v>
+                  <c:v>0.20677665482708163</c:v>
                 </c:pt>
                 <c:pt idx="14">
-                  <c:v>0.6510079386436183</c:v>
+                  <c:v>0.2040153767322715</c:v>
                 </c:pt>
                 <c:pt idx="15">
-                  <c:v>0.6550692348805879</c:v>
+                  <c:v>0.2021823281852391</c:v>
                 </c:pt>
                 <c:pt idx="16">
-                  <c:v>0.6564786349047376</c:v>
+                  <c:v>0.20001707501228402</c:v>
                 </c:pt>
                 <c:pt idx="17">
-                  <c:v>0.6982273237001728</c:v>
+                  <c:v>0.20003492464127084</c:v>
                 </c:pt>
                 <c:pt idx="18">
-                  <c:v>0.7330095587366693</c:v>
+                  <c:v>0.1992053714807535</c:v>
                 </c:pt>
                 <c:pt idx="19">
-                  <c:v>0.7558375923926345</c:v>
+                  <c:v>0.1976894452022828</c:v>
                 </c:pt>
                 <c:pt idx="20">
-                  <c:v>0.7768821589598052</c:v>
+                  <c:v>0.19637175599196519</c:v>
                 </c:pt>
                 <c:pt idx="21">
-                  <c:v>0.7939494569059435</c:v>
+                  <c:v>0.19518150761368974</c:v>
                 </c:pt>
                 <c:pt idx="22">
-                  <c:v>0.8072823281219291</c:v>
+                  <c:v>0.19429106604436522</c:v>
                 </c:pt>
                 <c:pt idx="23">
-                  <c:v>0.8206794809092743</c:v>
+                  <c:v>0.19373682197404593</c:v>
                 </c:pt>
               </c:numCache>
             </c:numRef>
@@ -2112,76 +2112,76 @@
                 <c:formatCode>General</c:formatCode>
                 <c:ptCount val="24"/>
                 <c:pt idx="0">
-                  <c:v>0.37376036945317126</c:v>
+                  <c:v>0.26249999999999996</c:v>
                 </c:pt>
                 <c:pt idx="1">
-                  <c:v>0.4534902649059153</c:v>
+                  <c:v>0.2333333333333333</c:v>
                 </c:pt>
                 <c:pt idx="2">
-                  <c:v>0.5119739185861738</c:v>
+                  <c:v>0.20999999999999996</c:v>
                 </c:pt>
                 <c:pt idx="3">
-                  <c:v>0.5377277248268592</c:v>
+                  <c:v>0.19322411172633283</c:v>
                 </c:pt>
                 <c:pt idx="4">
-                  <c:v>0.5607057774557781</c:v>
+                  <c:v>0.18035799116594556</c:v>
                 </c:pt>
                 <c:pt idx="5">
-                  <c:v>0.5769692447303715</c:v>
+                  <c:v>0.16756424118843788</c:v>
                 </c:pt>
                 <c:pt idx="6">
-                  <c:v>0.6003126591553253</c:v>
+                  <c:v>0.16112481167465248</c:v>
                 </c:pt>
                 <c:pt idx="7">
-                  <c:v>0.6135376652582577</c:v>
+                  <c:v>0.1525615033973333</c:v>
                 </c:pt>
                 <c:pt idx="8">
-                  <c:v>0.6258113572951561</c:v>
+                  <c:v>0.1486685491503644</c:v>
                 </c:pt>
                 <c:pt idx="9">
-                  <c:v>0.6335799066896851</c:v>
+                  <c:v>0.14596418454082927</c:v>
                 </c:pt>
                 <c:pt idx="10">
-                  <c:v>0.6374095123731796</c:v>
+                  <c:v>0.14415308872665203</c:v>
                 </c:pt>
                 <c:pt idx="11">
-                  <c:v>0.6480748386301295</c:v>
+                  <c:v>0.1430025319525646</c:v>
                 </c:pt>
                 <c:pt idx="12">
-                  <c:v>0.6398529918955544</c:v>
+                  <c:v>0.14233230955029177</c:v>
                 </c:pt>
                 <c:pt idx="13">
-                  <c:v>0.6327527564236708</c:v>
+                  <c:v>0.14200261816996262</c:v>
                 </c:pt>
                 <c:pt idx="14">
-                  <c:v>0.6265207758300677</c:v>
+                  <c:v>0.1419051782942121</c:v>
                 </c:pt>
                 <c:pt idx="15">
-                  <c:v>0.626573076466686</c:v>
+                  <c:v>0.14189126922707984</c:v>
                 </c:pt>
                 <c:pt idx="16">
-                  <c:v>0.6241279327722391</c:v>
+                  <c:v>0.1418892824400692</c:v>
                 </c:pt>
                 <c:pt idx="17">
-                  <c:v>0.6619975496055593</c:v>
+                  <c:v>0.14188928244006924</c:v>
                 </c:pt>
                 <c:pt idx="18">
-                  <c:v>0.692410108862932</c:v>
+                  <c:v>0.1375738244627196</c:v>
                 </c:pt>
                 <c:pt idx="19">
-                  <c:v>0.709915713954104</c:v>
+                  <c:v>0.1343878330158353</c:v>
                 </c:pt>
                 <c:pt idx="20">
-                  <c:v>0.7252453799645966</c:v>
+                  <c:v>0.13158473705770823</c:v>
                 </c:pt>
                 <c:pt idx="21">
-                  <c:v>0.7367818089942946</c:v>
+                  <c:v>0.12956539859178826</c:v>
                 </c:pt>
                 <c:pt idx="22">
-                  <c:v>0.7448373995672475</c:v>
+                  <c:v>0.12826499675969516</c:v>
                 </c:pt>
                 <c:pt idx="23">
-                  <c:v>0.7531838018040169</c:v>
+                  <c:v>0.12753888168707447</c:v>
                 </c:pt>
               </c:numCache>
             </c:numRef>
@@ -2346,76 +2346,76 @@
                 <c:formatCode>General</c:formatCode>
                 <c:ptCount val="24"/>
                 <c:pt idx="0">
-                  <c:v>0.37376036945317126</c:v>
+                  <c:v>0.2625</c:v>
                 </c:pt>
                 <c:pt idx="1">
-                  <c:v>0.4534902649059153</c:v>
+                  <c:v>0.2333333333333333</c:v>
                 </c:pt>
                 <c:pt idx="2">
-                  <c:v>0.5119739185861738</c:v>
+                  <c:v>0.20999999999999996</c:v>
                 </c:pt>
                 <c:pt idx="3">
-                  <c:v>0.5377277248268592</c:v>
+                  <c:v>0.1909090909090909</c:v>
                 </c:pt>
                 <c:pt idx="4">
-                  <c:v>0.5607057774557781</c:v>
+                  <c:v>0.17746478873239432</c:v>
                 </c:pt>
                 <c:pt idx="5">
-                  <c:v>0.5769692447303715</c:v>
+                  <c:v>0.16799999999999995</c:v>
                 </c:pt>
                 <c:pt idx="6">
-                  <c:v>0.6003126591553253</c:v>
+                  <c:v>0.16153846153846146</c:v>
                 </c:pt>
                 <c:pt idx="7">
-                  <c:v>0.6135376652582577</c:v>
+                  <c:v>0.15749999999999995</c:v>
                 </c:pt>
                 <c:pt idx="8">
-                  <c:v>0.6258113572951561</c:v>
+                  <c:v>0.15523613963039012</c:v>
                 </c:pt>
                 <c:pt idx="9">
-                  <c:v>0.6335799066896851</c:v>
+                  <c:v>0.15428571428571428</c:v>
                 </c:pt>
                 <c:pt idx="10">
-                  <c:v>0.6374095123731796</c:v>
+                  <c:v>0.15415088843577046</c:v>
                 </c:pt>
                 <c:pt idx="11">
-                  <c:v>0.6480748386301295</c:v>
+                  <c:v>0.1541316468336523</c:v>
                 </c:pt>
                 <c:pt idx="12">
-                  <c:v>0.6398529918955544</c:v>
+                  <c:v>0.15412889842547295</c:v>
                 </c:pt>
                 <c:pt idx="13">
-                  <c:v>0.6327527564236708</c:v>
+                  <c:v>0.1541285058037344</c:v>
                 </c:pt>
                 <c:pt idx="14">
-                  <c:v>0.6265207758300677</c:v>
+                  <c:v>0.15412844971507794</c:v>
                 </c:pt>
                 <c:pt idx="15">
-                  <c:v>0.626573076466686</c:v>
+                  <c:v>0.15412844170241607</c:v>
                 </c:pt>
                 <c:pt idx="16">
-                  <c:v>0.6241279327722391</c:v>
+                  <c:v>0.15412844055775016</c:v>
                 </c:pt>
                 <c:pt idx="17">
-                  <c:v>0.6619975496055593</c:v>
+                  <c:v>0.15412844055775016</c:v>
                 </c:pt>
                 <c:pt idx="18">
-                  <c:v>0.692410108862932</c:v>
+                  <c:v>0.1496682574103539</c:v>
                 </c:pt>
                 <c:pt idx="19">
-                  <c:v>0.709915713954104</c:v>
+                  <c:v>0.1462073808339993</c:v>
                 </c:pt>
                 <c:pt idx="20">
-                  <c:v>0.7252453799645966</c:v>
+                  <c:v>0.14316242776012045</c:v>
                 </c:pt>
                 <c:pt idx="21">
-                  <c:v>0.7367818089942946</c:v>
+                  <c:v>0.14096883795137777</c:v>
                 </c:pt>
                 <c:pt idx="22">
-                  <c:v>0.7448373995672475</c:v>
+                  <c:v>0.13955619919871126</c:v>
                 </c:pt>
                 <c:pt idx="23">
-                  <c:v>0.7531838018040169</c:v>
+                  <c:v>0.1387673843450973</c:v>
                 </c:pt>
               </c:numCache>
             </c:numRef>
@@ -8658,7 +8658,7 @@
                           <a:ea typeface="Calibri" pitchFamily="34" charset="-122"/>
                           <a:cs typeface="Calibri" pitchFamily="34" charset="-120"/>
                         </a:rPr>
-                        <a:t>-0,00</a:t>
+                        <a:t>-13,33</a:t>
                       </a:r>
                       <a:endParaRPr lang="en-US" sz="620" dirty="0">
                         <a:latin typeface="Calibri" charset="0"/>
@@ -8726,7 +8726,7 @@
                           <a:ea typeface="Calibri" pitchFamily="34" charset="-122"/>
                           <a:cs typeface="Calibri" pitchFamily="34" charset="-120"/>
                         </a:rPr>
-                        <a:t>Sem Over90 no M1</a:t>
+                        <a:t>100% do NPL 90-360</a:t>
                       </a:r>
                       <a:endParaRPr lang="en-US" sz="620" dirty="0">
                         <a:latin typeface="Calibri" charset="0"/>
@@ -9276,7 +9276,7 @@
                           <a:ea typeface="Calibri" pitchFamily="34" charset="-122"/>
                           <a:cs typeface="Calibri" pitchFamily="34" charset="-120"/>
                         </a:rPr>
-                        <a:t>11,15</a:t>
+                        <a:t>-2,18</a:t>
                       </a:r>
                       <a:endParaRPr lang="en-US" sz="620" dirty="0">
                         <a:latin typeface="Calibri" charset="0"/>
@@ -9344,7 +9344,7 @@
                           <a:ea typeface="Calibri" pitchFamily="34" charset="-122"/>
                           <a:cs typeface="Calibri" pitchFamily="34" charset="-120"/>
                         </a:rPr>
-                        <a:t>Target estoque: R$ 1 bi</a:t>
+                        <a:t>Compra nova safra até target; saldo fica em caixa</a:t>
                       </a:r>
                       <a:endParaRPr lang="en-US" sz="620" dirty="0">
                         <a:latin typeface="Calibri" charset="0"/>
@@ -11568,211 +11568,7 @@
                           <a:ea typeface="Calibri" pitchFamily="34" charset="-122"/>
                           <a:cs typeface="Calibri" pitchFamily="34" charset="-120"/>
                         </a:rPr>
-                        <a:t>R$ 85,7 mi</a:t>
-                      </a:r>
-                      <a:endParaRPr lang="en-US" sz="615" dirty="0">
-                        <a:latin typeface="Calibri" charset="0"/>
-                        <a:ea typeface="Calibri" charset="0"/>
-                        <a:cs typeface="Calibri" charset="0"/>
-                      </a:endParaRPr>
-                    </a:p>
-                  </a:txBody>
-                  <a:tcPr marL="36576" marR="36576" marT="18288" marB="18288" anchor="mid">
-                    <a:lnL w="5715" cap="flat" cmpd="sng" algn="ctr">
-                      <a:solidFill>
-                        <a:srgbClr val="FFFFFF"/>
-                      </a:solidFill>
-                      <a:prstDash val="solid"/>
-                      <a:round/>
-                      <a:headEnd type="none" w="med" len="med"/>
-                      <a:tailEnd type="none" w="med" len="med"/>
-                    </a:lnL>
-                    <a:lnR w="5715" cap="flat" cmpd="sng" algn="ctr">
-                      <a:solidFill>
-                        <a:srgbClr val="FFFFFF"/>
-                      </a:solidFill>
-                      <a:prstDash val="solid"/>
-                      <a:round/>
-                      <a:headEnd type="none" w="med" len="med"/>
-                      <a:tailEnd type="none" w="med" len="med"/>
-                    </a:lnR>
-                    <a:lnT w="5715" cap="flat" cmpd="sng" algn="ctr">
-                      <a:solidFill>
-                        <a:srgbClr val="FFFFFF"/>
-                      </a:solidFill>
-                      <a:prstDash val="solid"/>
-                      <a:round/>
-                      <a:headEnd type="none" w="med" len="med"/>
-                      <a:tailEnd type="none" w="med" len="med"/>
-                    </a:lnT>
-                    <a:lnB w="5715" cap="flat" cmpd="sng" algn="ctr">
-                      <a:solidFill>
-                        <a:srgbClr val="FFFFFF"/>
-                      </a:solidFill>
-                      <a:prstDash val="solid"/>
-                      <a:round/>
-                      <a:headEnd type="none" w="med" len="med"/>
-                      <a:tailEnd type="none" w="med" len="med"/>
-                    </a:lnB>
-                    <a:solidFill>
-                      <a:srgbClr val="FFFFFF"/>
-                    </a:solidFill>
-                  </a:tcPr>
-                </a:tc>
-                <a:tc>
-                  <a:txBody>
-                    <a:bodyPr/>
-                    <a:lstStyle/>
-                    <a:p>
-                      <a:pPr algn="ctr" indent="0" marL="0">
-                        <a:buNone/>
-                      </a:pPr>
-                      <a:r>
-                        <a:rPr lang="en-US" sz="615" dirty="0">
-                          <a:solidFill>
-                            <a:srgbClr val="1F1F1F"/>
-                          </a:solidFill>
-                          <a:latin typeface="Calibri" pitchFamily="34" charset="0"/>
-                          <a:ea typeface="Calibri" pitchFamily="34" charset="-122"/>
-                          <a:cs typeface="Calibri" pitchFamily="34" charset="-120"/>
-                        </a:rPr>
-                        <a:t>R$ 15,3 mi</a:t>
-                      </a:r>
-                      <a:endParaRPr lang="en-US" sz="615" dirty="0">
-                        <a:latin typeface="Calibri" charset="0"/>
-                        <a:ea typeface="Calibri" charset="0"/>
-                        <a:cs typeface="Calibri" charset="0"/>
-                      </a:endParaRPr>
-                    </a:p>
-                  </a:txBody>
-                  <a:tcPr marL="36576" marR="36576" marT="18288" marB="18288" anchor="mid">
-                    <a:lnL w="5715" cap="flat" cmpd="sng" algn="ctr">
-                      <a:solidFill>
-                        <a:srgbClr val="FFFFFF"/>
-                      </a:solidFill>
-                      <a:prstDash val="solid"/>
-                      <a:round/>
-                      <a:headEnd type="none" w="med" len="med"/>
-                      <a:tailEnd type="none" w="med" len="med"/>
-                    </a:lnL>
-                    <a:lnR w="5715" cap="flat" cmpd="sng" algn="ctr">
-                      <a:solidFill>
-                        <a:srgbClr val="FFFFFF"/>
-                      </a:solidFill>
-                      <a:prstDash val="solid"/>
-                      <a:round/>
-                      <a:headEnd type="none" w="med" len="med"/>
-                      <a:tailEnd type="none" w="med" len="med"/>
-                    </a:lnR>
-                    <a:lnT w="5715" cap="flat" cmpd="sng" algn="ctr">
-                      <a:solidFill>
-                        <a:srgbClr val="FFFFFF"/>
-                      </a:solidFill>
-                      <a:prstDash val="solid"/>
-                      <a:round/>
-                      <a:headEnd type="none" w="med" len="med"/>
-                      <a:tailEnd type="none" w="med" len="med"/>
-                    </a:lnT>
-                    <a:lnB w="5715" cap="flat" cmpd="sng" algn="ctr">
-                      <a:solidFill>
-                        <a:srgbClr val="FFFFFF"/>
-                      </a:solidFill>
-                      <a:prstDash val="solid"/>
-                      <a:round/>
-                      <a:headEnd type="none" w="med" len="med"/>
-                      <a:tailEnd type="none" w="med" len="med"/>
-                    </a:lnB>
-                    <a:solidFill>
-                      <a:srgbClr val="FFFFFF"/>
-                    </a:solidFill>
-                  </a:tcPr>
-                </a:tc>
-                <a:tc>
-                  <a:txBody>
-                    <a:bodyPr/>
-                    <a:lstStyle/>
-                    <a:p>
-                      <a:pPr algn="ctr" indent="0" marL="0">
-                        <a:buNone/>
-                      </a:pPr>
-                      <a:r>
-                        <a:rPr lang="en-US" sz="615" dirty="0">
-                          <a:solidFill>
-                            <a:srgbClr val="1F1F1F"/>
-                          </a:solidFill>
-                          <a:latin typeface="Calibri" pitchFamily="34" charset="0"/>
-                          <a:ea typeface="Calibri" pitchFamily="34" charset="-122"/>
-                          <a:cs typeface="Calibri" pitchFamily="34" charset="-120"/>
-                        </a:rPr>
-                        <a:t>R$ 96,2 mi</a:t>
-                      </a:r>
-                      <a:endParaRPr lang="en-US" sz="615" dirty="0">
-                        <a:latin typeface="Calibri" charset="0"/>
-                        <a:ea typeface="Calibri" charset="0"/>
-                        <a:cs typeface="Calibri" charset="0"/>
-                      </a:endParaRPr>
-                    </a:p>
-                  </a:txBody>
-                  <a:tcPr marL="36576" marR="36576" marT="18288" marB="18288" anchor="mid">
-                    <a:lnL w="5715" cap="flat" cmpd="sng" algn="ctr">
-                      <a:solidFill>
-                        <a:srgbClr val="FFFFFF"/>
-                      </a:solidFill>
-                      <a:prstDash val="solid"/>
-                      <a:round/>
-                      <a:headEnd type="none" w="med" len="med"/>
-                      <a:tailEnd type="none" w="med" len="med"/>
-                    </a:lnL>
-                    <a:lnR w="5715" cap="flat" cmpd="sng" algn="ctr">
-                      <a:solidFill>
-                        <a:srgbClr val="FFFFFF"/>
-                      </a:solidFill>
-                      <a:prstDash val="solid"/>
-                      <a:round/>
-                      <a:headEnd type="none" w="med" len="med"/>
-                      <a:tailEnd type="none" w="med" len="med"/>
-                    </a:lnR>
-                    <a:lnT w="5715" cap="flat" cmpd="sng" algn="ctr">
-                      <a:solidFill>
-                        <a:srgbClr val="FFFFFF"/>
-                      </a:solidFill>
-                      <a:prstDash val="solid"/>
-                      <a:round/>
-                      <a:headEnd type="none" w="med" len="med"/>
-                      <a:tailEnd type="none" w="med" len="med"/>
-                    </a:lnT>
-                    <a:lnB w="5715" cap="flat" cmpd="sng" algn="ctr">
-                      <a:solidFill>
-                        <a:srgbClr val="FFFFFF"/>
-                      </a:solidFill>
-                      <a:prstDash val="solid"/>
-                      <a:round/>
-                      <a:headEnd type="none" w="med" len="med"/>
-                      <a:tailEnd type="none" w="med" len="med"/>
-                    </a:lnB>
-                    <a:solidFill>
-                      <a:srgbClr val="FFFFFF"/>
-                    </a:solidFill>
-                  </a:tcPr>
-                </a:tc>
-                <a:tc>
-                  <a:txBody>
-                    <a:bodyPr/>
-                    <a:lstStyle/>
-                    <a:p>
-                      <a:pPr algn="ctr" indent="0" marL="0">
-                        <a:buNone/>
-                      </a:pPr>
-                      <a:r>
-                        <a:rPr lang="en-US" sz="615" dirty="0">
-                          <a:solidFill>
-                            <a:srgbClr val="1F1F1F"/>
-                          </a:solidFill>
-                          <a:latin typeface="Calibri" pitchFamily="34" charset="0"/>
-                          <a:ea typeface="Calibri" pitchFamily="34" charset="-122"/>
-                          <a:cs typeface="Calibri" pitchFamily="34" charset="-120"/>
-                        </a:rPr>
-                        <a:t>R$ 101 mi</a:t>
+                        <a:t>R$ 142,9 mi</a:t>
                       </a:r>
                       <a:endParaRPr lang="en-US" sz="615" dirty="0">
                         <a:latin typeface="Calibri" charset="0"/>
@@ -11908,7 +11704,211 @@
                           <a:ea typeface="Calibri" pitchFamily="34" charset="-122"/>
                           <a:cs typeface="Calibri" pitchFamily="34" charset="-120"/>
                         </a:rPr>
-                        <a:t>37,02%</a:t>
+                        <a:t>R$ 0,00</a:t>
+                      </a:r>
+                      <a:endParaRPr lang="en-US" sz="615" dirty="0">
+                        <a:latin typeface="Calibri" charset="0"/>
+                        <a:ea typeface="Calibri" charset="0"/>
+                        <a:cs typeface="Calibri" charset="0"/>
+                      </a:endParaRPr>
+                    </a:p>
+                  </a:txBody>
+                  <a:tcPr marL="36576" marR="36576" marT="18288" marB="18288" anchor="mid">
+                    <a:lnL w="5715" cap="flat" cmpd="sng" algn="ctr">
+                      <a:solidFill>
+                        <a:srgbClr val="FFFFFF"/>
+                      </a:solidFill>
+                      <a:prstDash val="solid"/>
+                      <a:round/>
+                      <a:headEnd type="none" w="med" len="med"/>
+                      <a:tailEnd type="none" w="med" len="med"/>
+                    </a:lnL>
+                    <a:lnR w="5715" cap="flat" cmpd="sng" algn="ctr">
+                      <a:solidFill>
+                        <a:srgbClr val="FFFFFF"/>
+                      </a:solidFill>
+                      <a:prstDash val="solid"/>
+                      <a:round/>
+                      <a:headEnd type="none" w="med" len="med"/>
+                      <a:tailEnd type="none" w="med" len="med"/>
+                    </a:lnR>
+                    <a:lnT w="5715" cap="flat" cmpd="sng" algn="ctr">
+                      <a:solidFill>
+                        <a:srgbClr val="FFFFFF"/>
+                      </a:solidFill>
+                      <a:prstDash val="solid"/>
+                      <a:round/>
+                      <a:headEnd type="none" w="med" len="med"/>
+                      <a:tailEnd type="none" w="med" len="med"/>
+                    </a:lnT>
+                    <a:lnB w="5715" cap="flat" cmpd="sng" algn="ctr">
+                      <a:solidFill>
+                        <a:srgbClr val="FFFFFF"/>
+                      </a:solidFill>
+                      <a:prstDash val="solid"/>
+                      <a:round/>
+                      <a:headEnd type="none" w="med" len="med"/>
+                      <a:tailEnd type="none" w="med" len="med"/>
+                    </a:lnB>
+                    <a:solidFill>
+                      <a:srgbClr val="FFFFFF"/>
+                    </a:solidFill>
+                  </a:tcPr>
+                </a:tc>
+                <a:tc>
+                  <a:txBody>
+                    <a:bodyPr/>
+                    <a:lstStyle/>
+                    <a:p>
+                      <a:pPr algn="ctr" indent="0" marL="0">
+                        <a:buNone/>
+                      </a:pPr>
+                      <a:r>
+                        <a:rPr lang="en-US" sz="615" dirty="0">
+                          <a:solidFill>
+                            <a:srgbClr val="1F1F1F"/>
+                          </a:solidFill>
+                          <a:latin typeface="Calibri" pitchFamily="34" charset="0"/>
+                          <a:ea typeface="Calibri" pitchFamily="34" charset="-122"/>
+                          <a:cs typeface="Calibri" pitchFamily="34" charset="-120"/>
+                        </a:rPr>
+                        <a:t>R$ 142,9 mi</a:t>
+                      </a:r>
+                      <a:endParaRPr lang="en-US" sz="615" dirty="0">
+                        <a:latin typeface="Calibri" charset="0"/>
+                        <a:ea typeface="Calibri" charset="0"/>
+                        <a:cs typeface="Calibri" charset="0"/>
+                      </a:endParaRPr>
+                    </a:p>
+                  </a:txBody>
+                  <a:tcPr marL="36576" marR="36576" marT="18288" marB="18288" anchor="mid">
+                    <a:lnL w="5715" cap="flat" cmpd="sng" algn="ctr">
+                      <a:solidFill>
+                        <a:srgbClr val="FFFFFF"/>
+                      </a:solidFill>
+                      <a:prstDash val="solid"/>
+                      <a:round/>
+                      <a:headEnd type="none" w="med" len="med"/>
+                      <a:tailEnd type="none" w="med" len="med"/>
+                    </a:lnL>
+                    <a:lnR w="5715" cap="flat" cmpd="sng" algn="ctr">
+                      <a:solidFill>
+                        <a:srgbClr val="FFFFFF"/>
+                      </a:solidFill>
+                      <a:prstDash val="solid"/>
+                      <a:round/>
+                      <a:headEnd type="none" w="med" len="med"/>
+                      <a:tailEnd type="none" w="med" len="med"/>
+                    </a:lnR>
+                    <a:lnT w="5715" cap="flat" cmpd="sng" algn="ctr">
+                      <a:solidFill>
+                        <a:srgbClr val="FFFFFF"/>
+                      </a:solidFill>
+                      <a:prstDash val="solid"/>
+                      <a:round/>
+                      <a:headEnd type="none" w="med" len="med"/>
+                      <a:tailEnd type="none" w="med" len="med"/>
+                    </a:lnT>
+                    <a:lnB w="5715" cap="flat" cmpd="sng" algn="ctr">
+                      <a:solidFill>
+                        <a:srgbClr val="FFFFFF"/>
+                      </a:solidFill>
+                      <a:prstDash val="solid"/>
+                      <a:round/>
+                      <a:headEnd type="none" w="med" len="med"/>
+                      <a:tailEnd type="none" w="med" len="med"/>
+                    </a:lnB>
+                    <a:solidFill>
+                      <a:srgbClr val="FFFFFF"/>
+                    </a:solidFill>
+                  </a:tcPr>
+                </a:tc>
+                <a:tc>
+                  <a:txBody>
+                    <a:bodyPr/>
+                    <a:lstStyle/>
+                    <a:p>
+                      <a:pPr algn="ctr" indent="0" marL="0">
+                        <a:buNone/>
+                      </a:pPr>
+                      <a:r>
+                        <a:rPr lang="en-US" sz="615" dirty="0">
+                          <a:solidFill>
+                            <a:srgbClr val="1F1F1F"/>
+                          </a:solidFill>
+                          <a:latin typeface="Calibri" pitchFamily="34" charset="0"/>
+                          <a:ea typeface="Calibri" pitchFamily="34" charset="-122"/>
+                          <a:cs typeface="Calibri" pitchFamily="34" charset="-120"/>
+                        </a:rPr>
+                        <a:t>R$ 21,8 mi</a:t>
+                      </a:r>
+                      <a:endParaRPr lang="en-US" sz="615" dirty="0">
+                        <a:latin typeface="Calibri" charset="0"/>
+                        <a:ea typeface="Calibri" charset="0"/>
+                        <a:cs typeface="Calibri" charset="0"/>
+                      </a:endParaRPr>
+                    </a:p>
+                  </a:txBody>
+                  <a:tcPr marL="36576" marR="36576" marT="18288" marB="18288" anchor="mid">
+                    <a:lnL w="5715" cap="flat" cmpd="sng" algn="ctr">
+                      <a:solidFill>
+                        <a:srgbClr val="FFFFFF"/>
+                      </a:solidFill>
+                      <a:prstDash val="solid"/>
+                      <a:round/>
+                      <a:headEnd type="none" w="med" len="med"/>
+                      <a:tailEnd type="none" w="med" len="med"/>
+                    </a:lnL>
+                    <a:lnR w="5715" cap="flat" cmpd="sng" algn="ctr">
+                      <a:solidFill>
+                        <a:srgbClr val="FFFFFF"/>
+                      </a:solidFill>
+                      <a:prstDash val="solid"/>
+                      <a:round/>
+                      <a:headEnd type="none" w="med" len="med"/>
+                      <a:tailEnd type="none" w="med" len="med"/>
+                    </a:lnR>
+                    <a:lnT w="5715" cap="flat" cmpd="sng" algn="ctr">
+                      <a:solidFill>
+                        <a:srgbClr val="FFFFFF"/>
+                      </a:solidFill>
+                      <a:prstDash val="solid"/>
+                      <a:round/>
+                      <a:headEnd type="none" w="med" len="med"/>
+                      <a:tailEnd type="none" w="med" len="med"/>
+                    </a:lnT>
+                    <a:lnB w="5715" cap="flat" cmpd="sng" algn="ctr">
+                      <a:solidFill>
+                        <a:srgbClr val="FFFFFF"/>
+                      </a:solidFill>
+                      <a:prstDash val="solid"/>
+                      <a:round/>
+                      <a:headEnd type="none" w="med" len="med"/>
+                      <a:tailEnd type="none" w="med" len="med"/>
+                    </a:lnB>
+                    <a:solidFill>
+                      <a:srgbClr val="FFFFFF"/>
+                    </a:solidFill>
+                  </a:tcPr>
+                </a:tc>
+                <a:tc>
+                  <a:txBody>
+                    <a:bodyPr/>
+                    <a:lstStyle/>
+                    <a:p>
+                      <a:pPr algn="ctr" indent="0" marL="0">
+                        <a:buNone/>
+                      </a:pPr>
+                      <a:r>
+                        <a:rPr lang="en-US" sz="615" dirty="0">
+                          <a:solidFill>
+                            <a:srgbClr val="1F1F1F"/>
+                          </a:solidFill>
+                          <a:latin typeface="Calibri" pitchFamily="34" charset="0"/>
+                          <a:ea typeface="Calibri" pitchFamily="34" charset="-122"/>
+                          <a:cs typeface="Calibri" pitchFamily="34" charset="-120"/>
+                        </a:rPr>
+                        <a:t>30,00%</a:t>
                       </a:r>
                       <a:endParaRPr lang="en-US" sz="615" dirty="0">
                         <a:latin typeface="Calibri" charset="0"/>
@@ -12046,211 +12046,7 @@
                           <a:ea typeface="Calibri" pitchFamily="34" charset="-122"/>
                           <a:cs typeface="Calibri" pitchFamily="34" charset="-120"/>
                         </a:rPr>
-                        <a:t>R$ 87 mi</a:t>
-                      </a:r>
-                      <a:endParaRPr lang="en-US" sz="615" dirty="0">
-                        <a:latin typeface="Calibri" charset="0"/>
-                        <a:ea typeface="Calibri" charset="0"/>
-                        <a:cs typeface="Calibri" charset="0"/>
-                      </a:endParaRPr>
-                    </a:p>
-                  </a:txBody>
-                  <a:tcPr marL="36576" marR="36576" marT="18288" marB="18288" anchor="mid">
-                    <a:lnL w="5715" cap="flat" cmpd="sng" algn="ctr">
-                      <a:solidFill>
-                        <a:srgbClr val="FFFFFF"/>
-                      </a:solidFill>
-                      <a:prstDash val="solid"/>
-                      <a:round/>
-                      <a:headEnd type="none" w="med" len="med"/>
-                      <a:tailEnd type="none" w="med" len="med"/>
-                    </a:lnL>
-                    <a:lnR w="5715" cap="flat" cmpd="sng" algn="ctr">
-                      <a:solidFill>
-                        <a:srgbClr val="FFFFFF"/>
-                      </a:solidFill>
-                      <a:prstDash val="solid"/>
-                      <a:round/>
-                      <a:headEnd type="none" w="med" len="med"/>
-                      <a:tailEnd type="none" w="med" len="med"/>
-                    </a:lnR>
-                    <a:lnT w="5715" cap="flat" cmpd="sng" algn="ctr">
-                      <a:solidFill>
-                        <a:srgbClr val="FFFFFF"/>
-                      </a:solidFill>
-                      <a:prstDash val="solid"/>
-                      <a:round/>
-                      <a:headEnd type="none" w="med" len="med"/>
-                      <a:tailEnd type="none" w="med" len="med"/>
-                    </a:lnT>
-                    <a:lnB w="5715" cap="flat" cmpd="sng" algn="ctr">
-                      <a:solidFill>
-                        <a:srgbClr val="FFFFFF"/>
-                      </a:solidFill>
-                      <a:prstDash val="solid"/>
-                      <a:round/>
-                      <a:headEnd type="none" w="med" len="med"/>
-                      <a:tailEnd type="none" w="med" len="med"/>
-                    </a:lnB>
-                    <a:solidFill>
-                      <a:srgbClr val="F1F1F1"/>
-                    </a:solidFill>
-                  </a:tcPr>
-                </a:tc>
-                <a:tc>
-                  <a:txBody>
-                    <a:bodyPr/>
-                    <a:lstStyle/>
-                    <a:p>
-                      <a:pPr algn="ctr" indent="0" marL="0">
-                        <a:buNone/>
-                      </a:pPr>
-                      <a:r>
-                        <a:rPr lang="en-US" sz="615" dirty="0">
-                          <a:solidFill>
-                            <a:srgbClr val="1F1F1F"/>
-                          </a:solidFill>
-                          <a:latin typeface="Calibri" pitchFamily="34" charset="0"/>
-                          <a:ea typeface="Calibri" pitchFamily="34" charset="-122"/>
-                          <a:cs typeface="Calibri" pitchFamily="34" charset="-120"/>
-                        </a:rPr>
-                        <a:t>R$ 15,5 mi</a:t>
-                      </a:r>
-                      <a:endParaRPr lang="en-US" sz="615" dirty="0">
-                        <a:latin typeface="Calibri" charset="0"/>
-                        <a:ea typeface="Calibri" charset="0"/>
-                        <a:cs typeface="Calibri" charset="0"/>
-                      </a:endParaRPr>
-                    </a:p>
-                  </a:txBody>
-                  <a:tcPr marL="36576" marR="36576" marT="18288" marB="18288" anchor="mid">
-                    <a:lnL w="5715" cap="flat" cmpd="sng" algn="ctr">
-                      <a:solidFill>
-                        <a:srgbClr val="FFFFFF"/>
-                      </a:solidFill>
-                      <a:prstDash val="solid"/>
-                      <a:round/>
-                      <a:headEnd type="none" w="med" len="med"/>
-                      <a:tailEnd type="none" w="med" len="med"/>
-                    </a:lnL>
-                    <a:lnR w="5715" cap="flat" cmpd="sng" algn="ctr">
-                      <a:solidFill>
-                        <a:srgbClr val="FFFFFF"/>
-                      </a:solidFill>
-                      <a:prstDash val="solid"/>
-                      <a:round/>
-                      <a:headEnd type="none" w="med" len="med"/>
-                      <a:tailEnd type="none" w="med" len="med"/>
-                    </a:lnR>
-                    <a:lnT w="5715" cap="flat" cmpd="sng" algn="ctr">
-                      <a:solidFill>
-                        <a:srgbClr val="FFFFFF"/>
-                      </a:solidFill>
-                      <a:prstDash val="solid"/>
-                      <a:round/>
-                      <a:headEnd type="none" w="med" len="med"/>
-                      <a:tailEnd type="none" w="med" len="med"/>
-                    </a:lnT>
-                    <a:lnB w="5715" cap="flat" cmpd="sng" algn="ctr">
-                      <a:solidFill>
-                        <a:srgbClr val="FFFFFF"/>
-                      </a:solidFill>
-                      <a:prstDash val="solid"/>
-                      <a:round/>
-                      <a:headEnd type="none" w="med" len="med"/>
-                      <a:tailEnd type="none" w="med" len="med"/>
-                    </a:lnB>
-                    <a:solidFill>
-                      <a:srgbClr val="F1F1F1"/>
-                    </a:solidFill>
-                  </a:tcPr>
-                </a:tc>
-                <a:tc>
-                  <a:txBody>
-                    <a:bodyPr/>
-                    <a:lstStyle/>
-                    <a:p>
-                      <a:pPr algn="ctr" indent="0" marL="0">
-                        <a:buNone/>
-                      </a:pPr>
-                      <a:r>
-                        <a:rPr lang="en-US" sz="615" dirty="0">
-                          <a:solidFill>
-                            <a:srgbClr val="1F1F1F"/>
-                          </a:solidFill>
-                          <a:latin typeface="Calibri" pitchFamily="34" charset="0"/>
-                          <a:ea typeface="Calibri" pitchFamily="34" charset="-122"/>
-                          <a:cs typeface="Calibri" pitchFamily="34" charset="-120"/>
-                        </a:rPr>
-                        <a:t>R$ 118,8 mi</a:t>
-                      </a:r>
-                      <a:endParaRPr lang="en-US" sz="615" dirty="0">
-                        <a:latin typeface="Calibri" charset="0"/>
-                        <a:ea typeface="Calibri" charset="0"/>
-                        <a:cs typeface="Calibri" charset="0"/>
-                      </a:endParaRPr>
-                    </a:p>
-                  </a:txBody>
-                  <a:tcPr marL="36576" marR="36576" marT="18288" marB="18288" anchor="mid">
-                    <a:lnL w="5715" cap="flat" cmpd="sng" algn="ctr">
-                      <a:solidFill>
-                        <a:srgbClr val="FFFFFF"/>
-                      </a:solidFill>
-                      <a:prstDash val="solid"/>
-                      <a:round/>
-                      <a:headEnd type="none" w="med" len="med"/>
-                      <a:tailEnd type="none" w="med" len="med"/>
-                    </a:lnL>
-                    <a:lnR w="5715" cap="flat" cmpd="sng" algn="ctr">
-                      <a:solidFill>
-                        <a:srgbClr val="FFFFFF"/>
-                      </a:solidFill>
-                      <a:prstDash val="solid"/>
-                      <a:round/>
-                      <a:headEnd type="none" w="med" len="med"/>
-                      <a:tailEnd type="none" w="med" len="med"/>
-                    </a:lnR>
-                    <a:lnT w="5715" cap="flat" cmpd="sng" algn="ctr">
-                      <a:solidFill>
-                        <a:srgbClr val="FFFFFF"/>
-                      </a:solidFill>
-                      <a:prstDash val="solid"/>
-                      <a:round/>
-                      <a:headEnd type="none" w="med" len="med"/>
-                      <a:tailEnd type="none" w="med" len="med"/>
-                    </a:lnT>
-                    <a:lnB w="5715" cap="flat" cmpd="sng" algn="ctr">
-                      <a:solidFill>
-                        <a:srgbClr val="FFFFFF"/>
-                      </a:solidFill>
-                      <a:prstDash val="solid"/>
-                      <a:round/>
-                      <a:headEnd type="none" w="med" len="med"/>
-                      <a:tailEnd type="none" w="med" len="med"/>
-                    </a:lnB>
-                    <a:solidFill>
-                      <a:srgbClr val="F1F1F1"/>
-                    </a:solidFill>
-                  </a:tcPr>
-                </a:tc>
-                <a:tc>
-                  <a:txBody>
-                    <a:bodyPr/>
-                    <a:lstStyle/>
-                    <a:p>
-                      <a:pPr algn="ctr" indent="0" marL="0">
-                        <a:buNone/>
-                      </a:pPr>
-                      <a:r>
-                        <a:rPr lang="en-US" sz="615" dirty="0">
-                          <a:solidFill>
-                            <a:srgbClr val="1F1F1F"/>
-                          </a:solidFill>
-                          <a:latin typeface="Calibri" pitchFamily="34" charset="0"/>
-                          <a:ea typeface="Calibri" pitchFamily="34" charset="-122"/>
-                          <a:cs typeface="Calibri" pitchFamily="34" charset="-120"/>
-                        </a:rPr>
-                        <a:t>R$ 102,6 mi</a:t>
+                        <a:t>R$ 142,9 mi</a:t>
                       </a:r>
                       <a:endParaRPr lang="en-US" sz="615" dirty="0">
                         <a:latin typeface="Calibri" charset="0"/>
@@ -12386,7 +12182,211 @@
                           <a:ea typeface="Calibri" pitchFamily="34" charset="-122"/>
                           <a:cs typeface="Calibri" pitchFamily="34" charset="-120"/>
                         </a:rPr>
-                        <a:t>43,81%</a:t>
+                        <a:t>R$ 0,00</a:t>
+                      </a:r>
+                      <a:endParaRPr lang="en-US" sz="615" dirty="0">
+                        <a:latin typeface="Calibri" charset="0"/>
+                        <a:ea typeface="Calibri" charset="0"/>
+                        <a:cs typeface="Calibri" charset="0"/>
+                      </a:endParaRPr>
+                    </a:p>
+                  </a:txBody>
+                  <a:tcPr marL="36576" marR="36576" marT="18288" marB="18288" anchor="mid">
+                    <a:lnL w="5715" cap="flat" cmpd="sng" algn="ctr">
+                      <a:solidFill>
+                        <a:srgbClr val="FFFFFF"/>
+                      </a:solidFill>
+                      <a:prstDash val="solid"/>
+                      <a:round/>
+                      <a:headEnd type="none" w="med" len="med"/>
+                      <a:tailEnd type="none" w="med" len="med"/>
+                    </a:lnL>
+                    <a:lnR w="5715" cap="flat" cmpd="sng" algn="ctr">
+                      <a:solidFill>
+                        <a:srgbClr val="FFFFFF"/>
+                      </a:solidFill>
+                      <a:prstDash val="solid"/>
+                      <a:round/>
+                      <a:headEnd type="none" w="med" len="med"/>
+                      <a:tailEnd type="none" w="med" len="med"/>
+                    </a:lnR>
+                    <a:lnT w="5715" cap="flat" cmpd="sng" algn="ctr">
+                      <a:solidFill>
+                        <a:srgbClr val="FFFFFF"/>
+                      </a:solidFill>
+                      <a:prstDash val="solid"/>
+                      <a:round/>
+                      <a:headEnd type="none" w="med" len="med"/>
+                      <a:tailEnd type="none" w="med" len="med"/>
+                    </a:lnT>
+                    <a:lnB w="5715" cap="flat" cmpd="sng" algn="ctr">
+                      <a:solidFill>
+                        <a:srgbClr val="FFFFFF"/>
+                      </a:solidFill>
+                      <a:prstDash val="solid"/>
+                      <a:round/>
+                      <a:headEnd type="none" w="med" len="med"/>
+                      <a:tailEnd type="none" w="med" len="med"/>
+                    </a:lnB>
+                    <a:solidFill>
+                      <a:srgbClr val="F1F1F1"/>
+                    </a:solidFill>
+                  </a:tcPr>
+                </a:tc>
+                <a:tc>
+                  <a:txBody>
+                    <a:bodyPr/>
+                    <a:lstStyle/>
+                    <a:p>
+                      <a:pPr algn="ctr" indent="0" marL="0">
+                        <a:buNone/>
+                      </a:pPr>
+                      <a:r>
+                        <a:rPr lang="en-US" sz="615" dirty="0">
+                          <a:solidFill>
+                            <a:srgbClr val="1F1F1F"/>
+                          </a:solidFill>
+                          <a:latin typeface="Calibri" pitchFamily="34" charset="0"/>
+                          <a:ea typeface="Calibri" pitchFamily="34" charset="-122"/>
+                          <a:cs typeface="Calibri" pitchFamily="34" charset="-120"/>
+                        </a:rPr>
+                        <a:t>R$ 142,9 mi</a:t>
+                      </a:r>
+                      <a:endParaRPr lang="en-US" sz="615" dirty="0">
+                        <a:latin typeface="Calibri" charset="0"/>
+                        <a:ea typeface="Calibri" charset="0"/>
+                        <a:cs typeface="Calibri" charset="0"/>
+                      </a:endParaRPr>
+                    </a:p>
+                  </a:txBody>
+                  <a:tcPr marL="36576" marR="36576" marT="18288" marB="18288" anchor="mid">
+                    <a:lnL w="5715" cap="flat" cmpd="sng" algn="ctr">
+                      <a:solidFill>
+                        <a:srgbClr val="FFFFFF"/>
+                      </a:solidFill>
+                      <a:prstDash val="solid"/>
+                      <a:round/>
+                      <a:headEnd type="none" w="med" len="med"/>
+                      <a:tailEnd type="none" w="med" len="med"/>
+                    </a:lnL>
+                    <a:lnR w="5715" cap="flat" cmpd="sng" algn="ctr">
+                      <a:solidFill>
+                        <a:srgbClr val="FFFFFF"/>
+                      </a:solidFill>
+                      <a:prstDash val="solid"/>
+                      <a:round/>
+                      <a:headEnd type="none" w="med" len="med"/>
+                      <a:tailEnd type="none" w="med" len="med"/>
+                    </a:lnR>
+                    <a:lnT w="5715" cap="flat" cmpd="sng" algn="ctr">
+                      <a:solidFill>
+                        <a:srgbClr val="FFFFFF"/>
+                      </a:solidFill>
+                      <a:prstDash val="solid"/>
+                      <a:round/>
+                      <a:headEnd type="none" w="med" len="med"/>
+                      <a:tailEnd type="none" w="med" len="med"/>
+                    </a:lnT>
+                    <a:lnB w="5715" cap="flat" cmpd="sng" algn="ctr">
+                      <a:solidFill>
+                        <a:srgbClr val="FFFFFF"/>
+                      </a:solidFill>
+                      <a:prstDash val="solid"/>
+                      <a:round/>
+                      <a:headEnd type="none" w="med" len="med"/>
+                      <a:tailEnd type="none" w="med" len="med"/>
+                    </a:lnB>
+                    <a:solidFill>
+                      <a:srgbClr val="F1F1F1"/>
+                    </a:solidFill>
+                  </a:tcPr>
+                </a:tc>
+                <a:tc>
+                  <a:txBody>
+                    <a:bodyPr/>
+                    <a:lstStyle/>
+                    <a:p>
+                      <a:pPr algn="ctr" indent="0" marL="0">
+                        <a:buNone/>
+                      </a:pPr>
+                      <a:r>
+                        <a:rPr lang="en-US" sz="615" dirty="0">
+                          <a:solidFill>
+                            <a:srgbClr val="1F1F1F"/>
+                          </a:solidFill>
+                          <a:latin typeface="Calibri" pitchFamily="34" charset="0"/>
+                          <a:ea typeface="Calibri" pitchFamily="34" charset="-122"/>
+                          <a:cs typeface="Calibri" pitchFamily="34" charset="-120"/>
+                        </a:rPr>
+                        <a:t>R$ 1,9 mi</a:t>
+                      </a:r>
+                      <a:endParaRPr lang="en-US" sz="615" dirty="0">
+                        <a:latin typeface="Calibri" charset="0"/>
+                        <a:ea typeface="Calibri" charset="0"/>
+                        <a:cs typeface="Calibri" charset="0"/>
+                      </a:endParaRPr>
+                    </a:p>
+                  </a:txBody>
+                  <a:tcPr marL="36576" marR="36576" marT="18288" marB="18288" anchor="mid">
+                    <a:lnL w="5715" cap="flat" cmpd="sng" algn="ctr">
+                      <a:solidFill>
+                        <a:srgbClr val="FFFFFF"/>
+                      </a:solidFill>
+                      <a:prstDash val="solid"/>
+                      <a:round/>
+                      <a:headEnd type="none" w="med" len="med"/>
+                      <a:tailEnd type="none" w="med" len="med"/>
+                    </a:lnL>
+                    <a:lnR w="5715" cap="flat" cmpd="sng" algn="ctr">
+                      <a:solidFill>
+                        <a:srgbClr val="FFFFFF"/>
+                      </a:solidFill>
+                      <a:prstDash val="solid"/>
+                      <a:round/>
+                      <a:headEnd type="none" w="med" len="med"/>
+                      <a:tailEnd type="none" w="med" len="med"/>
+                    </a:lnR>
+                    <a:lnT w="5715" cap="flat" cmpd="sng" algn="ctr">
+                      <a:solidFill>
+                        <a:srgbClr val="FFFFFF"/>
+                      </a:solidFill>
+                      <a:prstDash val="solid"/>
+                      <a:round/>
+                      <a:headEnd type="none" w="med" len="med"/>
+                      <a:tailEnd type="none" w="med" len="med"/>
+                    </a:lnT>
+                    <a:lnB w="5715" cap="flat" cmpd="sng" algn="ctr">
+                      <a:solidFill>
+                        <a:srgbClr val="FFFFFF"/>
+                      </a:solidFill>
+                      <a:prstDash val="solid"/>
+                      <a:round/>
+                      <a:headEnd type="none" w="med" len="med"/>
+                      <a:tailEnd type="none" w="med" len="med"/>
+                    </a:lnB>
+                    <a:solidFill>
+                      <a:srgbClr val="F1F1F1"/>
+                    </a:solidFill>
+                  </a:tcPr>
+                </a:tc>
+                <a:tc>
+                  <a:txBody>
+                    <a:bodyPr/>
+                    <a:lstStyle/>
+                    <a:p>
+                      <a:pPr algn="ctr" indent="0" marL="0">
+                        <a:buNone/>
+                      </a:pPr>
+                      <a:r>
+                        <a:rPr lang="en-US" sz="615" dirty="0">
+                          <a:solidFill>
+                            <a:srgbClr val="1F1F1F"/>
+                          </a:solidFill>
+                          <a:latin typeface="Calibri" pitchFamily="34" charset="0"/>
+                          <a:ea typeface="Calibri" pitchFamily="34" charset="-122"/>
+                          <a:cs typeface="Calibri" pitchFamily="34" charset="-120"/>
+                        </a:rPr>
+                        <a:t>30,00%</a:t>
                       </a:r>
                       <a:endParaRPr lang="en-US" sz="615" dirty="0">
                         <a:latin typeface="Calibri" charset="0"/>
@@ -12524,211 +12524,7 @@
                           <a:ea typeface="Calibri" pitchFamily="34" charset="-122"/>
                           <a:cs typeface="Calibri" pitchFamily="34" charset="-120"/>
                         </a:rPr>
-                        <a:t>R$ 88,4 mi</a:t>
-                      </a:r>
-                      <a:endParaRPr lang="en-US" sz="615" dirty="0">
-                        <a:latin typeface="Calibri" charset="0"/>
-                        <a:ea typeface="Calibri" charset="0"/>
-                        <a:cs typeface="Calibri" charset="0"/>
-                      </a:endParaRPr>
-                    </a:p>
-                  </a:txBody>
-                  <a:tcPr marL="36576" marR="36576" marT="18288" marB="18288" anchor="mid">
-                    <a:lnL w="5715" cap="flat" cmpd="sng" algn="ctr">
-                      <a:solidFill>
-                        <a:srgbClr val="FFFFFF"/>
-                      </a:solidFill>
-                      <a:prstDash val="solid"/>
-                      <a:round/>
-                      <a:headEnd type="none" w="med" len="med"/>
-                      <a:tailEnd type="none" w="med" len="med"/>
-                    </a:lnL>
-                    <a:lnR w="5715" cap="flat" cmpd="sng" algn="ctr">
-                      <a:solidFill>
-                        <a:srgbClr val="FFFFFF"/>
-                      </a:solidFill>
-                      <a:prstDash val="solid"/>
-                      <a:round/>
-                      <a:headEnd type="none" w="med" len="med"/>
-                      <a:tailEnd type="none" w="med" len="med"/>
-                    </a:lnR>
-                    <a:lnT w="5715" cap="flat" cmpd="sng" algn="ctr">
-                      <a:solidFill>
-                        <a:srgbClr val="FFFFFF"/>
-                      </a:solidFill>
-                      <a:prstDash val="solid"/>
-                      <a:round/>
-                      <a:headEnd type="none" w="med" len="med"/>
-                      <a:tailEnd type="none" w="med" len="med"/>
-                    </a:lnT>
-                    <a:lnB w="5715" cap="flat" cmpd="sng" algn="ctr">
-                      <a:solidFill>
-                        <a:srgbClr val="FFFFFF"/>
-                      </a:solidFill>
-                      <a:prstDash val="solid"/>
-                      <a:round/>
-                      <a:headEnd type="none" w="med" len="med"/>
-                      <a:tailEnd type="none" w="med" len="med"/>
-                    </a:lnB>
-                    <a:solidFill>
-                      <a:srgbClr val="FFFFFF"/>
-                    </a:solidFill>
-                  </a:tcPr>
-                </a:tc>
-                <a:tc>
-                  <a:txBody>
-                    <a:bodyPr/>
-                    <a:lstStyle/>
-                    <a:p>
-                      <a:pPr algn="ctr" indent="0" marL="0">
-                        <a:buNone/>
-                      </a:pPr>
-                      <a:r>
-                        <a:rPr lang="en-US" sz="615" dirty="0">
-                          <a:solidFill>
-                            <a:srgbClr val="1F1F1F"/>
-                          </a:solidFill>
-                          <a:latin typeface="Calibri" pitchFamily="34" charset="0"/>
-                          <a:ea typeface="Calibri" pitchFamily="34" charset="-122"/>
-                          <a:cs typeface="Calibri" pitchFamily="34" charset="-120"/>
-                        </a:rPr>
-                        <a:t>R$ 15,8 mi</a:t>
-                      </a:r>
-                      <a:endParaRPr lang="en-US" sz="615" dirty="0">
-                        <a:latin typeface="Calibri" charset="0"/>
-                        <a:ea typeface="Calibri" charset="0"/>
-                        <a:cs typeface="Calibri" charset="0"/>
-                      </a:endParaRPr>
-                    </a:p>
-                  </a:txBody>
-                  <a:tcPr marL="36576" marR="36576" marT="18288" marB="18288" anchor="mid">
-                    <a:lnL w="5715" cap="flat" cmpd="sng" algn="ctr">
-                      <a:solidFill>
-                        <a:srgbClr val="FFFFFF"/>
-                      </a:solidFill>
-                      <a:prstDash val="solid"/>
-                      <a:round/>
-                      <a:headEnd type="none" w="med" len="med"/>
-                      <a:tailEnd type="none" w="med" len="med"/>
-                    </a:lnL>
-                    <a:lnR w="5715" cap="flat" cmpd="sng" algn="ctr">
-                      <a:solidFill>
-                        <a:srgbClr val="FFFFFF"/>
-                      </a:solidFill>
-                      <a:prstDash val="solid"/>
-                      <a:round/>
-                      <a:headEnd type="none" w="med" len="med"/>
-                      <a:tailEnd type="none" w="med" len="med"/>
-                    </a:lnR>
-                    <a:lnT w="5715" cap="flat" cmpd="sng" algn="ctr">
-                      <a:solidFill>
-                        <a:srgbClr val="FFFFFF"/>
-                      </a:solidFill>
-                      <a:prstDash val="solid"/>
-                      <a:round/>
-                      <a:headEnd type="none" w="med" len="med"/>
-                      <a:tailEnd type="none" w="med" len="med"/>
-                    </a:lnT>
-                    <a:lnB w="5715" cap="flat" cmpd="sng" algn="ctr">
-                      <a:solidFill>
-                        <a:srgbClr val="FFFFFF"/>
-                      </a:solidFill>
-                      <a:prstDash val="solid"/>
-                      <a:round/>
-                      <a:headEnd type="none" w="med" len="med"/>
-                      <a:tailEnd type="none" w="med" len="med"/>
-                    </a:lnB>
-                    <a:solidFill>
-                      <a:srgbClr val="FFFFFF"/>
-                    </a:solidFill>
-                  </a:tcPr>
-                </a:tc>
-                <a:tc>
-                  <a:txBody>
-                    <a:bodyPr/>
-                    <a:lstStyle/>
-                    <a:p>
-                      <a:pPr algn="ctr" indent="0" marL="0">
-                        <a:buNone/>
-                      </a:pPr>
-                      <a:r>
-                        <a:rPr lang="en-US" sz="615" dirty="0">
-                          <a:solidFill>
-                            <a:srgbClr val="1F1F1F"/>
-                          </a:solidFill>
-                          <a:latin typeface="Calibri" pitchFamily="34" charset="0"/>
-                          <a:ea typeface="Calibri" pitchFamily="34" charset="-122"/>
-                          <a:cs typeface="Calibri" pitchFamily="34" charset="-120"/>
-                        </a:rPr>
-                        <a:t>R$ 107,9 mi</a:t>
-                      </a:r>
-                      <a:endParaRPr lang="en-US" sz="615" dirty="0">
-                        <a:latin typeface="Calibri" charset="0"/>
-                        <a:ea typeface="Calibri" charset="0"/>
-                        <a:cs typeface="Calibri" charset="0"/>
-                      </a:endParaRPr>
-                    </a:p>
-                  </a:txBody>
-                  <a:tcPr marL="36576" marR="36576" marT="18288" marB="18288" anchor="mid">
-                    <a:lnL w="5715" cap="flat" cmpd="sng" algn="ctr">
-                      <a:solidFill>
-                        <a:srgbClr val="FFFFFF"/>
-                      </a:solidFill>
-                      <a:prstDash val="solid"/>
-                      <a:round/>
-                      <a:headEnd type="none" w="med" len="med"/>
-                      <a:tailEnd type="none" w="med" len="med"/>
-                    </a:lnL>
-                    <a:lnR w="5715" cap="flat" cmpd="sng" algn="ctr">
-                      <a:solidFill>
-                        <a:srgbClr val="FFFFFF"/>
-                      </a:solidFill>
-                      <a:prstDash val="solid"/>
-                      <a:round/>
-                      <a:headEnd type="none" w="med" len="med"/>
-                      <a:tailEnd type="none" w="med" len="med"/>
-                    </a:lnR>
-                    <a:lnT w="5715" cap="flat" cmpd="sng" algn="ctr">
-                      <a:solidFill>
-                        <a:srgbClr val="FFFFFF"/>
-                      </a:solidFill>
-                      <a:prstDash val="solid"/>
-                      <a:round/>
-                      <a:headEnd type="none" w="med" len="med"/>
-                      <a:tailEnd type="none" w="med" len="med"/>
-                    </a:lnT>
-                    <a:lnB w="5715" cap="flat" cmpd="sng" algn="ctr">
-                      <a:solidFill>
-                        <a:srgbClr val="FFFFFF"/>
-                      </a:solidFill>
-                      <a:prstDash val="solid"/>
-                      <a:round/>
-                      <a:headEnd type="none" w="med" len="med"/>
-                      <a:tailEnd type="none" w="med" len="med"/>
-                    </a:lnB>
-                    <a:solidFill>
-                      <a:srgbClr val="FFFFFF"/>
-                    </a:solidFill>
-                  </a:tcPr>
-                </a:tc>
-                <a:tc>
-                  <a:txBody>
-                    <a:bodyPr/>
-                    <a:lstStyle/>
-                    <a:p>
-                      <a:pPr algn="ctr" indent="0" marL="0">
-                        <a:buNone/>
-                      </a:pPr>
-                      <a:r>
-                        <a:rPr lang="en-US" sz="615" dirty="0">
-                          <a:solidFill>
-                            <a:srgbClr val="1F1F1F"/>
-                          </a:solidFill>
-                          <a:latin typeface="Calibri" pitchFamily="34" charset="0"/>
-                          <a:ea typeface="Calibri" pitchFamily="34" charset="-122"/>
-                          <a:cs typeface="Calibri" pitchFamily="34" charset="-120"/>
-                        </a:rPr>
-                        <a:t>R$ 104,1 mi</a:t>
+                        <a:t>R$ 142,9 mi</a:t>
                       </a:r>
                       <a:endParaRPr lang="en-US" sz="615" dirty="0">
                         <a:latin typeface="Calibri" charset="0"/>
@@ -12864,7 +12660,211 @@
                           <a:ea typeface="Calibri" pitchFamily="34" charset="-122"/>
                           <a:cs typeface="Calibri" pitchFamily="34" charset="-120"/>
                         </a:rPr>
-                        <a:t>48,89%</a:t>
+                        <a:t>R$ 0,00</a:t>
+                      </a:r>
+                      <a:endParaRPr lang="en-US" sz="615" dirty="0">
+                        <a:latin typeface="Calibri" charset="0"/>
+                        <a:ea typeface="Calibri" charset="0"/>
+                        <a:cs typeface="Calibri" charset="0"/>
+                      </a:endParaRPr>
+                    </a:p>
+                  </a:txBody>
+                  <a:tcPr marL="36576" marR="36576" marT="18288" marB="18288" anchor="mid">
+                    <a:lnL w="5715" cap="flat" cmpd="sng" algn="ctr">
+                      <a:solidFill>
+                        <a:srgbClr val="FFFFFF"/>
+                      </a:solidFill>
+                      <a:prstDash val="solid"/>
+                      <a:round/>
+                      <a:headEnd type="none" w="med" len="med"/>
+                      <a:tailEnd type="none" w="med" len="med"/>
+                    </a:lnL>
+                    <a:lnR w="5715" cap="flat" cmpd="sng" algn="ctr">
+                      <a:solidFill>
+                        <a:srgbClr val="FFFFFF"/>
+                      </a:solidFill>
+                      <a:prstDash val="solid"/>
+                      <a:round/>
+                      <a:headEnd type="none" w="med" len="med"/>
+                      <a:tailEnd type="none" w="med" len="med"/>
+                    </a:lnR>
+                    <a:lnT w="5715" cap="flat" cmpd="sng" algn="ctr">
+                      <a:solidFill>
+                        <a:srgbClr val="FFFFFF"/>
+                      </a:solidFill>
+                      <a:prstDash val="solid"/>
+                      <a:round/>
+                      <a:headEnd type="none" w="med" len="med"/>
+                      <a:tailEnd type="none" w="med" len="med"/>
+                    </a:lnT>
+                    <a:lnB w="5715" cap="flat" cmpd="sng" algn="ctr">
+                      <a:solidFill>
+                        <a:srgbClr val="FFFFFF"/>
+                      </a:solidFill>
+                      <a:prstDash val="solid"/>
+                      <a:round/>
+                      <a:headEnd type="none" w="med" len="med"/>
+                      <a:tailEnd type="none" w="med" len="med"/>
+                    </a:lnB>
+                    <a:solidFill>
+                      <a:srgbClr val="FFFFFF"/>
+                    </a:solidFill>
+                  </a:tcPr>
+                </a:tc>
+                <a:tc>
+                  <a:txBody>
+                    <a:bodyPr/>
+                    <a:lstStyle/>
+                    <a:p>
+                      <a:pPr algn="ctr" indent="0" marL="0">
+                        <a:buNone/>
+                      </a:pPr>
+                      <a:r>
+                        <a:rPr lang="en-US" sz="615" dirty="0">
+                          <a:solidFill>
+                            <a:srgbClr val="1F1F1F"/>
+                          </a:solidFill>
+                          <a:latin typeface="Calibri" pitchFamily="34" charset="0"/>
+                          <a:ea typeface="Calibri" pitchFamily="34" charset="-122"/>
+                          <a:cs typeface="Calibri" pitchFamily="34" charset="-120"/>
+                        </a:rPr>
+                        <a:t>R$ 142,9 mi</a:t>
+                      </a:r>
+                      <a:endParaRPr lang="en-US" sz="615" dirty="0">
+                        <a:latin typeface="Calibri" charset="0"/>
+                        <a:ea typeface="Calibri" charset="0"/>
+                        <a:cs typeface="Calibri" charset="0"/>
+                      </a:endParaRPr>
+                    </a:p>
+                  </a:txBody>
+                  <a:tcPr marL="36576" marR="36576" marT="18288" marB="18288" anchor="mid">
+                    <a:lnL w="5715" cap="flat" cmpd="sng" algn="ctr">
+                      <a:solidFill>
+                        <a:srgbClr val="FFFFFF"/>
+                      </a:solidFill>
+                      <a:prstDash val="solid"/>
+                      <a:round/>
+                      <a:headEnd type="none" w="med" len="med"/>
+                      <a:tailEnd type="none" w="med" len="med"/>
+                    </a:lnL>
+                    <a:lnR w="5715" cap="flat" cmpd="sng" algn="ctr">
+                      <a:solidFill>
+                        <a:srgbClr val="FFFFFF"/>
+                      </a:solidFill>
+                      <a:prstDash val="solid"/>
+                      <a:round/>
+                      <a:headEnd type="none" w="med" len="med"/>
+                      <a:tailEnd type="none" w="med" len="med"/>
+                    </a:lnR>
+                    <a:lnT w="5715" cap="flat" cmpd="sng" algn="ctr">
+                      <a:solidFill>
+                        <a:srgbClr val="FFFFFF"/>
+                      </a:solidFill>
+                      <a:prstDash val="solid"/>
+                      <a:round/>
+                      <a:headEnd type="none" w="med" len="med"/>
+                      <a:tailEnd type="none" w="med" len="med"/>
+                    </a:lnT>
+                    <a:lnB w="5715" cap="flat" cmpd="sng" algn="ctr">
+                      <a:solidFill>
+                        <a:srgbClr val="FFFFFF"/>
+                      </a:solidFill>
+                      <a:prstDash val="solid"/>
+                      <a:round/>
+                      <a:headEnd type="none" w="med" len="med"/>
+                      <a:tailEnd type="none" w="med" len="med"/>
+                    </a:lnB>
+                    <a:solidFill>
+                      <a:srgbClr val="FFFFFF"/>
+                    </a:solidFill>
+                  </a:tcPr>
+                </a:tc>
+                <a:tc>
+                  <a:txBody>
+                    <a:bodyPr/>
+                    <a:lstStyle/>
+                    <a:p>
+                      <a:pPr algn="ctr" indent="0" marL="0">
+                        <a:buNone/>
+                      </a:pPr>
+                      <a:r>
+                        <a:rPr lang="en-US" sz="615" dirty="0">
+                          <a:solidFill>
+                            <a:srgbClr val="1F1F1F"/>
+                          </a:solidFill>
+                          <a:latin typeface="Calibri" pitchFamily="34" charset="0"/>
+                          <a:ea typeface="Calibri" pitchFamily="34" charset="-122"/>
+                          <a:cs typeface="Calibri" pitchFamily="34" charset="-120"/>
+                        </a:rPr>
+                        <a:t>R$ 15,4 mi</a:t>
+                      </a:r>
+                      <a:endParaRPr lang="en-US" sz="615" dirty="0">
+                        <a:latin typeface="Calibri" charset="0"/>
+                        <a:ea typeface="Calibri" charset="0"/>
+                        <a:cs typeface="Calibri" charset="0"/>
+                      </a:endParaRPr>
+                    </a:p>
+                  </a:txBody>
+                  <a:tcPr marL="36576" marR="36576" marT="18288" marB="18288" anchor="mid">
+                    <a:lnL w="5715" cap="flat" cmpd="sng" algn="ctr">
+                      <a:solidFill>
+                        <a:srgbClr val="FFFFFF"/>
+                      </a:solidFill>
+                      <a:prstDash val="solid"/>
+                      <a:round/>
+                      <a:headEnd type="none" w="med" len="med"/>
+                      <a:tailEnd type="none" w="med" len="med"/>
+                    </a:lnL>
+                    <a:lnR w="5715" cap="flat" cmpd="sng" algn="ctr">
+                      <a:solidFill>
+                        <a:srgbClr val="FFFFFF"/>
+                      </a:solidFill>
+                      <a:prstDash val="solid"/>
+                      <a:round/>
+                      <a:headEnd type="none" w="med" len="med"/>
+                      <a:tailEnd type="none" w="med" len="med"/>
+                    </a:lnR>
+                    <a:lnT w="5715" cap="flat" cmpd="sng" algn="ctr">
+                      <a:solidFill>
+                        <a:srgbClr val="FFFFFF"/>
+                      </a:solidFill>
+                      <a:prstDash val="solid"/>
+                      <a:round/>
+                      <a:headEnd type="none" w="med" len="med"/>
+                      <a:tailEnd type="none" w="med" len="med"/>
+                    </a:lnT>
+                    <a:lnB w="5715" cap="flat" cmpd="sng" algn="ctr">
+                      <a:solidFill>
+                        <a:srgbClr val="FFFFFF"/>
+                      </a:solidFill>
+                      <a:prstDash val="solid"/>
+                      <a:round/>
+                      <a:headEnd type="none" w="med" len="med"/>
+                      <a:tailEnd type="none" w="med" len="med"/>
+                    </a:lnB>
+                    <a:solidFill>
+                      <a:srgbClr val="FFFFFF"/>
+                    </a:solidFill>
+                  </a:tcPr>
+                </a:tc>
+                <a:tc>
+                  <a:txBody>
+                    <a:bodyPr/>
+                    <a:lstStyle/>
+                    <a:p>
+                      <a:pPr algn="ctr" indent="0" marL="0">
+                        <a:buNone/>
+                      </a:pPr>
+                      <a:r>
+                        <a:rPr lang="en-US" sz="615" dirty="0">
+                          <a:solidFill>
+                            <a:srgbClr val="1F1F1F"/>
+                          </a:solidFill>
+                          <a:latin typeface="Calibri" pitchFamily="34" charset="0"/>
+                          <a:ea typeface="Calibri" pitchFamily="34" charset="-122"/>
+                          <a:cs typeface="Calibri" pitchFamily="34" charset="-120"/>
+                        </a:rPr>
+                        <a:t>30,00%</a:t>
                       </a:r>
                       <a:endParaRPr lang="en-US" sz="615" dirty="0">
                         <a:latin typeface="Calibri" charset="0"/>
@@ -13002,7 +13002,7 @@
                           <a:ea typeface="Calibri" pitchFamily="34" charset="-122"/>
                           <a:cs typeface="Calibri" pitchFamily="34" charset="-120"/>
                         </a:rPr>
-                        <a:t>R$ 89,7 mi</a:t>
+                        <a:t>R$ 142,9 mi</a:t>
                       </a:r>
                       <a:endParaRPr lang="en-US" sz="615" dirty="0">
                         <a:latin typeface="Calibri" charset="0"/>
@@ -13070,143 +13070,7 @@
                           <a:ea typeface="Calibri" pitchFamily="34" charset="-122"/>
                           <a:cs typeface="Calibri" pitchFamily="34" charset="-120"/>
                         </a:rPr>
-                        <a:t>R$ 16 mi</a:t>
-                      </a:r>
-                      <a:endParaRPr lang="en-US" sz="615" dirty="0">
-                        <a:latin typeface="Calibri" charset="0"/>
-                        <a:ea typeface="Calibri" charset="0"/>
-                        <a:cs typeface="Calibri" charset="0"/>
-                      </a:endParaRPr>
-                    </a:p>
-                  </a:txBody>
-                  <a:tcPr marL="36576" marR="36576" marT="18288" marB="18288" anchor="mid">
-                    <a:lnL w="5715" cap="flat" cmpd="sng" algn="ctr">
-                      <a:solidFill>
-                        <a:srgbClr val="FFFFFF"/>
-                      </a:solidFill>
-                      <a:prstDash val="solid"/>
-                      <a:round/>
-                      <a:headEnd type="none" w="med" len="med"/>
-                      <a:tailEnd type="none" w="med" len="med"/>
-                    </a:lnL>
-                    <a:lnR w="5715" cap="flat" cmpd="sng" algn="ctr">
-                      <a:solidFill>
-                        <a:srgbClr val="FFFFFF"/>
-                      </a:solidFill>
-                      <a:prstDash val="solid"/>
-                      <a:round/>
-                      <a:headEnd type="none" w="med" len="med"/>
-                      <a:tailEnd type="none" w="med" len="med"/>
-                    </a:lnR>
-                    <a:lnT w="5715" cap="flat" cmpd="sng" algn="ctr">
-                      <a:solidFill>
-                        <a:srgbClr val="FFFFFF"/>
-                      </a:solidFill>
-                      <a:prstDash val="solid"/>
-                      <a:round/>
-                      <a:headEnd type="none" w="med" len="med"/>
-                      <a:tailEnd type="none" w="med" len="med"/>
-                    </a:lnT>
-                    <a:lnB w="5715" cap="flat" cmpd="sng" algn="ctr">
-                      <a:solidFill>
-                        <a:srgbClr val="FFFFFF"/>
-                      </a:solidFill>
-                      <a:prstDash val="solid"/>
-                      <a:round/>
-                      <a:headEnd type="none" w="med" len="med"/>
-                      <a:tailEnd type="none" w="med" len="med"/>
-                    </a:lnB>
-                    <a:solidFill>
-                      <a:srgbClr val="F1F1F1"/>
-                    </a:solidFill>
-                  </a:tcPr>
-                </a:tc>
-                <a:tc>
-                  <a:txBody>
-                    <a:bodyPr/>
-                    <a:lstStyle/>
-                    <a:p>
-                      <a:pPr algn="ctr" indent="0" marL="0">
-                        <a:buNone/>
-                      </a:pPr>
-                      <a:r>
-                        <a:rPr lang="en-US" sz="615" dirty="0">
-                          <a:solidFill>
-                            <a:srgbClr val="1F1F1F"/>
-                          </a:solidFill>
-                          <a:latin typeface="Calibri" pitchFamily="34" charset="0"/>
-                          <a:ea typeface="Calibri" pitchFamily="34" charset="-122"/>
-                          <a:cs typeface="Calibri" pitchFamily="34" charset="-120"/>
-                        </a:rPr>
-                        <a:t>R$ 74,5 mi</a:t>
-                      </a:r>
-                      <a:endParaRPr lang="en-US" sz="615" dirty="0">
-                        <a:latin typeface="Calibri" charset="0"/>
-                        <a:ea typeface="Calibri" charset="0"/>
-                        <a:cs typeface="Calibri" charset="0"/>
-                      </a:endParaRPr>
-                    </a:p>
-                  </a:txBody>
-                  <a:tcPr marL="36576" marR="36576" marT="18288" marB="18288" anchor="mid">
-                    <a:lnL w="5715" cap="flat" cmpd="sng" algn="ctr">
-                      <a:solidFill>
-                        <a:srgbClr val="FFFFFF"/>
-                      </a:solidFill>
-                      <a:prstDash val="solid"/>
-                      <a:round/>
-                      <a:headEnd type="none" w="med" len="med"/>
-                      <a:tailEnd type="none" w="med" len="med"/>
-                    </a:lnL>
-                    <a:lnR w="5715" cap="flat" cmpd="sng" algn="ctr">
-                      <a:solidFill>
-                        <a:srgbClr val="FFFFFF"/>
-                      </a:solidFill>
-                      <a:prstDash val="solid"/>
-                      <a:round/>
-                      <a:headEnd type="none" w="med" len="med"/>
-                      <a:tailEnd type="none" w="med" len="med"/>
-                    </a:lnR>
-                    <a:lnT w="5715" cap="flat" cmpd="sng" algn="ctr">
-                      <a:solidFill>
-                        <a:srgbClr val="FFFFFF"/>
-                      </a:solidFill>
-                      <a:prstDash val="solid"/>
-                      <a:round/>
-                      <a:headEnd type="none" w="med" len="med"/>
-                      <a:tailEnd type="none" w="med" len="med"/>
-                    </a:lnT>
-                    <a:lnB w="5715" cap="flat" cmpd="sng" algn="ctr">
-                      <a:solidFill>
-                        <a:srgbClr val="FFFFFF"/>
-                      </a:solidFill>
-                      <a:prstDash val="solid"/>
-                      <a:round/>
-                      <a:headEnd type="none" w="med" len="med"/>
-                      <a:tailEnd type="none" w="med" len="med"/>
-                    </a:lnB>
-                    <a:solidFill>
-                      <a:srgbClr val="F1F1F1"/>
-                    </a:solidFill>
-                  </a:tcPr>
-                </a:tc>
-                <a:tc>
-                  <a:txBody>
-                    <a:bodyPr/>
-                    <a:lstStyle/>
-                    <a:p>
-                      <a:pPr algn="ctr" indent="0" marL="0">
-                        <a:buNone/>
-                      </a:pPr>
-                      <a:r>
-                        <a:rPr lang="en-US" sz="615" dirty="0">
-                          <a:solidFill>
-                            <a:srgbClr val="1F1F1F"/>
-                          </a:solidFill>
-                          <a:latin typeface="Calibri" pitchFamily="34" charset="0"/>
-                          <a:ea typeface="Calibri" pitchFamily="34" charset="-122"/>
-                          <a:cs typeface="Calibri" pitchFamily="34" charset="-120"/>
-                        </a:rPr>
-                        <a:t>R$ 105,7 mi</a:t>
+                        <a:t>R$ 4,5 mi</a:t>
                       </a:r>
                       <a:endParaRPr lang="en-US" sz="615" dirty="0">
                         <a:latin typeface="Calibri" charset="0"/>
@@ -13342,7 +13206,143 @@
                           <a:ea typeface="Calibri" pitchFamily="34" charset="-122"/>
                           <a:cs typeface="Calibri" pitchFamily="34" charset="-120"/>
                         </a:rPr>
-                        <a:t>52,06%</a:t>
+                        <a:t>R$ 147,4 mi</a:t>
+                      </a:r>
+                      <a:endParaRPr lang="en-US" sz="615" dirty="0">
+                        <a:latin typeface="Calibri" charset="0"/>
+                        <a:ea typeface="Calibri" charset="0"/>
+                        <a:cs typeface="Calibri" charset="0"/>
+                      </a:endParaRPr>
+                    </a:p>
+                  </a:txBody>
+                  <a:tcPr marL="36576" marR="36576" marT="18288" marB="18288" anchor="mid">
+                    <a:lnL w="5715" cap="flat" cmpd="sng" algn="ctr">
+                      <a:solidFill>
+                        <a:srgbClr val="FFFFFF"/>
+                      </a:solidFill>
+                      <a:prstDash val="solid"/>
+                      <a:round/>
+                      <a:headEnd type="none" w="med" len="med"/>
+                      <a:tailEnd type="none" w="med" len="med"/>
+                    </a:lnL>
+                    <a:lnR w="5715" cap="flat" cmpd="sng" algn="ctr">
+                      <a:solidFill>
+                        <a:srgbClr val="FFFFFF"/>
+                      </a:solidFill>
+                      <a:prstDash val="solid"/>
+                      <a:round/>
+                      <a:headEnd type="none" w="med" len="med"/>
+                      <a:tailEnd type="none" w="med" len="med"/>
+                    </a:lnR>
+                    <a:lnT w="5715" cap="flat" cmpd="sng" algn="ctr">
+                      <a:solidFill>
+                        <a:srgbClr val="FFFFFF"/>
+                      </a:solidFill>
+                      <a:prstDash val="solid"/>
+                      <a:round/>
+                      <a:headEnd type="none" w="med" len="med"/>
+                      <a:tailEnd type="none" w="med" len="med"/>
+                    </a:lnT>
+                    <a:lnB w="5715" cap="flat" cmpd="sng" algn="ctr">
+                      <a:solidFill>
+                        <a:srgbClr val="FFFFFF"/>
+                      </a:solidFill>
+                      <a:prstDash val="solid"/>
+                      <a:round/>
+                      <a:headEnd type="none" w="med" len="med"/>
+                      <a:tailEnd type="none" w="med" len="med"/>
+                    </a:lnB>
+                    <a:solidFill>
+                      <a:srgbClr val="F1F1F1"/>
+                    </a:solidFill>
+                  </a:tcPr>
+                </a:tc>
+                <a:tc>
+                  <a:txBody>
+                    <a:bodyPr/>
+                    <a:lstStyle/>
+                    <a:p>
+                      <a:pPr algn="ctr" indent="0" marL="0">
+                        <a:buNone/>
+                      </a:pPr>
+                      <a:r>
+                        <a:rPr lang="en-US" sz="615" dirty="0">
+                          <a:solidFill>
+                            <a:srgbClr val="1F1F1F"/>
+                          </a:solidFill>
+                          <a:latin typeface="Calibri" pitchFamily="34" charset="0"/>
+                          <a:ea typeface="Calibri" pitchFamily="34" charset="-122"/>
+                          <a:cs typeface="Calibri" pitchFamily="34" charset="-120"/>
+                        </a:rPr>
+                        <a:t>R$ 0,00</a:t>
+                      </a:r>
+                      <a:endParaRPr lang="en-US" sz="615" dirty="0">
+                        <a:latin typeface="Calibri" charset="0"/>
+                        <a:ea typeface="Calibri" charset="0"/>
+                        <a:cs typeface="Calibri" charset="0"/>
+                      </a:endParaRPr>
+                    </a:p>
+                  </a:txBody>
+                  <a:tcPr marL="36576" marR="36576" marT="18288" marB="18288" anchor="mid">
+                    <a:lnL w="5715" cap="flat" cmpd="sng" algn="ctr">
+                      <a:solidFill>
+                        <a:srgbClr val="FFFFFF"/>
+                      </a:solidFill>
+                      <a:prstDash val="solid"/>
+                      <a:round/>
+                      <a:headEnd type="none" w="med" len="med"/>
+                      <a:tailEnd type="none" w="med" len="med"/>
+                    </a:lnL>
+                    <a:lnR w="5715" cap="flat" cmpd="sng" algn="ctr">
+                      <a:solidFill>
+                        <a:srgbClr val="FFFFFF"/>
+                      </a:solidFill>
+                      <a:prstDash val="solid"/>
+                      <a:round/>
+                      <a:headEnd type="none" w="med" len="med"/>
+                      <a:tailEnd type="none" w="med" len="med"/>
+                    </a:lnR>
+                    <a:lnT w="5715" cap="flat" cmpd="sng" algn="ctr">
+                      <a:solidFill>
+                        <a:srgbClr val="FFFFFF"/>
+                      </a:solidFill>
+                      <a:prstDash val="solid"/>
+                      <a:round/>
+                      <a:headEnd type="none" w="med" len="med"/>
+                      <a:tailEnd type="none" w="med" len="med"/>
+                    </a:lnT>
+                    <a:lnB w="5715" cap="flat" cmpd="sng" algn="ctr">
+                      <a:solidFill>
+                        <a:srgbClr val="FFFFFF"/>
+                      </a:solidFill>
+                      <a:prstDash val="solid"/>
+                      <a:round/>
+                      <a:headEnd type="none" w="med" len="med"/>
+                      <a:tailEnd type="none" w="med" len="med"/>
+                    </a:lnB>
+                    <a:solidFill>
+                      <a:srgbClr val="F1F1F1"/>
+                    </a:solidFill>
+                  </a:tcPr>
+                </a:tc>
+                <a:tc>
+                  <a:txBody>
+                    <a:bodyPr/>
+                    <a:lstStyle/>
+                    <a:p>
+                      <a:pPr algn="ctr" indent="0" marL="0">
+                        <a:buNone/>
+                      </a:pPr>
+                      <a:r>
+                        <a:rPr lang="en-US" sz="615" dirty="0">
+                          <a:solidFill>
+                            <a:srgbClr val="1F1F1F"/>
+                          </a:solidFill>
+                          <a:latin typeface="Calibri" pitchFamily="34" charset="0"/>
+                          <a:ea typeface="Calibri" pitchFamily="34" charset="-122"/>
+                          <a:cs typeface="Calibri" pitchFamily="34" charset="-120"/>
+                        </a:rPr>
+                        <a:t>30,31%</a:t>
                       </a:r>
                       <a:endParaRPr lang="en-US" sz="615" dirty="0">
                         <a:latin typeface="Calibri" charset="0"/>
@@ -13480,7 +13480,7 @@
                           <a:ea typeface="Calibri" pitchFamily="34" charset="-122"/>
                           <a:cs typeface="Calibri" pitchFamily="34" charset="-120"/>
                         </a:rPr>
-                        <a:t>R$ 91,1 mi</a:t>
+                        <a:t>R$ 124,5 mi</a:t>
                       </a:r>
                       <a:endParaRPr lang="en-US" sz="615" dirty="0">
                         <a:latin typeface="Calibri" charset="0"/>
@@ -13548,143 +13548,7 @@
                           <a:ea typeface="Calibri" pitchFamily="34" charset="-122"/>
                           <a:cs typeface="Calibri" pitchFamily="34" charset="-120"/>
                         </a:rPr>
-                        <a:t>R$ 16,3 mi</a:t>
-                      </a:r>
-                      <a:endParaRPr lang="en-US" sz="615" dirty="0">
-                        <a:latin typeface="Calibri" charset="0"/>
-                        <a:ea typeface="Calibri" charset="0"/>
-                        <a:cs typeface="Calibri" charset="0"/>
-                      </a:endParaRPr>
-                    </a:p>
-                  </a:txBody>
-                  <a:tcPr marL="36576" marR="36576" marT="18288" marB="18288" anchor="mid">
-                    <a:lnL w="5715" cap="flat" cmpd="sng" algn="ctr">
-                      <a:solidFill>
-                        <a:srgbClr val="FFFFFF"/>
-                      </a:solidFill>
-                      <a:prstDash val="solid"/>
-                      <a:round/>
-                      <a:headEnd type="none" w="med" len="med"/>
-                      <a:tailEnd type="none" w="med" len="med"/>
-                    </a:lnL>
-                    <a:lnR w="5715" cap="flat" cmpd="sng" algn="ctr">
-                      <a:solidFill>
-                        <a:srgbClr val="FFFFFF"/>
-                      </a:solidFill>
-                      <a:prstDash val="solid"/>
-                      <a:round/>
-                      <a:headEnd type="none" w="med" len="med"/>
-                      <a:tailEnd type="none" w="med" len="med"/>
-                    </a:lnR>
-                    <a:lnT w="5715" cap="flat" cmpd="sng" algn="ctr">
-                      <a:solidFill>
-                        <a:srgbClr val="FFFFFF"/>
-                      </a:solidFill>
-                      <a:prstDash val="solid"/>
-                      <a:round/>
-                      <a:headEnd type="none" w="med" len="med"/>
-                      <a:tailEnd type="none" w="med" len="med"/>
-                    </a:lnT>
-                    <a:lnB w="5715" cap="flat" cmpd="sng" algn="ctr">
-                      <a:solidFill>
-                        <a:srgbClr val="FFFFFF"/>
-                      </a:solidFill>
-                      <a:prstDash val="solid"/>
-                      <a:round/>
-                      <a:headEnd type="none" w="med" len="med"/>
-                      <a:tailEnd type="none" w="med" len="med"/>
-                    </a:lnB>
-                    <a:solidFill>
-                      <a:srgbClr val="FFFFFF"/>
-                    </a:solidFill>
-                  </a:tcPr>
-                </a:tc>
-                <a:tc>
-                  <a:txBody>
-                    <a:bodyPr/>
-                    <a:lstStyle/>
-                    <a:p>
-                      <a:pPr algn="ctr" indent="0" marL="0">
-                        <a:buNone/>
-                      </a:pPr>
-                      <a:r>
-                        <a:rPr lang="en-US" sz="615" dirty="0">
-                          <a:solidFill>
-                            <a:srgbClr val="1F1F1F"/>
-                          </a:solidFill>
-                          <a:latin typeface="Calibri" pitchFamily="34" charset="0"/>
-                          <a:ea typeface="Calibri" pitchFamily="34" charset="-122"/>
-                          <a:cs typeface="Calibri" pitchFamily="34" charset="-120"/>
-                        </a:rPr>
-                        <a:t>R$ 76,4 mi</a:t>
-                      </a:r>
-                      <a:endParaRPr lang="en-US" sz="615" dirty="0">
-                        <a:latin typeface="Calibri" charset="0"/>
-                        <a:ea typeface="Calibri" charset="0"/>
-                        <a:cs typeface="Calibri" charset="0"/>
-                      </a:endParaRPr>
-                    </a:p>
-                  </a:txBody>
-                  <a:tcPr marL="36576" marR="36576" marT="18288" marB="18288" anchor="mid">
-                    <a:lnL w="5715" cap="flat" cmpd="sng" algn="ctr">
-                      <a:solidFill>
-                        <a:srgbClr val="FFFFFF"/>
-                      </a:solidFill>
-                      <a:prstDash val="solid"/>
-                      <a:round/>
-                      <a:headEnd type="none" w="med" len="med"/>
-                      <a:tailEnd type="none" w="med" len="med"/>
-                    </a:lnL>
-                    <a:lnR w="5715" cap="flat" cmpd="sng" algn="ctr">
-                      <a:solidFill>
-                        <a:srgbClr val="FFFFFF"/>
-                      </a:solidFill>
-                      <a:prstDash val="solid"/>
-                      <a:round/>
-                      <a:headEnd type="none" w="med" len="med"/>
-                      <a:tailEnd type="none" w="med" len="med"/>
-                    </a:lnR>
-                    <a:lnT w="5715" cap="flat" cmpd="sng" algn="ctr">
-                      <a:solidFill>
-                        <a:srgbClr val="FFFFFF"/>
-                      </a:solidFill>
-                      <a:prstDash val="solid"/>
-                      <a:round/>
-                      <a:headEnd type="none" w="med" len="med"/>
-                      <a:tailEnd type="none" w="med" len="med"/>
-                    </a:lnT>
-                    <a:lnB w="5715" cap="flat" cmpd="sng" algn="ctr">
-                      <a:solidFill>
-                        <a:srgbClr val="FFFFFF"/>
-                      </a:solidFill>
-                      <a:prstDash val="solid"/>
-                      <a:round/>
-                      <a:headEnd type="none" w="med" len="med"/>
-                      <a:tailEnd type="none" w="med" len="med"/>
-                    </a:lnB>
-                    <a:solidFill>
-                      <a:srgbClr val="FFFFFF"/>
-                    </a:solidFill>
-                  </a:tcPr>
-                </a:tc>
-                <a:tc>
-                  <a:txBody>
-                    <a:bodyPr/>
-                    <a:lstStyle/>
-                    <a:p>
-                      <a:pPr algn="ctr" indent="0" marL="0">
-                        <a:buNone/>
-                      </a:pPr>
-                      <a:r>
-                        <a:rPr lang="en-US" sz="615" dirty="0">
-                          <a:solidFill>
-                            <a:srgbClr val="1F1F1F"/>
-                          </a:solidFill>
-                          <a:latin typeface="Calibri" pitchFamily="34" charset="0"/>
-                          <a:ea typeface="Calibri" pitchFamily="34" charset="-122"/>
-                          <a:cs typeface="Calibri" pitchFamily="34" charset="-120"/>
-                        </a:rPr>
-                        <a:t>R$ 107,4 mi</a:t>
+                        <a:t>R$ 2,6 mi</a:t>
                       </a:r>
                       <a:endParaRPr lang="en-US" sz="615" dirty="0">
                         <a:latin typeface="Calibri" charset="0"/>
@@ -13820,7 +13684,143 @@
                           <a:ea typeface="Calibri" pitchFamily="34" charset="-122"/>
                           <a:cs typeface="Calibri" pitchFamily="34" charset="-120"/>
                         </a:rPr>
-                        <a:t>54,92%</a:t>
+                        <a:t>R$ 127,1 mi</a:t>
+                      </a:r>
+                      <a:endParaRPr lang="en-US" sz="615" dirty="0">
+                        <a:latin typeface="Calibri" charset="0"/>
+                        <a:ea typeface="Calibri" charset="0"/>
+                        <a:cs typeface="Calibri" charset="0"/>
+                      </a:endParaRPr>
+                    </a:p>
+                  </a:txBody>
+                  <a:tcPr marL="36576" marR="36576" marT="18288" marB="18288" anchor="mid">
+                    <a:lnL w="5715" cap="flat" cmpd="sng" algn="ctr">
+                      <a:solidFill>
+                        <a:srgbClr val="FFFFFF"/>
+                      </a:solidFill>
+                      <a:prstDash val="solid"/>
+                      <a:round/>
+                      <a:headEnd type="none" w="med" len="med"/>
+                      <a:tailEnd type="none" w="med" len="med"/>
+                    </a:lnL>
+                    <a:lnR w="5715" cap="flat" cmpd="sng" algn="ctr">
+                      <a:solidFill>
+                        <a:srgbClr val="FFFFFF"/>
+                      </a:solidFill>
+                      <a:prstDash val="solid"/>
+                      <a:round/>
+                      <a:headEnd type="none" w="med" len="med"/>
+                      <a:tailEnd type="none" w="med" len="med"/>
+                    </a:lnR>
+                    <a:lnT w="5715" cap="flat" cmpd="sng" algn="ctr">
+                      <a:solidFill>
+                        <a:srgbClr val="FFFFFF"/>
+                      </a:solidFill>
+                      <a:prstDash val="solid"/>
+                      <a:round/>
+                      <a:headEnd type="none" w="med" len="med"/>
+                      <a:tailEnd type="none" w="med" len="med"/>
+                    </a:lnT>
+                    <a:lnB w="5715" cap="flat" cmpd="sng" algn="ctr">
+                      <a:solidFill>
+                        <a:srgbClr val="FFFFFF"/>
+                      </a:solidFill>
+                      <a:prstDash val="solid"/>
+                      <a:round/>
+                      <a:headEnd type="none" w="med" len="med"/>
+                      <a:tailEnd type="none" w="med" len="med"/>
+                    </a:lnB>
+                    <a:solidFill>
+                      <a:srgbClr val="FFFFFF"/>
+                    </a:solidFill>
+                  </a:tcPr>
+                </a:tc>
+                <a:tc>
+                  <a:txBody>
+                    <a:bodyPr/>
+                    <a:lstStyle/>
+                    <a:p>
+                      <a:pPr algn="ctr" indent="0" marL="0">
+                        <a:buNone/>
+                      </a:pPr>
+                      <a:r>
+                        <a:rPr lang="en-US" sz="615" dirty="0">
+                          <a:solidFill>
+                            <a:srgbClr val="1F1F1F"/>
+                          </a:solidFill>
+                          <a:latin typeface="Calibri" pitchFamily="34" charset="0"/>
+                          <a:ea typeface="Calibri" pitchFamily="34" charset="-122"/>
+                          <a:cs typeface="Calibri" pitchFamily="34" charset="-120"/>
+                        </a:rPr>
+                        <a:t>R$ 0,00</a:t>
+                      </a:r>
+                      <a:endParaRPr lang="en-US" sz="615" dirty="0">
+                        <a:latin typeface="Calibri" charset="0"/>
+                        <a:ea typeface="Calibri" charset="0"/>
+                        <a:cs typeface="Calibri" charset="0"/>
+                      </a:endParaRPr>
+                    </a:p>
+                  </a:txBody>
+                  <a:tcPr marL="36576" marR="36576" marT="18288" marB="18288" anchor="mid">
+                    <a:lnL w="5715" cap="flat" cmpd="sng" algn="ctr">
+                      <a:solidFill>
+                        <a:srgbClr val="FFFFFF"/>
+                      </a:solidFill>
+                      <a:prstDash val="solid"/>
+                      <a:round/>
+                      <a:headEnd type="none" w="med" len="med"/>
+                      <a:tailEnd type="none" w="med" len="med"/>
+                    </a:lnL>
+                    <a:lnR w="5715" cap="flat" cmpd="sng" algn="ctr">
+                      <a:solidFill>
+                        <a:srgbClr val="FFFFFF"/>
+                      </a:solidFill>
+                      <a:prstDash val="solid"/>
+                      <a:round/>
+                      <a:headEnd type="none" w="med" len="med"/>
+                      <a:tailEnd type="none" w="med" len="med"/>
+                    </a:lnR>
+                    <a:lnT w="5715" cap="flat" cmpd="sng" algn="ctr">
+                      <a:solidFill>
+                        <a:srgbClr val="FFFFFF"/>
+                      </a:solidFill>
+                      <a:prstDash val="solid"/>
+                      <a:round/>
+                      <a:headEnd type="none" w="med" len="med"/>
+                      <a:tailEnd type="none" w="med" len="med"/>
+                    </a:lnT>
+                    <a:lnB w="5715" cap="flat" cmpd="sng" algn="ctr">
+                      <a:solidFill>
+                        <a:srgbClr val="FFFFFF"/>
+                      </a:solidFill>
+                      <a:prstDash val="solid"/>
+                      <a:round/>
+                      <a:headEnd type="none" w="med" len="med"/>
+                      <a:tailEnd type="none" w="med" len="med"/>
+                    </a:lnB>
+                    <a:solidFill>
+                      <a:srgbClr val="FFFFFF"/>
+                    </a:solidFill>
+                  </a:tcPr>
+                </a:tc>
+                <a:tc>
+                  <a:txBody>
+                    <a:bodyPr/>
+                    <a:lstStyle/>
+                    <a:p>
+                      <a:pPr algn="ctr" indent="0" marL="0">
+                        <a:buNone/>
+                      </a:pPr>
+                      <a:r>
+                        <a:rPr lang="en-US" sz="615" dirty="0">
+                          <a:solidFill>
+                            <a:srgbClr val="1F1F1F"/>
+                          </a:solidFill>
+                          <a:latin typeface="Calibri" pitchFamily="34" charset="0"/>
+                          <a:ea typeface="Calibri" pitchFamily="34" charset="-122"/>
+                          <a:cs typeface="Calibri" pitchFamily="34" charset="-120"/>
+                        </a:rPr>
+                        <a:t>30,50%</a:t>
                       </a:r>
                       <a:endParaRPr lang="en-US" sz="615" dirty="0">
                         <a:latin typeface="Calibri" charset="0"/>
@@ -13958,211 +13958,7 @@
                           <a:ea typeface="Calibri" pitchFamily="34" charset="-122"/>
                           <a:cs typeface="Calibri" pitchFamily="34" charset="-120"/>
                         </a:rPr>
-                        <a:t>R$ 92,5 mi</a:t>
-                      </a:r>
-                      <a:endParaRPr lang="en-US" sz="615" dirty="0">
-                        <a:latin typeface="Calibri" charset="0"/>
-                        <a:ea typeface="Calibri" charset="0"/>
-                        <a:cs typeface="Calibri" charset="0"/>
-                      </a:endParaRPr>
-                    </a:p>
-                  </a:txBody>
-                  <a:tcPr marL="36576" marR="36576" marT="18288" marB="18288" anchor="mid">
-                    <a:lnL w="5715" cap="flat" cmpd="sng" algn="ctr">
-                      <a:solidFill>
-                        <a:srgbClr val="FFFFFF"/>
-                      </a:solidFill>
-                      <a:prstDash val="solid"/>
-                      <a:round/>
-                      <a:headEnd type="none" w="med" len="med"/>
-                      <a:tailEnd type="none" w="med" len="med"/>
-                    </a:lnL>
-                    <a:lnR w="5715" cap="flat" cmpd="sng" algn="ctr">
-                      <a:solidFill>
-                        <a:srgbClr val="FFFFFF"/>
-                      </a:solidFill>
-                      <a:prstDash val="solid"/>
-                      <a:round/>
-                      <a:headEnd type="none" w="med" len="med"/>
-                      <a:tailEnd type="none" w="med" len="med"/>
-                    </a:lnR>
-                    <a:lnT w="5715" cap="flat" cmpd="sng" algn="ctr">
-                      <a:solidFill>
-                        <a:srgbClr val="FFFFFF"/>
-                      </a:solidFill>
-                      <a:prstDash val="solid"/>
-                      <a:round/>
-                      <a:headEnd type="none" w="med" len="med"/>
-                      <a:tailEnd type="none" w="med" len="med"/>
-                    </a:lnT>
-                    <a:lnB w="5715" cap="flat" cmpd="sng" algn="ctr">
-                      <a:solidFill>
-                        <a:srgbClr val="FFFFFF"/>
-                      </a:solidFill>
-                      <a:prstDash val="solid"/>
-                      <a:round/>
-                      <a:headEnd type="none" w="med" len="med"/>
-                      <a:tailEnd type="none" w="med" len="med"/>
-                    </a:lnB>
-                    <a:solidFill>
-                      <a:srgbClr val="F1F1F1"/>
-                    </a:solidFill>
-                  </a:tcPr>
-                </a:tc>
-                <a:tc>
-                  <a:txBody>
-                    <a:bodyPr/>
-                    <a:lstStyle/>
-                    <a:p>
-                      <a:pPr algn="ctr" indent="0" marL="0">
-                        <a:buNone/>
-                      </a:pPr>
-                      <a:r>
-                        <a:rPr lang="en-US" sz="615" dirty="0">
-                          <a:solidFill>
-                            <a:srgbClr val="1F1F1F"/>
-                          </a:solidFill>
-                          <a:latin typeface="Calibri" pitchFamily="34" charset="0"/>
-                          <a:ea typeface="Calibri" pitchFamily="34" charset="-122"/>
-                          <a:cs typeface="Calibri" pitchFamily="34" charset="-120"/>
-                        </a:rPr>
-                        <a:t>R$ 16,5 mi</a:t>
-                      </a:r>
-                      <a:endParaRPr lang="en-US" sz="615" dirty="0">
-                        <a:latin typeface="Calibri" charset="0"/>
-                        <a:ea typeface="Calibri" charset="0"/>
-                        <a:cs typeface="Calibri" charset="0"/>
-                      </a:endParaRPr>
-                    </a:p>
-                  </a:txBody>
-                  <a:tcPr marL="36576" marR="36576" marT="18288" marB="18288" anchor="mid">
-                    <a:lnL w="5715" cap="flat" cmpd="sng" algn="ctr">
-                      <a:solidFill>
-                        <a:srgbClr val="FFFFFF"/>
-                      </a:solidFill>
-                      <a:prstDash val="solid"/>
-                      <a:round/>
-                      <a:headEnd type="none" w="med" len="med"/>
-                      <a:tailEnd type="none" w="med" len="med"/>
-                    </a:lnL>
-                    <a:lnR w="5715" cap="flat" cmpd="sng" algn="ctr">
-                      <a:solidFill>
-                        <a:srgbClr val="FFFFFF"/>
-                      </a:solidFill>
-                      <a:prstDash val="solid"/>
-                      <a:round/>
-                      <a:headEnd type="none" w="med" len="med"/>
-                      <a:tailEnd type="none" w="med" len="med"/>
-                    </a:lnR>
-                    <a:lnT w="5715" cap="flat" cmpd="sng" algn="ctr">
-                      <a:solidFill>
-                        <a:srgbClr val="FFFFFF"/>
-                      </a:solidFill>
-                      <a:prstDash val="solid"/>
-                      <a:round/>
-                      <a:headEnd type="none" w="med" len="med"/>
-                      <a:tailEnd type="none" w="med" len="med"/>
-                    </a:lnT>
-                    <a:lnB w="5715" cap="flat" cmpd="sng" algn="ctr">
-                      <a:solidFill>
-                        <a:srgbClr val="FFFFFF"/>
-                      </a:solidFill>
-                      <a:prstDash val="solid"/>
-                      <a:round/>
-                      <a:headEnd type="none" w="med" len="med"/>
-                      <a:tailEnd type="none" w="med" len="med"/>
-                    </a:lnB>
-                    <a:solidFill>
-                      <a:srgbClr val="F1F1F1"/>
-                    </a:solidFill>
-                  </a:tcPr>
-                </a:tc>
-                <a:tc>
-                  <a:txBody>
-                    <a:bodyPr/>
-                    <a:lstStyle/>
-                    <a:p>
-                      <a:pPr algn="ctr" indent="0" marL="0">
-                        <a:buNone/>
-                      </a:pPr>
-                      <a:r>
-                        <a:rPr lang="en-US" sz="615" dirty="0">
-                          <a:solidFill>
-                            <a:srgbClr val="1F1F1F"/>
-                          </a:solidFill>
-                          <a:latin typeface="Calibri" pitchFamily="34" charset="0"/>
-                          <a:ea typeface="Calibri" pitchFamily="34" charset="-122"/>
-                          <a:cs typeface="Calibri" pitchFamily="34" charset="-120"/>
-                        </a:rPr>
-                        <a:t>R$ 71,1 mi</a:t>
-                      </a:r>
-                      <a:endParaRPr lang="en-US" sz="615" dirty="0">
-                        <a:latin typeface="Calibri" charset="0"/>
-                        <a:ea typeface="Calibri" charset="0"/>
-                        <a:cs typeface="Calibri" charset="0"/>
-                      </a:endParaRPr>
-                    </a:p>
-                  </a:txBody>
-                  <a:tcPr marL="36576" marR="36576" marT="18288" marB="18288" anchor="mid">
-                    <a:lnL w="5715" cap="flat" cmpd="sng" algn="ctr">
-                      <a:solidFill>
-                        <a:srgbClr val="FFFFFF"/>
-                      </a:solidFill>
-                      <a:prstDash val="solid"/>
-                      <a:round/>
-                      <a:headEnd type="none" w="med" len="med"/>
-                      <a:tailEnd type="none" w="med" len="med"/>
-                    </a:lnL>
-                    <a:lnR w="5715" cap="flat" cmpd="sng" algn="ctr">
-                      <a:solidFill>
-                        <a:srgbClr val="FFFFFF"/>
-                      </a:solidFill>
-                      <a:prstDash val="solid"/>
-                      <a:round/>
-                      <a:headEnd type="none" w="med" len="med"/>
-                      <a:tailEnd type="none" w="med" len="med"/>
-                    </a:lnR>
-                    <a:lnT w="5715" cap="flat" cmpd="sng" algn="ctr">
-                      <a:solidFill>
-                        <a:srgbClr val="FFFFFF"/>
-                      </a:solidFill>
-                      <a:prstDash val="solid"/>
-                      <a:round/>
-                      <a:headEnd type="none" w="med" len="med"/>
-                      <a:tailEnd type="none" w="med" len="med"/>
-                    </a:lnT>
-                    <a:lnB w="5715" cap="flat" cmpd="sng" algn="ctr">
-                      <a:solidFill>
-                        <a:srgbClr val="FFFFFF"/>
-                      </a:solidFill>
-                      <a:prstDash val="solid"/>
-                      <a:round/>
-                      <a:headEnd type="none" w="med" len="med"/>
-                      <a:tailEnd type="none" w="med" len="med"/>
-                    </a:lnB>
-                    <a:solidFill>
-                      <a:srgbClr val="F1F1F1"/>
-                    </a:solidFill>
-                  </a:tcPr>
-                </a:tc>
-                <a:tc>
-                  <a:txBody>
-                    <a:bodyPr/>
-                    <a:lstStyle/>
-                    <a:p>
-                      <a:pPr algn="ctr" indent="0" marL="0">
-                        <a:buNone/>
-                      </a:pPr>
-                      <a:r>
-                        <a:rPr lang="en-US" sz="615" dirty="0">
-                          <a:solidFill>
-                            <a:srgbClr val="1F1F1F"/>
-                          </a:solidFill>
-                          <a:latin typeface="Calibri" pitchFamily="34" charset="0"/>
-                          <a:ea typeface="Calibri" pitchFamily="34" charset="-122"/>
-                          <a:cs typeface="Calibri" pitchFamily="34" charset="-120"/>
-                        </a:rPr>
-                        <a:t>R$ 109 mi</a:t>
+                        <a:t>R$ 105,8 mi</a:t>
                       </a:r>
                       <a:endParaRPr lang="en-US" sz="615" dirty="0">
                         <a:latin typeface="Calibri" charset="0"/>
@@ -14298,7 +14094,211 @@
                           <a:ea typeface="Calibri" pitchFamily="34" charset="-122"/>
                           <a:cs typeface="Calibri" pitchFamily="34" charset="-120"/>
                         </a:rPr>
-                        <a:t>57,33%</a:t>
+                        <a:t>R$ 0,00</a:t>
+                      </a:r>
+                      <a:endParaRPr lang="en-US" sz="615" dirty="0">
+                        <a:latin typeface="Calibri" charset="0"/>
+                        <a:ea typeface="Calibri" charset="0"/>
+                        <a:cs typeface="Calibri" charset="0"/>
+                      </a:endParaRPr>
+                    </a:p>
+                  </a:txBody>
+                  <a:tcPr marL="36576" marR="36576" marT="18288" marB="18288" anchor="mid">
+                    <a:lnL w="5715" cap="flat" cmpd="sng" algn="ctr">
+                      <a:solidFill>
+                        <a:srgbClr val="FFFFFF"/>
+                      </a:solidFill>
+                      <a:prstDash val="solid"/>
+                      <a:round/>
+                      <a:headEnd type="none" w="med" len="med"/>
+                      <a:tailEnd type="none" w="med" len="med"/>
+                    </a:lnL>
+                    <a:lnR w="5715" cap="flat" cmpd="sng" algn="ctr">
+                      <a:solidFill>
+                        <a:srgbClr val="FFFFFF"/>
+                      </a:solidFill>
+                      <a:prstDash val="solid"/>
+                      <a:round/>
+                      <a:headEnd type="none" w="med" len="med"/>
+                      <a:tailEnd type="none" w="med" len="med"/>
+                    </a:lnR>
+                    <a:lnT w="5715" cap="flat" cmpd="sng" algn="ctr">
+                      <a:solidFill>
+                        <a:srgbClr val="FFFFFF"/>
+                      </a:solidFill>
+                      <a:prstDash val="solid"/>
+                      <a:round/>
+                      <a:headEnd type="none" w="med" len="med"/>
+                      <a:tailEnd type="none" w="med" len="med"/>
+                    </a:lnT>
+                    <a:lnB w="5715" cap="flat" cmpd="sng" algn="ctr">
+                      <a:solidFill>
+                        <a:srgbClr val="FFFFFF"/>
+                      </a:solidFill>
+                      <a:prstDash val="solid"/>
+                      <a:round/>
+                      <a:headEnd type="none" w="med" len="med"/>
+                      <a:tailEnd type="none" w="med" len="med"/>
+                    </a:lnB>
+                    <a:solidFill>
+                      <a:srgbClr val="F1F1F1"/>
+                    </a:solidFill>
+                  </a:tcPr>
+                </a:tc>
+                <a:tc>
+                  <a:txBody>
+                    <a:bodyPr/>
+                    <a:lstStyle/>
+                    <a:p>
+                      <a:pPr algn="ctr" indent="0" marL="0">
+                        <a:buNone/>
+                      </a:pPr>
+                      <a:r>
+                        <a:rPr lang="en-US" sz="615" dirty="0">
+                          <a:solidFill>
+                            <a:srgbClr val="1F1F1F"/>
+                          </a:solidFill>
+                          <a:latin typeface="Calibri" pitchFamily="34" charset="0"/>
+                          <a:ea typeface="Calibri" pitchFamily="34" charset="-122"/>
+                          <a:cs typeface="Calibri" pitchFamily="34" charset="-120"/>
+                        </a:rPr>
+                        <a:t>R$ 105,8 mi</a:t>
+                      </a:r>
+                      <a:endParaRPr lang="en-US" sz="615" dirty="0">
+                        <a:latin typeface="Calibri" charset="0"/>
+                        <a:ea typeface="Calibri" charset="0"/>
+                        <a:cs typeface="Calibri" charset="0"/>
+                      </a:endParaRPr>
+                    </a:p>
+                  </a:txBody>
+                  <a:tcPr marL="36576" marR="36576" marT="18288" marB="18288" anchor="mid">
+                    <a:lnL w="5715" cap="flat" cmpd="sng" algn="ctr">
+                      <a:solidFill>
+                        <a:srgbClr val="FFFFFF"/>
+                      </a:solidFill>
+                      <a:prstDash val="solid"/>
+                      <a:round/>
+                      <a:headEnd type="none" w="med" len="med"/>
+                      <a:tailEnd type="none" w="med" len="med"/>
+                    </a:lnL>
+                    <a:lnR w="5715" cap="flat" cmpd="sng" algn="ctr">
+                      <a:solidFill>
+                        <a:srgbClr val="FFFFFF"/>
+                      </a:solidFill>
+                      <a:prstDash val="solid"/>
+                      <a:round/>
+                      <a:headEnd type="none" w="med" len="med"/>
+                      <a:tailEnd type="none" w="med" len="med"/>
+                    </a:lnR>
+                    <a:lnT w="5715" cap="flat" cmpd="sng" algn="ctr">
+                      <a:solidFill>
+                        <a:srgbClr val="FFFFFF"/>
+                      </a:solidFill>
+                      <a:prstDash val="solid"/>
+                      <a:round/>
+                      <a:headEnd type="none" w="med" len="med"/>
+                      <a:tailEnd type="none" w="med" len="med"/>
+                    </a:lnT>
+                    <a:lnB w="5715" cap="flat" cmpd="sng" algn="ctr">
+                      <a:solidFill>
+                        <a:srgbClr val="FFFFFF"/>
+                      </a:solidFill>
+                      <a:prstDash val="solid"/>
+                      <a:round/>
+                      <a:headEnd type="none" w="med" len="med"/>
+                      <a:tailEnd type="none" w="med" len="med"/>
+                    </a:lnB>
+                    <a:solidFill>
+                      <a:srgbClr val="F1F1F1"/>
+                    </a:solidFill>
+                  </a:tcPr>
+                </a:tc>
+                <a:tc>
+                  <a:txBody>
+                    <a:bodyPr/>
+                    <a:lstStyle/>
+                    <a:p>
+                      <a:pPr algn="ctr" indent="0" marL="0">
+                        <a:buNone/>
+                      </a:pPr>
+                      <a:r>
+                        <a:rPr lang="en-US" sz="615" dirty="0">
+                          <a:solidFill>
+                            <a:srgbClr val="1F1F1F"/>
+                          </a:solidFill>
+                          <a:latin typeface="Calibri" pitchFamily="34" charset="0"/>
+                          <a:ea typeface="Calibri" pitchFamily="34" charset="-122"/>
+                          <a:cs typeface="Calibri" pitchFamily="34" charset="-120"/>
+                        </a:rPr>
+                        <a:t>R$ 0,00</a:t>
+                      </a:r>
+                      <a:endParaRPr lang="en-US" sz="615" dirty="0">
+                        <a:latin typeface="Calibri" charset="0"/>
+                        <a:ea typeface="Calibri" charset="0"/>
+                        <a:cs typeface="Calibri" charset="0"/>
+                      </a:endParaRPr>
+                    </a:p>
+                  </a:txBody>
+                  <a:tcPr marL="36576" marR="36576" marT="18288" marB="18288" anchor="mid">
+                    <a:lnL w="5715" cap="flat" cmpd="sng" algn="ctr">
+                      <a:solidFill>
+                        <a:srgbClr val="FFFFFF"/>
+                      </a:solidFill>
+                      <a:prstDash val="solid"/>
+                      <a:round/>
+                      <a:headEnd type="none" w="med" len="med"/>
+                      <a:tailEnd type="none" w="med" len="med"/>
+                    </a:lnL>
+                    <a:lnR w="5715" cap="flat" cmpd="sng" algn="ctr">
+                      <a:solidFill>
+                        <a:srgbClr val="FFFFFF"/>
+                      </a:solidFill>
+                      <a:prstDash val="solid"/>
+                      <a:round/>
+                      <a:headEnd type="none" w="med" len="med"/>
+                      <a:tailEnd type="none" w="med" len="med"/>
+                    </a:lnR>
+                    <a:lnT w="5715" cap="flat" cmpd="sng" algn="ctr">
+                      <a:solidFill>
+                        <a:srgbClr val="FFFFFF"/>
+                      </a:solidFill>
+                      <a:prstDash val="solid"/>
+                      <a:round/>
+                      <a:headEnd type="none" w="med" len="med"/>
+                      <a:tailEnd type="none" w="med" len="med"/>
+                    </a:lnT>
+                    <a:lnB w="5715" cap="flat" cmpd="sng" algn="ctr">
+                      <a:solidFill>
+                        <a:srgbClr val="FFFFFF"/>
+                      </a:solidFill>
+                      <a:prstDash val="solid"/>
+                      <a:round/>
+                      <a:headEnd type="none" w="med" len="med"/>
+                      <a:tailEnd type="none" w="med" len="med"/>
+                    </a:lnB>
+                    <a:solidFill>
+                      <a:srgbClr val="F1F1F1"/>
+                    </a:solidFill>
+                  </a:tcPr>
+                </a:tc>
+                <a:tc>
+                  <a:txBody>
+                    <a:bodyPr/>
+                    <a:lstStyle/>
+                    <a:p>
+                      <a:pPr algn="ctr" indent="0" marL="0">
+                        <a:buNone/>
+                      </a:pPr>
+                      <a:r>
+                        <a:rPr lang="en-US" sz="615" dirty="0">
+                          <a:solidFill>
+                            <a:srgbClr val="1F1F1F"/>
+                          </a:solidFill>
+                          <a:latin typeface="Calibri" pitchFamily="34" charset="0"/>
+                          <a:ea typeface="Calibri" pitchFamily="34" charset="-122"/>
+                          <a:cs typeface="Calibri" pitchFamily="34" charset="-120"/>
+                        </a:rPr>
+                        <a:t>30,22%</a:t>
                       </a:r>
                       <a:endParaRPr lang="en-US" sz="615" dirty="0">
                         <a:latin typeface="Calibri" charset="0"/>
@@ -14436,7 +14436,7 @@
                           <a:ea typeface="Calibri" pitchFamily="34" charset="-122"/>
                           <a:cs typeface="Calibri" pitchFamily="34" charset="-120"/>
                         </a:rPr>
-                        <a:t>R$ 93,9 mi</a:t>
+                        <a:t>R$ 86,7 mi</a:t>
                       </a:r>
                       <a:endParaRPr lang="en-US" sz="615" dirty="0">
                         <a:latin typeface="Calibri" charset="0"/>
@@ -14504,143 +14504,7 @@
                           <a:ea typeface="Calibri" pitchFamily="34" charset="-122"/>
                           <a:cs typeface="Calibri" pitchFamily="34" charset="-120"/>
                         </a:rPr>
-                        <a:t>R$ 16,8 mi</a:t>
-                      </a:r>
-                      <a:endParaRPr lang="en-US" sz="615" dirty="0">
-                        <a:latin typeface="Calibri" charset="0"/>
-                        <a:ea typeface="Calibri" charset="0"/>
-                        <a:cs typeface="Calibri" charset="0"/>
-                      </a:endParaRPr>
-                    </a:p>
-                  </a:txBody>
-                  <a:tcPr marL="36576" marR="36576" marT="18288" marB="18288" anchor="mid">
-                    <a:lnL w="5715" cap="flat" cmpd="sng" algn="ctr">
-                      <a:solidFill>
-                        <a:srgbClr val="FFFFFF"/>
-                      </a:solidFill>
-                      <a:prstDash val="solid"/>
-                      <a:round/>
-                      <a:headEnd type="none" w="med" len="med"/>
-                      <a:tailEnd type="none" w="med" len="med"/>
-                    </a:lnL>
-                    <a:lnR w="5715" cap="flat" cmpd="sng" algn="ctr">
-                      <a:solidFill>
-                        <a:srgbClr val="FFFFFF"/>
-                      </a:solidFill>
-                      <a:prstDash val="solid"/>
-                      <a:round/>
-                      <a:headEnd type="none" w="med" len="med"/>
-                      <a:tailEnd type="none" w="med" len="med"/>
-                    </a:lnR>
-                    <a:lnT w="5715" cap="flat" cmpd="sng" algn="ctr">
-                      <a:solidFill>
-                        <a:srgbClr val="FFFFFF"/>
-                      </a:solidFill>
-                      <a:prstDash val="solid"/>
-                      <a:round/>
-                      <a:headEnd type="none" w="med" len="med"/>
-                      <a:tailEnd type="none" w="med" len="med"/>
-                    </a:lnT>
-                    <a:lnB w="5715" cap="flat" cmpd="sng" algn="ctr">
-                      <a:solidFill>
-                        <a:srgbClr val="FFFFFF"/>
-                      </a:solidFill>
-                      <a:prstDash val="solid"/>
-                      <a:round/>
-                      <a:headEnd type="none" w="med" len="med"/>
-                      <a:tailEnd type="none" w="med" len="med"/>
-                    </a:lnB>
-                    <a:solidFill>
-                      <a:srgbClr val="FFFFFF"/>
-                    </a:solidFill>
-                  </a:tcPr>
-                </a:tc>
-                <a:tc>
-                  <a:txBody>
-                    <a:bodyPr/>
-                    <a:lstStyle/>
-                    <a:p>
-                      <a:pPr algn="ctr" indent="0" marL="0">
-                        <a:buNone/>
-                      </a:pPr>
-                      <a:r>
-                        <a:rPr lang="en-US" sz="615" dirty="0">
-                          <a:solidFill>
-                            <a:srgbClr val="1F1F1F"/>
-                          </a:solidFill>
-                          <a:latin typeface="Calibri" pitchFamily="34" charset="0"/>
-                          <a:ea typeface="Calibri" pitchFamily="34" charset="-122"/>
-                          <a:cs typeface="Calibri" pitchFamily="34" charset="-120"/>
-                        </a:rPr>
-                        <a:t>R$ 87,7 mi</a:t>
-                      </a:r>
-                      <a:endParaRPr lang="en-US" sz="615" dirty="0">
-                        <a:latin typeface="Calibri" charset="0"/>
-                        <a:ea typeface="Calibri" charset="0"/>
-                        <a:cs typeface="Calibri" charset="0"/>
-                      </a:endParaRPr>
-                    </a:p>
-                  </a:txBody>
-                  <a:tcPr marL="36576" marR="36576" marT="18288" marB="18288" anchor="mid">
-                    <a:lnL w="5715" cap="flat" cmpd="sng" algn="ctr">
-                      <a:solidFill>
-                        <a:srgbClr val="FFFFFF"/>
-                      </a:solidFill>
-                      <a:prstDash val="solid"/>
-                      <a:round/>
-                      <a:headEnd type="none" w="med" len="med"/>
-                      <a:tailEnd type="none" w="med" len="med"/>
-                    </a:lnL>
-                    <a:lnR w="5715" cap="flat" cmpd="sng" algn="ctr">
-                      <a:solidFill>
-                        <a:srgbClr val="FFFFFF"/>
-                      </a:solidFill>
-                      <a:prstDash val="solid"/>
-                      <a:round/>
-                      <a:headEnd type="none" w="med" len="med"/>
-                      <a:tailEnd type="none" w="med" len="med"/>
-                    </a:lnR>
-                    <a:lnT w="5715" cap="flat" cmpd="sng" algn="ctr">
-                      <a:solidFill>
-                        <a:srgbClr val="FFFFFF"/>
-                      </a:solidFill>
-                      <a:prstDash val="solid"/>
-                      <a:round/>
-                      <a:headEnd type="none" w="med" len="med"/>
-                      <a:tailEnd type="none" w="med" len="med"/>
-                    </a:lnT>
-                    <a:lnB w="5715" cap="flat" cmpd="sng" algn="ctr">
-                      <a:solidFill>
-                        <a:srgbClr val="FFFFFF"/>
-                      </a:solidFill>
-                      <a:prstDash val="solid"/>
-                      <a:round/>
-                      <a:headEnd type="none" w="med" len="med"/>
-                      <a:tailEnd type="none" w="med" len="med"/>
-                    </a:lnB>
-                    <a:solidFill>
-                      <a:srgbClr val="FFFFFF"/>
-                    </a:solidFill>
-                  </a:tcPr>
-                </a:tc>
-                <a:tc>
-                  <a:txBody>
-                    <a:bodyPr/>
-                    <a:lstStyle/>
-                    <a:p>
-                      <a:pPr algn="ctr" indent="0" marL="0">
-                        <a:buNone/>
-                      </a:pPr>
-                      <a:r>
-                        <a:rPr lang="en-US" sz="615" dirty="0">
-                          <a:solidFill>
-                            <a:srgbClr val="1F1F1F"/>
-                          </a:solidFill>
-                          <a:latin typeface="Calibri" pitchFamily="34" charset="0"/>
-                          <a:ea typeface="Calibri" pitchFamily="34" charset="-122"/>
-                          <a:cs typeface="Calibri" pitchFamily="34" charset="-120"/>
-                        </a:rPr>
-                        <a:t>R$ 110,7 mi</a:t>
+                        <a:t>R$ 2,8 mi</a:t>
                       </a:r>
                       <a:endParaRPr lang="en-US" sz="615" dirty="0">
                         <a:latin typeface="Calibri" charset="0"/>
@@ -14776,7 +14640,143 @@
                           <a:ea typeface="Calibri" pitchFamily="34" charset="-122"/>
                           <a:cs typeface="Calibri" pitchFamily="34" charset="-120"/>
                         </a:rPr>
-                        <a:t>59,88%</a:t>
+                        <a:t>R$ 89,5 mi</a:t>
+                      </a:r>
+                      <a:endParaRPr lang="en-US" sz="615" dirty="0">
+                        <a:latin typeface="Calibri" charset="0"/>
+                        <a:ea typeface="Calibri" charset="0"/>
+                        <a:cs typeface="Calibri" charset="0"/>
+                      </a:endParaRPr>
+                    </a:p>
+                  </a:txBody>
+                  <a:tcPr marL="36576" marR="36576" marT="18288" marB="18288" anchor="mid">
+                    <a:lnL w="5715" cap="flat" cmpd="sng" algn="ctr">
+                      <a:solidFill>
+                        <a:srgbClr val="FFFFFF"/>
+                      </a:solidFill>
+                      <a:prstDash val="solid"/>
+                      <a:round/>
+                      <a:headEnd type="none" w="med" len="med"/>
+                      <a:tailEnd type="none" w="med" len="med"/>
+                    </a:lnL>
+                    <a:lnR w="5715" cap="flat" cmpd="sng" algn="ctr">
+                      <a:solidFill>
+                        <a:srgbClr val="FFFFFF"/>
+                      </a:solidFill>
+                      <a:prstDash val="solid"/>
+                      <a:round/>
+                      <a:headEnd type="none" w="med" len="med"/>
+                      <a:tailEnd type="none" w="med" len="med"/>
+                    </a:lnR>
+                    <a:lnT w="5715" cap="flat" cmpd="sng" algn="ctr">
+                      <a:solidFill>
+                        <a:srgbClr val="FFFFFF"/>
+                      </a:solidFill>
+                      <a:prstDash val="solid"/>
+                      <a:round/>
+                      <a:headEnd type="none" w="med" len="med"/>
+                      <a:tailEnd type="none" w="med" len="med"/>
+                    </a:lnT>
+                    <a:lnB w="5715" cap="flat" cmpd="sng" algn="ctr">
+                      <a:solidFill>
+                        <a:srgbClr val="FFFFFF"/>
+                      </a:solidFill>
+                      <a:prstDash val="solid"/>
+                      <a:round/>
+                      <a:headEnd type="none" w="med" len="med"/>
+                      <a:tailEnd type="none" w="med" len="med"/>
+                    </a:lnB>
+                    <a:solidFill>
+                      <a:srgbClr val="FFFFFF"/>
+                    </a:solidFill>
+                  </a:tcPr>
+                </a:tc>
+                <a:tc>
+                  <a:txBody>
+                    <a:bodyPr/>
+                    <a:lstStyle/>
+                    <a:p>
+                      <a:pPr algn="ctr" indent="0" marL="0">
+                        <a:buNone/>
+                      </a:pPr>
+                      <a:r>
+                        <a:rPr lang="en-US" sz="615" dirty="0">
+                          <a:solidFill>
+                            <a:srgbClr val="1F1F1F"/>
+                          </a:solidFill>
+                          <a:latin typeface="Calibri" pitchFamily="34" charset="0"/>
+                          <a:ea typeface="Calibri" pitchFamily="34" charset="-122"/>
+                          <a:cs typeface="Calibri" pitchFamily="34" charset="-120"/>
+                        </a:rPr>
+                        <a:t>R$ 0,00</a:t>
+                      </a:r>
+                      <a:endParaRPr lang="en-US" sz="615" dirty="0">
+                        <a:latin typeface="Calibri" charset="0"/>
+                        <a:ea typeface="Calibri" charset="0"/>
+                        <a:cs typeface="Calibri" charset="0"/>
+                      </a:endParaRPr>
+                    </a:p>
+                  </a:txBody>
+                  <a:tcPr marL="36576" marR="36576" marT="18288" marB="18288" anchor="mid">
+                    <a:lnL w="5715" cap="flat" cmpd="sng" algn="ctr">
+                      <a:solidFill>
+                        <a:srgbClr val="FFFFFF"/>
+                      </a:solidFill>
+                      <a:prstDash val="solid"/>
+                      <a:round/>
+                      <a:headEnd type="none" w="med" len="med"/>
+                      <a:tailEnd type="none" w="med" len="med"/>
+                    </a:lnL>
+                    <a:lnR w="5715" cap="flat" cmpd="sng" algn="ctr">
+                      <a:solidFill>
+                        <a:srgbClr val="FFFFFF"/>
+                      </a:solidFill>
+                      <a:prstDash val="solid"/>
+                      <a:round/>
+                      <a:headEnd type="none" w="med" len="med"/>
+                      <a:tailEnd type="none" w="med" len="med"/>
+                    </a:lnR>
+                    <a:lnT w="5715" cap="flat" cmpd="sng" algn="ctr">
+                      <a:solidFill>
+                        <a:srgbClr val="FFFFFF"/>
+                      </a:solidFill>
+                      <a:prstDash val="solid"/>
+                      <a:round/>
+                      <a:headEnd type="none" w="med" len="med"/>
+                      <a:tailEnd type="none" w="med" len="med"/>
+                    </a:lnT>
+                    <a:lnB w="5715" cap="flat" cmpd="sng" algn="ctr">
+                      <a:solidFill>
+                        <a:srgbClr val="FFFFFF"/>
+                      </a:solidFill>
+                      <a:prstDash val="solid"/>
+                      <a:round/>
+                      <a:headEnd type="none" w="med" len="med"/>
+                      <a:tailEnd type="none" w="med" len="med"/>
+                    </a:lnB>
+                    <a:solidFill>
+                      <a:srgbClr val="FFFFFF"/>
+                    </a:solidFill>
+                  </a:tcPr>
+                </a:tc>
+                <a:tc>
+                  <a:txBody>
+                    <a:bodyPr/>
+                    <a:lstStyle/>
+                    <a:p>
+                      <a:pPr algn="ctr" indent="0" marL="0">
+                        <a:buNone/>
+                      </a:pPr>
+                      <a:r>
+                        <a:rPr lang="en-US" sz="615" dirty="0">
+                          <a:solidFill>
+                            <a:srgbClr val="1F1F1F"/>
+                          </a:solidFill>
+                          <a:latin typeface="Calibri" pitchFamily="34" charset="0"/>
+                          <a:ea typeface="Calibri" pitchFamily="34" charset="-122"/>
+                          <a:cs typeface="Calibri" pitchFamily="34" charset="-120"/>
+                        </a:rPr>
+                        <a:t>30,41%</a:t>
                       </a:r>
                       <a:endParaRPr lang="en-US" sz="615" dirty="0">
                         <a:latin typeface="Calibri" charset="0"/>
@@ -14914,211 +14914,7 @@
                           <a:ea typeface="Calibri" pitchFamily="34" charset="-122"/>
                           <a:cs typeface="Calibri" pitchFamily="34" charset="-120"/>
                         </a:rPr>
-                        <a:t>R$ 95,3 mi</a:t>
-                      </a:r>
-                      <a:endParaRPr lang="en-US" sz="615" dirty="0">
-                        <a:latin typeface="Calibri" charset="0"/>
-                        <a:ea typeface="Calibri" charset="0"/>
-                        <a:cs typeface="Calibri" charset="0"/>
-                      </a:endParaRPr>
-                    </a:p>
-                  </a:txBody>
-                  <a:tcPr marL="36576" marR="36576" marT="18288" marB="18288" anchor="mid">
-                    <a:lnL w="5715" cap="flat" cmpd="sng" algn="ctr">
-                      <a:solidFill>
-                        <a:srgbClr val="FFFFFF"/>
-                      </a:solidFill>
-                      <a:prstDash val="solid"/>
-                      <a:round/>
-                      <a:headEnd type="none" w="med" len="med"/>
-                      <a:tailEnd type="none" w="med" len="med"/>
-                    </a:lnL>
-                    <a:lnR w="5715" cap="flat" cmpd="sng" algn="ctr">
-                      <a:solidFill>
-                        <a:srgbClr val="FFFFFF"/>
-                      </a:solidFill>
-                      <a:prstDash val="solid"/>
-                      <a:round/>
-                      <a:headEnd type="none" w="med" len="med"/>
-                      <a:tailEnd type="none" w="med" len="med"/>
-                    </a:lnR>
-                    <a:lnT w="5715" cap="flat" cmpd="sng" algn="ctr">
-                      <a:solidFill>
-                        <a:srgbClr val="FFFFFF"/>
-                      </a:solidFill>
-                      <a:prstDash val="solid"/>
-                      <a:round/>
-                      <a:headEnd type="none" w="med" len="med"/>
-                      <a:tailEnd type="none" w="med" len="med"/>
-                    </a:lnT>
-                    <a:lnB w="5715" cap="flat" cmpd="sng" algn="ctr">
-                      <a:solidFill>
-                        <a:srgbClr val="FFFFFF"/>
-                      </a:solidFill>
-                      <a:prstDash val="solid"/>
-                      <a:round/>
-                      <a:headEnd type="none" w="med" len="med"/>
-                      <a:tailEnd type="none" w="med" len="med"/>
-                    </a:lnB>
-                    <a:solidFill>
-                      <a:srgbClr val="F1F1F1"/>
-                    </a:solidFill>
-                  </a:tcPr>
-                </a:tc>
-                <a:tc>
-                  <a:txBody>
-                    <a:bodyPr/>
-                    <a:lstStyle/>
-                    <a:p>
-                      <a:pPr algn="ctr" indent="0" marL="0">
-                        <a:buNone/>
-                      </a:pPr>
-                      <a:r>
-                        <a:rPr lang="en-US" sz="615" dirty="0">
-                          <a:solidFill>
-                            <a:srgbClr val="1F1F1F"/>
-                          </a:solidFill>
-                          <a:latin typeface="Calibri" pitchFamily="34" charset="0"/>
-                          <a:ea typeface="Calibri" pitchFamily="34" charset="-122"/>
-                          <a:cs typeface="Calibri" pitchFamily="34" charset="-120"/>
-                        </a:rPr>
-                        <a:t>R$ 17 mi</a:t>
-                      </a:r>
-                      <a:endParaRPr lang="en-US" sz="615" dirty="0">
-                        <a:latin typeface="Calibri" charset="0"/>
-                        <a:ea typeface="Calibri" charset="0"/>
-                        <a:cs typeface="Calibri" charset="0"/>
-                      </a:endParaRPr>
-                    </a:p>
-                  </a:txBody>
-                  <a:tcPr marL="36576" marR="36576" marT="18288" marB="18288" anchor="mid">
-                    <a:lnL w="5715" cap="flat" cmpd="sng" algn="ctr">
-                      <a:solidFill>
-                        <a:srgbClr val="FFFFFF"/>
-                      </a:solidFill>
-                      <a:prstDash val="solid"/>
-                      <a:round/>
-                      <a:headEnd type="none" w="med" len="med"/>
-                      <a:tailEnd type="none" w="med" len="med"/>
-                    </a:lnL>
-                    <a:lnR w="5715" cap="flat" cmpd="sng" algn="ctr">
-                      <a:solidFill>
-                        <a:srgbClr val="FFFFFF"/>
-                      </a:solidFill>
-                      <a:prstDash val="solid"/>
-                      <a:round/>
-                      <a:headEnd type="none" w="med" len="med"/>
-                      <a:tailEnd type="none" w="med" len="med"/>
-                    </a:lnR>
-                    <a:lnT w="5715" cap="flat" cmpd="sng" algn="ctr">
-                      <a:solidFill>
-                        <a:srgbClr val="FFFFFF"/>
-                      </a:solidFill>
-                      <a:prstDash val="solid"/>
-                      <a:round/>
-                      <a:headEnd type="none" w="med" len="med"/>
-                      <a:tailEnd type="none" w="med" len="med"/>
-                    </a:lnT>
-                    <a:lnB w="5715" cap="flat" cmpd="sng" algn="ctr">
-                      <a:solidFill>
-                        <a:srgbClr val="FFFFFF"/>
-                      </a:solidFill>
-                      <a:prstDash val="solid"/>
-                      <a:round/>
-                      <a:headEnd type="none" w="med" len="med"/>
-                      <a:tailEnd type="none" w="med" len="med"/>
-                    </a:lnB>
-                    <a:solidFill>
-                      <a:srgbClr val="F1F1F1"/>
-                    </a:solidFill>
-                  </a:tcPr>
-                </a:tc>
-                <a:tc>
-                  <a:txBody>
-                    <a:bodyPr/>
-                    <a:lstStyle/>
-                    <a:p>
-                      <a:pPr algn="ctr" indent="0" marL="0">
-                        <a:buNone/>
-                      </a:pPr>
-                      <a:r>
-                        <a:rPr lang="en-US" sz="615" dirty="0">
-                          <a:solidFill>
-                            <a:srgbClr val="1F1F1F"/>
-                          </a:solidFill>
-                          <a:latin typeface="Calibri" pitchFamily="34" charset="0"/>
-                          <a:ea typeface="Calibri" pitchFamily="34" charset="-122"/>
-                          <a:cs typeface="Calibri" pitchFamily="34" charset="-120"/>
-                        </a:rPr>
-                        <a:t>R$ 74,9 mi</a:t>
-                      </a:r>
-                      <a:endParaRPr lang="en-US" sz="615" dirty="0">
-                        <a:latin typeface="Calibri" charset="0"/>
-                        <a:ea typeface="Calibri" charset="0"/>
-                        <a:cs typeface="Calibri" charset="0"/>
-                      </a:endParaRPr>
-                    </a:p>
-                  </a:txBody>
-                  <a:tcPr marL="36576" marR="36576" marT="18288" marB="18288" anchor="mid">
-                    <a:lnL w="5715" cap="flat" cmpd="sng" algn="ctr">
-                      <a:solidFill>
-                        <a:srgbClr val="FFFFFF"/>
-                      </a:solidFill>
-                      <a:prstDash val="solid"/>
-                      <a:round/>
-                      <a:headEnd type="none" w="med" len="med"/>
-                      <a:tailEnd type="none" w="med" len="med"/>
-                    </a:lnL>
-                    <a:lnR w="5715" cap="flat" cmpd="sng" algn="ctr">
-                      <a:solidFill>
-                        <a:srgbClr val="FFFFFF"/>
-                      </a:solidFill>
-                      <a:prstDash val="solid"/>
-                      <a:round/>
-                      <a:headEnd type="none" w="med" len="med"/>
-                      <a:tailEnd type="none" w="med" len="med"/>
-                    </a:lnR>
-                    <a:lnT w="5715" cap="flat" cmpd="sng" algn="ctr">
-                      <a:solidFill>
-                        <a:srgbClr val="FFFFFF"/>
-                      </a:solidFill>
-                      <a:prstDash val="solid"/>
-                      <a:round/>
-                      <a:headEnd type="none" w="med" len="med"/>
-                      <a:tailEnd type="none" w="med" len="med"/>
-                    </a:lnT>
-                    <a:lnB w="5715" cap="flat" cmpd="sng" algn="ctr">
-                      <a:solidFill>
-                        <a:srgbClr val="FFFFFF"/>
-                      </a:solidFill>
-                      <a:prstDash val="solid"/>
-                      <a:round/>
-                      <a:headEnd type="none" w="med" len="med"/>
-                      <a:tailEnd type="none" w="med" len="med"/>
-                    </a:lnB>
-                    <a:solidFill>
-                      <a:srgbClr val="F1F1F1"/>
-                    </a:solidFill>
-                  </a:tcPr>
-                </a:tc>
-                <a:tc>
-                  <a:txBody>
-                    <a:bodyPr/>
-                    <a:lstStyle/>
-                    <a:p>
-                      <a:pPr algn="ctr" indent="0" marL="0">
-                        <a:buNone/>
-                      </a:pPr>
-                      <a:r>
-                        <a:rPr lang="en-US" sz="615" dirty="0">
-                          <a:solidFill>
-                            <a:srgbClr val="1F1F1F"/>
-                          </a:solidFill>
-                          <a:latin typeface="Calibri" pitchFamily="34" charset="0"/>
-                          <a:ea typeface="Calibri" pitchFamily="34" charset="-122"/>
-                          <a:cs typeface="Calibri" pitchFamily="34" charset="-120"/>
-                        </a:rPr>
-                        <a:t>R$ 112,4 mi</a:t>
+                        <a:t>R$ 68,1 mi</a:t>
                       </a:r>
                       <a:endParaRPr lang="en-US" sz="615" dirty="0">
                         <a:latin typeface="Calibri" charset="0"/>
@@ -15254,7 +15050,211 @@
                           <a:ea typeface="Calibri" pitchFamily="34" charset="-122"/>
                           <a:cs typeface="Calibri" pitchFamily="34" charset="-120"/>
                         </a:rPr>
-                        <a:t>61,89%</a:t>
+                        <a:t>R$ 0,00</a:t>
+                      </a:r>
+                      <a:endParaRPr lang="en-US" sz="615" dirty="0">
+                        <a:latin typeface="Calibri" charset="0"/>
+                        <a:ea typeface="Calibri" charset="0"/>
+                        <a:cs typeface="Calibri" charset="0"/>
+                      </a:endParaRPr>
+                    </a:p>
+                  </a:txBody>
+                  <a:tcPr marL="36576" marR="36576" marT="18288" marB="18288" anchor="mid">
+                    <a:lnL w="5715" cap="flat" cmpd="sng" algn="ctr">
+                      <a:solidFill>
+                        <a:srgbClr val="FFFFFF"/>
+                      </a:solidFill>
+                      <a:prstDash val="solid"/>
+                      <a:round/>
+                      <a:headEnd type="none" w="med" len="med"/>
+                      <a:tailEnd type="none" w="med" len="med"/>
+                    </a:lnL>
+                    <a:lnR w="5715" cap="flat" cmpd="sng" algn="ctr">
+                      <a:solidFill>
+                        <a:srgbClr val="FFFFFF"/>
+                      </a:solidFill>
+                      <a:prstDash val="solid"/>
+                      <a:round/>
+                      <a:headEnd type="none" w="med" len="med"/>
+                      <a:tailEnd type="none" w="med" len="med"/>
+                    </a:lnR>
+                    <a:lnT w="5715" cap="flat" cmpd="sng" algn="ctr">
+                      <a:solidFill>
+                        <a:srgbClr val="FFFFFF"/>
+                      </a:solidFill>
+                      <a:prstDash val="solid"/>
+                      <a:round/>
+                      <a:headEnd type="none" w="med" len="med"/>
+                      <a:tailEnd type="none" w="med" len="med"/>
+                    </a:lnT>
+                    <a:lnB w="5715" cap="flat" cmpd="sng" algn="ctr">
+                      <a:solidFill>
+                        <a:srgbClr val="FFFFFF"/>
+                      </a:solidFill>
+                      <a:prstDash val="solid"/>
+                      <a:round/>
+                      <a:headEnd type="none" w="med" len="med"/>
+                      <a:tailEnd type="none" w="med" len="med"/>
+                    </a:lnB>
+                    <a:solidFill>
+                      <a:srgbClr val="F1F1F1"/>
+                    </a:solidFill>
+                  </a:tcPr>
+                </a:tc>
+                <a:tc>
+                  <a:txBody>
+                    <a:bodyPr/>
+                    <a:lstStyle/>
+                    <a:p>
+                      <a:pPr algn="ctr" indent="0" marL="0">
+                        <a:buNone/>
+                      </a:pPr>
+                      <a:r>
+                        <a:rPr lang="en-US" sz="615" dirty="0">
+                          <a:solidFill>
+                            <a:srgbClr val="1F1F1F"/>
+                          </a:solidFill>
+                          <a:latin typeface="Calibri" pitchFamily="34" charset="0"/>
+                          <a:ea typeface="Calibri" pitchFamily="34" charset="-122"/>
+                          <a:cs typeface="Calibri" pitchFamily="34" charset="-120"/>
+                        </a:rPr>
+                        <a:t>R$ 68,1 mi</a:t>
+                      </a:r>
+                      <a:endParaRPr lang="en-US" sz="615" dirty="0">
+                        <a:latin typeface="Calibri" charset="0"/>
+                        <a:ea typeface="Calibri" charset="0"/>
+                        <a:cs typeface="Calibri" charset="0"/>
+                      </a:endParaRPr>
+                    </a:p>
+                  </a:txBody>
+                  <a:tcPr marL="36576" marR="36576" marT="18288" marB="18288" anchor="mid">
+                    <a:lnL w="5715" cap="flat" cmpd="sng" algn="ctr">
+                      <a:solidFill>
+                        <a:srgbClr val="FFFFFF"/>
+                      </a:solidFill>
+                      <a:prstDash val="solid"/>
+                      <a:round/>
+                      <a:headEnd type="none" w="med" len="med"/>
+                      <a:tailEnd type="none" w="med" len="med"/>
+                    </a:lnL>
+                    <a:lnR w="5715" cap="flat" cmpd="sng" algn="ctr">
+                      <a:solidFill>
+                        <a:srgbClr val="FFFFFF"/>
+                      </a:solidFill>
+                      <a:prstDash val="solid"/>
+                      <a:round/>
+                      <a:headEnd type="none" w="med" len="med"/>
+                      <a:tailEnd type="none" w="med" len="med"/>
+                    </a:lnR>
+                    <a:lnT w="5715" cap="flat" cmpd="sng" algn="ctr">
+                      <a:solidFill>
+                        <a:srgbClr val="FFFFFF"/>
+                      </a:solidFill>
+                      <a:prstDash val="solid"/>
+                      <a:round/>
+                      <a:headEnd type="none" w="med" len="med"/>
+                      <a:tailEnd type="none" w="med" len="med"/>
+                    </a:lnT>
+                    <a:lnB w="5715" cap="flat" cmpd="sng" algn="ctr">
+                      <a:solidFill>
+                        <a:srgbClr val="FFFFFF"/>
+                      </a:solidFill>
+                      <a:prstDash val="solid"/>
+                      <a:round/>
+                      <a:headEnd type="none" w="med" len="med"/>
+                      <a:tailEnd type="none" w="med" len="med"/>
+                    </a:lnB>
+                    <a:solidFill>
+                      <a:srgbClr val="F1F1F1"/>
+                    </a:solidFill>
+                  </a:tcPr>
+                </a:tc>
+                <a:tc>
+                  <a:txBody>
+                    <a:bodyPr/>
+                    <a:lstStyle/>
+                    <a:p>
+                      <a:pPr algn="ctr" indent="0" marL="0">
+                        <a:buNone/>
+                      </a:pPr>
+                      <a:r>
+                        <a:rPr lang="en-US" sz="615" dirty="0">
+                          <a:solidFill>
+                            <a:srgbClr val="1F1F1F"/>
+                          </a:solidFill>
+                          <a:latin typeface="Calibri" pitchFamily="34" charset="0"/>
+                          <a:ea typeface="Calibri" pitchFamily="34" charset="-122"/>
+                          <a:cs typeface="Calibri" pitchFamily="34" charset="-120"/>
+                        </a:rPr>
+                        <a:t>R$ 50.908,78</a:t>
+                      </a:r>
+                      <a:endParaRPr lang="en-US" sz="615" dirty="0">
+                        <a:latin typeface="Calibri" charset="0"/>
+                        <a:ea typeface="Calibri" charset="0"/>
+                        <a:cs typeface="Calibri" charset="0"/>
+                      </a:endParaRPr>
+                    </a:p>
+                  </a:txBody>
+                  <a:tcPr marL="36576" marR="36576" marT="18288" marB="18288" anchor="mid">
+                    <a:lnL w="5715" cap="flat" cmpd="sng" algn="ctr">
+                      <a:solidFill>
+                        <a:srgbClr val="FFFFFF"/>
+                      </a:solidFill>
+                      <a:prstDash val="solid"/>
+                      <a:round/>
+                      <a:headEnd type="none" w="med" len="med"/>
+                      <a:tailEnd type="none" w="med" len="med"/>
+                    </a:lnL>
+                    <a:lnR w="5715" cap="flat" cmpd="sng" algn="ctr">
+                      <a:solidFill>
+                        <a:srgbClr val="FFFFFF"/>
+                      </a:solidFill>
+                      <a:prstDash val="solid"/>
+                      <a:round/>
+                      <a:headEnd type="none" w="med" len="med"/>
+                      <a:tailEnd type="none" w="med" len="med"/>
+                    </a:lnR>
+                    <a:lnT w="5715" cap="flat" cmpd="sng" algn="ctr">
+                      <a:solidFill>
+                        <a:srgbClr val="FFFFFF"/>
+                      </a:solidFill>
+                      <a:prstDash val="solid"/>
+                      <a:round/>
+                      <a:headEnd type="none" w="med" len="med"/>
+                      <a:tailEnd type="none" w="med" len="med"/>
+                    </a:lnT>
+                    <a:lnB w="5715" cap="flat" cmpd="sng" algn="ctr">
+                      <a:solidFill>
+                        <a:srgbClr val="FFFFFF"/>
+                      </a:solidFill>
+                      <a:prstDash val="solid"/>
+                      <a:round/>
+                      <a:headEnd type="none" w="med" len="med"/>
+                      <a:tailEnd type="none" w="med" len="med"/>
+                    </a:lnB>
+                    <a:solidFill>
+                      <a:srgbClr val="F1F1F1"/>
+                    </a:solidFill>
+                  </a:tcPr>
+                </a:tc>
+                <a:tc>
+                  <a:txBody>
+                    <a:bodyPr/>
+                    <a:lstStyle/>
+                    <a:p>
+                      <a:pPr algn="ctr" indent="0" marL="0">
+                        <a:buNone/>
+                      </a:pPr>
+                      <a:r>
+                        <a:rPr lang="en-US" sz="615" dirty="0">
+                          <a:solidFill>
+                            <a:srgbClr val="1F1F1F"/>
+                          </a:solidFill>
+                          <a:latin typeface="Calibri" pitchFamily="34" charset="0"/>
+                          <a:ea typeface="Calibri" pitchFamily="34" charset="-122"/>
+                          <a:cs typeface="Calibri" pitchFamily="34" charset="-120"/>
+                        </a:rPr>
+                        <a:t>30,00%</a:t>
                       </a:r>
                       <a:endParaRPr lang="en-US" sz="615" dirty="0">
                         <a:latin typeface="Calibri" charset="0"/>
@@ -16872,7 +16872,7 @@
                 <a:ea typeface="Calibri" pitchFamily="34" charset="-122"/>
                 <a:cs typeface="Calibri" pitchFamily="34" charset="-120"/>
               </a:rPr>
-              <a:t>•  Sem PDD no M1; primeira entrada em Over90 no M4.</a:t>
+              <a:t>•  Receita do primeiro mês cobre PDD: R$ 118,9 mi / R$ 133,3 mi = 0,9x.</a:t>
             </a:r>
             <a:endParaRPr lang="en-US" sz="1000" dirty="0"/>
           </a:p>
@@ -16889,7 +16889,7 @@
                 <a:ea typeface="Calibri" pitchFamily="34" charset="-122"/>
                 <a:cs typeface="Calibri" pitchFamily="34" charset="-120"/>
               </a:rPr>
-              <a:t>•  Cenários até 50% preservam SUB/originada acima de 30%.</a:t>
+              <a:t>•  Cenários que cruzam 30% SUB/originada: Perda 20%, Perda 30%, Perda 40%, Perda 50%.</a:t>
             </a:r>
             <a:endParaRPr lang="en-US" sz="1000" dirty="0"/>
           </a:p>
@@ -16906,7 +16906,7 @@
                 <a:ea typeface="Calibri" pitchFamily="34" charset="-122"/>
                 <a:cs typeface="Calibri" pitchFamily="34" charset="-120"/>
               </a:rPr>
-              <a:t>•  Target/teto final: R$ 1,4 bi; caixa retido por limite: R$ 1,1 bi; caixa final: R$ 1,4 bi.</a:t>
+              <a:t>•  Target/teto final: R$ 1,4 bi; caixa retido por limite: R$ 0,00; caixa final: R$ 0,00.</a:t>
             </a:r>
             <a:endParaRPr lang="en-US" sz="1000" dirty="0"/>
           </a:p>
@@ -16923,7 +16923,7 @@
                 <a:ea typeface="Calibri" pitchFamily="34" charset="-122"/>
                 <a:cs typeface="Calibri" pitchFamily="34" charset="-120"/>
               </a:rPr>
-              <a:t>•  Carteira originada efetiva: R$ 3,2 bi.</a:t>
+              <a:t>•  Carteira originada efetiva: R$ 2,1 bi.</a:t>
             </a:r>
             <a:endParaRPr lang="en-US" sz="1000" dirty="0"/>
           </a:p>
@@ -16940,7 +16940,7 @@
                 <a:ea typeface="Calibri" pitchFamily="34" charset="-122"/>
                 <a:cs typeface="Calibri" pitchFamily="34" charset="-120"/>
               </a:rPr>
-              <a:t>•  SUB / PL final: 100,00%; colchão sobre originada: 75,32%.</a:t>
+              <a:t>•  SUB / PL final: 100,00%; colchão sobre originada: 12,75%.</a:t>
             </a:r>
             <a:endParaRPr lang="en-US" sz="1000" dirty="0"/>
           </a:p>

</xml_diff>

<commit_message>
Regenera PPTX MC3 com modelo de cartoes
</commit_message>
<xml_diff>
--- a/outputs/modelo_fidc_mc3_comite_trava_30.pptx
+++ b/outputs/modelo_fidc_mc3_comite_trava_30.pptx
@@ -719,76 +719,76 @@
                   <c:v>300</c:v>
                 </c:pt>
                 <c:pt idx="1">
-                  <c:v>299.99999999999994</c:v>
+                  <c:v>411.5200868374183</c:v>
                 </c:pt>
                 <c:pt idx="2">
-                  <c:v>300</c:v>
+                  <c:v>545.8177664793182</c:v>
                 </c:pt>
                 <c:pt idx="3">
-                  <c:v>300</c:v>
+                  <c:v>669.5261169901383</c:v>
                 </c:pt>
                 <c:pt idx="4">
-                  <c:v>304.50917027707686</c:v>
+                  <c:v>760.0619139268873</c:v>
                 </c:pt>
                 <c:pt idx="5">
-                  <c:v>307.1566830895734</c:v>
+                  <c:v>852.7345714756229</c:v>
                 </c:pt>
                 <c:pt idx="6">
-                  <c:v>303.09409257726134</c:v>
+                  <c:v>940.3474202939591</c:v>
                 </c:pt>
                 <c:pt idx="7">
-                  <c:v>305.8688077874529</c:v>
+                  <c:v>1044.829696601214</c:v>
                 </c:pt>
                 <c:pt idx="8">
-                  <c:v>300</c:v>
+                  <c:v>1136.7985987650422</c:v>
                 </c:pt>
                 <c:pt idx="9">
-                  <c:v>300</c:v>
+                  <c:v>1230.9503033400242</c:v>
                 </c:pt>
                 <c:pt idx="10">
-                  <c:v>299.99999999999994</c:v>
+                  <c:v>1319.5914988436336</c:v>
                 </c:pt>
                 <c:pt idx="11">
-                  <c:v>300</c:v>
+                  <c:v>1402.5270842973305</c:v>
                 </c:pt>
                 <c:pt idx="12">
-                  <c:v>300</c:v>
+                  <c:v>1503.3687293698754</c:v>
                 </c:pt>
                 <c:pt idx="13">
-                  <c:v>299.99999999999994</c:v>
+                  <c:v>1598.433792178873</c:v>
                 </c:pt>
                 <c:pt idx="14">
-                  <c:v>299.99999999999994</c:v>
+                  <c:v>1695.2893830831322</c:v>
                 </c:pt>
                 <c:pt idx="15">
-                  <c:v>300</c:v>
+                  <c:v>1793.793812065324</c:v>
                 </c:pt>
                 <c:pt idx="16">
-                  <c:v>300</c:v>
+                  <c:v>1910.9244865205155</c:v>
                 </c:pt>
                 <c:pt idx="17">
-                  <c:v>299.99999999999994</c:v>
+                  <c:v>2021.7603536314807</c:v>
                 </c:pt>
                 <c:pt idx="18">
-                  <c:v>300</c:v>
+                  <c:v>2144.4555068043246</c:v>
                 </c:pt>
                 <c:pt idx="19">
-                  <c:v>290.8757210485456</c:v>
+                  <c:v>2242.9706223552544</c:v>
                 </c:pt>
                 <c:pt idx="20">
-                  <c:v>284.1395009646291</c:v>
+                  <c:v>2299.6711337326587</c:v>
                 </c:pt>
                 <c:pt idx="21">
-                  <c:v>278.2128462309053</c:v>
+                  <c:v>2349.3117131275303</c:v>
                 </c:pt>
                 <c:pt idx="22">
-                  <c:v>273.9433092415145</c:v>
+                  <c:v>2386.6900907807603</c:v>
                 </c:pt>
                 <c:pt idx="23">
-                  <c:v>271.19383766114544</c:v>
+                  <c:v>2412.787678734156</c:v>
                 </c:pt>
                 <c:pt idx="24">
-                  <c:v>269.6585947024095</c:v>
+                  <c:v>2439.8242684314423</c:v>
                 </c:pt>
               </c:numCache>
             </c:numRef>
@@ -1644,76 +1644,76 @@
                 <c:formatCode>General</c:formatCode>
                 <c:ptCount val="24"/>
                 <c:pt idx="0">
-                  <c:v>0.2977580394682725</c:v>
+                  <c:v>0.3643075788390353</c:v>
                 </c:pt>
                 <c:pt idx="1">
-                  <c:v>0.31150658038790974</c:v>
+                  <c:v>0.4327853190500355</c:v>
                 </c:pt>
                 <c:pt idx="2">
-                  <c:v>0.31343118563634753</c:v>
+                  <c:v>0.480026859426042</c:v>
                 </c:pt>
                 <c:pt idx="3">
-                  <c:v>0.31648964763067633</c:v>
+                  <c:v>0.5153095822887083</c:v>
                 </c:pt>
                 <c:pt idx="4">
-                  <c:v>0.31884200796203</c:v>
+                  <c:v>0.5458826266622901</c:v>
                 </c:pt>
                 <c:pt idx="5">
-                  <c:v>0.31845500745571914</c:v>
+                  <c:v>0.568733930101844</c:v>
                 </c:pt>
                 <c:pt idx="6">
-                  <c:v>0.32222059252586877</c:v>
+                  <c:v>0.5966943466577707</c:v>
                 </c:pt>
                 <c:pt idx="7">
-                  <c:v>0.32161128899806996</c:v>
+                  <c:v>0.6146044472412792</c:v>
                 </c:pt>
                 <c:pt idx="8">
-                  <c:v>0.3210916883298545</c:v>
+                  <c:v>0.630908815955256</c:v>
                 </c:pt>
                 <c:pt idx="9">
-                  <c:v>0.31902821670816034</c:v>
+                  <c:v>0.6426341190765434</c:v>
                 </c:pt>
                 <c:pt idx="10">
-                  <c:v>0.31574425512746684</c:v>
+                  <c:v>0.6504733370694455</c:v>
                 </c:pt>
                 <c:pt idx="11">
-                  <c:v>0.31567271169811906</c:v>
+                  <c:v>0.6638247084491612</c:v>
                 </c:pt>
                 <c:pt idx="12">
-                  <c:v>0.31428831462521056</c:v>
+                  <c:v>0.6667617712502767</c:v>
                 </c:pt>
                 <c:pt idx="13">
-                  <c:v>0.3130805866683232</c:v>
+                  <c:v>0.6696889506142399</c:v>
                 </c:pt>
                 <c:pt idx="14">
-                  <c:v>0.3119924505957278</c:v>
+                  <c:v>0.6725551226901157</c:v>
                 </c:pt>
                 <c:pt idx="15">
-                  <c:v>0.31317309355908146</c:v>
+                  <c:v>0.6802876853904452</c:v>
                 </c:pt>
                 <c:pt idx="16">
-                  <c:v>0.3132408008678476</c:v>
+                  <c:v>0.6852514727133233</c:v>
                 </c:pt>
                 <c:pt idx="17">
-                  <c:v>0.329835107461231</c:v>
+                  <c:v>0.730456507178859</c:v>
                 </c:pt>
                 <c:pt idx="18">
-                  <c:v>0.3430691763787842</c:v>
+                  <c:v>0.7691245834138859</c:v>
                 </c:pt>
                 <c:pt idx="19">
-                  <c:v>0.3507475950530244</c:v>
+                  <c:v>0.7966874213148741</c:v>
                 </c:pt>
                 <c:pt idx="20">
-                  <c:v>0.3579679495809608</c:v>
+                  <c:v>0.8228162006709301</c:v>
                 </c:pt>
                 <c:pt idx="21">
-                  <c:v>0.36277185361004055</c:v>
+                  <c:v>0.8447869504652507</c:v>
                 </c:pt>
                 <c:pt idx="22">
-                  <c:v>0.36587183524654665</c:v>
+                  <c:v>0.8627908808425118</c:v>
                 </c:pt>
                 <c:pt idx="23">
-                  <c:v>0.36858409468093983</c:v>
+                  <c:v>0.8806652666104404</c:v>
                 </c:pt>
               </c:numCache>
             </c:numRef>
@@ -1878,76 +1878,76 @@
                 <c:formatCode>General</c:formatCode>
                 <c:ptCount val="24"/>
                 <c:pt idx="0">
-                  <c:v>0.2698598680085226</c:v>
+                  <c:v>0.368973901614079</c:v>
                 </c:pt>
                 <c:pt idx="1">
-                  <c:v>0.2603368227991252</c:v>
+                  <c:v>0.4428957596101661</c:v>
                 </c:pt>
                 <c:pt idx="2">
-                  <c:v>0.24424283545045805</c:v>
+                  <c:v>0.49548596790236443</c:v>
                 </c:pt>
                 <c:pt idx="3">
-                  <c:v>0.24045818887851528</c:v>
+                  <c:v>0.5260734063778625</c:v>
                 </c:pt>
                 <c:pt idx="4">
-                  <c:v>0.23734007111571204</c:v>
+                  <c:v>0.5529518593089251</c:v>
                 </c:pt>
                 <c:pt idx="5">
-                  <c:v>0.23232068588095112</c:v>
+                  <c:v>0.5726355882195933</c:v>
                 </c:pt>
                 <c:pt idx="6">
-                  <c:v>0.2320903116461056</c:v>
+                  <c:v>0.5983990499524763</c:v>
                 </c:pt>
                 <c:pt idx="7">
-                  <c:v>0.2281967638123475</c:v>
+                  <c:v>0.6141054602757794</c:v>
                 </c:pt>
                 <c:pt idx="8">
-                  <c:v>0.22475854930987152</c:v>
+                  <c:v>0.6285316324538239</c:v>
                 </c:pt>
                 <c:pt idx="9">
-                  <c:v>0.22039869688269484</c:v>
+                  <c:v>0.6384170691287716</c:v>
                 </c:pt>
                 <c:pt idx="10">
-                  <c:v>0.2154680112030049</c:v>
+                  <c:v>0.6444092659645382</c:v>
                 </c:pt>
                 <c:pt idx="11">
-                  <c:v>0.21290992970531977</c:v>
+                  <c:v>0.656534914518623</c:v>
                 </c:pt>
                 <c:pt idx="12">
-                  <c:v>0.20970832538801493</c:v>
+                  <c:v>0.6542559713452294</c:v>
                 </c:pt>
                 <c:pt idx="13">
-                  <c:v>0.20677665482708163</c:v>
+                  <c:v>0.6524581463491433</c:v>
                 </c:pt>
                 <c:pt idx="14">
-                  <c:v>0.2040153767322715</c:v>
+                  <c:v>0.651007979236902</c:v>
                 </c:pt>
                 <c:pt idx="15">
-                  <c:v>0.2021823281852391</c:v>
+                  <c:v>0.6550711723033412</c:v>
                 </c:pt>
                 <c:pt idx="16">
-                  <c:v>0.20001707501228402</c:v>
+                  <c:v>0.6564778294834862</c:v>
                 </c:pt>
                 <c:pt idx="17">
-                  <c:v>0.20003492464127084</c:v>
+                  <c:v>0.6982330737492419</c:v>
                 </c:pt>
                 <c:pt idx="18">
-                  <c:v>0.1992053714807535</c:v>
+                  <c:v>0.7330148638721267</c:v>
                 </c:pt>
                 <c:pt idx="19">
-                  <c:v>0.1976894452022828</c:v>
+                  <c:v>0.755841121502963</c:v>
                 </c:pt>
                 <c:pt idx="20">
-                  <c:v>0.19637175599196519</c:v>
+                  <c:v>0.7768806209749458</c:v>
                 </c:pt>
                 <c:pt idx="21">
-                  <c:v>0.19518150761368974</c:v>
+                  <c:v>0.7939502299436911</c:v>
                 </c:pt>
                 <c:pt idx="22">
-                  <c:v>0.19429106604436522</c:v>
+                  <c:v>0.8072839103346202</c:v>
                 </c:pt>
                 <c:pt idx="23">
-                  <c:v>0.19373682197404593</c:v>
+                  <c:v>0.8206809898110485</c:v>
                 </c:pt>
               </c:numCache>
             </c:numRef>
@@ -2112,76 +2112,76 @@
                 <c:formatCode>General</c:formatCode>
                 <c:ptCount val="24"/>
                 <c:pt idx="0">
-                  <c:v>0.26249999999999996</c:v>
+                  <c:v>0.37376131488068187</c:v>
                 </c:pt>
                 <c:pt idx="1">
-                  <c:v>0.2333333333333333</c:v>
+                  <c:v>0.45348988639591353</c:v>
                 </c:pt>
                 <c:pt idx="2">
-                  <c:v>0.20999999999999996</c:v>
+                  <c:v>0.5119739210817217</c:v>
                 </c:pt>
                 <c:pt idx="3">
-                  <c:v>0.19322411172633283</c:v>
+                  <c:v>0.5377277271586897</c:v>
                 </c:pt>
                 <c:pt idx="4">
-                  <c:v>0.18035799116594556</c:v>
+                  <c:v>0.560705779644561</c:v>
                 </c:pt>
                 <c:pt idx="5">
-                  <c:v>0.16756424118843788</c:v>
+                  <c:v>0.5769636636492029</c:v>
                 </c:pt>
                 <c:pt idx="6">
-                  <c:v>0.16112481167465248</c:v>
+                  <c:v>0.6003088712825563</c:v>
                 </c:pt>
                 <c:pt idx="7">
-                  <c:v>0.1525615033973333</c:v>
+                  <c:v>0.6135415158209295</c:v>
                 </c:pt>
                 <c:pt idx="8">
-                  <c:v>0.1486685491503644</c:v>
+                  <c:v>0.6258239449662919</c:v>
                 </c:pt>
                 <c:pt idx="9">
-                  <c:v>0.14596418454082927</c:v>
+                  <c:v>0.6335799943562277</c:v>
                 </c:pt>
                 <c:pt idx="10">
-                  <c:v>0.14415308872665203</c:v>
+                  <c:v>0.6374095961795965</c:v>
                 </c:pt>
                 <c:pt idx="11">
-                  <c:v>0.1430025319525646</c:v>
+                  <c:v>0.6480721830077729</c:v>
                 </c:pt>
                 <c:pt idx="12">
-                  <c:v>0.14233230955029177</c:v>
+                  <c:v>0.6398530406195243</c:v>
                 </c:pt>
                 <c:pt idx="13">
-                  <c:v>0.14200261816996262</c:v>
+                  <c:v>0.6327528023059854</c:v>
                 </c:pt>
                 <c:pt idx="14">
-                  <c:v>0.1419051782942121</c:v>
+                  <c:v>0.6265208191927429</c:v>
                 </c:pt>
                 <c:pt idx="15">
-                  <c:v>0.14189126922707984</c:v>
+                  <c:v>0.62657513987465</c:v>
                 </c:pt>
                 <c:pt idx="16">
-                  <c:v>0.1418892824400692</c:v>
+                  <c:v>0.6241270772864282</c:v>
                 </c:pt>
                 <c:pt idx="17">
-                  <c:v>0.14188928244006924</c:v>
+                  <c:v>0.6620036570746458</c:v>
                 </c:pt>
                 <c:pt idx="18">
-                  <c:v>0.1375738244627196</c:v>
+                  <c:v>0.6924157437628111</c:v>
                 </c:pt>
                 <c:pt idx="19">
-                  <c:v>0.1343878330158353</c:v>
+                  <c:v>0.7099194624320694</c:v>
                 </c:pt>
                 <c:pt idx="20">
-                  <c:v>0.13158473705770823</c:v>
+                  <c:v>0.7252437463794106</c:v>
                 </c:pt>
                 <c:pt idx="21">
-                  <c:v>0.12956539859178826</c:v>
+                  <c:v>0.7367826300836615</c:v>
                 </c:pt>
                 <c:pt idx="22">
-                  <c:v>0.12826499675969516</c:v>
+                  <c:v>0.7448390801294454</c:v>
                 </c:pt>
                 <c:pt idx="23">
-                  <c:v>0.12753888168707447</c:v>
+                  <c:v>0.7531854044983303</c:v>
                 </c:pt>
               </c:numCache>
             </c:numRef>
@@ -2346,76 +2346,76 @@
                 <c:formatCode>General</c:formatCode>
                 <c:ptCount val="24"/>
                 <c:pt idx="0">
-                  <c:v>0.2625</c:v>
+                  <c:v>0.378674594023799</c:v>
                 </c:pt>
                 <c:pt idx="1">
-                  <c:v>0.2333333333333333</c:v>
+                  <c:v>0.4646032595311101</c:v>
                 </c:pt>
                 <c:pt idx="2">
-                  <c:v>0.20999999999999996</c:v>
+                  <c:v>0.5295969628906294</c:v>
                 </c:pt>
                 <c:pt idx="3">
-                  <c:v>0.1909090909090909</c:v>
+                  <c:v>0.550387819894599</c:v>
                 </c:pt>
                 <c:pt idx="4">
-                  <c:v>0.17746478873239432</c:v>
+                  <c:v>0.5692489227474313</c:v>
                 </c:pt>
                 <c:pt idx="5">
-                  <c:v>0.16799999999999995</c:v>
+                  <c:v>0.5817921027978562</c:v>
                 </c:pt>
                 <c:pt idx="6">
-                  <c:v>0.16153846153846146</c:v>
+                  <c:v>0.6024632016776186</c:v>
                 </c:pt>
                 <c:pt idx="7">
-                  <c:v>0.15749999999999995</c:v>
+                  <c:v>0.6128990466707255</c:v>
                 </c:pt>
                 <c:pt idx="8">
-                  <c:v>0.15523613963039012</c:v>
+                  <c:v>0.6227116782662687</c:v>
                 </c:pt>
                 <c:pt idx="9">
-                  <c:v>0.15428571428571428</c:v>
+                  <c:v>0.6279753030939259</c:v>
                 </c:pt>
                 <c:pt idx="10">
-                  <c:v>0.15415088843577046</c:v>
+                  <c:v>0.6292397041312255</c:v>
                 </c:pt>
                 <c:pt idx="11">
-                  <c:v>0.1541316468336523</c:v>
+                  <c:v>0.6381286556809219</c:v>
                 </c:pt>
                 <c:pt idx="12">
-                  <c:v>0.15412889842547295</c:v>
+                  <c:v>0.6264854488982616</c:v>
                 </c:pt>
                 <c:pt idx="13">
-                  <c:v>0.1541285058037344</c:v>
+                  <c:v>0.6162310653349193</c:v>
                 </c:pt>
                 <c:pt idx="14">
-                  <c:v>0.15412844971507794</c:v>
+                  <c:v>0.6070744709589718</c:v>
                 </c:pt>
                 <c:pt idx="15">
-                  <c:v>0.15412844170241607</c:v>
+                  <c:v>0.6011506279832521</c:v>
                 </c:pt>
                 <c:pt idx="16">
-                  <c:v>0.15412844055775016</c:v>
+                  <c:v>0.594869933873521</c:v>
                 </c:pt>
                 <c:pt idx="17">
-                  <c:v>0.15412844055775016</c:v>
+                  <c:v>0.6271100096238017</c:v>
                 </c:pt>
                 <c:pt idx="18">
-                  <c:v>0.1496682574103539</c:v>
+                  <c:v>0.6517105240116348</c:v>
                 </c:pt>
                 <c:pt idx="19">
-                  <c:v>0.1462073808339993</c:v>
+                  <c:v>0.662577085497987</c:v>
                 </c:pt>
                 <c:pt idx="20">
-                  <c:v>0.14316242776012045</c:v>
+                  <c:v>0.6709180349516719</c:v>
                 </c:pt>
                 <c:pt idx="21">
-                  <c:v>0.14096883795137777</c:v>
+                  <c:v>0.6757107197830992</c:v>
                 </c:pt>
                 <c:pt idx="22">
-                  <c:v>0.13955619919871126</c:v>
+                  <c:v>0.6773488861166156</c:v>
                 </c:pt>
                 <c:pt idx="23">
-                  <c:v>0.1387673843450973</c:v>
+                  <c:v>0.6794073974011063</c:v>
                 </c:pt>
               </c:numCache>
             </c:numRef>
@@ -8658,7 +8658,7 @@
                           <a:ea typeface="Calibri" pitchFamily="34" charset="-122"/>
                           <a:cs typeface="Calibri" pitchFamily="34" charset="-120"/>
                         </a:rPr>
-                        <a:t>-13,33</a:t>
+                        <a:t>-0,00</a:t>
                       </a:r>
                       <a:endParaRPr lang="en-US" sz="620" dirty="0">
                         <a:latin typeface="Calibri" charset="0"/>
@@ -8726,7 +8726,7 @@
                           <a:ea typeface="Calibri" pitchFamily="34" charset="-122"/>
                           <a:cs typeface="Calibri" pitchFamily="34" charset="-120"/>
                         </a:rPr>
-                        <a:t>100% do NPL 90-360</a:t>
+                        <a:t>Sem Over90 no M1</a:t>
                       </a:r>
                       <a:endParaRPr lang="en-US" sz="620" dirty="0">
                         <a:latin typeface="Calibri" charset="0"/>
@@ -9276,7 +9276,7 @@
                           <a:ea typeface="Calibri" pitchFamily="34" charset="-122"/>
                           <a:cs typeface="Calibri" pitchFamily="34" charset="-120"/>
                         </a:rPr>
-                        <a:t>-2,18</a:t>
+                        <a:t>11,15</a:t>
                       </a:r>
                       <a:endParaRPr lang="en-US" sz="620" dirty="0">
                         <a:latin typeface="Calibri" charset="0"/>
@@ -9344,7 +9344,7 @@
                           <a:ea typeface="Calibri" pitchFamily="34" charset="-122"/>
                           <a:cs typeface="Calibri" pitchFamily="34" charset="-120"/>
                         </a:rPr>
-                        <a:t>Compra nova safra até target; saldo fica em caixa</a:t>
+                        <a:t>Target estoque: R$ 1 bi</a:t>
                       </a:r>
                       <a:endParaRPr lang="en-US" sz="620" dirty="0">
                         <a:latin typeface="Calibri" charset="0"/>
@@ -11568,7 +11568,211 @@
                           <a:ea typeface="Calibri" pitchFamily="34" charset="-122"/>
                           <a:cs typeface="Calibri" pitchFamily="34" charset="-120"/>
                         </a:rPr>
-                        <a:t>R$ 142,9 mi</a:t>
+                        <a:t>R$ 85,7 mi</a:t>
+                      </a:r>
+                      <a:endParaRPr lang="en-US" sz="615" dirty="0">
+                        <a:latin typeface="Calibri" charset="0"/>
+                        <a:ea typeface="Calibri" charset="0"/>
+                        <a:cs typeface="Calibri" charset="0"/>
+                      </a:endParaRPr>
+                    </a:p>
+                  </a:txBody>
+                  <a:tcPr marL="36576" marR="36576" marT="18288" marB="18288" anchor="mid">
+                    <a:lnL w="5715" cap="flat" cmpd="sng" algn="ctr">
+                      <a:solidFill>
+                        <a:srgbClr val="FFFFFF"/>
+                      </a:solidFill>
+                      <a:prstDash val="solid"/>
+                      <a:round/>
+                      <a:headEnd type="none" w="med" len="med"/>
+                      <a:tailEnd type="none" w="med" len="med"/>
+                    </a:lnL>
+                    <a:lnR w="5715" cap="flat" cmpd="sng" algn="ctr">
+                      <a:solidFill>
+                        <a:srgbClr val="FFFFFF"/>
+                      </a:solidFill>
+                      <a:prstDash val="solid"/>
+                      <a:round/>
+                      <a:headEnd type="none" w="med" len="med"/>
+                      <a:tailEnd type="none" w="med" len="med"/>
+                    </a:lnR>
+                    <a:lnT w="5715" cap="flat" cmpd="sng" algn="ctr">
+                      <a:solidFill>
+                        <a:srgbClr val="FFFFFF"/>
+                      </a:solidFill>
+                      <a:prstDash val="solid"/>
+                      <a:round/>
+                      <a:headEnd type="none" w="med" len="med"/>
+                      <a:tailEnd type="none" w="med" len="med"/>
+                    </a:lnT>
+                    <a:lnB w="5715" cap="flat" cmpd="sng" algn="ctr">
+                      <a:solidFill>
+                        <a:srgbClr val="FFFFFF"/>
+                      </a:solidFill>
+                      <a:prstDash val="solid"/>
+                      <a:round/>
+                      <a:headEnd type="none" w="med" len="med"/>
+                      <a:tailEnd type="none" w="med" len="med"/>
+                    </a:lnB>
+                    <a:solidFill>
+                      <a:srgbClr val="FFFFFF"/>
+                    </a:solidFill>
+                  </a:tcPr>
+                </a:tc>
+                <a:tc>
+                  <a:txBody>
+                    <a:bodyPr/>
+                    <a:lstStyle/>
+                    <a:p>
+                      <a:pPr algn="ctr" indent="0" marL="0">
+                        <a:buNone/>
+                      </a:pPr>
+                      <a:r>
+                        <a:rPr lang="en-US" sz="615" dirty="0">
+                          <a:solidFill>
+                            <a:srgbClr val="1F1F1F"/>
+                          </a:solidFill>
+                          <a:latin typeface="Calibri" pitchFamily="34" charset="0"/>
+                          <a:ea typeface="Calibri" pitchFamily="34" charset="-122"/>
+                          <a:cs typeface="Calibri" pitchFamily="34" charset="-120"/>
+                        </a:rPr>
+                        <a:t>R$ 15,3 mi</a:t>
+                      </a:r>
+                      <a:endParaRPr lang="en-US" sz="615" dirty="0">
+                        <a:latin typeface="Calibri" charset="0"/>
+                        <a:ea typeface="Calibri" charset="0"/>
+                        <a:cs typeface="Calibri" charset="0"/>
+                      </a:endParaRPr>
+                    </a:p>
+                  </a:txBody>
+                  <a:tcPr marL="36576" marR="36576" marT="18288" marB="18288" anchor="mid">
+                    <a:lnL w="5715" cap="flat" cmpd="sng" algn="ctr">
+                      <a:solidFill>
+                        <a:srgbClr val="FFFFFF"/>
+                      </a:solidFill>
+                      <a:prstDash val="solid"/>
+                      <a:round/>
+                      <a:headEnd type="none" w="med" len="med"/>
+                      <a:tailEnd type="none" w="med" len="med"/>
+                    </a:lnL>
+                    <a:lnR w="5715" cap="flat" cmpd="sng" algn="ctr">
+                      <a:solidFill>
+                        <a:srgbClr val="FFFFFF"/>
+                      </a:solidFill>
+                      <a:prstDash val="solid"/>
+                      <a:round/>
+                      <a:headEnd type="none" w="med" len="med"/>
+                      <a:tailEnd type="none" w="med" len="med"/>
+                    </a:lnR>
+                    <a:lnT w="5715" cap="flat" cmpd="sng" algn="ctr">
+                      <a:solidFill>
+                        <a:srgbClr val="FFFFFF"/>
+                      </a:solidFill>
+                      <a:prstDash val="solid"/>
+                      <a:round/>
+                      <a:headEnd type="none" w="med" len="med"/>
+                      <a:tailEnd type="none" w="med" len="med"/>
+                    </a:lnT>
+                    <a:lnB w="5715" cap="flat" cmpd="sng" algn="ctr">
+                      <a:solidFill>
+                        <a:srgbClr val="FFFFFF"/>
+                      </a:solidFill>
+                      <a:prstDash val="solid"/>
+                      <a:round/>
+                      <a:headEnd type="none" w="med" len="med"/>
+                      <a:tailEnd type="none" w="med" len="med"/>
+                    </a:lnB>
+                    <a:solidFill>
+                      <a:srgbClr val="FFFFFF"/>
+                    </a:solidFill>
+                  </a:tcPr>
+                </a:tc>
+                <a:tc>
+                  <a:txBody>
+                    <a:bodyPr/>
+                    <a:lstStyle/>
+                    <a:p>
+                      <a:pPr algn="ctr" indent="0" marL="0">
+                        <a:buNone/>
+                      </a:pPr>
+                      <a:r>
+                        <a:rPr lang="en-US" sz="615" dirty="0">
+                          <a:solidFill>
+                            <a:srgbClr val="1F1F1F"/>
+                          </a:solidFill>
+                          <a:latin typeface="Calibri" pitchFamily="34" charset="0"/>
+                          <a:ea typeface="Calibri" pitchFamily="34" charset="-122"/>
+                          <a:cs typeface="Calibri" pitchFamily="34" charset="-120"/>
+                        </a:rPr>
+                        <a:t>R$ 96,2 mi</a:t>
+                      </a:r>
+                      <a:endParaRPr lang="en-US" sz="615" dirty="0">
+                        <a:latin typeface="Calibri" charset="0"/>
+                        <a:ea typeface="Calibri" charset="0"/>
+                        <a:cs typeface="Calibri" charset="0"/>
+                      </a:endParaRPr>
+                    </a:p>
+                  </a:txBody>
+                  <a:tcPr marL="36576" marR="36576" marT="18288" marB="18288" anchor="mid">
+                    <a:lnL w="5715" cap="flat" cmpd="sng" algn="ctr">
+                      <a:solidFill>
+                        <a:srgbClr val="FFFFFF"/>
+                      </a:solidFill>
+                      <a:prstDash val="solid"/>
+                      <a:round/>
+                      <a:headEnd type="none" w="med" len="med"/>
+                      <a:tailEnd type="none" w="med" len="med"/>
+                    </a:lnL>
+                    <a:lnR w="5715" cap="flat" cmpd="sng" algn="ctr">
+                      <a:solidFill>
+                        <a:srgbClr val="FFFFFF"/>
+                      </a:solidFill>
+                      <a:prstDash val="solid"/>
+                      <a:round/>
+                      <a:headEnd type="none" w="med" len="med"/>
+                      <a:tailEnd type="none" w="med" len="med"/>
+                    </a:lnR>
+                    <a:lnT w="5715" cap="flat" cmpd="sng" algn="ctr">
+                      <a:solidFill>
+                        <a:srgbClr val="FFFFFF"/>
+                      </a:solidFill>
+                      <a:prstDash val="solid"/>
+                      <a:round/>
+                      <a:headEnd type="none" w="med" len="med"/>
+                      <a:tailEnd type="none" w="med" len="med"/>
+                    </a:lnT>
+                    <a:lnB w="5715" cap="flat" cmpd="sng" algn="ctr">
+                      <a:solidFill>
+                        <a:srgbClr val="FFFFFF"/>
+                      </a:solidFill>
+                      <a:prstDash val="solid"/>
+                      <a:round/>
+                      <a:headEnd type="none" w="med" len="med"/>
+                      <a:tailEnd type="none" w="med" len="med"/>
+                    </a:lnB>
+                    <a:solidFill>
+                      <a:srgbClr val="FFFFFF"/>
+                    </a:solidFill>
+                  </a:tcPr>
+                </a:tc>
+                <a:tc>
+                  <a:txBody>
+                    <a:bodyPr/>
+                    <a:lstStyle/>
+                    <a:p>
+                      <a:pPr algn="ctr" indent="0" marL="0">
+                        <a:buNone/>
+                      </a:pPr>
+                      <a:r>
+                        <a:rPr lang="en-US" sz="615" dirty="0">
+                          <a:solidFill>
+                            <a:srgbClr val="1F1F1F"/>
+                          </a:solidFill>
+                          <a:latin typeface="Calibri" pitchFamily="34" charset="0"/>
+                          <a:ea typeface="Calibri" pitchFamily="34" charset="-122"/>
+                          <a:cs typeface="Calibri" pitchFamily="34" charset="-120"/>
+                        </a:rPr>
+                        <a:t>R$ 101 mi</a:t>
                       </a:r>
                       <a:endParaRPr lang="en-US" sz="615" dirty="0">
                         <a:latin typeface="Calibri" charset="0"/>
@@ -11704,211 +11908,7 @@
                           <a:ea typeface="Calibri" pitchFamily="34" charset="-122"/>
                           <a:cs typeface="Calibri" pitchFamily="34" charset="-120"/>
                         </a:rPr>
-                        <a:t>R$ 0,00</a:t>
-                      </a:r>
-                      <a:endParaRPr lang="en-US" sz="615" dirty="0">
-                        <a:latin typeface="Calibri" charset="0"/>
-                        <a:ea typeface="Calibri" charset="0"/>
-                        <a:cs typeface="Calibri" charset="0"/>
-                      </a:endParaRPr>
-                    </a:p>
-                  </a:txBody>
-                  <a:tcPr marL="36576" marR="36576" marT="18288" marB="18288" anchor="mid">
-                    <a:lnL w="5715" cap="flat" cmpd="sng" algn="ctr">
-                      <a:solidFill>
-                        <a:srgbClr val="FFFFFF"/>
-                      </a:solidFill>
-                      <a:prstDash val="solid"/>
-                      <a:round/>
-                      <a:headEnd type="none" w="med" len="med"/>
-                      <a:tailEnd type="none" w="med" len="med"/>
-                    </a:lnL>
-                    <a:lnR w="5715" cap="flat" cmpd="sng" algn="ctr">
-                      <a:solidFill>
-                        <a:srgbClr val="FFFFFF"/>
-                      </a:solidFill>
-                      <a:prstDash val="solid"/>
-                      <a:round/>
-                      <a:headEnd type="none" w="med" len="med"/>
-                      <a:tailEnd type="none" w="med" len="med"/>
-                    </a:lnR>
-                    <a:lnT w="5715" cap="flat" cmpd="sng" algn="ctr">
-                      <a:solidFill>
-                        <a:srgbClr val="FFFFFF"/>
-                      </a:solidFill>
-                      <a:prstDash val="solid"/>
-                      <a:round/>
-                      <a:headEnd type="none" w="med" len="med"/>
-                      <a:tailEnd type="none" w="med" len="med"/>
-                    </a:lnT>
-                    <a:lnB w="5715" cap="flat" cmpd="sng" algn="ctr">
-                      <a:solidFill>
-                        <a:srgbClr val="FFFFFF"/>
-                      </a:solidFill>
-                      <a:prstDash val="solid"/>
-                      <a:round/>
-                      <a:headEnd type="none" w="med" len="med"/>
-                      <a:tailEnd type="none" w="med" len="med"/>
-                    </a:lnB>
-                    <a:solidFill>
-                      <a:srgbClr val="FFFFFF"/>
-                    </a:solidFill>
-                  </a:tcPr>
-                </a:tc>
-                <a:tc>
-                  <a:txBody>
-                    <a:bodyPr/>
-                    <a:lstStyle/>
-                    <a:p>
-                      <a:pPr algn="ctr" indent="0" marL="0">
-                        <a:buNone/>
-                      </a:pPr>
-                      <a:r>
-                        <a:rPr lang="en-US" sz="615" dirty="0">
-                          <a:solidFill>
-                            <a:srgbClr val="1F1F1F"/>
-                          </a:solidFill>
-                          <a:latin typeface="Calibri" pitchFamily="34" charset="0"/>
-                          <a:ea typeface="Calibri" pitchFamily="34" charset="-122"/>
-                          <a:cs typeface="Calibri" pitchFamily="34" charset="-120"/>
-                        </a:rPr>
-                        <a:t>R$ 142,9 mi</a:t>
-                      </a:r>
-                      <a:endParaRPr lang="en-US" sz="615" dirty="0">
-                        <a:latin typeface="Calibri" charset="0"/>
-                        <a:ea typeface="Calibri" charset="0"/>
-                        <a:cs typeface="Calibri" charset="0"/>
-                      </a:endParaRPr>
-                    </a:p>
-                  </a:txBody>
-                  <a:tcPr marL="36576" marR="36576" marT="18288" marB="18288" anchor="mid">
-                    <a:lnL w="5715" cap="flat" cmpd="sng" algn="ctr">
-                      <a:solidFill>
-                        <a:srgbClr val="FFFFFF"/>
-                      </a:solidFill>
-                      <a:prstDash val="solid"/>
-                      <a:round/>
-                      <a:headEnd type="none" w="med" len="med"/>
-                      <a:tailEnd type="none" w="med" len="med"/>
-                    </a:lnL>
-                    <a:lnR w="5715" cap="flat" cmpd="sng" algn="ctr">
-                      <a:solidFill>
-                        <a:srgbClr val="FFFFFF"/>
-                      </a:solidFill>
-                      <a:prstDash val="solid"/>
-                      <a:round/>
-                      <a:headEnd type="none" w="med" len="med"/>
-                      <a:tailEnd type="none" w="med" len="med"/>
-                    </a:lnR>
-                    <a:lnT w="5715" cap="flat" cmpd="sng" algn="ctr">
-                      <a:solidFill>
-                        <a:srgbClr val="FFFFFF"/>
-                      </a:solidFill>
-                      <a:prstDash val="solid"/>
-                      <a:round/>
-                      <a:headEnd type="none" w="med" len="med"/>
-                      <a:tailEnd type="none" w="med" len="med"/>
-                    </a:lnT>
-                    <a:lnB w="5715" cap="flat" cmpd="sng" algn="ctr">
-                      <a:solidFill>
-                        <a:srgbClr val="FFFFFF"/>
-                      </a:solidFill>
-                      <a:prstDash val="solid"/>
-                      <a:round/>
-                      <a:headEnd type="none" w="med" len="med"/>
-                      <a:tailEnd type="none" w="med" len="med"/>
-                    </a:lnB>
-                    <a:solidFill>
-                      <a:srgbClr val="FFFFFF"/>
-                    </a:solidFill>
-                  </a:tcPr>
-                </a:tc>
-                <a:tc>
-                  <a:txBody>
-                    <a:bodyPr/>
-                    <a:lstStyle/>
-                    <a:p>
-                      <a:pPr algn="ctr" indent="0" marL="0">
-                        <a:buNone/>
-                      </a:pPr>
-                      <a:r>
-                        <a:rPr lang="en-US" sz="615" dirty="0">
-                          <a:solidFill>
-                            <a:srgbClr val="1F1F1F"/>
-                          </a:solidFill>
-                          <a:latin typeface="Calibri" pitchFamily="34" charset="0"/>
-                          <a:ea typeface="Calibri" pitchFamily="34" charset="-122"/>
-                          <a:cs typeface="Calibri" pitchFamily="34" charset="-120"/>
-                        </a:rPr>
-                        <a:t>R$ 21,8 mi</a:t>
-                      </a:r>
-                      <a:endParaRPr lang="en-US" sz="615" dirty="0">
-                        <a:latin typeface="Calibri" charset="0"/>
-                        <a:ea typeface="Calibri" charset="0"/>
-                        <a:cs typeface="Calibri" charset="0"/>
-                      </a:endParaRPr>
-                    </a:p>
-                  </a:txBody>
-                  <a:tcPr marL="36576" marR="36576" marT="18288" marB="18288" anchor="mid">
-                    <a:lnL w="5715" cap="flat" cmpd="sng" algn="ctr">
-                      <a:solidFill>
-                        <a:srgbClr val="FFFFFF"/>
-                      </a:solidFill>
-                      <a:prstDash val="solid"/>
-                      <a:round/>
-                      <a:headEnd type="none" w="med" len="med"/>
-                      <a:tailEnd type="none" w="med" len="med"/>
-                    </a:lnL>
-                    <a:lnR w="5715" cap="flat" cmpd="sng" algn="ctr">
-                      <a:solidFill>
-                        <a:srgbClr val="FFFFFF"/>
-                      </a:solidFill>
-                      <a:prstDash val="solid"/>
-                      <a:round/>
-                      <a:headEnd type="none" w="med" len="med"/>
-                      <a:tailEnd type="none" w="med" len="med"/>
-                    </a:lnR>
-                    <a:lnT w="5715" cap="flat" cmpd="sng" algn="ctr">
-                      <a:solidFill>
-                        <a:srgbClr val="FFFFFF"/>
-                      </a:solidFill>
-                      <a:prstDash val="solid"/>
-                      <a:round/>
-                      <a:headEnd type="none" w="med" len="med"/>
-                      <a:tailEnd type="none" w="med" len="med"/>
-                    </a:lnT>
-                    <a:lnB w="5715" cap="flat" cmpd="sng" algn="ctr">
-                      <a:solidFill>
-                        <a:srgbClr val="FFFFFF"/>
-                      </a:solidFill>
-                      <a:prstDash val="solid"/>
-                      <a:round/>
-                      <a:headEnd type="none" w="med" len="med"/>
-                      <a:tailEnd type="none" w="med" len="med"/>
-                    </a:lnB>
-                    <a:solidFill>
-                      <a:srgbClr val="FFFFFF"/>
-                    </a:solidFill>
-                  </a:tcPr>
-                </a:tc>
-                <a:tc>
-                  <a:txBody>
-                    <a:bodyPr/>
-                    <a:lstStyle/>
-                    <a:p>
-                      <a:pPr algn="ctr" indent="0" marL="0">
-                        <a:buNone/>
-                      </a:pPr>
-                      <a:r>
-                        <a:rPr lang="en-US" sz="615" dirty="0">
-                          <a:solidFill>
-                            <a:srgbClr val="1F1F1F"/>
-                          </a:solidFill>
-                          <a:latin typeface="Calibri" pitchFamily="34" charset="0"/>
-                          <a:ea typeface="Calibri" pitchFamily="34" charset="-122"/>
-                          <a:cs typeface="Calibri" pitchFamily="34" charset="-120"/>
-                        </a:rPr>
-                        <a:t>30,00%</a:t>
+                        <a:t>37,02%</a:t>
                       </a:r>
                       <a:endParaRPr lang="en-US" sz="615" dirty="0">
                         <a:latin typeface="Calibri" charset="0"/>
@@ -12046,7 +12046,211 @@
                           <a:ea typeface="Calibri" pitchFamily="34" charset="-122"/>
                           <a:cs typeface="Calibri" pitchFamily="34" charset="-120"/>
                         </a:rPr>
-                        <a:t>R$ 142,9 mi</a:t>
+                        <a:t>R$ 87 mi</a:t>
+                      </a:r>
+                      <a:endParaRPr lang="en-US" sz="615" dirty="0">
+                        <a:latin typeface="Calibri" charset="0"/>
+                        <a:ea typeface="Calibri" charset="0"/>
+                        <a:cs typeface="Calibri" charset="0"/>
+                      </a:endParaRPr>
+                    </a:p>
+                  </a:txBody>
+                  <a:tcPr marL="36576" marR="36576" marT="18288" marB="18288" anchor="mid">
+                    <a:lnL w="5715" cap="flat" cmpd="sng" algn="ctr">
+                      <a:solidFill>
+                        <a:srgbClr val="FFFFFF"/>
+                      </a:solidFill>
+                      <a:prstDash val="solid"/>
+                      <a:round/>
+                      <a:headEnd type="none" w="med" len="med"/>
+                      <a:tailEnd type="none" w="med" len="med"/>
+                    </a:lnL>
+                    <a:lnR w="5715" cap="flat" cmpd="sng" algn="ctr">
+                      <a:solidFill>
+                        <a:srgbClr val="FFFFFF"/>
+                      </a:solidFill>
+                      <a:prstDash val="solid"/>
+                      <a:round/>
+                      <a:headEnd type="none" w="med" len="med"/>
+                      <a:tailEnd type="none" w="med" len="med"/>
+                    </a:lnR>
+                    <a:lnT w="5715" cap="flat" cmpd="sng" algn="ctr">
+                      <a:solidFill>
+                        <a:srgbClr val="FFFFFF"/>
+                      </a:solidFill>
+                      <a:prstDash val="solid"/>
+                      <a:round/>
+                      <a:headEnd type="none" w="med" len="med"/>
+                      <a:tailEnd type="none" w="med" len="med"/>
+                    </a:lnT>
+                    <a:lnB w="5715" cap="flat" cmpd="sng" algn="ctr">
+                      <a:solidFill>
+                        <a:srgbClr val="FFFFFF"/>
+                      </a:solidFill>
+                      <a:prstDash val="solid"/>
+                      <a:round/>
+                      <a:headEnd type="none" w="med" len="med"/>
+                      <a:tailEnd type="none" w="med" len="med"/>
+                    </a:lnB>
+                    <a:solidFill>
+                      <a:srgbClr val="F1F1F1"/>
+                    </a:solidFill>
+                  </a:tcPr>
+                </a:tc>
+                <a:tc>
+                  <a:txBody>
+                    <a:bodyPr/>
+                    <a:lstStyle/>
+                    <a:p>
+                      <a:pPr algn="ctr" indent="0" marL="0">
+                        <a:buNone/>
+                      </a:pPr>
+                      <a:r>
+                        <a:rPr lang="en-US" sz="615" dirty="0">
+                          <a:solidFill>
+                            <a:srgbClr val="1F1F1F"/>
+                          </a:solidFill>
+                          <a:latin typeface="Calibri" pitchFamily="34" charset="0"/>
+                          <a:ea typeface="Calibri" pitchFamily="34" charset="-122"/>
+                          <a:cs typeface="Calibri" pitchFamily="34" charset="-120"/>
+                        </a:rPr>
+                        <a:t>R$ 15,5 mi</a:t>
+                      </a:r>
+                      <a:endParaRPr lang="en-US" sz="615" dirty="0">
+                        <a:latin typeface="Calibri" charset="0"/>
+                        <a:ea typeface="Calibri" charset="0"/>
+                        <a:cs typeface="Calibri" charset="0"/>
+                      </a:endParaRPr>
+                    </a:p>
+                  </a:txBody>
+                  <a:tcPr marL="36576" marR="36576" marT="18288" marB="18288" anchor="mid">
+                    <a:lnL w="5715" cap="flat" cmpd="sng" algn="ctr">
+                      <a:solidFill>
+                        <a:srgbClr val="FFFFFF"/>
+                      </a:solidFill>
+                      <a:prstDash val="solid"/>
+                      <a:round/>
+                      <a:headEnd type="none" w="med" len="med"/>
+                      <a:tailEnd type="none" w="med" len="med"/>
+                    </a:lnL>
+                    <a:lnR w="5715" cap="flat" cmpd="sng" algn="ctr">
+                      <a:solidFill>
+                        <a:srgbClr val="FFFFFF"/>
+                      </a:solidFill>
+                      <a:prstDash val="solid"/>
+                      <a:round/>
+                      <a:headEnd type="none" w="med" len="med"/>
+                      <a:tailEnd type="none" w="med" len="med"/>
+                    </a:lnR>
+                    <a:lnT w="5715" cap="flat" cmpd="sng" algn="ctr">
+                      <a:solidFill>
+                        <a:srgbClr val="FFFFFF"/>
+                      </a:solidFill>
+                      <a:prstDash val="solid"/>
+                      <a:round/>
+                      <a:headEnd type="none" w="med" len="med"/>
+                      <a:tailEnd type="none" w="med" len="med"/>
+                    </a:lnT>
+                    <a:lnB w="5715" cap="flat" cmpd="sng" algn="ctr">
+                      <a:solidFill>
+                        <a:srgbClr val="FFFFFF"/>
+                      </a:solidFill>
+                      <a:prstDash val="solid"/>
+                      <a:round/>
+                      <a:headEnd type="none" w="med" len="med"/>
+                      <a:tailEnd type="none" w="med" len="med"/>
+                    </a:lnB>
+                    <a:solidFill>
+                      <a:srgbClr val="F1F1F1"/>
+                    </a:solidFill>
+                  </a:tcPr>
+                </a:tc>
+                <a:tc>
+                  <a:txBody>
+                    <a:bodyPr/>
+                    <a:lstStyle/>
+                    <a:p>
+                      <a:pPr algn="ctr" indent="0" marL="0">
+                        <a:buNone/>
+                      </a:pPr>
+                      <a:r>
+                        <a:rPr lang="en-US" sz="615" dirty="0">
+                          <a:solidFill>
+                            <a:srgbClr val="1F1F1F"/>
+                          </a:solidFill>
+                          <a:latin typeface="Calibri" pitchFamily="34" charset="0"/>
+                          <a:ea typeface="Calibri" pitchFamily="34" charset="-122"/>
+                          <a:cs typeface="Calibri" pitchFamily="34" charset="-120"/>
+                        </a:rPr>
+                        <a:t>R$ 118,8 mi</a:t>
+                      </a:r>
+                      <a:endParaRPr lang="en-US" sz="615" dirty="0">
+                        <a:latin typeface="Calibri" charset="0"/>
+                        <a:ea typeface="Calibri" charset="0"/>
+                        <a:cs typeface="Calibri" charset="0"/>
+                      </a:endParaRPr>
+                    </a:p>
+                  </a:txBody>
+                  <a:tcPr marL="36576" marR="36576" marT="18288" marB="18288" anchor="mid">
+                    <a:lnL w="5715" cap="flat" cmpd="sng" algn="ctr">
+                      <a:solidFill>
+                        <a:srgbClr val="FFFFFF"/>
+                      </a:solidFill>
+                      <a:prstDash val="solid"/>
+                      <a:round/>
+                      <a:headEnd type="none" w="med" len="med"/>
+                      <a:tailEnd type="none" w="med" len="med"/>
+                    </a:lnL>
+                    <a:lnR w="5715" cap="flat" cmpd="sng" algn="ctr">
+                      <a:solidFill>
+                        <a:srgbClr val="FFFFFF"/>
+                      </a:solidFill>
+                      <a:prstDash val="solid"/>
+                      <a:round/>
+                      <a:headEnd type="none" w="med" len="med"/>
+                      <a:tailEnd type="none" w="med" len="med"/>
+                    </a:lnR>
+                    <a:lnT w="5715" cap="flat" cmpd="sng" algn="ctr">
+                      <a:solidFill>
+                        <a:srgbClr val="FFFFFF"/>
+                      </a:solidFill>
+                      <a:prstDash val="solid"/>
+                      <a:round/>
+                      <a:headEnd type="none" w="med" len="med"/>
+                      <a:tailEnd type="none" w="med" len="med"/>
+                    </a:lnT>
+                    <a:lnB w="5715" cap="flat" cmpd="sng" algn="ctr">
+                      <a:solidFill>
+                        <a:srgbClr val="FFFFFF"/>
+                      </a:solidFill>
+                      <a:prstDash val="solid"/>
+                      <a:round/>
+                      <a:headEnd type="none" w="med" len="med"/>
+                      <a:tailEnd type="none" w="med" len="med"/>
+                    </a:lnB>
+                    <a:solidFill>
+                      <a:srgbClr val="F1F1F1"/>
+                    </a:solidFill>
+                  </a:tcPr>
+                </a:tc>
+                <a:tc>
+                  <a:txBody>
+                    <a:bodyPr/>
+                    <a:lstStyle/>
+                    <a:p>
+                      <a:pPr algn="ctr" indent="0" marL="0">
+                        <a:buNone/>
+                      </a:pPr>
+                      <a:r>
+                        <a:rPr lang="en-US" sz="615" dirty="0">
+                          <a:solidFill>
+                            <a:srgbClr val="1F1F1F"/>
+                          </a:solidFill>
+                          <a:latin typeface="Calibri" pitchFamily="34" charset="0"/>
+                          <a:ea typeface="Calibri" pitchFamily="34" charset="-122"/>
+                          <a:cs typeface="Calibri" pitchFamily="34" charset="-120"/>
+                        </a:rPr>
+                        <a:t>R$ 102,6 mi</a:t>
                       </a:r>
                       <a:endParaRPr lang="en-US" sz="615" dirty="0">
                         <a:latin typeface="Calibri" charset="0"/>
@@ -12182,211 +12386,7 @@
                           <a:ea typeface="Calibri" pitchFamily="34" charset="-122"/>
                           <a:cs typeface="Calibri" pitchFamily="34" charset="-120"/>
                         </a:rPr>
-                        <a:t>R$ 0,00</a:t>
-                      </a:r>
-                      <a:endParaRPr lang="en-US" sz="615" dirty="0">
-                        <a:latin typeface="Calibri" charset="0"/>
-                        <a:ea typeface="Calibri" charset="0"/>
-                        <a:cs typeface="Calibri" charset="0"/>
-                      </a:endParaRPr>
-                    </a:p>
-                  </a:txBody>
-                  <a:tcPr marL="36576" marR="36576" marT="18288" marB="18288" anchor="mid">
-                    <a:lnL w="5715" cap="flat" cmpd="sng" algn="ctr">
-                      <a:solidFill>
-                        <a:srgbClr val="FFFFFF"/>
-                      </a:solidFill>
-                      <a:prstDash val="solid"/>
-                      <a:round/>
-                      <a:headEnd type="none" w="med" len="med"/>
-                      <a:tailEnd type="none" w="med" len="med"/>
-                    </a:lnL>
-                    <a:lnR w="5715" cap="flat" cmpd="sng" algn="ctr">
-                      <a:solidFill>
-                        <a:srgbClr val="FFFFFF"/>
-                      </a:solidFill>
-                      <a:prstDash val="solid"/>
-                      <a:round/>
-                      <a:headEnd type="none" w="med" len="med"/>
-                      <a:tailEnd type="none" w="med" len="med"/>
-                    </a:lnR>
-                    <a:lnT w="5715" cap="flat" cmpd="sng" algn="ctr">
-                      <a:solidFill>
-                        <a:srgbClr val="FFFFFF"/>
-                      </a:solidFill>
-                      <a:prstDash val="solid"/>
-                      <a:round/>
-                      <a:headEnd type="none" w="med" len="med"/>
-                      <a:tailEnd type="none" w="med" len="med"/>
-                    </a:lnT>
-                    <a:lnB w="5715" cap="flat" cmpd="sng" algn="ctr">
-                      <a:solidFill>
-                        <a:srgbClr val="FFFFFF"/>
-                      </a:solidFill>
-                      <a:prstDash val="solid"/>
-                      <a:round/>
-                      <a:headEnd type="none" w="med" len="med"/>
-                      <a:tailEnd type="none" w="med" len="med"/>
-                    </a:lnB>
-                    <a:solidFill>
-                      <a:srgbClr val="F1F1F1"/>
-                    </a:solidFill>
-                  </a:tcPr>
-                </a:tc>
-                <a:tc>
-                  <a:txBody>
-                    <a:bodyPr/>
-                    <a:lstStyle/>
-                    <a:p>
-                      <a:pPr algn="ctr" indent="0" marL="0">
-                        <a:buNone/>
-                      </a:pPr>
-                      <a:r>
-                        <a:rPr lang="en-US" sz="615" dirty="0">
-                          <a:solidFill>
-                            <a:srgbClr val="1F1F1F"/>
-                          </a:solidFill>
-                          <a:latin typeface="Calibri" pitchFamily="34" charset="0"/>
-                          <a:ea typeface="Calibri" pitchFamily="34" charset="-122"/>
-                          <a:cs typeface="Calibri" pitchFamily="34" charset="-120"/>
-                        </a:rPr>
-                        <a:t>R$ 142,9 mi</a:t>
-                      </a:r>
-                      <a:endParaRPr lang="en-US" sz="615" dirty="0">
-                        <a:latin typeface="Calibri" charset="0"/>
-                        <a:ea typeface="Calibri" charset="0"/>
-                        <a:cs typeface="Calibri" charset="0"/>
-                      </a:endParaRPr>
-                    </a:p>
-                  </a:txBody>
-                  <a:tcPr marL="36576" marR="36576" marT="18288" marB="18288" anchor="mid">
-                    <a:lnL w="5715" cap="flat" cmpd="sng" algn="ctr">
-                      <a:solidFill>
-                        <a:srgbClr val="FFFFFF"/>
-                      </a:solidFill>
-                      <a:prstDash val="solid"/>
-                      <a:round/>
-                      <a:headEnd type="none" w="med" len="med"/>
-                      <a:tailEnd type="none" w="med" len="med"/>
-                    </a:lnL>
-                    <a:lnR w="5715" cap="flat" cmpd="sng" algn="ctr">
-                      <a:solidFill>
-                        <a:srgbClr val="FFFFFF"/>
-                      </a:solidFill>
-                      <a:prstDash val="solid"/>
-                      <a:round/>
-                      <a:headEnd type="none" w="med" len="med"/>
-                      <a:tailEnd type="none" w="med" len="med"/>
-                    </a:lnR>
-                    <a:lnT w="5715" cap="flat" cmpd="sng" algn="ctr">
-                      <a:solidFill>
-                        <a:srgbClr val="FFFFFF"/>
-                      </a:solidFill>
-                      <a:prstDash val="solid"/>
-                      <a:round/>
-                      <a:headEnd type="none" w="med" len="med"/>
-                      <a:tailEnd type="none" w="med" len="med"/>
-                    </a:lnT>
-                    <a:lnB w="5715" cap="flat" cmpd="sng" algn="ctr">
-                      <a:solidFill>
-                        <a:srgbClr val="FFFFFF"/>
-                      </a:solidFill>
-                      <a:prstDash val="solid"/>
-                      <a:round/>
-                      <a:headEnd type="none" w="med" len="med"/>
-                      <a:tailEnd type="none" w="med" len="med"/>
-                    </a:lnB>
-                    <a:solidFill>
-                      <a:srgbClr val="F1F1F1"/>
-                    </a:solidFill>
-                  </a:tcPr>
-                </a:tc>
-                <a:tc>
-                  <a:txBody>
-                    <a:bodyPr/>
-                    <a:lstStyle/>
-                    <a:p>
-                      <a:pPr algn="ctr" indent="0" marL="0">
-                        <a:buNone/>
-                      </a:pPr>
-                      <a:r>
-                        <a:rPr lang="en-US" sz="615" dirty="0">
-                          <a:solidFill>
-                            <a:srgbClr val="1F1F1F"/>
-                          </a:solidFill>
-                          <a:latin typeface="Calibri" pitchFamily="34" charset="0"/>
-                          <a:ea typeface="Calibri" pitchFamily="34" charset="-122"/>
-                          <a:cs typeface="Calibri" pitchFamily="34" charset="-120"/>
-                        </a:rPr>
-                        <a:t>R$ 1,9 mi</a:t>
-                      </a:r>
-                      <a:endParaRPr lang="en-US" sz="615" dirty="0">
-                        <a:latin typeface="Calibri" charset="0"/>
-                        <a:ea typeface="Calibri" charset="0"/>
-                        <a:cs typeface="Calibri" charset="0"/>
-                      </a:endParaRPr>
-                    </a:p>
-                  </a:txBody>
-                  <a:tcPr marL="36576" marR="36576" marT="18288" marB="18288" anchor="mid">
-                    <a:lnL w="5715" cap="flat" cmpd="sng" algn="ctr">
-                      <a:solidFill>
-                        <a:srgbClr val="FFFFFF"/>
-                      </a:solidFill>
-                      <a:prstDash val="solid"/>
-                      <a:round/>
-                      <a:headEnd type="none" w="med" len="med"/>
-                      <a:tailEnd type="none" w="med" len="med"/>
-                    </a:lnL>
-                    <a:lnR w="5715" cap="flat" cmpd="sng" algn="ctr">
-                      <a:solidFill>
-                        <a:srgbClr val="FFFFFF"/>
-                      </a:solidFill>
-                      <a:prstDash val="solid"/>
-                      <a:round/>
-                      <a:headEnd type="none" w="med" len="med"/>
-                      <a:tailEnd type="none" w="med" len="med"/>
-                    </a:lnR>
-                    <a:lnT w="5715" cap="flat" cmpd="sng" algn="ctr">
-                      <a:solidFill>
-                        <a:srgbClr val="FFFFFF"/>
-                      </a:solidFill>
-                      <a:prstDash val="solid"/>
-                      <a:round/>
-                      <a:headEnd type="none" w="med" len="med"/>
-                      <a:tailEnd type="none" w="med" len="med"/>
-                    </a:lnT>
-                    <a:lnB w="5715" cap="flat" cmpd="sng" algn="ctr">
-                      <a:solidFill>
-                        <a:srgbClr val="FFFFFF"/>
-                      </a:solidFill>
-                      <a:prstDash val="solid"/>
-                      <a:round/>
-                      <a:headEnd type="none" w="med" len="med"/>
-                      <a:tailEnd type="none" w="med" len="med"/>
-                    </a:lnB>
-                    <a:solidFill>
-                      <a:srgbClr val="F1F1F1"/>
-                    </a:solidFill>
-                  </a:tcPr>
-                </a:tc>
-                <a:tc>
-                  <a:txBody>
-                    <a:bodyPr/>
-                    <a:lstStyle/>
-                    <a:p>
-                      <a:pPr algn="ctr" indent="0" marL="0">
-                        <a:buNone/>
-                      </a:pPr>
-                      <a:r>
-                        <a:rPr lang="en-US" sz="615" dirty="0">
-                          <a:solidFill>
-                            <a:srgbClr val="1F1F1F"/>
-                          </a:solidFill>
-                          <a:latin typeface="Calibri" pitchFamily="34" charset="0"/>
-                          <a:ea typeface="Calibri" pitchFamily="34" charset="-122"/>
-                          <a:cs typeface="Calibri" pitchFamily="34" charset="-120"/>
-                        </a:rPr>
-                        <a:t>30,00%</a:t>
+                        <a:t>43,81%</a:t>
                       </a:r>
                       <a:endParaRPr lang="en-US" sz="615" dirty="0">
                         <a:latin typeface="Calibri" charset="0"/>
@@ -12524,7 +12524,211 @@
                           <a:ea typeface="Calibri" pitchFamily="34" charset="-122"/>
                           <a:cs typeface="Calibri" pitchFamily="34" charset="-120"/>
                         </a:rPr>
-                        <a:t>R$ 142,9 mi</a:t>
+                        <a:t>R$ 88,4 mi</a:t>
+                      </a:r>
+                      <a:endParaRPr lang="en-US" sz="615" dirty="0">
+                        <a:latin typeface="Calibri" charset="0"/>
+                        <a:ea typeface="Calibri" charset="0"/>
+                        <a:cs typeface="Calibri" charset="0"/>
+                      </a:endParaRPr>
+                    </a:p>
+                  </a:txBody>
+                  <a:tcPr marL="36576" marR="36576" marT="18288" marB="18288" anchor="mid">
+                    <a:lnL w="5715" cap="flat" cmpd="sng" algn="ctr">
+                      <a:solidFill>
+                        <a:srgbClr val="FFFFFF"/>
+                      </a:solidFill>
+                      <a:prstDash val="solid"/>
+                      <a:round/>
+                      <a:headEnd type="none" w="med" len="med"/>
+                      <a:tailEnd type="none" w="med" len="med"/>
+                    </a:lnL>
+                    <a:lnR w="5715" cap="flat" cmpd="sng" algn="ctr">
+                      <a:solidFill>
+                        <a:srgbClr val="FFFFFF"/>
+                      </a:solidFill>
+                      <a:prstDash val="solid"/>
+                      <a:round/>
+                      <a:headEnd type="none" w="med" len="med"/>
+                      <a:tailEnd type="none" w="med" len="med"/>
+                    </a:lnR>
+                    <a:lnT w="5715" cap="flat" cmpd="sng" algn="ctr">
+                      <a:solidFill>
+                        <a:srgbClr val="FFFFFF"/>
+                      </a:solidFill>
+                      <a:prstDash val="solid"/>
+                      <a:round/>
+                      <a:headEnd type="none" w="med" len="med"/>
+                      <a:tailEnd type="none" w="med" len="med"/>
+                    </a:lnT>
+                    <a:lnB w="5715" cap="flat" cmpd="sng" algn="ctr">
+                      <a:solidFill>
+                        <a:srgbClr val="FFFFFF"/>
+                      </a:solidFill>
+                      <a:prstDash val="solid"/>
+                      <a:round/>
+                      <a:headEnd type="none" w="med" len="med"/>
+                      <a:tailEnd type="none" w="med" len="med"/>
+                    </a:lnB>
+                    <a:solidFill>
+                      <a:srgbClr val="FFFFFF"/>
+                    </a:solidFill>
+                  </a:tcPr>
+                </a:tc>
+                <a:tc>
+                  <a:txBody>
+                    <a:bodyPr/>
+                    <a:lstStyle/>
+                    <a:p>
+                      <a:pPr algn="ctr" indent="0" marL="0">
+                        <a:buNone/>
+                      </a:pPr>
+                      <a:r>
+                        <a:rPr lang="en-US" sz="615" dirty="0">
+                          <a:solidFill>
+                            <a:srgbClr val="1F1F1F"/>
+                          </a:solidFill>
+                          <a:latin typeface="Calibri" pitchFamily="34" charset="0"/>
+                          <a:ea typeface="Calibri" pitchFamily="34" charset="-122"/>
+                          <a:cs typeface="Calibri" pitchFamily="34" charset="-120"/>
+                        </a:rPr>
+                        <a:t>R$ 15,8 mi</a:t>
+                      </a:r>
+                      <a:endParaRPr lang="en-US" sz="615" dirty="0">
+                        <a:latin typeface="Calibri" charset="0"/>
+                        <a:ea typeface="Calibri" charset="0"/>
+                        <a:cs typeface="Calibri" charset="0"/>
+                      </a:endParaRPr>
+                    </a:p>
+                  </a:txBody>
+                  <a:tcPr marL="36576" marR="36576" marT="18288" marB="18288" anchor="mid">
+                    <a:lnL w="5715" cap="flat" cmpd="sng" algn="ctr">
+                      <a:solidFill>
+                        <a:srgbClr val="FFFFFF"/>
+                      </a:solidFill>
+                      <a:prstDash val="solid"/>
+                      <a:round/>
+                      <a:headEnd type="none" w="med" len="med"/>
+                      <a:tailEnd type="none" w="med" len="med"/>
+                    </a:lnL>
+                    <a:lnR w="5715" cap="flat" cmpd="sng" algn="ctr">
+                      <a:solidFill>
+                        <a:srgbClr val="FFFFFF"/>
+                      </a:solidFill>
+                      <a:prstDash val="solid"/>
+                      <a:round/>
+                      <a:headEnd type="none" w="med" len="med"/>
+                      <a:tailEnd type="none" w="med" len="med"/>
+                    </a:lnR>
+                    <a:lnT w="5715" cap="flat" cmpd="sng" algn="ctr">
+                      <a:solidFill>
+                        <a:srgbClr val="FFFFFF"/>
+                      </a:solidFill>
+                      <a:prstDash val="solid"/>
+                      <a:round/>
+                      <a:headEnd type="none" w="med" len="med"/>
+                      <a:tailEnd type="none" w="med" len="med"/>
+                    </a:lnT>
+                    <a:lnB w="5715" cap="flat" cmpd="sng" algn="ctr">
+                      <a:solidFill>
+                        <a:srgbClr val="FFFFFF"/>
+                      </a:solidFill>
+                      <a:prstDash val="solid"/>
+                      <a:round/>
+                      <a:headEnd type="none" w="med" len="med"/>
+                      <a:tailEnd type="none" w="med" len="med"/>
+                    </a:lnB>
+                    <a:solidFill>
+                      <a:srgbClr val="FFFFFF"/>
+                    </a:solidFill>
+                  </a:tcPr>
+                </a:tc>
+                <a:tc>
+                  <a:txBody>
+                    <a:bodyPr/>
+                    <a:lstStyle/>
+                    <a:p>
+                      <a:pPr algn="ctr" indent="0" marL="0">
+                        <a:buNone/>
+                      </a:pPr>
+                      <a:r>
+                        <a:rPr lang="en-US" sz="615" dirty="0">
+                          <a:solidFill>
+                            <a:srgbClr val="1F1F1F"/>
+                          </a:solidFill>
+                          <a:latin typeface="Calibri" pitchFamily="34" charset="0"/>
+                          <a:ea typeface="Calibri" pitchFamily="34" charset="-122"/>
+                          <a:cs typeface="Calibri" pitchFamily="34" charset="-120"/>
+                        </a:rPr>
+                        <a:t>R$ 107,9 mi</a:t>
+                      </a:r>
+                      <a:endParaRPr lang="en-US" sz="615" dirty="0">
+                        <a:latin typeface="Calibri" charset="0"/>
+                        <a:ea typeface="Calibri" charset="0"/>
+                        <a:cs typeface="Calibri" charset="0"/>
+                      </a:endParaRPr>
+                    </a:p>
+                  </a:txBody>
+                  <a:tcPr marL="36576" marR="36576" marT="18288" marB="18288" anchor="mid">
+                    <a:lnL w="5715" cap="flat" cmpd="sng" algn="ctr">
+                      <a:solidFill>
+                        <a:srgbClr val="FFFFFF"/>
+                      </a:solidFill>
+                      <a:prstDash val="solid"/>
+                      <a:round/>
+                      <a:headEnd type="none" w="med" len="med"/>
+                      <a:tailEnd type="none" w="med" len="med"/>
+                    </a:lnL>
+                    <a:lnR w="5715" cap="flat" cmpd="sng" algn="ctr">
+                      <a:solidFill>
+                        <a:srgbClr val="FFFFFF"/>
+                      </a:solidFill>
+                      <a:prstDash val="solid"/>
+                      <a:round/>
+                      <a:headEnd type="none" w="med" len="med"/>
+                      <a:tailEnd type="none" w="med" len="med"/>
+                    </a:lnR>
+                    <a:lnT w="5715" cap="flat" cmpd="sng" algn="ctr">
+                      <a:solidFill>
+                        <a:srgbClr val="FFFFFF"/>
+                      </a:solidFill>
+                      <a:prstDash val="solid"/>
+                      <a:round/>
+                      <a:headEnd type="none" w="med" len="med"/>
+                      <a:tailEnd type="none" w="med" len="med"/>
+                    </a:lnT>
+                    <a:lnB w="5715" cap="flat" cmpd="sng" algn="ctr">
+                      <a:solidFill>
+                        <a:srgbClr val="FFFFFF"/>
+                      </a:solidFill>
+                      <a:prstDash val="solid"/>
+                      <a:round/>
+                      <a:headEnd type="none" w="med" len="med"/>
+                      <a:tailEnd type="none" w="med" len="med"/>
+                    </a:lnB>
+                    <a:solidFill>
+                      <a:srgbClr val="FFFFFF"/>
+                    </a:solidFill>
+                  </a:tcPr>
+                </a:tc>
+                <a:tc>
+                  <a:txBody>
+                    <a:bodyPr/>
+                    <a:lstStyle/>
+                    <a:p>
+                      <a:pPr algn="ctr" indent="0" marL="0">
+                        <a:buNone/>
+                      </a:pPr>
+                      <a:r>
+                        <a:rPr lang="en-US" sz="615" dirty="0">
+                          <a:solidFill>
+                            <a:srgbClr val="1F1F1F"/>
+                          </a:solidFill>
+                          <a:latin typeface="Calibri" pitchFamily="34" charset="0"/>
+                          <a:ea typeface="Calibri" pitchFamily="34" charset="-122"/>
+                          <a:cs typeface="Calibri" pitchFamily="34" charset="-120"/>
+                        </a:rPr>
+                        <a:t>R$ 104,1 mi</a:t>
                       </a:r>
                       <a:endParaRPr lang="en-US" sz="615" dirty="0">
                         <a:latin typeface="Calibri" charset="0"/>
@@ -12660,211 +12864,7 @@
                           <a:ea typeface="Calibri" pitchFamily="34" charset="-122"/>
                           <a:cs typeface="Calibri" pitchFamily="34" charset="-120"/>
                         </a:rPr>
-                        <a:t>R$ 0,00</a:t>
-                      </a:r>
-                      <a:endParaRPr lang="en-US" sz="615" dirty="0">
-                        <a:latin typeface="Calibri" charset="0"/>
-                        <a:ea typeface="Calibri" charset="0"/>
-                        <a:cs typeface="Calibri" charset="0"/>
-                      </a:endParaRPr>
-                    </a:p>
-                  </a:txBody>
-                  <a:tcPr marL="36576" marR="36576" marT="18288" marB="18288" anchor="mid">
-                    <a:lnL w="5715" cap="flat" cmpd="sng" algn="ctr">
-                      <a:solidFill>
-                        <a:srgbClr val="FFFFFF"/>
-                      </a:solidFill>
-                      <a:prstDash val="solid"/>
-                      <a:round/>
-                      <a:headEnd type="none" w="med" len="med"/>
-                      <a:tailEnd type="none" w="med" len="med"/>
-                    </a:lnL>
-                    <a:lnR w="5715" cap="flat" cmpd="sng" algn="ctr">
-                      <a:solidFill>
-                        <a:srgbClr val="FFFFFF"/>
-                      </a:solidFill>
-                      <a:prstDash val="solid"/>
-                      <a:round/>
-                      <a:headEnd type="none" w="med" len="med"/>
-                      <a:tailEnd type="none" w="med" len="med"/>
-                    </a:lnR>
-                    <a:lnT w="5715" cap="flat" cmpd="sng" algn="ctr">
-                      <a:solidFill>
-                        <a:srgbClr val="FFFFFF"/>
-                      </a:solidFill>
-                      <a:prstDash val="solid"/>
-                      <a:round/>
-                      <a:headEnd type="none" w="med" len="med"/>
-                      <a:tailEnd type="none" w="med" len="med"/>
-                    </a:lnT>
-                    <a:lnB w="5715" cap="flat" cmpd="sng" algn="ctr">
-                      <a:solidFill>
-                        <a:srgbClr val="FFFFFF"/>
-                      </a:solidFill>
-                      <a:prstDash val="solid"/>
-                      <a:round/>
-                      <a:headEnd type="none" w="med" len="med"/>
-                      <a:tailEnd type="none" w="med" len="med"/>
-                    </a:lnB>
-                    <a:solidFill>
-                      <a:srgbClr val="FFFFFF"/>
-                    </a:solidFill>
-                  </a:tcPr>
-                </a:tc>
-                <a:tc>
-                  <a:txBody>
-                    <a:bodyPr/>
-                    <a:lstStyle/>
-                    <a:p>
-                      <a:pPr algn="ctr" indent="0" marL="0">
-                        <a:buNone/>
-                      </a:pPr>
-                      <a:r>
-                        <a:rPr lang="en-US" sz="615" dirty="0">
-                          <a:solidFill>
-                            <a:srgbClr val="1F1F1F"/>
-                          </a:solidFill>
-                          <a:latin typeface="Calibri" pitchFamily="34" charset="0"/>
-                          <a:ea typeface="Calibri" pitchFamily="34" charset="-122"/>
-                          <a:cs typeface="Calibri" pitchFamily="34" charset="-120"/>
-                        </a:rPr>
-                        <a:t>R$ 142,9 mi</a:t>
-                      </a:r>
-                      <a:endParaRPr lang="en-US" sz="615" dirty="0">
-                        <a:latin typeface="Calibri" charset="0"/>
-                        <a:ea typeface="Calibri" charset="0"/>
-                        <a:cs typeface="Calibri" charset="0"/>
-                      </a:endParaRPr>
-                    </a:p>
-                  </a:txBody>
-                  <a:tcPr marL="36576" marR="36576" marT="18288" marB="18288" anchor="mid">
-                    <a:lnL w="5715" cap="flat" cmpd="sng" algn="ctr">
-                      <a:solidFill>
-                        <a:srgbClr val="FFFFFF"/>
-                      </a:solidFill>
-                      <a:prstDash val="solid"/>
-                      <a:round/>
-                      <a:headEnd type="none" w="med" len="med"/>
-                      <a:tailEnd type="none" w="med" len="med"/>
-                    </a:lnL>
-                    <a:lnR w="5715" cap="flat" cmpd="sng" algn="ctr">
-                      <a:solidFill>
-                        <a:srgbClr val="FFFFFF"/>
-                      </a:solidFill>
-                      <a:prstDash val="solid"/>
-                      <a:round/>
-                      <a:headEnd type="none" w="med" len="med"/>
-                      <a:tailEnd type="none" w="med" len="med"/>
-                    </a:lnR>
-                    <a:lnT w="5715" cap="flat" cmpd="sng" algn="ctr">
-                      <a:solidFill>
-                        <a:srgbClr val="FFFFFF"/>
-                      </a:solidFill>
-                      <a:prstDash val="solid"/>
-                      <a:round/>
-                      <a:headEnd type="none" w="med" len="med"/>
-                      <a:tailEnd type="none" w="med" len="med"/>
-                    </a:lnT>
-                    <a:lnB w="5715" cap="flat" cmpd="sng" algn="ctr">
-                      <a:solidFill>
-                        <a:srgbClr val="FFFFFF"/>
-                      </a:solidFill>
-                      <a:prstDash val="solid"/>
-                      <a:round/>
-                      <a:headEnd type="none" w="med" len="med"/>
-                      <a:tailEnd type="none" w="med" len="med"/>
-                    </a:lnB>
-                    <a:solidFill>
-                      <a:srgbClr val="FFFFFF"/>
-                    </a:solidFill>
-                  </a:tcPr>
-                </a:tc>
-                <a:tc>
-                  <a:txBody>
-                    <a:bodyPr/>
-                    <a:lstStyle/>
-                    <a:p>
-                      <a:pPr algn="ctr" indent="0" marL="0">
-                        <a:buNone/>
-                      </a:pPr>
-                      <a:r>
-                        <a:rPr lang="en-US" sz="615" dirty="0">
-                          <a:solidFill>
-                            <a:srgbClr val="1F1F1F"/>
-                          </a:solidFill>
-                          <a:latin typeface="Calibri" pitchFamily="34" charset="0"/>
-                          <a:ea typeface="Calibri" pitchFamily="34" charset="-122"/>
-                          <a:cs typeface="Calibri" pitchFamily="34" charset="-120"/>
-                        </a:rPr>
-                        <a:t>R$ 15,4 mi</a:t>
-                      </a:r>
-                      <a:endParaRPr lang="en-US" sz="615" dirty="0">
-                        <a:latin typeface="Calibri" charset="0"/>
-                        <a:ea typeface="Calibri" charset="0"/>
-                        <a:cs typeface="Calibri" charset="0"/>
-                      </a:endParaRPr>
-                    </a:p>
-                  </a:txBody>
-                  <a:tcPr marL="36576" marR="36576" marT="18288" marB="18288" anchor="mid">
-                    <a:lnL w="5715" cap="flat" cmpd="sng" algn="ctr">
-                      <a:solidFill>
-                        <a:srgbClr val="FFFFFF"/>
-                      </a:solidFill>
-                      <a:prstDash val="solid"/>
-                      <a:round/>
-                      <a:headEnd type="none" w="med" len="med"/>
-                      <a:tailEnd type="none" w="med" len="med"/>
-                    </a:lnL>
-                    <a:lnR w="5715" cap="flat" cmpd="sng" algn="ctr">
-                      <a:solidFill>
-                        <a:srgbClr val="FFFFFF"/>
-                      </a:solidFill>
-                      <a:prstDash val="solid"/>
-                      <a:round/>
-                      <a:headEnd type="none" w="med" len="med"/>
-                      <a:tailEnd type="none" w="med" len="med"/>
-                    </a:lnR>
-                    <a:lnT w="5715" cap="flat" cmpd="sng" algn="ctr">
-                      <a:solidFill>
-                        <a:srgbClr val="FFFFFF"/>
-                      </a:solidFill>
-                      <a:prstDash val="solid"/>
-                      <a:round/>
-                      <a:headEnd type="none" w="med" len="med"/>
-                      <a:tailEnd type="none" w="med" len="med"/>
-                    </a:lnT>
-                    <a:lnB w="5715" cap="flat" cmpd="sng" algn="ctr">
-                      <a:solidFill>
-                        <a:srgbClr val="FFFFFF"/>
-                      </a:solidFill>
-                      <a:prstDash val="solid"/>
-                      <a:round/>
-                      <a:headEnd type="none" w="med" len="med"/>
-                      <a:tailEnd type="none" w="med" len="med"/>
-                    </a:lnB>
-                    <a:solidFill>
-                      <a:srgbClr val="FFFFFF"/>
-                    </a:solidFill>
-                  </a:tcPr>
-                </a:tc>
-                <a:tc>
-                  <a:txBody>
-                    <a:bodyPr/>
-                    <a:lstStyle/>
-                    <a:p>
-                      <a:pPr algn="ctr" indent="0" marL="0">
-                        <a:buNone/>
-                      </a:pPr>
-                      <a:r>
-                        <a:rPr lang="en-US" sz="615" dirty="0">
-                          <a:solidFill>
-                            <a:srgbClr val="1F1F1F"/>
-                          </a:solidFill>
-                          <a:latin typeface="Calibri" pitchFamily="34" charset="0"/>
-                          <a:ea typeface="Calibri" pitchFamily="34" charset="-122"/>
-                          <a:cs typeface="Calibri" pitchFamily="34" charset="-120"/>
-                        </a:rPr>
-                        <a:t>30,00%</a:t>
+                        <a:t>48,89%</a:t>
                       </a:r>
                       <a:endParaRPr lang="en-US" sz="615" dirty="0">
                         <a:latin typeface="Calibri" charset="0"/>
@@ -13002,7 +13002,7 @@
                           <a:ea typeface="Calibri" pitchFamily="34" charset="-122"/>
                           <a:cs typeface="Calibri" pitchFamily="34" charset="-120"/>
                         </a:rPr>
-                        <a:t>R$ 142,9 mi</a:t>
+                        <a:t>R$ 89,7 mi</a:t>
                       </a:r>
                       <a:endParaRPr lang="en-US" sz="615" dirty="0">
                         <a:latin typeface="Calibri" charset="0"/>
@@ -13070,7 +13070,143 @@
                           <a:ea typeface="Calibri" pitchFamily="34" charset="-122"/>
                           <a:cs typeface="Calibri" pitchFamily="34" charset="-120"/>
                         </a:rPr>
-                        <a:t>R$ 4,5 mi</a:t>
+                        <a:t>R$ 16 mi</a:t>
+                      </a:r>
+                      <a:endParaRPr lang="en-US" sz="615" dirty="0">
+                        <a:latin typeface="Calibri" charset="0"/>
+                        <a:ea typeface="Calibri" charset="0"/>
+                        <a:cs typeface="Calibri" charset="0"/>
+                      </a:endParaRPr>
+                    </a:p>
+                  </a:txBody>
+                  <a:tcPr marL="36576" marR="36576" marT="18288" marB="18288" anchor="mid">
+                    <a:lnL w="5715" cap="flat" cmpd="sng" algn="ctr">
+                      <a:solidFill>
+                        <a:srgbClr val="FFFFFF"/>
+                      </a:solidFill>
+                      <a:prstDash val="solid"/>
+                      <a:round/>
+                      <a:headEnd type="none" w="med" len="med"/>
+                      <a:tailEnd type="none" w="med" len="med"/>
+                    </a:lnL>
+                    <a:lnR w="5715" cap="flat" cmpd="sng" algn="ctr">
+                      <a:solidFill>
+                        <a:srgbClr val="FFFFFF"/>
+                      </a:solidFill>
+                      <a:prstDash val="solid"/>
+                      <a:round/>
+                      <a:headEnd type="none" w="med" len="med"/>
+                      <a:tailEnd type="none" w="med" len="med"/>
+                    </a:lnR>
+                    <a:lnT w="5715" cap="flat" cmpd="sng" algn="ctr">
+                      <a:solidFill>
+                        <a:srgbClr val="FFFFFF"/>
+                      </a:solidFill>
+                      <a:prstDash val="solid"/>
+                      <a:round/>
+                      <a:headEnd type="none" w="med" len="med"/>
+                      <a:tailEnd type="none" w="med" len="med"/>
+                    </a:lnT>
+                    <a:lnB w="5715" cap="flat" cmpd="sng" algn="ctr">
+                      <a:solidFill>
+                        <a:srgbClr val="FFFFFF"/>
+                      </a:solidFill>
+                      <a:prstDash val="solid"/>
+                      <a:round/>
+                      <a:headEnd type="none" w="med" len="med"/>
+                      <a:tailEnd type="none" w="med" len="med"/>
+                    </a:lnB>
+                    <a:solidFill>
+                      <a:srgbClr val="F1F1F1"/>
+                    </a:solidFill>
+                  </a:tcPr>
+                </a:tc>
+                <a:tc>
+                  <a:txBody>
+                    <a:bodyPr/>
+                    <a:lstStyle/>
+                    <a:p>
+                      <a:pPr algn="ctr" indent="0" marL="0">
+                        <a:buNone/>
+                      </a:pPr>
+                      <a:r>
+                        <a:rPr lang="en-US" sz="615" dirty="0">
+                          <a:solidFill>
+                            <a:srgbClr val="1F1F1F"/>
+                          </a:solidFill>
+                          <a:latin typeface="Calibri" pitchFamily="34" charset="0"/>
+                          <a:ea typeface="Calibri" pitchFamily="34" charset="-122"/>
+                          <a:cs typeface="Calibri" pitchFamily="34" charset="-120"/>
+                        </a:rPr>
+                        <a:t>R$ 74,5 mi</a:t>
+                      </a:r>
+                      <a:endParaRPr lang="en-US" sz="615" dirty="0">
+                        <a:latin typeface="Calibri" charset="0"/>
+                        <a:ea typeface="Calibri" charset="0"/>
+                        <a:cs typeface="Calibri" charset="0"/>
+                      </a:endParaRPr>
+                    </a:p>
+                  </a:txBody>
+                  <a:tcPr marL="36576" marR="36576" marT="18288" marB="18288" anchor="mid">
+                    <a:lnL w="5715" cap="flat" cmpd="sng" algn="ctr">
+                      <a:solidFill>
+                        <a:srgbClr val="FFFFFF"/>
+                      </a:solidFill>
+                      <a:prstDash val="solid"/>
+                      <a:round/>
+                      <a:headEnd type="none" w="med" len="med"/>
+                      <a:tailEnd type="none" w="med" len="med"/>
+                    </a:lnL>
+                    <a:lnR w="5715" cap="flat" cmpd="sng" algn="ctr">
+                      <a:solidFill>
+                        <a:srgbClr val="FFFFFF"/>
+                      </a:solidFill>
+                      <a:prstDash val="solid"/>
+                      <a:round/>
+                      <a:headEnd type="none" w="med" len="med"/>
+                      <a:tailEnd type="none" w="med" len="med"/>
+                    </a:lnR>
+                    <a:lnT w="5715" cap="flat" cmpd="sng" algn="ctr">
+                      <a:solidFill>
+                        <a:srgbClr val="FFFFFF"/>
+                      </a:solidFill>
+                      <a:prstDash val="solid"/>
+                      <a:round/>
+                      <a:headEnd type="none" w="med" len="med"/>
+                      <a:tailEnd type="none" w="med" len="med"/>
+                    </a:lnT>
+                    <a:lnB w="5715" cap="flat" cmpd="sng" algn="ctr">
+                      <a:solidFill>
+                        <a:srgbClr val="FFFFFF"/>
+                      </a:solidFill>
+                      <a:prstDash val="solid"/>
+                      <a:round/>
+                      <a:headEnd type="none" w="med" len="med"/>
+                      <a:tailEnd type="none" w="med" len="med"/>
+                    </a:lnB>
+                    <a:solidFill>
+                      <a:srgbClr val="F1F1F1"/>
+                    </a:solidFill>
+                  </a:tcPr>
+                </a:tc>
+                <a:tc>
+                  <a:txBody>
+                    <a:bodyPr/>
+                    <a:lstStyle/>
+                    <a:p>
+                      <a:pPr algn="ctr" indent="0" marL="0">
+                        <a:buNone/>
+                      </a:pPr>
+                      <a:r>
+                        <a:rPr lang="en-US" sz="615" dirty="0">
+                          <a:solidFill>
+                            <a:srgbClr val="1F1F1F"/>
+                          </a:solidFill>
+                          <a:latin typeface="Calibri" pitchFamily="34" charset="0"/>
+                          <a:ea typeface="Calibri" pitchFamily="34" charset="-122"/>
+                          <a:cs typeface="Calibri" pitchFamily="34" charset="-120"/>
+                        </a:rPr>
+                        <a:t>R$ 105,7 mi</a:t>
                       </a:r>
                       <a:endParaRPr lang="en-US" sz="615" dirty="0">
                         <a:latin typeface="Calibri" charset="0"/>
@@ -13206,143 +13342,7 @@
                           <a:ea typeface="Calibri" pitchFamily="34" charset="-122"/>
                           <a:cs typeface="Calibri" pitchFamily="34" charset="-120"/>
                         </a:rPr>
-                        <a:t>R$ 147,4 mi</a:t>
-                      </a:r>
-                      <a:endParaRPr lang="en-US" sz="615" dirty="0">
-                        <a:latin typeface="Calibri" charset="0"/>
-                        <a:ea typeface="Calibri" charset="0"/>
-                        <a:cs typeface="Calibri" charset="0"/>
-                      </a:endParaRPr>
-                    </a:p>
-                  </a:txBody>
-                  <a:tcPr marL="36576" marR="36576" marT="18288" marB="18288" anchor="mid">
-                    <a:lnL w="5715" cap="flat" cmpd="sng" algn="ctr">
-                      <a:solidFill>
-                        <a:srgbClr val="FFFFFF"/>
-                      </a:solidFill>
-                      <a:prstDash val="solid"/>
-                      <a:round/>
-                      <a:headEnd type="none" w="med" len="med"/>
-                      <a:tailEnd type="none" w="med" len="med"/>
-                    </a:lnL>
-                    <a:lnR w="5715" cap="flat" cmpd="sng" algn="ctr">
-                      <a:solidFill>
-                        <a:srgbClr val="FFFFFF"/>
-                      </a:solidFill>
-                      <a:prstDash val="solid"/>
-                      <a:round/>
-                      <a:headEnd type="none" w="med" len="med"/>
-                      <a:tailEnd type="none" w="med" len="med"/>
-                    </a:lnR>
-                    <a:lnT w="5715" cap="flat" cmpd="sng" algn="ctr">
-                      <a:solidFill>
-                        <a:srgbClr val="FFFFFF"/>
-                      </a:solidFill>
-                      <a:prstDash val="solid"/>
-                      <a:round/>
-                      <a:headEnd type="none" w="med" len="med"/>
-                      <a:tailEnd type="none" w="med" len="med"/>
-                    </a:lnT>
-                    <a:lnB w="5715" cap="flat" cmpd="sng" algn="ctr">
-                      <a:solidFill>
-                        <a:srgbClr val="FFFFFF"/>
-                      </a:solidFill>
-                      <a:prstDash val="solid"/>
-                      <a:round/>
-                      <a:headEnd type="none" w="med" len="med"/>
-                      <a:tailEnd type="none" w="med" len="med"/>
-                    </a:lnB>
-                    <a:solidFill>
-                      <a:srgbClr val="F1F1F1"/>
-                    </a:solidFill>
-                  </a:tcPr>
-                </a:tc>
-                <a:tc>
-                  <a:txBody>
-                    <a:bodyPr/>
-                    <a:lstStyle/>
-                    <a:p>
-                      <a:pPr algn="ctr" indent="0" marL="0">
-                        <a:buNone/>
-                      </a:pPr>
-                      <a:r>
-                        <a:rPr lang="en-US" sz="615" dirty="0">
-                          <a:solidFill>
-                            <a:srgbClr val="1F1F1F"/>
-                          </a:solidFill>
-                          <a:latin typeface="Calibri" pitchFamily="34" charset="0"/>
-                          <a:ea typeface="Calibri" pitchFamily="34" charset="-122"/>
-                          <a:cs typeface="Calibri" pitchFamily="34" charset="-120"/>
-                        </a:rPr>
-                        <a:t>R$ 0,00</a:t>
-                      </a:r>
-                      <a:endParaRPr lang="en-US" sz="615" dirty="0">
-                        <a:latin typeface="Calibri" charset="0"/>
-                        <a:ea typeface="Calibri" charset="0"/>
-                        <a:cs typeface="Calibri" charset="0"/>
-                      </a:endParaRPr>
-                    </a:p>
-                  </a:txBody>
-                  <a:tcPr marL="36576" marR="36576" marT="18288" marB="18288" anchor="mid">
-                    <a:lnL w="5715" cap="flat" cmpd="sng" algn="ctr">
-                      <a:solidFill>
-                        <a:srgbClr val="FFFFFF"/>
-                      </a:solidFill>
-                      <a:prstDash val="solid"/>
-                      <a:round/>
-                      <a:headEnd type="none" w="med" len="med"/>
-                      <a:tailEnd type="none" w="med" len="med"/>
-                    </a:lnL>
-                    <a:lnR w="5715" cap="flat" cmpd="sng" algn="ctr">
-                      <a:solidFill>
-                        <a:srgbClr val="FFFFFF"/>
-                      </a:solidFill>
-                      <a:prstDash val="solid"/>
-                      <a:round/>
-                      <a:headEnd type="none" w="med" len="med"/>
-                      <a:tailEnd type="none" w="med" len="med"/>
-                    </a:lnR>
-                    <a:lnT w="5715" cap="flat" cmpd="sng" algn="ctr">
-                      <a:solidFill>
-                        <a:srgbClr val="FFFFFF"/>
-                      </a:solidFill>
-                      <a:prstDash val="solid"/>
-                      <a:round/>
-                      <a:headEnd type="none" w="med" len="med"/>
-                      <a:tailEnd type="none" w="med" len="med"/>
-                    </a:lnT>
-                    <a:lnB w="5715" cap="flat" cmpd="sng" algn="ctr">
-                      <a:solidFill>
-                        <a:srgbClr val="FFFFFF"/>
-                      </a:solidFill>
-                      <a:prstDash val="solid"/>
-                      <a:round/>
-                      <a:headEnd type="none" w="med" len="med"/>
-                      <a:tailEnd type="none" w="med" len="med"/>
-                    </a:lnB>
-                    <a:solidFill>
-                      <a:srgbClr val="F1F1F1"/>
-                    </a:solidFill>
-                  </a:tcPr>
-                </a:tc>
-                <a:tc>
-                  <a:txBody>
-                    <a:bodyPr/>
-                    <a:lstStyle/>
-                    <a:p>
-                      <a:pPr algn="ctr" indent="0" marL="0">
-                        <a:buNone/>
-                      </a:pPr>
-                      <a:r>
-                        <a:rPr lang="en-US" sz="615" dirty="0">
-                          <a:solidFill>
-                            <a:srgbClr val="1F1F1F"/>
-                          </a:solidFill>
-                          <a:latin typeface="Calibri" pitchFamily="34" charset="0"/>
-                          <a:ea typeface="Calibri" pitchFamily="34" charset="-122"/>
-                          <a:cs typeface="Calibri" pitchFamily="34" charset="-120"/>
-                        </a:rPr>
-                        <a:t>30,31%</a:t>
+                        <a:t>52,06%</a:t>
                       </a:r>
                       <a:endParaRPr lang="en-US" sz="615" dirty="0">
                         <a:latin typeface="Calibri" charset="0"/>
@@ -13480,7 +13480,7 @@
                           <a:ea typeface="Calibri" pitchFamily="34" charset="-122"/>
                           <a:cs typeface="Calibri" pitchFamily="34" charset="-120"/>
                         </a:rPr>
-                        <a:t>R$ 124,5 mi</a:t>
+                        <a:t>R$ 91,1 mi</a:t>
                       </a:r>
                       <a:endParaRPr lang="en-US" sz="615" dirty="0">
                         <a:latin typeface="Calibri" charset="0"/>
@@ -13548,7 +13548,143 @@
                           <a:ea typeface="Calibri" pitchFamily="34" charset="-122"/>
                           <a:cs typeface="Calibri" pitchFamily="34" charset="-120"/>
                         </a:rPr>
-                        <a:t>R$ 2,6 mi</a:t>
+                        <a:t>R$ 16,3 mi</a:t>
+                      </a:r>
+                      <a:endParaRPr lang="en-US" sz="615" dirty="0">
+                        <a:latin typeface="Calibri" charset="0"/>
+                        <a:ea typeface="Calibri" charset="0"/>
+                        <a:cs typeface="Calibri" charset="0"/>
+                      </a:endParaRPr>
+                    </a:p>
+                  </a:txBody>
+                  <a:tcPr marL="36576" marR="36576" marT="18288" marB="18288" anchor="mid">
+                    <a:lnL w="5715" cap="flat" cmpd="sng" algn="ctr">
+                      <a:solidFill>
+                        <a:srgbClr val="FFFFFF"/>
+                      </a:solidFill>
+                      <a:prstDash val="solid"/>
+                      <a:round/>
+                      <a:headEnd type="none" w="med" len="med"/>
+                      <a:tailEnd type="none" w="med" len="med"/>
+                    </a:lnL>
+                    <a:lnR w="5715" cap="flat" cmpd="sng" algn="ctr">
+                      <a:solidFill>
+                        <a:srgbClr val="FFFFFF"/>
+                      </a:solidFill>
+                      <a:prstDash val="solid"/>
+                      <a:round/>
+                      <a:headEnd type="none" w="med" len="med"/>
+                      <a:tailEnd type="none" w="med" len="med"/>
+                    </a:lnR>
+                    <a:lnT w="5715" cap="flat" cmpd="sng" algn="ctr">
+                      <a:solidFill>
+                        <a:srgbClr val="FFFFFF"/>
+                      </a:solidFill>
+                      <a:prstDash val="solid"/>
+                      <a:round/>
+                      <a:headEnd type="none" w="med" len="med"/>
+                      <a:tailEnd type="none" w="med" len="med"/>
+                    </a:lnT>
+                    <a:lnB w="5715" cap="flat" cmpd="sng" algn="ctr">
+                      <a:solidFill>
+                        <a:srgbClr val="FFFFFF"/>
+                      </a:solidFill>
+                      <a:prstDash val="solid"/>
+                      <a:round/>
+                      <a:headEnd type="none" w="med" len="med"/>
+                      <a:tailEnd type="none" w="med" len="med"/>
+                    </a:lnB>
+                    <a:solidFill>
+                      <a:srgbClr val="FFFFFF"/>
+                    </a:solidFill>
+                  </a:tcPr>
+                </a:tc>
+                <a:tc>
+                  <a:txBody>
+                    <a:bodyPr/>
+                    <a:lstStyle/>
+                    <a:p>
+                      <a:pPr algn="ctr" indent="0" marL="0">
+                        <a:buNone/>
+                      </a:pPr>
+                      <a:r>
+                        <a:rPr lang="en-US" sz="615" dirty="0">
+                          <a:solidFill>
+                            <a:srgbClr val="1F1F1F"/>
+                          </a:solidFill>
+                          <a:latin typeface="Calibri" pitchFamily="34" charset="0"/>
+                          <a:ea typeface="Calibri" pitchFamily="34" charset="-122"/>
+                          <a:cs typeface="Calibri" pitchFamily="34" charset="-120"/>
+                        </a:rPr>
+                        <a:t>R$ 76,4 mi</a:t>
+                      </a:r>
+                      <a:endParaRPr lang="en-US" sz="615" dirty="0">
+                        <a:latin typeface="Calibri" charset="0"/>
+                        <a:ea typeface="Calibri" charset="0"/>
+                        <a:cs typeface="Calibri" charset="0"/>
+                      </a:endParaRPr>
+                    </a:p>
+                  </a:txBody>
+                  <a:tcPr marL="36576" marR="36576" marT="18288" marB="18288" anchor="mid">
+                    <a:lnL w="5715" cap="flat" cmpd="sng" algn="ctr">
+                      <a:solidFill>
+                        <a:srgbClr val="FFFFFF"/>
+                      </a:solidFill>
+                      <a:prstDash val="solid"/>
+                      <a:round/>
+                      <a:headEnd type="none" w="med" len="med"/>
+                      <a:tailEnd type="none" w="med" len="med"/>
+                    </a:lnL>
+                    <a:lnR w="5715" cap="flat" cmpd="sng" algn="ctr">
+                      <a:solidFill>
+                        <a:srgbClr val="FFFFFF"/>
+                      </a:solidFill>
+                      <a:prstDash val="solid"/>
+                      <a:round/>
+                      <a:headEnd type="none" w="med" len="med"/>
+                      <a:tailEnd type="none" w="med" len="med"/>
+                    </a:lnR>
+                    <a:lnT w="5715" cap="flat" cmpd="sng" algn="ctr">
+                      <a:solidFill>
+                        <a:srgbClr val="FFFFFF"/>
+                      </a:solidFill>
+                      <a:prstDash val="solid"/>
+                      <a:round/>
+                      <a:headEnd type="none" w="med" len="med"/>
+                      <a:tailEnd type="none" w="med" len="med"/>
+                    </a:lnT>
+                    <a:lnB w="5715" cap="flat" cmpd="sng" algn="ctr">
+                      <a:solidFill>
+                        <a:srgbClr val="FFFFFF"/>
+                      </a:solidFill>
+                      <a:prstDash val="solid"/>
+                      <a:round/>
+                      <a:headEnd type="none" w="med" len="med"/>
+                      <a:tailEnd type="none" w="med" len="med"/>
+                    </a:lnB>
+                    <a:solidFill>
+                      <a:srgbClr val="FFFFFF"/>
+                    </a:solidFill>
+                  </a:tcPr>
+                </a:tc>
+                <a:tc>
+                  <a:txBody>
+                    <a:bodyPr/>
+                    <a:lstStyle/>
+                    <a:p>
+                      <a:pPr algn="ctr" indent="0" marL="0">
+                        <a:buNone/>
+                      </a:pPr>
+                      <a:r>
+                        <a:rPr lang="en-US" sz="615" dirty="0">
+                          <a:solidFill>
+                            <a:srgbClr val="1F1F1F"/>
+                          </a:solidFill>
+                          <a:latin typeface="Calibri" pitchFamily="34" charset="0"/>
+                          <a:ea typeface="Calibri" pitchFamily="34" charset="-122"/>
+                          <a:cs typeface="Calibri" pitchFamily="34" charset="-120"/>
+                        </a:rPr>
+                        <a:t>R$ 107,4 mi</a:t>
                       </a:r>
                       <a:endParaRPr lang="en-US" sz="615" dirty="0">
                         <a:latin typeface="Calibri" charset="0"/>
@@ -13684,143 +13820,7 @@
                           <a:ea typeface="Calibri" pitchFamily="34" charset="-122"/>
                           <a:cs typeface="Calibri" pitchFamily="34" charset="-120"/>
                         </a:rPr>
-                        <a:t>R$ 127,1 mi</a:t>
-                      </a:r>
-                      <a:endParaRPr lang="en-US" sz="615" dirty="0">
-                        <a:latin typeface="Calibri" charset="0"/>
-                        <a:ea typeface="Calibri" charset="0"/>
-                        <a:cs typeface="Calibri" charset="0"/>
-                      </a:endParaRPr>
-                    </a:p>
-                  </a:txBody>
-                  <a:tcPr marL="36576" marR="36576" marT="18288" marB="18288" anchor="mid">
-                    <a:lnL w="5715" cap="flat" cmpd="sng" algn="ctr">
-                      <a:solidFill>
-                        <a:srgbClr val="FFFFFF"/>
-                      </a:solidFill>
-                      <a:prstDash val="solid"/>
-                      <a:round/>
-                      <a:headEnd type="none" w="med" len="med"/>
-                      <a:tailEnd type="none" w="med" len="med"/>
-                    </a:lnL>
-                    <a:lnR w="5715" cap="flat" cmpd="sng" algn="ctr">
-                      <a:solidFill>
-                        <a:srgbClr val="FFFFFF"/>
-                      </a:solidFill>
-                      <a:prstDash val="solid"/>
-                      <a:round/>
-                      <a:headEnd type="none" w="med" len="med"/>
-                      <a:tailEnd type="none" w="med" len="med"/>
-                    </a:lnR>
-                    <a:lnT w="5715" cap="flat" cmpd="sng" algn="ctr">
-                      <a:solidFill>
-                        <a:srgbClr val="FFFFFF"/>
-                      </a:solidFill>
-                      <a:prstDash val="solid"/>
-                      <a:round/>
-                      <a:headEnd type="none" w="med" len="med"/>
-                      <a:tailEnd type="none" w="med" len="med"/>
-                    </a:lnT>
-                    <a:lnB w="5715" cap="flat" cmpd="sng" algn="ctr">
-                      <a:solidFill>
-                        <a:srgbClr val="FFFFFF"/>
-                      </a:solidFill>
-                      <a:prstDash val="solid"/>
-                      <a:round/>
-                      <a:headEnd type="none" w="med" len="med"/>
-                      <a:tailEnd type="none" w="med" len="med"/>
-                    </a:lnB>
-                    <a:solidFill>
-                      <a:srgbClr val="FFFFFF"/>
-                    </a:solidFill>
-                  </a:tcPr>
-                </a:tc>
-                <a:tc>
-                  <a:txBody>
-                    <a:bodyPr/>
-                    <a:lstStyle/>
-                    <a:p>
-                      <a:pPr algn="ctr" indent="0" marL="0">
-                        <a:buNone/>
-                      </a:pPr>
-                      <a:r>
-                        <a:rPr lang="en-US" sz="615" dirty="0">
-                          <a:solidFill>
-                            <a:srgbClr val="1F1F1F"/>
-                          </a:solidFill>
-                          <a:latin typeface="Calibri" pitchFamily="34" charset="0"/>
-                          <a:ea typeface="Calibri" pitchFamily="34" charset="-122"/>
-                          <a:cs typeface="Calibri" pitchFamily="34" charset="-120"/>
-                        </a:rPr>
-                        <a:t>R$ 0,00</a:t>
-                      </a:r>
-                      <a:endParaRPr lang="en-US" sz="615" dirty="0">
-                        <a:latin typeface="Calibri" charset="0"/>
-                        <a:ea typeface="Calibri" charset="0"/>
-                        <a:cs typeface="Calibri" charset="0"/>
-                      </a:endParaRPr>
-                    </a:p>
-                  </a:txBody>
-                  <a:tcPr marL="36576" marR="36576" marT="18288" marB="18288" anchor="mid">
-                    <a:lnL w="5715" cap="flat" cmpd="sng" algn="ctr">
-                      <a:solidFill>
-                        <a:srgbClr val="FFFFFF"/>
-                      </a:solidFill>
-                      <a:prstDash val="solid"/>
-                      <a:round/>
-                      <a:headEnd type="none" w="med" len="med"/>
-                      <a:tailEnd type="none" w="med" len="med"/>
-                    </a:lnL>
-                    <a:lnR w="5715" cap="flat" cmpd="sng" algn="ctr">
-                      <a:solidFill>
-                        <a:srgbClr val="FFFFFF"/>
-                      </a:solidFill>
-                      <a:prstDash val="solid"/>
-                      <a:round/>
-                      <a:headEnd type="none" w="med" len="med"/>
-                      <a:tailEnd type="none" w="med" len="med"/>
-                    </a:lnR>
-                    <a:lnT w="5715" cap="flat" cmpd="sng" algn="ctr">
-                      <a:solidFill>
-                        <a:srgbClr val="FFFFFF"/>
-                      </a:solidFill>
-                      <a:prstDash val="solid"/>
-                      <a:round/>
-                      <a:headEnd type="none" w="med" len="med"/>
-                      <a:tailEnd type="none" w="med" len="med"/>
-                    </a:lnT>
-                    <a:lnB w="5715" cap="flat" cmpd="sng" algn="ctr">
-                      <a:solidFill>
-                        <a:srgbClr val="FFFFFF"/>
-                      </a:solidFill>
-                      <a:prstDash val="solid"/>
-                      <a:round/>
-                      <a:headEnd type="none" w="med" len="med"/>
-                      <a:tailEnd type="none" w="med" len="med"/>
-                    </a:lnB>
-                    <a:solidFill>
-                      <a:srgbClr val="FFFFFF"/>
-                    </a:solidFill>
-                  </a:tcPr>
-                </a:tc>
-                <a:tc>
-                  <a:txBody>
-                    <a:bodyPr/>
-                    <a:lstStyle/>
-                    <a:p>
-                      <a:pPr algn="ctr" indent="0" marL="0">
-                        <a:buNone/>
-                      </a:pPr>
-                      <a:r>
-                        <a:rPr lang="en-US" sz="615" dirty="0">
-                          <a:solidFill>
-                            <a:srgbClr val="1F1F1F"/>
-                          </a:solidFill>
-                          <a:latin typeface="Calibri" pitchFamily="34" charset="0"/>
-                          <a:ea typeface="Calibri" pitchFamily="34" charset="-122"/>
-                          <a:cs typeface="Calibri" pitchFamily="34" charset="-120"/>
-                        </a:rPr>
-                        <a:t>30,50%</a:t>
+                        <a:t>54,92%</a:t>
                       </a:r>
                       <a:endParaRPr lang="en-US" sz="615" dirty="0">
                         <a:latin typeface="Calibri" charset="0"/>
@@ -13958,7 +13958,211 @@
                           <a:ea typeface="Calibri" pitchFamily="34" charset="-122"/>
                           <a:cs typeface="Calibri" pitchFamily="34" charset="-120"/>
                         </a:rPr>
-                        <a:t>R$ 105,8 mi</a:t>
+                        <a:t>R$ 92,5 mi</a:t>
+                      </a:r>
+                      <a:endParaRPr lang="en-US" sz="615" dirty="0">
+                        <a:latin typeface="Calibri" charset="0"/>
+                        <a:ea typeface="Calibri" charset="0"/>
+                        <a:cs typeface="Calibri" charset="0"/>
+                      </a:endParaRPr>
+                    </a:p>
+                  </a:txBody>
+                  <a:tcPr marL="36576" marR="36576" marT="18288" marB="18288" anchor="mid">
+                    <a:lnL w="5715" cap="flat" cmpd="sng" algn="ctr">
+                      <a:solidFill>
+                        <a:srgbClr val="FFFFFF"/>
+                      </a:solidFill>
+                      <a:prstDash val="solid"/>
+                      <a:round/>
+                      <a:headEnd type="none" w="med" len="med"/>
+                      <a:tailEnd type="none" w="med" len="med"/>
+                    </a:lnL>
+                    <a:lnR w="5715" cap="flat" cmpd="sng" algn="ctr">
+                      <a:solidFill>
+                        <a:srgbClr val="FFFFFF"/>
+                      </a:solidFill>
+                      <a:prstDash val="solid"/>
+                      <a:round/>
+                      <a:headEnd type="none" w="med" len="med"/>
+                      <a:tailEnd type="none" w="med" len="med"/>
+                    </a:lnR>
+                    <a:lnT w="5715" cap="flat" cmpd="sng" algn="ctr">
+                      <a:solidFill>
+                        <a:srgbClr val="FFFFFF"/>
+                      </a:solidFill>
+                      <a:prstDash val="solid"/>
+                      <a:round/>
+                      <a:headEnd type="none" w="med" len="med"/>
+                      <a:tailEnd type="none" w="med" len="med"/>
+                    </a:lnT>
+                    <a:lnB w="5715" cap="flat" cmpd="sng" algn="ctr">
+                      <a:solidFill>
+                        <a:srgbClr val="FFFFFF"/>
+                      </a:solidFill>
+                      <a:prstDash val="solid"/>
+                      <a:round/>
+                      <a:headEnd type="none" w="med" len="med"/>
+                      <a:tailEnd type="none" w="med" len="med"/>
+                    </a:lnB>
+                    <a:solidFill>
+                      <a:srgbClr val="F1F1F1"/>
+                    </a:solidFill>
+                  </a:tcPr>
+                </a:tc>
+                <a:tc>
+                  <a:txBody>
+                    <a:bodyPr/>
+                    <a:lstStyle/>
+                    <a:p>
+                      <a:pPr algn="ctr" indent="0" marL="0">
+                        <a:buNone/>
+                      </a:pPr>
+                      <a:r>
+                        <a:rPr lang="en-US" sz="615" dirty="0">
+                          <a:solidFill>
+                            <a:srgbClr val="1F1F1F"/>
+                          </a:solidFill>
+                          <a:latin typeface="Calibri" pitchFamily="34" charset="0"/>
+                          <a:ea typeface="Calibri" pitchFamily="34" charset="-122"/>
+                          <a:cs typeface="Calibri" pitchFamily="34" charset="-120"/>
+                        </a:rPr>
+                        <a:t>R$ 16,5 mi</a:t>
+                      </a:r>
+                      <a:endParaRPr lang="en-US" sz="615" dirty="0">
+                        <a:latin typeface="Calibri" charset="0"/>
+                        <a:ea typeface="Calibri" charset="0"/>
+                        <a:cs typeface="Calibri" charset="0"/>
+                      </a:endParaRPr>
+                    </a:p>
+                  </a:txBody>
+                  <a:tcPr marL="36576" marR="36576" marT="18288" marB="18288" anchor="mid">
+                    <a:lnL w="5715" cap="flat" cmpd="sng" algn="ctr">
+                      <a:solidFill>
+                        <a:srgbClr val="FFFFFF"/>
+                      </a:solidFill>
+                      <a:prstDash val="solid"/>
+                      <a:round/>
+                      <a:headEnd type="none" w="med" len="med"/>
+                      <a:tailEnd type="none" w="med" len="med"/>
+                    </a:lnL>
+                    <a:lnR w="5715" cap="flat" cmpd="sng" algn="ctr">
+                      <a:solidFill>
+                        <a:srgbClr val="FFFFFF"/>
+                      </a:solidFill>
+                      <a:prstDash val="solid"/>
+                      <a:round/>
+                      <a:headEnd type="none" w="med" len="med"/>
+                      <a:tailEnd type="none" w="med" len="med"/>
+                    </a:lnR>
+                    <a:lnT w="5715" cap="flat" cmpd="sng" algn="ctr">
+                      <a:solidFill>
+                        <a:srgbClr val="FFFFFF"/>
+                      </a:solidFill>
+                      <a:prstDash val="solid"/>
+                      <a:round/>
+                      <a:headEnd type="none" w="med" len="med"/>
+                      <a:tailEnd type="none" w="med" len="med"/>
+                    </a:lnT>
+                    <a:lnB w="5715" cap="flat" cmpd="sng" algn="ctr">
+                      <a:solidFill>
+                        <a:srgbClr val="FFFFFF"/>
+                      </a:solidFill>
+                      <a:prstDash val="solid"/>
+                      <a:round/>
+                      <a:headEnd type="none" w="med" len="med"/>
+                      <a:tailEnd type="none" w="med" len="med"/>
+                    </a:lnB>
+                    <a:solidFill>
+                      <a:srgbClr val="F1F1F1"/>
+                    </a:solidFill>
+                  </a:tcPr>
+                </a:tc>
+                <a:tc>
+                  <a:txBody>
+                    <a:bodyPr/>
+                    <a:lstStyle/>
+                    <a:p>
+                      <a:pPr algn="ctr" indent="0" marL="0">
+                        <a:buNone/>
+                      </a:pPr>
+                      <a:r>
+                        <a:rPr lang="en-US" sz="615" dirty="0">
+                          <a:solidFill>
+                            <a:srgbClr val="1F1F1F"/>
+                          </a:solidFill>
+                          <a:latin typeface="Calibri" pitchFamily="34" charset="0"/>
+                          <a:ea typeface="Calibri" pitchFamily="34" charset="-122"/>
+                          <a:cs typeface="Calibri" pitchFamily="34" charset="-120"/>
+                        </a:rPr>
+                        <a:t>R$ 71,1 mi</a:t>
+                      </a:r>
+                      <a:endParaRPr lang="en-US" sz="615" dirty="0">
+                        <a:latin typeface="Calibri" charset="0"/>
+                        <a:ea typeface="Calibri" charset="0"/>
+                        <a:cs typeface="Calibri" charset="0"/>
+                      </a:endParaRPr>
+                    </a:p>
+                  </a:txBody>
+                  <a:tcPr marL="36576" marR="36576" marT="18288" marB="18288" anchor="mid">
+                    <a:lnL w="5715" cap="flat" cmpd="sng" algn="ctr">
+                      <a:solidFill>
+                        <a:srgbClr val="FFFFFF"/>
+                      </a:solidFill>
+                      <a:prstDash val="solid"/>
+                      <a:round/>
+                      <a:headEnd type="none" w="med" len="med"/>
+                      <a:tailEnd type="none" w="med" len="med"/>
+                    </a:lnL>
+                    <a:lnR w="5715" cap="flat" cmpd="sng" algn="ctr">
+                      <a:solidFill>
+                        <a:srgbClr val="FFFFFF"/>
+                      </a:solidFill>
+                      <a:prstDash val="solid"/>
+                      <a:round/>
+                      <a:headEnd type="none" w="med" len="med"/>
+                      <a:tailEnd type="none" w="med" len="med"/>
+                    </a:lnR>
+                    <a:lnT w="5715" cap="flat" cmpd="sng" algn="ctr">
+                      <a:solidFill>
+                        <a:srgbClr val="FFFFFF"/>
+                      </a:solidFill>
+                      <a:prstDash val="solid"/>
+                      <a:round/>
+                      <a:headEnd type="none" w="med" len="med"/>
+                      <a:tailEnd type="none" w="med" len="med"/>
+                    </a:lnT>
+                    <a:lnB w="5715" cap="flat" cmpd="sng" algn="ctr">
+                      <a:solidFill>
+                        <a:srgbClr val="FFFFFF"/>
+                      </a:solidFill>
+                      <a:prstDash val="solid"/>
+                      <a:round/>
+                      <a:headEnd type="none" w="med" len="med"/>
+                      <a:tailEnd type="none" w="med" len="med"/>
+                    </a:lnB>
+                    <a:solidFill>
+                      <a:srgbClr val="F1F1F1"/>
+                    </a:solidFill>
+                  </a:tcPr>
+                </a:tc>
+                <a:tc>
+                  <a:txBody>
+                    <a:bodyPr/>
+                    <a:lstStyle/>
+                    <a:p>
+                      <a:pPr algn="ctr" indent="0" marL="0">
+                        <a:buNone/>
+                      </a:pPr>
+                      <a:r>
+                        <a:rPr lang="en-US" sz="615" dirty="0">
+                          <a:solidFill>
+                            <a:srgbClr val="1F1F1F"/>
+                          </a:solidFill>
+                          <a:latin typeface="Calibri" pitchFamily="34" charset="0"/>
+                          <a:ea typeface="Calibri" pitchFamily="34" charset="-122"/>
+                          <a:cs typeface="Calibri" pitchFamily="34" charset="-120"/>
+                        </a:rPr>
+                        <a:t>R$ 109 mi</a:t>
                       </a:r>
                       <a:endParaRPr lang="en-US" sz="615" dirty="0">
                         <a:latin typeface="Calibri" charset="0"/>
@@ -14094,211 +14298,7 @@
                           <a:ea typeface="Calibri" pitchFamily="34" charset="-122"/>
                           <a:cs typeface="Calibri" pitchFamily="34" charset="-120"/>
                         </a:rPr>
-                        <a:t>R$ 0,00</a:t>
-                      </a:r>
-                      <a:endParaRPr lang="en-US" sz="615" dirty="0">
-                        <a:latin typeface="Calibri" charset="0"/>
-                        <a:ea typeface="Calibri" charset="0"/>
-                        <a:cs typeface="Calibri" charset="0"/>
-                      </a:endParaRPr>
-                    </a:p>
-                  </a:txBody>
-                  <a:tcPr marL="36576" marR="36576" marT="18288" marB="18288" anchor="mid">
-                    <a:lnL w="5715" cap="flat" cmpd="sng" algn="ctr">
-                      <a:solidFill>
-                        <a:srgbClr val="FFFFFF"/>
-                      </a:solidFill>
-                      <a:prstDash val="solid"/>
-                      <a:round/>
-                      <a:headEnd type="none" w="med" len="med"/>
-                      <a:tailEnd type="none" w="med" len="med"/>
-                    </a:lnL>
-                    <a:lnR w="5715" cap="flat" cmpd="sng" algn="ctr">
-                      <a:solidFill>
-                        <a:srgbClr val="FFFFFF"/>
-                      </a:solidFill>
-                      <a:prstDash val="solid"/>
-                      <a:round/>
-                      <a:headEnd type="none" w="med" len="med"/>
-                      <a:tailEnd type="none" w="med" len="med"/>
-                    </a:lnR>
-                    <a:lnT w="5715" cap="flat" cmpd="sng" algn="ctr">
-                      <a:solidFill>
-                        <a:srgbClr val="FFFFFF"/>
-                      </a:solidFill>
-                      <a:prstDash val="solid"/>
-                      <a:round/>
-                      <a:headEnd type="none" w="med" len="med"/>
-                      <a:tailEnd type="none" w="med" len="med"/>
-                    </a:lnT>
-                    <a:lnB w="5715" cap="flat" cmpd="sng" algn="ctr">
-                      <a:solidFill>
-                        <a:srgbClr val="FFFFFF"/>
-                      </a:solidFill>
-                      <a:prstDash val="solid"/>
-                      <a:round/>
-                      <a:headEnd type="none" w="med" len="med"/>
-                      <a:tailEnd type="none" w="med" len="med"/>
-                    </a:lnB>
-                    <a:solidFill>
-                      <a:srgbClr val="F1F1F1"/>
-                    </a:solidFill>
-                  </a:tcPr>
-                </a:tc>
-                <a:tc>
-                  <a:txBody>
-                    <a:bodyPr/>
-                    <a:lstStyle/>
-                    <a:p>
-                      <a:pPr algn="ctr" indent="0" marL="0">
-                        <a:buNone/>
-                      </a:pPr>
-                      <a:r>
-                        <a:rPr lang="en-US" sz="615" dirty="0">
-                          <a:solidFill>
-                            <a:srgbClr val="1F1F1F"/>
-                          </a:solidFill>
-                          <a:latin typeface="Calibri" pitchFamily="34" charset="0"/>
-                          <a:ea typeface="Calibri" pitchFamily="34" charset="-122"/>
-                          <a:cs typeface="Calibri" pitchFamily="34" charset="-120"/>
-                        </a:rPr>
-                        <a:t>R$ 105,8 mi</a:t>
-                      </a:r>
-                      <a:endParaRPr lang="en-US" sz="615" dirty="0">
-                        <a:latin typeface="Calibri" charset="0"/>
-                        <a:ea typeface="Calibri" charset="0"/>
-                        <a:cs typeface="Calibri" charset="0"/>
-                      </a:endParaRPr>
-                    </a:p>
-                  </a:txBody>
-                  <a:tcPr marL="36576" marR="36576" marT="18288" marB="18288" anchor="mid">
-                    <a:lnL w="5715" cap="flat" cmpd="sng" algn="ctr">
-                      <a:solidFill>
-                        <a:srgbClr val="FFFFFF"/>
-                      </a:solidFill>
-                      <a:prstDash val="solid"/>
-                      <a:round/>
-                      <a:headEnd type="none" w="med" len="med"/>
-                      <a:tailEnd type="none" w="med" len="med"/>
-                    </a:lnL>
-                    <a:lnR w="5715" cap="flat" cmpd="sng" algn="ctr">
-                      <a:solidFill>
-                        <a:srgbClr val="FFFFFF"/>
-                      </a:solidFill>
-                      <a:prstDash val="solid"/>
-                      <a:round/>
-                      <a:headEnd type="none" w="med" len="med"/>
-                      <a:tailEnd type="none" w="med" len="med"/>
-                    </a:lnR>
-                    <a:lnT w="5715" cap="flat" cmpd="sng" algn="ctr">
-                      <a:solidFill>
-                        <a:srgbClr val="FFFFFF"/>
-                      </a:solidFill>
-                      <a:prstDash val="solid"/>
-                      <a:round/>
-                      <a:headEnd type="none" w="med" len="med"/>
-                      <a:tailEnd type="none" w="med" len="med"/>
-                    </a:lnT>
-                    <a:lnB w="5715" cap="flat" cmpd="sng" algn="ctr">
-                      <a:solidFill>
-                        <a:srgbClr val="FFFFFF"/>
-                      </a:solidFill>
-                      <a:prstDash val="solid"/>
-                      <a:round/>
-                      <a:headEnd type="none" w="med" len="med"/>
-                      <a:tailEnd type="none" w="med" len="med"/>
-                    </a:lnB>
-                    <a:solidFill>
-                      <a:srgbClr val="F1F1F1"/>
-                    </a:solidFill>
-                  </a:tcPr>
-                </a:tc>
-                <a:tc>
-                  <a:txBody>
-                    <a:bodyPr/>
-                    <a:lstStyle/>
-                    <a:p>
-                      <a:pPr algn="ctr" indent="0" marL="0">
-                        <a:buNone/>
-                      </a:pPr>
-                      <a:r>
-                        <a:rPr lang="en-US" sz="615" dirty="0">
-                          <a:solidFill>
-                            <a:srgbClr val="1F1F1F"/>
-                          </a:solidFill>
-                          <a:latin typeface="Calibri" pitchFamily="34" charset="0"/>
-                          <a:ea typeface="Calibri" pitchFamily="34" charset="-122"/>
-                          <a:cs typeface="Calibri" pitchFamily="34" charset="-120"/>
-                        </a:rPr>
-                        <a:t>R$ 0,00</a:t>
-                      </a:r>
-                      <a:endParaRPr lang="en-US" sz="615" dirty="0">
-                        <a:latin typeface="Calibri" charset="0"/>
-                        <a:ea typeface="Calibri" charset="0"/>
-                        <a:cs typeface="Calibri" charset="0"/>
-                      </a:endParaRPr>
-                    </a:p>
-                  </a:txBody>
-                  <a:tcPr marL="36576" marR="36576" marT="18288" marB="18288" anchor="mid">
-                    <a:lnL w="5715" cap="flat" cmpd="sng" algn="ctr">
-                      <a:solidFill>
-                        <a:srgbClr val="FFFFFF"/>
-                      </a:solidFill>
-                      <a:prstDash val="solid"/>
-                      <a:round/>
-                      <a:headEnd type="none" w="med" len="med"/>
-                      <a:tailEnd type="none" w="med" len="med"/>
-                    </a:lnL>
-                    <a:lnR w="5715" cap="flat" cmpd="sng" algn="ctr">
-                      <a:solidFill>
-                        <a:srgbClr val="FFFFFF"/>
-                      </a:solidFill>
-                      <a:prstDash val="solid"/>
-                      <a:round/>
-                      <a:headEnd type="none" w="med" len="med"/>
-                      <a:tailEnd type="none" w="med" len="med"/>
-                    </a:lnR>
-                    <a:lnT w="5715" cap="flat" cmpd="sng" algn="ctr">
-                      <a:solidFill>
-                        <a:srgbClr val="FFFFFF"/>
-                      </a:solidFill>
-                      <a:prstDash val="solid"/>
-                      <a:round/>
-                      <a:headEnd type="none" w="med" len="med"/>
-                      <a:tailEnd type="none" w="med" len="med"/>
-                    </a:lnT>
-                    <a:lnB w="5715" cap="flat" cmpd="sng" algn="ctr">
-                      <a:solidFill>
-                        <a:srgbClr val="FFFFFF"/>
-                      </a:solidFill>
-                      <a:prstDash val="solid"/>
-                      <a:round/>
-                      <a:headEnd type="none" w="med" len="med"/>
-                      <a:tailEnd type="none" w="med" len="med"/>
-                    </a:lnB>
-                    <a:solidFill>
-                      <a:srgbClr val="F1F1F1"/>
-                    </a:solidFill>
-                  </a:tcPr>
-                </a:tc>
-                <a:tc>
-                  <a:txBody>
-                    <a:bodyPr/>
-                    <a:lstStyle/>
-                    <a:p>
-                      <a:pPr algn="ctr" indent="0" marL="0">
-                        <a:buNone/>
-                      </a:pPr>
-                      <a:r>
-                        <a:rPr lang="en-US" sz="615" dirty="0">
-                          <a:solidFill>
-                            <a:srgbClr val="1F1F1F"/>
-                          </a:solidFill>
-                          <a:latin typeface="Calibri" pitchFamily="34" charset="0"/>
-                          <a:ea typeface="Calibri" pitchFamily="34" charset="-122"/>
-                          <a:cs typeface="Calibri" pitchFamily="34" charset="-120"/>
-                        </a:rPr>
-                        <a:t>30,22%</a:t>
+                        <a:t>57,33%</a:t>
                       </a:r>
                       <a:endParaRPr lang="en-US" sz="615" dirty="0">
                         <a:latin typeface="Calibri" charset="0"/>
@@ -14436,7 +14436,7 @@
                           <a:ea typeface="Calibri" pitchFamily="34" charset="-122"/>
                           <a:cs typeface="Calibri" pitchFamily="34" charset="-120"/>
                         </a:rPr>
-                        <a:t>R$ 86,7 mi</a:t>
+                        <a:t>R$ 93,9 mi</a:t>
                       </a:r>
                       <a:endParaRPr lang="en-US" sz="615" dirty="0">
                         <a:latin typeface="Calibri" charset="0"/>
@@ -14504,7 +14504,143 @@
                           <a:ea typeface="Calibri" pitchFamily="34" charset="-122"/>
                           <a:cs typeface="Calibri" pitchFamily="34" charset="-120"/>
                         </a:rPr>
-                        <a:t>R$ 2,8 mi</a:t>
+                        <a:t>R$ 16,8 mi</a:t>
+                      </a:r>
+                      <a:endParaRPr lang="en-US" sz="615" dirty="0">
+                        <a:latin typeface="Calibri" charset="0"/>
+                        <a:ea typeface="Calibri" charset="0"/>
+                        <a:cs typeface="Calibri" charset="0"/>
+                      </a:endParaRPr>
+                    </a:p>
+                  </a:txBody>
+                  <a:tcPr marL="36576" marR="36576" marT="18288" marB="18288" anchor="mid">
+                    <a:lnL w="5715" cap="flat" cmpd="sng" algn="ctr">
+                      <a:solidFill>
+                        <a:srgbClr val="FFFFFF"/>
+                      </a:solidFill>
+                      <a:prstDash val="solid"/>
+                      <a:round/>
+                      <a:headEnd type="none" w="med" len="med"/>
+                      <a:tailEnd type="none" w="med" len="med"/>
+                    </a:lnL>
+                    <a:lnR w="5715" cap="flat" cmpd="sng" algn="ctr">
+                      <a:solidFill>
+                        <a:srgbClr val="FFFFFF"/>
+                      </a:solidFill>
+                      <a:prstDash val="solid"/>
+                      <a:round/>
+                      <a:headEnd type="none" w="med" len="med"/>
+                      <a:tailEnd type="none" w="med" len="med"/>
+                    </a:lnR>
+                    <a:lnT w="5715" cap="flat" cmpd="sng" algn="ctr">
+                      <a:solidFill>
+                        <a:srgbClr val="FFFFFF"/>
+                      </a:solidFill>
+                      <a:prstDash val="solid"/>
+                      <a:round/>
+                      <a:headEnd type="none" w="med" len="med"/>
+                      <a:tailEnd type="none" w="med" len="med"/>
+                    </a:lnT>
+                    <a:lnB w="5715" cap="flat" cmpd="sng" algn="ctr">
+                      <a:solidFill>
+                        <a:srgbClr val="FFFFFF"/>
+                      </a:solidFill>
+                      <a:prstDash val="solid"/>
+                      <a:round/>
+                      <a:headEnd type="none" w="med" len="med"/>
+                      <a:tailEnd type="none" w="med" len="med"/>
+                    </a:lnB>
+                    <a:solidFill>
+                      <a:srgbClr val="FFFFFF"/>
+                    </a:solidFill>
+                  </a:tcPr>
+                </a:tc>
+                <a:tc>
+                  <a:txBody>
+                    <a:bodyPr/>
+                    <a:lstStyle/>
+                    <a:p>
+                      <a:pPr algn="ctr" indent="0" marL="0">
+                        <a:buNone/>
+                      </a:pPr>
+                      <a:r>
+                        <a:rPr lang="en-US" sz="615" dirty="0">
+                          <a:solidFill>
+                            <a:srgbClr val="1F1F1F"/>
+                          </a:solidFill>
+                          <a:latin typeface="Calibri" pitchFamily="34" charset="0"/>
+                          <a:ea typeface="Calibri" pitchFamily="34" charset="-122"/>
+                          <a:cs typeface="Calibri" pitchFamily="34" charset="-120"/>
+                        </a:rPr>
+                        <a:t>R$ 87,7 mi</a:t>
+                      </a:r>
+                      <a:endParaRPr lang="en-US" sz="615" dirty="0">
+                        <a:latin typeface="Calibri" charset="0"/>
+                        <a:ea typeface="Calibri" charset="0"/>
+                        <a:cs typeface="Calibri" charset="0"/>
+                      </a:endParaRPr>
+                    </a:p>
+                  </a:txBody>
+                  <a:tcPr marL="36576" marR="36576" marT="18288" marB="18288" anchor="mid">
+                    <a:lnL w="5715" cap="flat" cmpd="sng" algn="ctr">
+                      <a:solidFill>
+                        <a:srgbClr val="FFFFFF"/>
+                      </a:solidFill>
+                      <a:prstDash val="solid"/>
+                      <a:round/>
+                      <a:headEnd type="none" w="med" len="med"/>
+                      <a:tailEnd type="none" w="med" len="med"/>
+                    </a:lnL>
+                    <a:lnR w="5715" cap="flat" cmpd="sng" algn="ctr">
+                      <a:solidFill>
+                        <a:srgbClr val="FFFFFF"/>
+                      </a:solidFill>
+                      <a:prstDash val="solid"/>
+                      <a:round/>
+                      <a:headEnd type="none" w="med" len="med"/>
+                      <a:tailEnd type="none" w="med" len="med"/>
+                    </a:lnR>
+                    <a:lnT w="5715" cap="flat" cmpd="sng" algn="ctr">
+                      <a:solidFill>
+                        <a:srgbClr val="FFFFFF"/>
+                      </a:solidFill>
+                      <a:prstDash val="solid"/>
+                      <a:round/>
+                      <a:headEnd type="none" w="med" len="med"/>
+                      <a:tailEnd type="none" w="med" len="med"/>
+                    </a:lnT>
+                    <a:lnB w="5715" cap="flat" cmpd="sng" algn="ctr">
+                      <a:solidFill>
+                        <a:srgbClr val="FFFFFF"/>
+                      </a:solidFill>
+                      <a:prstDash val="solid"/>
+                      <a:round/>
+                      <a:headEnd type="none" w="med" len="med"/>
+                      <a:tailEnd type="none" w="med" len="med"/>
+                    </a:lnB>
+                    <a:solidFill>
+                      <a:srgbClr val="FFFFFF"/>
+                    </a:solidFill>
+                  </a:tcPr>
+                </a:tc>
+                <a:tc>
+                  <a:txBody>
+                    <a:bodyPr/>
+                    <a:lstStyle/>
+                    <a:p>
+                      <a:pPr algn="ctr" indent="0" marL="0">
+                        <a:buNone/>
+                      </a:pPr>
+                      <a:r>
+                        <a:rPr lang="en-US" sz="615" dirty="0">
+                          <a:solidFill>
+                            <a:srgbClr val="1F1F1F"/>
+                          </a:solidFill>
+                          <a:latin typeface="Calibri" pitchFamily="34" charset="0"/>
+                          <a:ea typeface="Calibri" pitchFamily="34" charset="-122"/>
+                          <a:cs typeface="Calibri" pitchFamily="34" charset="-120"/>
+                        </a:rPr>
+                        <a:t>R$ 110,7 mi</a:t>
                       </a:r>
                       <a:endParaRPr lang="en-US" sz="615" dirty="0">
                         <a:latin typeface="Calibri" charset="0"/>
@@ -14640,143 +14776,7 @@
                           <a:ea typeface="Calibri" pitchFamily="34" charset="-122"/>
                           <a:cs typeface="Calibri" pitchFamily="34" charset="-120"/>
                         </a:rPr>
-                        <a:t>R$ 89,5 mi</a:t>
-                      </a:r>
-                      <a:endParaRPr lang="en-US" sz="615" dirty="0">
-                        <a:latin typeface="Calibri" charset="0"/>
-                        <a:ea typeface="Calibri" charset="0"/>
-                        <a:cs typeface="Calibri" charset="0"/>
-                      </a:endParaRPr>
-                    </a:p>
-                  </a:txBody>
-                  <a:tcPr marL="36576" marR="36576" marT="18288" marB="18288" anchor="mid">
-                    <a:lnL w="5715" cap="flat" cmpd="sng" algn="ctr">
-                      <a:solidFill>
-                        <a:srgbClr val="FFFFFF"/>
-                      </a:solidFill>
-                      <a:prstDash val="solid"/>
-                      <a:round/>
-                      <a:headEnd type="none" w="med" len="med"/>
-                      <a:tailEnd type="none" w="med" len="med"/>
-                    </a:lnL>
-                    <a:lnR w="5715" cap="flat" cmpd="sng" algn="ctr">
-                      <a:solidFill>
-                        <a:srgbClr val="FFFFFF"/>
-                      </a:solidFill>
-                      <a:prstDash val="solid"/>
-                      <a:round/>
-                      <a:headEnd type="none" w="med" len="med"/>
-                      <a:tailEnd type="none" w="med" len="med"/>
-                    </a:lnR>
-                    <a:lnT w="5715" cap="flat" cmpd="sng" algn="ctr">
-                      <a:solidFill>
-                        <a:srgbClr val="FFFFFF"/>
-                      </a:solidFill>
-                      <a:prstDash val="solid"/>
-                      <a:round/>
-                      <a:headEnd type="none" w="med" len="med"/>
-                      <a:tailEnd type="none" w="med" len="med"/>
-                    </a:lnT>
-                    <a:lnB w="5715" cap="flat" cmpd="sng" algn="ctr">
-                      <a:solidFill>
-                        <a:srgbClr val="FFFFFF"/>
-                      </a:solidFill>
-                      <a:prstDash val="solid"/>
-                      <a:round/>
-                      <a:headEnd type="none" w="med" len="med"/>
-                      <a:tailEnd type="none" w="med" len="med"/>
-                    </a:lnB>
-                    <a:solidFill>
-                      <a:srgbClr val="FFFFFF"/>
-                    </a:solidFill>
-                  </a:tcPr>
-                </a:tc>
-                <a:tc>
-                  <a:txBody>
-                    <a:bodyPr/>
-                    <a:lstStyle/>
-                    <a:p>
-                      <a:pPr algn="ctr" indent="0" marL="0">
-                        <a:buNone/>
-                      </a:pPr>
-                      <a:r>
-                        <a:rPr lang="en-US" sz="615" dirty="0">
-                          <a:solidFill>
-                            <a:srgbClr val="1F1F1F"/>
-                          </a:solidFill>
-                          <a:latin typeface="Calibri" pitchFamily="34" charset="0"/>
-                          <a:ea typeface="Calibri" pitchFamily="34" charset="-122"/>
-                          <a:cs typeface="Calibri" pitchFamily="34" charset="-120"/>
-                        </a:rPr>
-                        <a:t>R$ 0,00</a:t>
-                      </a:r>
-                      <a:endParaRPr lang="en-US" sz="615" dirty="0">
-                        <a:latin typeface="Calibri" charset="0"/>
-                        <a:ea typeface="Calibri" charset="0"/>
-                        <a:cs typeface="Calibri" charset="0"/>
-                      </a:endParaRPr>
-                    </a:p>
-                  </a:txBody>
-                  <a:tcPr marL="36576" marR="36576" marT="18288" marB="18288" anchor="mid">
-                    <a:lnL w="5715" cap="flat" cmpd="sng" algn="ctr">
-                      <a:solidFill>
-                        <a:srgbClr val="FFFFFF"/>
-                      </a:solidFill>
-                      <a:prstDash val="solid"/>
-                      <a:round/>
-                      <a:headEnd type="none" w="med" len="med"/>
-                      <a:tailEnd type="none" w="med" len="med"/>
-                    </a:lnL>
-                    <a:lnR w="5715" cap="flat" cmpd="sng" algn="ctr">
-                      <a:solidFill>
-                        <a:srgbClr val="FFFFFF"/>
-                      </a:solidFill>
-                      <a:prstDash val="solid"/>
-                      <a:round/>
-                      <a:headEnd type="none" w="med" len="med"/>
-                      <a:tailEnd type="none" w="med" len="med"/>
-                    </a:lnR>
-                    <a:lnT w="5715" cap="flat" cmpd="sng" algn="ctr">
-                      <a:solidFill>
-                        <a:srgbClr val="FFFFFF"/>
-                      </a:solidFill>
-                      <a:prstDash val="solid"/>
-                      <a:round/>
-                      <a:headEnd type="none" w="med" len="med"/>
-                      <a:tailEnd type="none" w="med" len="med"/>
-                    </a:lnT>
-                    <a:lnB w="5715" cap="flat" cmpd="sng" algn="ctr">
-                      <a:solidFill>
-                        <a:srgbClr val="FFFFFF"/>
-                      </a:solidFill>
-                      <a:prstDash val="solid"/>
-                      <a:round/>
-                      <a:headEnd type="none" w="med" len="med"/>
-                      <a:tailEnd type="none" w="med" len="med"/>
-                    </a:lnB>
-                    <a:solidFill>
-                      <a:srgbClr val="FFFFFF"/>
-                    </a:solidFill>
-                  </a:tcPr>
-                </a:tc>
-                <a:tc>
-                  <a:txBody>
-                    <a:bodyPr/>
-                    <a:lstStyle/>
-                    <a:p>
-                      <a:pPr algn="ctr" indent="0" marL="0">
-                        <a:buNone/>
-                      </a:pPr>
-                      <a:r>
-                        <a:rPr lang="en-US" sz="615" dirty="0">
-                          <a:solidFill>
-                            <a:srgbClr val="1F1F1F"/>
-                          </a:solidFill>
-                          <a:latin typeface="Calibri" pitchFamily="34" charset="0"/>
-                          <a:ea typeface="Calibri" pitchFamily="34" charset="-122"/>
-                          <a:cs typeface="Calibri" pitchFamily="34" charset="-120"/>
-                        </a:rPr>
-                        <a:t>30,41%</a:t>
+                        <a:t>59,88%</a:t>
                       </a:r>
                       <a:endParaRPr lang="en-US" sz="615" dirty="0">
                         <a:latin typeface="Calibri" charset="0"/>
@@ -14914,7 +14914,211 @@
                           <a:ea typeface="Calibri" pitchFamily="34" charset="-122"/>
                           <a:cs typeface="Calibri" pitchFamily="34" charset="-120"/>
                         </a:rPr>
-                        <a:t>R$ 68,1 mi</a:t>
+                        <a:t>R$ 95,3 mi</a:t>
+                      </a:r>
+                      <a:endParaRPr lang="en-US" sz="615" dirty="0">
+                        <a:latin typeface="Calibri" charset="0"/>
+                        <a:ea typeface="Calibri" charset="0"/>
+                        <a:cs typeface="Calibri" charset="0"/>
+                      </a:endParaRPr>
+                    </a:p>
+                  </a:txBody>
+                  <a:tcPr marL="36576" marR="36576" marT="18288" marB="18288" anchor="mid">
+                    <a:lnL w="5715" cap="flat" cmpd="sng" algn="ctr">
+                      <a:solidFill>
+                        <a:srgbClr val="FFFFFF"/>
+                      </a:solidFill>
+                      <a:prstDash val="solid"/>
+                      <a:round/>
+                      <a:headEnd type="none" w="med" len="med"/>
+                      <a:tailEnd type="none" w="med" len="med"/>
+                    </a:lnL>
+                    <a:lnR w="5715" cap="flat" cmpd="sng" algn="ctr">
+                      <a:solidFill>
+                        <a:srgbClr val="FFFFFF"/>
+                      </a:solidFill>
+                      <a:prstDash val="solid"/>
+                      <a:round/>
+                      <a:headEnd type="none" w="med" len="med"/>
+                      <a:tailEnd type="none" w="med" len="med"/>
+                    </a:lnR>
+                    <a:lnT w="5715" cap="flat" cmpd="sng" algn="ctr">
+                      <a:solidFill>
+                        <a:srgbClr val="FFFFFF"/>
+                      </a:solidFill>
+                      <a:prstDash val="solid"/>
+                      <a:round/>
+                      <a:headEnd type="none" w="med" len="med"/>
+                      <a:tailEnd type="none" w="med" len="med"/>
+                    </a:lnT>
+                    <a:lnB w="5715" cap="flat" cmpd="sng" algn="ctr">
+                      <a:solidFill>
+                        <a:srgbClr val="FFFFFF"/>
+                      </a:solidFill>
+                      <a:prstDash val="solid"/>
+                      <a:round/>
+                      <a:headEnd type="none" w="med" len="med"/>
+                      <a:tailEnd type="none" w="med" len="med"/>
+                    </a:lnB>
+                    <a:solidFill>
+                      <a:srgbClr val="F1F1F1"/>
+                    </a:solidFill>
+                  </a:tcPr>
+                </a:tc>
+                <a:tc>
+                  <a:txBody>
+                    <a:bodyPr/>
+                    <a:lstStyle/>
+                    <a:p>
+                      <a:pPr algn="ctr" indent="0" marL="0">
+                        <a:buNone/>
+                      </a:pPr>
+                      <a:r>
+                        <a:rPr lang="en-US" sz="615" dirty="0">
+                          <a:solidFill>
+                            <a:srgbClr val="1F1F1F"/>
+                          </a:solidFill>
+                          <a:latin typeface="Calibri" pitchFamily="34" charset="0"/>
+                          <a:ea typeface="Calibri" pitchFamily="34" charset="-122"/>
+                          <a:cs typeface="Calibri" pitchFamily="34" charset="-120"/>
+                        </a:rPr>
+                        <a:t>R$ 17 mi</a:t>
+                      </a:r>
+                      <a:endParaRPr lang="en-US" sz="615" dirty="0">
+                        <a:latin typeface="Calibri" charset="0"/>
+                        <a:ea typeface="Calibri" charset="0"/>
+                        <a:cs typeface="Calibri" charset="0"/>
+                      </a:endParaRPr>
+                    </a:p>
+                  </a:txBody>
+                  <a:tcPr marL="36576" marR="36576" marT="18288" marB="18288" anchor="mid">
+                    <a:lnL w="5715" cap="flat" cmpd="sng" algn="ctr">
+                      <a:solidFill>
+                        <a:srgbClr val="FFFFFF"/>
+                      </a:solidFill>
+                      <a:prstDash val="solid"/>
+                      <a:round/>
+                      <a:headEnd type="none" w="med" len="med"/>
+                      <a:tailEnd type="none" w="med" len="med"/>
+                    </a:lnL>
+                    <a:lnR w="5715" cap="flat" cmpd="sng" algn="ctr">
+                      <a:solidFill>
+                        <a:srgbClr val="FFFFFF"/>
+                      </a:solidFill>
+                      <a:prstDash val="solid"/>
+                      <a:round/>
+                      <a:headEnd type="none" w="med" len="med"/>
+                      <a:tailEnd type="none" w="med" len="med"/>
+                    </a:lnR>
+                    <a:lnT w="5715" cap="flat" cmpd="sng" algn="ctr">
+                      <a:solidFill>
+                        <a:srgbClr val="FFFFFF"/>
+                      </a:solidFill>
+                      <a:prstDash val="solid"/>
+                      <a:round/>
+                      <a:headEnd type="none" w="med" len="med"/>
+                      <a:tailEnd type="none" w="med" len="med"/>
+                    </a:lnT>
+                    <a:lnB w="5715" cap="flat" cmpd="sng" algn="ctr">
+                      <a:solidFill>
+                        <a:srgbClr val="FFFFFF"/>
+                      </a:solidFill>
+                      <a:prstDash val="solid"/>
+                      <a:round/>
+                      <a:headEnd type="none" w="med" len="med"/>
+                      <a:tailEnd type="none" w="med" len="med"/>
+                    </a:lnB>
+                    <a:solidFill>
+                      <a:srgbClr val="F1F1F1"/>
+                    </a:solidFill>
+                  </a:tcPr>
+                </a:tc>
+                <a:tc>
+                  <a:txBody>
+                    <a:bodyPr/>
+                    <a:lstStyle/>
+                    <a:p>
+                      <a:pPr algn="ctr" indent="0" marL="0">
+                        <a:buNone/>
+                      </a:pPr>
+                      <a:r>
+                        <a:rPr lang="en-US" sz="615" dirty="0">
+                          <a:solidFill>
+                            <a:srgbClr val="1F1F1F"/>
+                          </a:solidFill>
+                          <a:latin typeface="Calibri" pitchFamily="34" charset="0"/>
+                          <a:ea typeface="Calibri" pitchFamily="34" charset="-122"/>
+                          <a:cs typeface="Calibri" pitchFamily="34" charset="-120"/>
+                        </a:rPr>
+                        <a:t>R$ 74,9 mi</a:t>
+                      </a:r>
+                      <a:endParaRPr lang="en-US" sz="615" dirty="0">
+                        <a:latin typeface="Calibri" charset="0"/>
+                        <a:ea typeface="Calibri" charset="0"/>
+                        <a:cs typeface="Calibri" charset="0"/>
+                      </a:endParaRPr>
+                    </a:p>
+                  </a:txBody>
+                  <a:tcPr marL="36576" marR="36576" marT="18288" marB="18288" anchor="mid">
+                    <a:lnL w="5715" cap="flat" cmpd="sng" algn="ctr">
+                      <a:solidFill>
+                        <a:srgbClr val="FFFFFF"/>
+                      </a:solidFill>
+                      <a:prstDash val="solid"/>
+                      <a:round/>
+                      <a:headEnd type="none" w="med" len="med"/>
+                      <a:tailEnd type="none" w="med" len="med"/>
+                    </a:lnL>
+                    <a:lnR w="5715" cap="flat" cmpd="sng" algn="ctr">
+                      <a:solidFill>
+                        <a:srgbClr val="FFFFFF"/>
+                      </a:solidFill>
+                      <a:prstDash val="solid"/>
+                      <a:round/>
+                      <a:headEnd type="none" w="med" len="med"/>
+                      <a:tailEnd type="none" w="med" len="med"/>
+                    </a:lnR>
+                    <a:lnT w="5715" cap="flat" cmpd="sng" algn="ctr">
+                      <a:solidFill>
+                        <a:srgbClr val="FFFFFF"/>
+                      </a:solidFill>
+                      <a:prstDash val="solid"/>
+                      <a:round/>
+                      <a:headEnd type="none" w="med" len="med"/>
+                      <a:tailEnd type="none" w="med" len="med"/>
+                    </a:lnT>
+                    <a:lnB w="5715" cap="flat" cmpd="sng" algn="ctr">
+                      <a:solidFill>
+                        <a:srgbClr val="FFFFFF"/>
+                      </a:solidFill>
+                      <a:prstDash val="solid"/>
+                      <a:round/>
+                      <a:headEnd type="none" w="med" len="med"/>
+                      <a:tailEnd type="none" w="med" len="med"/>
+                    </a:lnB>
+                    <a:solidFill>
+                      <a:srgbClr val="F1F1F1"/>
+                    </a:solidFill>
+                  </a:tcPr>
+                </a:tc>
+                <a:tc>
+                  <a:txBody>
+                    <a:bodyPr/>
+                    <a:lstStyle/>
+                    <a:p>
+                      <a:pPr algn="ctr" indent="0" marL="0">
+                        <a:buNone/>
+                      </a:pPr>
+                      <a:r>
+                        <a:rPr lang="en-US" sz="615" dirty="0">
+                          <a:solidFill>
+                            <a:srgbClr val="1F1F1F"/>
+                          </a:solidFill>
+                          <a:latin typeface="Calibri" pitchFamily="34" charset="0"/>
+                          <a:ea typeface="Calibri" pitchFamily="34" charset="-122"/>
+                          <a:cs typeface="Calibri" pitchFamily="34" charset="-120"/>
+                        </a:rPr>
+                        <a:t>R$ 112,4 mi</a:t>
                       </a:r>
                       <a:endParaRPr lang="en-US" sz="615" dirty="0">
                         <a:latin typeface="Calibri" charset="0"/>
@@ -15050,211 +15254,7 @@
                           <a:ea typeface="Calibri" pitchFamily="34" charset="-122"/>
                           <a:cs typeface="Calibri" pitchFamily="34" charset="-120"/>
                         </a:rPr>
-                        <a:t>R$ 0,00</a:t>
-                      </a:r>
-                      <a:endParaRPr lang="en-US" sz="615" dirty="0">
-                        <a:latin typeface="Calibri" charset="0"/>
-                        <a:ea typeface="Calibri" charset="0"/>
-                        <a:cs typeface="Calibri" charset="0"/>
-                      </a:endParaRPr>
-                    </a:p>
-                  </a:txBody>
-                  <a:tcPr marL="36576" marR="36576" marT="18288" marB="18288" anchor="mid">
-                    <a:lnL w="5715" cap="flat" cmpd="sng" algn="ctr">
-                      <a:solidFill>
-                        <a:srgbClr val="FFFFFF"/>
-                      </a:solidFill>
-                      <a:prstDash val="solid"/>
-                      <a:round/>
-                      <a:headEnd type="none" w="med" len="med"/>
-                      <a:tailEnd type="none" w="med" len="med"/>
-                    </a:lnL>
-                    <a:lnR w="5715" cap="flat" cmpd="sng" algn="ctr">
-                      <a:solidFill>
-                        <a:srgbClr val="FFFFFF"/>
-                      </a:solidFill>
-                      <a:prstDash val="solid"/>
-                      <a:round/>
-                      <a:headEnd type="none" w="med" len="med"/>
-                      <a:tailEnd type="none" w="med" len="med"/>
-                    </a:lnR>
-                    <a:lnT w="5715" cap="flat" cmpd="sng" algn="ctr">
-                      <a:solidFill>
-                        <a:srgbClr val="FFFFFF"/>
-                      </a:solidFill>
-                      <a:prstDash val="solid"/>
-                      <a:round/>
-                      <a:headEnd type="none" w="med" len="med"/>
-                      <a:tailEnd type="none" w="med" len="med"/>
-                    </a:lnT>
-                    <a:lnB w="5715" cap="flat" cmpd="sng" algn="ctr">
-                      <a:solidFill>
-                        <a:srgbClr val="FFFFFF"/>
-                      </a:solidFill>
-                      <a:prstDash val="solid"/>
-                      <a:round/>
-                      <a:headEnd type="none" w="med" len="med"/>
-                      <a:tailEnd type="none" w="med" len="med"/>
-                    </a:lnB>
-                    <a:solidFill>
-                      <a:srgbClr val="F1F1F1"/>
-                    </a:solidFill>
-                  </a:tcPr>
-                </a:tc>
-                <a:tc>
-                  <a:txBody>
-                    <a:bodyPr/>
-                    <a:lstStyle/>
-                    <a:p>
-                      <a:pPr algn="ctr" indent="0" marL="0">
-                        <a:buNone/>
-                      </a:pPr>
-                      <a:r>
-                        <a:rPr lang="en-US" sz="615" dirty="0">
-                          <a:solidFill>
-                            <a:srgbClr val="1F1F1F"/>
-                          </a:solidFill>
-                          <a:latin typeface="Calibri" pitchFamily="34" charset="0"/>
-                          <a:ea typeface="Calibri" pitchFamily="34" charset="-122"/>
-                          <a:cs typeface="Calibri" pitchFamily="34" charset="-120"/>
-                        </a:rPr>
-                        <a:t>R$ 68,1 mi</a:t>
-                      </a:r>
-                      <a:endParaRPr lang="en-US" sz="615" dirty="0">
-                        <a:latin typeface="Calibri" charset="0"/>
-                        <a:ea typeface="Calibri" charset="0"/>
-                        <a:cs typeface="Calibri" charset="0"/>
-                      </a:endParaRPr>
-                    </a:p>
-                  </a:txBody>
-                  <a:tcPr marL="36576" marR="36576" marT="18288" marB="18288" anchor="mid">
-                    <a:lnL w="5715" cap="flat" cmpd="sng" algn="ctr">
-                      <a:solidFill>
-                        <a:srgbClr val="FFFFFF"/>
-                      </a:solidFill>
-                      <a:prstDash val="solid"/>
-                      <a:round/>
-                      <a:headEnd type="none" w="med" len="med"/>
-                      <a:tailEnd type="none" w="med" len="med"/>
-                    </a:lnL>
-                    <a:lnR w="5715" cap="flat" cmpd="sng" algn="ctr">
-                      <a:solidFill>
-                        <a:srgbClr val="FFFFFF"/>
-                      </a:solidFill>
-                      <a:prstDash val="solid"/>
-                      <a:round/>
-                      <a:headEnd type="none" w="med" len="med"/>
-                      <a:tailEnd type="none" w="med" len="med"/>
-                    </a:lnR>
-                    <a:lnT w="5715" cap="flat" cmpd="sng" algn="ctr">
-                      <a:solidFill>
-                        <a:srgbClr val="FFFFFF"/>
-                      </a:solidFill>
-                      <a:prstDash val="solid"/>
-                      <a:round/>
-                      <a:headEnd type="none" w="med" len="med"/>
-                      <a:tailEnd type="none" w="med" len="med"/>
-                    </a:lnT>
-                    <a:lnB w="5715" cap="flat" cmpd="sng" algn="ctr">
-                      <a:solidFill>
-                        <a:srgbClr val="FFFFFF"/>
-                      </a:solidFill>
-                      <a:prstDash val="solid"/>
-                      <a:round/>
-                      <a:headEnd type="none" w="med" len="med"/>
-                      <a:tailEnd type="none" w="med" len="med"/>
-                    </a:lnB>
-                    <a:solidFill>
-                      <a:srgbClr val="F1F1F1"/>
-                    </a:solidFill>
-                  </a:tcPr>
-                </a:tc>
-                <a:tc>
-                  <a:txBody>
-                    <a:bodyPr/>
-                    <a:lstStyle/>
-                    <a:p>
-                      <a:pPr algn="ctr" indent="0" marL="0">
-                        <a:buNone/>
-                      </a:pPr>
-                      <a:r>
-                        <a:rPr lang="en-US" sz="615" dirty="0">
-                          <a:solidFill>
-                            <a:srgbClr val="1F1F1F"/>
-                          </a:solidFill>
-                          <a:latin typeface="Calibri" pitchFamily="34" charset="0"/>
-                          <a:ea typeface="Calibri" pitchFamily="34" charset="-122"/>
-                          <a:cs typeface="Calibri" pitchFamily="34" charset="-120"/>
-                        </a:rPr>
-                        <a:t>R$ 50.908,78</a:t>
-                      </a:r>
-                      <a:endParaRPr lang="en-US" sz="615" dirty="0">
-                        <a:latin typeface="Calibri" charset="0"/>
-                        <a:ea typeface="Calibri" charset="0"/>
-                        <a:cs typeface="Calibri" charset="0"/>
-                      </a:endParaRPr>
-                    </a:p>
-                  </a:txBody>
-                  <a:tcPr marL="36576" marR="36576" marT="18288" marB="18288" anchor="mid">
-                    <a:lnL w="5715" cap="flat" cmpd="sng" algn="ctr">
-                      <a:solidFill>
-                        <a:srgbClr val="FFFFFF"/>
-                      </a:solidFill>
-                      <a:prstDash val="solid"/>
-                      <a:round/>
-                      <a:headEnd type="none" w="med" len="med"/>
-                      <a:tailEnd type="none" w="med" len="med"/>
-                    </a:lnL>
-                    <a:lnR w="5715" cap="flat" cmpd="sng" algn="ctr">
-                      <a:solidFill>
-                        <a:srgbClr val="FFFFFF"/>
-                      </a:solidFill>
-                      <a:prstDash val="solid"/>
-                      <a:round/>
-                      <a:headEnd type="none" w="med" len="med"/>
-                      <a:tailEnd type="none" w="med" len="med"/>
-                    </a:lnR>
-                    <a:lnT w="5715" cap="flat" cmpd="sng" algn="ctr">
-                      <a:solidFill>
-                        <a:srgbClr val="FFFFFF"/>
-                      </a:solidFill>
-                      <a:prstDash val="solid"/>
-                      <a:round/>
-                      <a:headEnd type="none" w="med" len="med"/>
-                      <a:tailEnd type="none" w="med" len="med"/>
-                    </a:lnT>
-                    <a:lnB w="5715" cap="flat" cmpd="sng" algn="ctr">
-                      <a:solidFill>
-                        <a:srgbClr val="FFFFFF"/>
-                      </a:solidFill>
-                      <a:prstDash val="solid"/>
-                      <a:round/>
-                      <a:headEnd type="none" w="med" len="med"/>
-                      <a:tailEnd type="none" w="med" len="med"/>
-                    </a:lnB>
-                    <a:solidFill>
-                      <a:srgbClr val="F1F1F1"/>
-                    </a:solidFill>
-                  </a:tcPr>
-                </a:tc>
-                <a:tc>
-                  <a:txBody>
-                    <a:bodyPr/>
-                    <a:lstStyle/>
-                    <a:p>
-                      <a:pPr algn="ctr" indent="0" marL="0">
-                        <a:buNone/>
-                      </a:pPr>
-                      <a:r>
-                        <a:rPr lang="en-US" sz="615" dirty="0">
-                          <a:solidFill>
-                            <a:srgbClr val="1F1F1F"/>
-                          </a:solidFill>
-                          <a:latin typeface="Calibri" pitchFamily="34" charset="0"/>
-                          <a:ea typeface="Calibri" pitchFamily="34" charset="-122"/>
-                          <a:cs typeface="Calibri" pitchFamily="34" charset="-120"/>
-                        </a:rPr>
-                        <a:t>30,00%</a:t>
+                        <a:t>61,89%</a:t>
                       </a:r>
                       <a:endParaRPr lang="en-US" sz="615" dirty="0">
                         <a:latin typeface="Calibri" charset="0"/>
@@ -16872,7 +16872,7 @@
                 <a:ea typeface="Calibri" pitchFamily="34" charset="-122"/>
                 <a:cs typeface="Calibri" pitchFamily="34" charset="-120"/>
               </a:rPr>
-              <a:t>•  Receita do primeiro mês cobre PDD: R$ 118,9 mi / R$ 133,3 mi = 0,9x.</a:t>
+              <a:t>•  Sem PDD no M1; primeira entrada em Over90 no M4.</a:t>
             </a:r>
             <a:endParaRPr lang="en-US" sz="1000" dirty="0"/>
           </a:p>
@@ -16889,7 +16889,7 @@
                 <a:ea typeface="Calibri" pitchFamily="34" charset="-122"/>
                 <a:cs typeface="Calibri" pitchFamily="34" charset="-120"/>
               </a:rPr>
-              <a:t>•  Cenários que cruzam 30% SUB/originada: Perda 20%, Perda 30%, Perda 40%, Perda 50%.</a:t>
+              <a:t>•  Cenários até 50% preservam SUB/originada acima de 30%.</a:t>
             </a:r>
             <a:endParaRPr lang="en-US" sz="1000" dirty="0"/>
           </a:p>
@@ -16906,7 +16906,7 @@
                 <a:ea typeface="Calibri" pitchFamily="34" charset="-122"/>
                 <a:cs typeface="Calibri" pitchFamily="34" charset="-120"/>
               </a:rPr>
-              <a:t>•  Target/teto final: R$ 1,4 bi; caixa retido por limite: R$ 0,00; caixa final: R$ 0,00.</a:t>
+              <a:t>•  Target/teto final: R$ 1,4 bi; caixa retido por limite: R$ 1,1 bi; caixa final: R$ 1,4 bi.</a:t>
             </a:r>
             <a:endParaRPr lang="en-US" sz="1000" dirty="0"/>
           </a:p>
@@ -16923,7 +16923,7 @@
                 <a:ea typeface="Calibri" pitchFamily="34" charset="-122"/>
                 <a:cs typeface="Calibri" pitchFamily="34" charset="-120"/>
               </a:rPr>
-              <a:t>•  Carteira originada efetiva: R$ 2,1 bi.</a:t>
+              <a:t>•  Carteira originada efetiva: R$ 3,2 bi.</a:t>
             </a:r>
             <a:endParaRPr lang="en-US" sz="1000" dirty="0"/>
           </a:p>
@@ -16940,7 +16940,7 @@
                 <a:ea typeface="Calibri" pitchFamily="34" charset="-122"/>
                 <a:cs typeface="Calibri" pitchFamily="34" charset="-120"/>
               </a:rPr>
-              <a:t>•  SUB / PL final: 100,00%; colchão sobre originada: 12,75%.</a:t>
+              <a:t>•  SUB / PL final: 100,00%; colchão sobre originada: 75,32%.</a:t>
             </a:r>
             <a:endParaRPr lang="en-US" sz="1000" dirty="0"/>
           </a:p>

</xml_diff>